<commit_message>
Apresentação enviável v2 na voz do sócio + versão de 1 página (V3i)
Reescrita a partir do discurso ditado pelo sócio: AI native, a árvore
(da diretoria até cada funcionário), as 3 perguntas da mentalidade, os
6 serviços com os nomes dele, parcerias Microsoft + CrewAI (P8, redação
sem prometer licença — R9), investimento com preços v1.

- abba-apresentacao.pdf/pptx (3 páginas, substitui a v1)
- abba-um-minuto.pdf/pptx (1 página, para WhatsApp) — NOVO
- kit-de-presenca.md: ordem de envio atualizada
- registro V3i. Ambos os documentos: PASS no Revisor (0 achados).

Co-Authored-By: Claude Fable 5 <noreply@anthropic.com>
Claude-Session: https://claude.ai/code/session_016RZJT8nVEB7u33HvjY5KvZ
</commit_message>
<xml_diff>
--- a/08-materiais/modelos/abba-apresentacao.pptx
+++ b/08-materiais/modelos/abba-apresentacao.pptx
@@ -7,9 +7,10 @@
   <p:sldIdLst>
     <p:sldId id="256" r:id="rId2"/>
     <p:sldId id="257" r:id="rId3"/>
+    <p:sldId id="258" r:id="rId4"/>
   </p:sldIdLst>
   <p:notesMasterIdLst>
-    <p:notesMasterId r:id="rId4"/>
+    <p:notesMasterId r:id="rId5"/>
   </p:notesMasterIdLst>
   <p:sldSz cx="7562088" cy="10689336"/>
   <p:notesSz cx="10689336" cy="7562088"/>
@@ -633,6 +634,94 @@
 </p:notes>
 </file>
 
+<file path=ppt/notesSlides/notesSlide3.xml><?xml version="1.0" encoding="utf-8"?>
+<p:notes xmlns:a="http://schemas.openxmlformats.org/drawingml/2006/main" xmlns:r="http://schemas.openxmlformats.org/officeDocument/2006/relationships" xmlns:p="http://schemas.openxmlformats.org/presentationml/2006/main">
+  <p:cSld>
+    <p:spTree>
+      <p:nvGrpSpPr>
+        <p:cNvPr id="1" name=""/>
+        <p:cNvGrpSpPr/>
+        <p:nvPr/>
+      </p:nvGrpSpPr>
+      <p:grpSpPr>
+        <a:xfrm>
+          <a:off x="0" y="0"/>
+          <a:ext cx="0" cy="0"/>
+          <a:chOff x="0" y="0"/>
+          <a:chExt cx="0" cy="0"/>
+        </a:xfrm>
+      </p:grpSpPr>
+      <p:sp>
+        <p:nvSpPr>
+          <p:cNvPr id="2" name="Slide Image Placeholder 1"/>
+          <p:cNvSpPr>
+            <a:spLocks noGrp="1" noRot="1" noChangeAspect="1"/>
+          </p:cNvSpPr>
+          <p:nvPr>
+            <p:ph type="sldImg"/>
+          </p:nvPr>
+        </p:nvSpPr>
+        <p:spPr/>
+      </p:sp>
+      <p:sp>
+        <p:nvSpPr>
+          <p:cNvPr id="3" name="Notes Placeholder 2"/>
+          <p:cNvSpPr>
+            <a:spLocks noGrp="1"/>
+          </p:cNvSpPr>
+          <p:nvPr>
+            <p:ph type="body" idx="1"/>
+          </p:nvPr>
+        </p:nvSpPr>
+        <p:spPr/>
+        <p:txBody>
+          <a:bodyPr/>
+          <a:lstStyle/>
+          <a:p>
+            <a:r>
+              <a:rPr lang="en-US" dirty="0"/>
+              <a:t/>
+            </a:r>
+            <a:endParaRPr lang="en-US" dirty="0"/>
+          </a:p>
+        </p:txBody>
+      </p:sp>
+      <p:sp>
+        <p:nvSpPr>
+          <p:cNvPr id="4" name="Slide Number Placeholder 3"/>
+          <p:cNvSpPr>
+            <a:spLocks noGrp="1"/>
+          </p:cNvSpPr>
+          <p:nvPr>
+            <p:ph type="sldNum" sz="quarter" idx="10"/>
+          </p:nvPr>
+        </p:nvSpPr>
+        <p:spPr/>
+        <p:txBody>
+          <a:bodyPr/>
+          <a:lstStyle/>
+          <a:p>
+            <a:fld id="{F7021451-1387-4CA6-816F-3879F97B5CBC}" type="slidenum">
+              <a:rPr lang="en-US"/>
+              <a:t>3</a:t>
+            </a:fld>
+            <a:endParaRPr lang="en-US"/>
+          </a:p>
+        </p:txBody>
+      </p:sp>
+    </p:spTree>
+    <p:extLst>
+      <p:ext uri="{BB962C8B-B14F-4D97-AF65-F5344CB8AC3E}">
+        <p14:creationId xmlns:p14="http://schemas.microsoft.com/office/powerpoint/2010/main" val="1024086991"/>
+      </p:ext>
+    </p:extLst>
+  </p:cSld>
+  <p:clrMapOvr>
+    <a:masterClrMapping/>
+  </p:clrMapOvr>
+</p:notes>
+</file>
+
 <file path=ppt/slideLayouts/slideLayout1.xml><?xml version="1.0" encoding="utf-8"?>
 <p:sldLayout xmlns:a="http://schemas.openxmlformats.org/drawingml/2006/main" xmlns:r="http://schemas.openxmlformats.org/officeDocument/2006/relationships" xmlns:p="http://schemas.openxmlformats.org/presentationml/2006/main" preserve="1">
   <p:cSld name="DEFAULT">
@@ -973,7 +1062,7 @@
         <p:spPr>
           <a:xfrm>
             <a:off x="0" y="0"/>
-            <a:ext cx="7562088" cy="2286000"/>
+            <a:ext cx="7562088" cy="2514600"/>
           </a:xfrm>
           <a:prstGeom prst="rect">
             <a:avLst/>
@@ -1032,7 +1121,7 @@
         <p:spPr>
           <a:xfrm>
             <a:off x="502920" y="621792"/>
-            <a:ext cx="3657600" cy="274320"/>
+            <a:ext cx="4572000" cy="274320"/>
           </a:xfrm>
           <a:prstGeom prst="rect">
             <a:avLst/>
@@ -1056,7 +1145,7 @@
                 <a:ea typeface="Calibri" pitchFamily="34" charset="-122"/>
                 <a:cs typeface="Calibri" pitchFamily="34" charset="-120"/>
               </a:rPr>
-              <a:t>Consultoria de IA</a:t>
+              <a:t>Consultoria de Inteligência Artificial</a:t>
             </a:r>
             <a:endParaRPr lang="en-US" sz="1050" dirty="0"/>
           </a:p>
@@ -1070,24 +1159,24 @@
         </p:nvSpPr>
         <p:spPr>
           <a:xfrm>
-            <a:off x="502920" y="1005840"/>
-            <a:ext cx="6583680" cy="841248"/>
-          </a:xfrm>
-          <a:prstGeom prst="rect">
-            <a:avLst/>
-          </a:prstGeom>
-          <a:noFill/>
-          <a:ln/>
-        </p:spPr>
-        <p:txBody>
-          <a:bodyPr wrap="square" lIns="0" tIns="0" rIns="0" bIns="0" rtlCol="0" anchor="ctr"/>
-          <a:lstStyle/>
-          <a:p>
-            <a:pPr indent="0" marL="0">
-              <a:buNone/>
-            </a:pPr>
-            <a:r>
-              <a:rPr lang="en-US" sz="2000" b="1" dirty="0">
+            <a:off x="502920" y="1051560"/>
+            <a:ext cx="6583680" cy="502920"/>
+          </a:xfrm>
+          <a:prstGeom prst="rect">
+            <a:avLst/>
+          </a:prstGeom>
+          <a:noFill/>
+          <a:ln/>
+        </p:spPr>
+        <p:txBody>
+          <a:bodyPr wrap="square" lIns="0" tIns="0" rIns="0" bIns="0" rtlCol="0" anchor="ctr"/>
+          <a:lstStyle/>
+          <a:p>
+            <a:pPr indent="0" marL="0">
+              <a:buNone/>
+            </a:pPr>
+            <a:r>
+              <a:rPr lang="en-US" sz="2400" b="1" dirty="0">
                 <a:solidFill>
                   <a:srgbClr val="FFFFFF"/>
                 </a:solidFill>
@@ -1095,26 +1184,9 @@
                 <a:ea typeface="Calibri" pitchFamily="34" charset="-122"/>
                 <a:cs typeface="Calibri" pitchFamily="34" charset="-120"/>
               </a:rPr>
-              <a:t>Instalamos capacidade de IA —</a:t>
-            </a:r>
-            <a:endParaRPr lang="en-US" sz="2000" dirty="0"/>
-          </a:p>
-          <a:p>
-            <a:pPr indent="0" marL="0">
-              <a:buNone/>
-            </a:pPr>
-            <a:r>
-              <a:rPr lang="en-US" sz="2000" b="1" dirty="0">
-                <a:solidFill>
-                  <a:srgbClr val="FFFFFF"/>
-                </a:solidFill>
-                <a:latin typeface="Calibri" pitchFamily="34" charset="0"/>
-                <a:ea typeface="Calibri" pitchFamily="34" charset="-122"/>
-                <a:cs typeface="Calibri" pitchFamily="34" charset="-120"/>
-              </a:rPr>
-              <a:t>e provamos, de fora, o que ela mudou.</a:t>
-            </a:r>
-            <a:endParaRPr lang="en-US" sz="2000" dirty="0"/>
+              <a:t>Tornamos a sua empresa AI native.</a:t>
+            </a:r>
+            <a:endParaRPr lang="en-US" sz="2400" dirty="0"/>
           </a:p>
         </p:txBody>
       </p:sp>
@@ -1126,24 +1198,80 @@
         </p:nvSpPr>
         <p:spPr>
           <a:xfrm>
-            <a:off x="502920" y="1901952"/>
-            <a:ext cx="6583680" cy="274320"/>
-          </a:xfrm>
-          <a:prstGeom prst="rect">
-            <a:avLst/>
-          </a:prstGeom>
-          <a:noFill/>
-          <a:ln/>
-        </p:spPr>
-        <p:txBody>
-          <a:bodyPr wrap="square" lIns="0" tIns="0" rIns="0" bIns="0" rtlCol="0" anchor="ctr"/>
-          <a:lstStyle/>
-          <a:p>
-            <a:pPr indent="0" marL="0">
-              <a:buNone/>
-            </a:pPr>
-            <a:r>
-              <a:rPr lang="en-US" sz="1150" i="1" dirty="0">
+            <a:off x="502920" y="1627632"/>
+            <a:ext cx="6583680" cy="594360"/>
+          </a:xfrm>
+          <a:prstGeom prst="rect">
+            <a:avLst/>
+          </a:prstGeom>
+          <a:noFill/>
+          <a:ln/>
+        </p:spPr>
+        <p:txBody>
+          <a:bodyPr wrap="square" lIns="0" tIns="0" rIns="0" bIns="0" rtlCol="0" anchor="ctr"/>
+          <a:lstStyle/>
+          <a:p>
+            <a:pPr indent="0" marL="0">
+              <a:buNone/>
+            </a:pPr>
+            <a:r>
+              <a:rPr lang="en-US" sz="1100" dirty="0">
+                <a:solidFill>
+                  <a:srgbClr val="C9D2E4"/>
+                </a:solidFill>
+                <a:latin typeface="Calibri" pitchFamily="34" charset="0"/>
+                <a:ea typeface="Calibri" pitchFamily="34" charset="-122"/>
+                <a:cs typeface="Calibri" pitchFamily="34" charset="-120"/>
+              </a:rPr>
+              <a:t>Construímos as soluções que melhoram o dia a dia da operação, formamos as pessoas</a:t>
+            </a:r>
+            <a:endParaRPr lang="en-US" sz="1100" dirty="0"/>
+          </a:p>
+          <a:p>
+            <a:pPr indent="0" marL="0">
+              <a:buNone/>
+            </a:pPr>
+            <a:r>
+              <a:rPr lang="en-US" sz="1100" dirty="0">
+                <a:solidFill>
+                  <a:srgbClr val="C9D2E4"/>
+                </a:solidFill>
+                <a:latin typeface="Calibri" pitchFamily="34" charset="0"/>
+                <a:ea typeface="Calibri" pitchFamily="34" charset="-122"/>
+                <a:cs typeface="Calibri" pitchFamily="34" charset="-120"/>
+              </a:rPr>
+              <a:t>para trabalhar com IA — e provamos o que mudou, com número combinado antes e medido depois.</a:t>
+            </a:r>
+            <a:endParaRPr lang="en-US" sz="1100" dirty="0"/>
+          </a:p>
+        </p:txBody>
+      </p:sp>
+      <p:sp>
+        <p:nvSpPr>
+          <p:cNvPr id="7" name="Text 5"/>
+          <p:cNvSpPr/>
+          <p:nvPr/>
+        </p:nvSpPr>
+        <p:spPr>
+          <a:xfrm>
+            <a:off x="502920" y="2194560"/>
+            <a:ext cx="6583680" cy="256032"/>
+          </a:xfrm>
+          <a:prstGeom prst="rect">
+            <a:avLst/>
+          </a:prstGeom>
+          <a:noFill/>
+          <a:ln/>
+        </p:spPr>
+        <p:txBody>
+          <a:bodyPr wrap="square" lIns="0" tIns="0" rIns="0" bIns="0" rtlCol="0" anchor="ctr"/>
+          <a:lstStyle/>
+          <a:p>
+            <a:pPr indent="0" marL="0">
+              <a:buNone/>
+            </a:pPr>
+            <a:r>
+              <a:rPr lang="en-US" sz="1050" i="1" dirty="0">
                 <a:solidFill>
                   <a:srgbClr val="C2A35B"/>
                 </a:solidFill>
@@ -1153,36 +1281,36 @@
               </a:rPr>
               <a:t>Número combinado antes · medido depois · assinado por gente</a:t>
             </a:r>
-            <a:endParaRPr lang="en-US" sz="1150" dirty="0"/>
-          </a:p>
-        </p:txBody>
-      </p:sp>
-      <p:sp>
-        <p:nvSpPr>
-          <p:cNvPr id="7" name="Text 5"/>
-          <p:cNvSpPr/>
-          <p:nvPr/>
-        </p:nvSpPr>
-        <p:spPr>
-          <a:xfrm>
-            <a:off x="502920" y="2560320"/>
-            <a:ext cx="6583680" cy="274320"/>
-          </a:xfrm>
-          <a:prstGeom prst="rect">
-            <a:avLst/>
-          </a:prstGeom>
-          <a:noFill/>
-          <a:ln/>
-        </p:spPr>
-        <p:txBody>
-          <a:bodyPr wrap="square" lIns="0" tIns="0" rIns="0" bIns="0" rtlCol="0" anchor="ctr"/>
-          <a:lstStyle/>
-          <a:p>
-            <a:pPr indent="0" marL="0">
-              <a:buNone/>
-            </a:pPr>
-            <a:r>
-              <a:rPr lang="en-US" sz="1350" b="1" dirty="0">
+            <a:endParaRPr lang="en-US" sz="1050" dirty="0"/>
+          </a:p>
+        </p:txBody>
+      </p:sp>
+      <p:sp>
+        <p:nvSpPr>
+          <p:cNvPr id="8" name="Text 6"/>
+          <p:cNvSpPr/>
+          <p:nvPr/>
+        </p:nvSpPr>
+        <p:spPr>
+          <a:xfrm>
+            <a:off x="502920" y="2788920"/>
+            <a:ext cx="6583680" cy="292608"/>
+          </a:xfrm>
+          <a:prstGeom prst="rect">
+            <a:avLst/>
+          </a:prstGeom>
+          <a:noFill/>
+          <a:ln/>
+        </p:spPr>
+        <p:txBody>
+          <a:bodyPr wrap="square" lIns="0" tIns="0" rIns="0" bIns="0" rtlCol="0" anchor="ctr"/>
+          <a:lstStyle/>
+          <a:p>
+            <a:pPr indent="0" marL="0">
+              <a:buNone/>
+            </a:pPr>
+            <a:r>
+              <a:rPr lang="en-US" sz="1400" b="1" dirty="0">
                 <a:solidFill>
                   <a:srgbClr val="1B2A4A"/>
                 </a:solidFill>
@@ -1190,22 +1318,22 @@
                 <a:ea typeface="Calibri" pitchFamily="34" charset="-122"/>
                 <a:cs typeface="Calibri" pitchFamily="34" charset="-120"/>
               </a:rPr>
-              <a:t>Por que a maioria dos projetos de IA falha</a:t>
-            </a:r>
-            <a:endParaRPr lang="en-US" sz="1350" dirty="0"/>
-          </a:p>
-        </p:txBody>
-      </p:sp>
-      <p:sp>
-        <p:nvSpPr>
-          <p:cNvPr id="8" name="Text 6"/>
-          <p:cNvSpPr/>
-          <p:nvPr/>
-        </p:nvSpPr>
-        <p:spPr>
-          <a:xfrm>
-            <a:off x="502920" y="2852928"/>
-            <a:ext cx="6583680" cy="685800"/>
+              <a:t>A transformação como uma árvore</a:t>
+            </a:r>
+            <a:endParaRPr lang="en-US" sz="1400" dirty="0"/>
+          </a:p>
+        </p:txBody>
+      </p:sp>
+      <p:sp>
+        <p:nvSpPr>
+          <p:cNvPr id="9" name="Text 7"/>
+          <p:cNvSpPr/>
+          <p:nvPr/>
+        </p:nvSpPr>
+        <p:spPr>
+          <a:xfrm>
+            <a:off x="502920" y="3108960"/>
+            <a:ext cx="6583680" cy="960120"/>
           </a:xfrm>
           <a:prstGeom prst="rect">
             <a:avLst/>
@@ -1229,7 +1357,7 @@
                 <a:ea typeface="Calibri" pitchFamily="34" charset="-122"/>
                 <a:cs typeface="Calibri" pitchFamily="34" charset="-120"/>
               </a:rPr>
-              <a:t>Não é a tecnologia. É a adoção: 70% do valor de uma transformação em IA vive em pessoas, processos e cultura — e ninguém combina, antes de começar, o número que dirá se deu certo. O mercado vende os outros 30%: ferramenta, piloto sem métrica, curso.</a:t>
+              <a:t>Uma transformação que funciona não é um sistema instalado num canto. É uma árvore: plantada com a diretoria, ela estende as raízes até tocar cada funcionário — do conselho à linha de frente. Por isso trabalhamos nas duas pontas ao mesmo tempo: no fluxo de trabalho, construindo soluções que tornam a operação mais eficiente e mais poderosa; e na mentalidade, formando cada pessoa para enxergar o próprio trabalho de um jeito novo.</a:t>
             </a:r>
             <a:endParaRPr lang="en-US" sz="1050" dirty="0"/>
           </a:p>
@@ -1237,392 +1365,14 @@
       </p:sp>
       <p:sp>
         <p:nvSpPr>
-          <p:cNvPr id="9" name="Text 7"/>
-          <p:cNvSpPr/>
-          <p:nvPr/>
-        </p:nvSpPr>
-        <p:spPr>
-          <a:xfrm>
-            <a:off x="502920" y="3657600"/>
-            <a:ext cx="6583680" cy="274320"/>
-          </a:xfrm>
-          <a:prstGeom prst="rect">
-            <a:avLst/>
-          </a:prstGeom>
-          <a:noFill/>
-          <a:ln/>
-        </p:spPr>
-        <p:txBody>
-          <a:bodyPr wrap="square" lIns="0" tIns="0" rIns="0" bIns="0" rtlCol="0" anchor="ctr"/>
-          <a:lstStyle/>
-          <a:p>
-            <a:pPr indent="0" marL="0">
-              <a:buNone/>
-            </a:pPr>
-            <a:r>
-              <a:rPr lang="en-US" sz="1350" b="1" dirty="0">
-                <a:solidFill>
-                  <a:srgbClr val="1B2A4A"/>
-                </a:solidFill>
-                <a:latin typeface="Calibri" pitchFamily="34" charset="0"/>
-                <a:ea typeface="Calibri" pitchFamily="34" charset="-122"/>
-                <a:cs typeface="Calibri" pitchFamily="34" charset="-120"/>
-              </a:rPr>
-              <a:t>O que fazemos — as duas coisas que não dá para fazer de dentro</a:t>
-            </a:r>
-            <a:endParaRPr lang="en-US" sz="1350" dirty="0"/>
-          </a:p>
-        </p:txBody>
-      </p:sp>
-      <p:sp>
-        <p:nvSpPr>
           <p:cNvPr id="10" name="Shape 8"/>
           <p:cNvSpPr/>
           <p:nvPr/>
         </p:nvSpPr>
         <p:spPr>
           <a:xfrm>
-            <a:off x="502920" y="3977640"/>
-            <a:ext cx="2103120" cy="1965960"/>
-          </a:xfrm>
-          <a:prstGeom prst="roundRect">
-            <a:avLst>
-              <a:gd name="adj" fmla="val 2791"/>
-            </a:avLst>
-          </a:prstGeom>
-          <a:solidFill>
-            <a:srgbClr val="F4F1EA"/>
-          </a:solidFill>
-          <a:ln/>
-        </p:spPr>
-      </p:sp>
-      <p:sp>
-        <p:nvSpPr>
-          <p:cNvPr id="11" name="Text 9"/>
-          <p:cNvSpPr/>
-          <p:nvPr/>
-        </p:nvSpPr>
-        <p:spPr>
-          <a:xfrm>
-            <a:off x="640080" y="4114800"/>
-            <a:ext cx="1828800" cy="274320"/>
-          </a:xfrm>
-          <a:prstGeom prst="rect">
-            <a:avLst/>
-          </a:prstGeom>
-          <a:noFill/>
-          <a:ln/>
-        </p:spPr>
-        <p:txBody>
-          <a:bodyPr wrap="square" lIns="0" tIns="0" rIns="0" bIns="0" rtlCol="0" anchor="ctr"/>
-          <a:lstStyle/>
-          <a:p>
-            <a:pPr indent="0" marL="0">
-              <a:buNone/>
-            </a:pPr>
-            <a:r>
-              <a:rPr lang="en-US" sz="1200" b="1" dirty="0">
-                <a:solidFill>
-                  <a:srgbClr val="1B2A4A"/>
-                </a:solidFill>
-                <a:latin typeface="Calibri" pitchFamily="34" charset="0"/>
-                <a:ea typeface="Calibri" pitchFamily="34" charset="-122"/>
-                <a:cs typeface="Calibri" pitchFamily="34" charset="-120"/>
-              </a:rPr>
-              <a:t>Construímos</a:t>
-            </a:r>
-            <a:endParaRPr lang="en-US" sz="1200" dirty="0"/>
-          </a:p>
-        </p:txBody>
-      </p:sp>
-      <p:sp>
-        <p:nvSpPr>
-          <p:cNvPr id="12" name="Text 10"/>
-          <p:cNvSpPr/>
-          <p:nvPr/>
-        </p:nvSpPr>
-        <p:spPr>
-          <a:xfrm>
-            <a:off x="640080" y="4434840"/>
-            <a:ext cx="1828800" cy="1417320"/>
-          </a:xfrm>
-          <a:prstGeom prst="rect">
-            <a:avLst/>
-          </a:prstGeom>
-          <a:noFill/>
-          <a:ln/>
-        </p:spPr>
-        <p:txBody>
-          <a:bodyPr wrap="square" lIns="0" tIns="0" rIns="0" bIns="0" rtlCol="0" anchor="ctr"/>
-          <a:lstStyle/>
-          <a:p>
-            <a:pPr indent="0" marL="0">
-              <a:buNone/>
-            </a:pPr>
-            <a:r>
-              <a:rPr lang="en-US" sz="880" dirty="0">
-                <a:solidFill>
-                  <a:srgbClr val="5A6472"/>
-                </a:solidFill>
-                <a:latin typeface="Calibri" pitchFamily="34" charset="0"/>
-                <a:ea typeface="Calibri" pitchFamily="34" charset="-122"/>
-                <a:cs typeface="Calibri" pitchFamily="34" charset="-120"/>
-              </a:rPr>
-              <a:t>Avaliamos a empresa a fundo (25 dimensões), validamos um protótipo com dados reais — a diretoria decide GO/NO-GO com números — e construímos agentes de IA sob medida, com aprovação humana.</a:t>
-            </a:r>
-            <a:endParaRPr lang="en-US" sz="880" dirty="0"/>
-          </a:p>
-        </p:txBody>
-      </p:sp>
-      <p:sp>
-        <p:nvSpPr>
-          <p:cNvPr id="13" name="Shape 11"/>
-          <p:cNvSpPr/>
-          <p:nvPr/>
-        </p:nvSpPr>
-        <p:spPr>
-          <a:xfrm>
-            <a:off x="2743200" y="3977640"/>
-            <a:ext cx="2103120" cy="1965960"/>
-          </a:xfrm>
-          <a:prstGeom prst="roundRect">
-            <a:avLst>
-              <a:gd name="adj" fmla="val 2791"/>
-            </a:avLst>
-          </a:prstGeom>
-          <a:solidFill>
-            <a:srgbClr val="F4F1EA"/>
-          </a:solidFill>
-          <a:ln/>
-        </p:spPr>
-      </p:sp>
-      <p:sp>
-        <p:nvSpPr>
-          <p:cNvPr id="14" name="Text 12"/>
-          <p:cNvSpPr/>
-          <p:nvPr/>
-        </p:nvSpPr>
-        <p:spPr>
-          <a:xfrm>
-            <a:off x="2880360" y="4114800"/>
-            <a:ext cx="1828800" cy="274320"/>
-          </a:xfrm>
-          <a:prstGeom prst="rect">
-            <a:avLst/>
-          </a:prstGeom>
-          <a:noFill/>
-          <a:ln/>
-        </p:spPr>
-        <p:txBody>
-          <a:bodyPr wrap="square" lIns="0" tIns="0" rIns="0" bIns="0" rtlCol="0" anchor="ctr"/>
-          <a:lstStyle/>
-          <a:p>
-            <a:pPr indent="0" marL="0">
-              <a:buNone/>
-            </a:pPr>
-            <a:r>
-              <a:rPr lang="en-US" sz="1200" b="1" dirty="0">
-                <a:solidFill>
-                  <a:srgbClr val="1B2A4A"/>
-                </a:solidFill>
-                <a:latin typeface="Calibri" pitchFamily="34" charset="0"/>
-                <a:ea typeface="Calibri" pitchFamily="34" charset="-122"/>
-                <a:cs typeface="Calibri" pitchFamily="34" charset="-120"/>
-              </a:rPr>
-              <a:t>Capacitamos</a:t>
-            </a:r>
-            <a:endParaRPr lang="en-US" sz="1200" dirty="0"/>
-          </a:p>
-        </p:txBody>
-      </p:sp>
-      <p:sp>
-        <p:nvSpPr>
-          <p:cNvPr id="15" name="Text 13"/>
-          <p:cNvSpPr/>
-          <p:nvPr/>
-        </p:nvSpPr>
-        <p:spPr>
-          <a:xfrm>
-            <a:off x="2880360" y="4434840"/>
-            <a:ext cx="1828800" cy="1417320"/>
-          </a:xfrm>
-          <a:prstGeom prst="rect">
-            <a:avLst/>
-          </a:prstGeom>
-          <a:noFill/>
-          <a:ln/>
-        </p:spPr>
-        <p:txBody>
-          <a:bodyPr wrap="square" lIns="0" tIns="0" rIns="0" bIns="0" rtlCol="0" anchor="ctr"/>
-          <a:lstStyle/>
-          <a:p>
-            <a:pPr indent="0" marL="0">
-              <a:buNone/>
-            </a:pPr>
-            <a:r>
-              <a:rPr lang="en-US" sz="880" dirty="0">
-                <a:solidFill>
-                  <a:srgbClr val="5A6472"/>
-                </a:solidFill>
-                <a:latin typeface="Calibri" pitchFamily="34" charset="0"/>
-                <a:ea typeface="Calibri" pitchFamily="34" charset="-122"/>
-                <a:cs typeface="Calibri" pitchFamily="34" charset="-120"/>
-              </a:rPr>
-              <a:t>Treinamos todos os níveis da equipe — plataforma própria + sessões presenciais. Campeões internos formados: no fim, a capacidade é de vocês, não nossa.</a:t>
-            </a:r>
-            <a:endParaRPr lang="en-US" sz="880" dirty="0"/>
-          </a:p>
-        </p:txBody>
-      </p:sp>
-      <p:sp>
-        <p:nvSpPr>
-          <p:cNvPr id="16" name="Shape 14"/>
-          <p:cNvSpPr/>
-          <p:nvPr/>
-        </p:nvSpPr>
-        <p:spPr>
-          <a:xfrm>
-            <a:off x="4983480" y="3977640"/>
-            <a:ext cx="2103120" cy="1965960"/>
-          </a:xfrm>
-          <a:prstGeom prst="roundRect">
-            <a:avLst>
-              <a:gd name="adj" fmla="val 2791"/>
-            </a:avLst>
-          </a:prstGeom>
-          <a:solidFill>
-            <a:srgbClr val="F4F1EA"/>
-          </a:solidFill>
-          <a:ln/>
-        </p:spPr>
-      </p:sp>
-      <p:sp>
-        <p:nvSpPr>
-          <p:cNvPr id="17" name="Text 15"/>
-          <p:cNvSpPr/>
-          <p:nvPr/>
-        </p:nvSpPr>
-        <p:spPr>
-          <a:xfrm>
-            <a:off x="5120640" y="4114800"/>
-            <a:ext cx="1828800" cy="274320"/>
-          </a:xfrm>
-          <a:prstGeom prst="rect">
-            <a:avLst/>
-          </a:prstGeom>
-          <a:noFill/>
-          <a:ln/>
-        </p:spPr>
-        <p:txBody>
-          <a:bodyPr wrap="square" lIns="0" tIns="0" rIns="0" bIns="0" rtlCol="0" anchor="ctr"/>
-          <a:lstStyle/>
-          <a:p>
-            <a:pPr indent="0" marL="0">
-              <a:buNone/>
-            </a:pPr>
-            <a:r>
-              <a:rPr lang="en-US" sz="1200" b="1" dirty="0">
-                <a:solidFill>
-                  <a:srgbClr val="1B2A4A"/>
-                </a:solidFill>
-                <a:latin typeface="Calibri" pitchFamily="34" charset="0"/>
-                <a:ea typeface="Calibri" pitchFamily="34" charset="-122"/>
-                <a:cs typeface="Calibri" pitchFamily="34" charset="-120"/>
-              </a:rPr>
-              <a:t>Provamos, de fora</a:t>
-            </a:r>
-            <a:endParaRPr lang="en-US" sz="1200" dirty="0"/>
-          </a:p>
-        </p:txBody>
-      </p:sp>
-      <p:sp>
-        <p:nvSpPr>
-          <p:cNvPr id="18" name="Text 16"/>
-          <p:cNvSpPr/>
-          <p:nvPr/>
-        </p:nvSpPr>
-        <p:spPr>
-          <a:xfrm>
-            <a:off x="5120640" y="4434840"/>
-            <a:ext cx="1828800" cy="1417320"/>
-          </a:xfrm>
-          <a:prstGeom prst="rect">
-            <a:avLst/>
-          </a:prstGeom>
-          <a:noFill/>
-          <a:ln/>
-        </p:spPr>
-        <p:txBody>
-          <a:bodyPr wrap="square" lIns="0" tIns="0" rIns="0" bIns="0" rtlCol="0" anchor="ctr"/>
-          <a:lstStyle/>
-          <a:p>
-            <a:pPr indent="0" marL="0">
-              <a:buNone/>
-            </a:pPr>
-            <a:r>
-              <a:rPr lang="en-US" sz="880" dirty="0">
-                <a:solidFill>
-                  <a:srgbClr val="5A6472"/>
-                </a:solidFill>
-                <a:latin typeface="Calibri" pitchFamily="34" charset="0"/>
-                <a:ea typeface="Calibri" pitchFamily="34" charset="-122"/>
-                <a:cs typeface="Calibri" pitchFamily="34" charset="-120"/>
-              </a:rPr>
-              <a:t>Cada decisão nasce com métrica combinada e vira resultado medido, assinado. Funciona como uma auditoria: ninguém dispensa o auditor por ter CFO.</a:t>
-            </a:r>
-            <a:endParaRPr lang="en-US" sz="880" dirty="0"/>
-          </a:p>
-        </p:txBody>
-      </p:sp>
-      <p:sp>
-        <p:nvSpPr>
-          <p:cNvPr id="19" name="Text 17"/>
-          <p:cNvSpPr/>
-          <p:nvPr/>
-        </p:nvSpPr>
-        <p:spPr>
-          <a:xfrm>
-            <a:off x="502920" y="6172200"/>
-            <a:ext cx="6583680" cy="274320"/>
-          </a:xfrm>
-          <a:prstGeom prst="rect">
-            <a:avLst/>
-          </a:prstGeom>
-          <a:noFill/>
-          <a:ln/>
-        </p:spPr>
-        <p:txBody>
-          <a:bodyPr wrap="square" lIns="0" tIns="0" rIns="0" bIns="0" rtlCol="0" anchor="ctr"/>
-          <a:lstStyle/>
-          <a:p>
-            <a:pPr indent="0" marL="0">
-              <a:buNone/>
-            </a:pPr>
-            <a:r>
-              <a:rPr lang="en-US" sz="1350" b="1" dirty="0">
-                <a:solidFill>
-                  <a:srgbClr val="1B2A4A"/>
-                </a:solidFill>
-                <a:latin typeface="Calibri" pitchFamily="34" charset="0"/>
-                <a:ea typeface="Calibri" pitchFamily="34" charset="-122"/>
-                <a:cs typeface="Calibri" pitchFamily="34" charset="-120"/>
-              </a:rPr>
-              <a:t>O que prometemos — e o que nos recusamos a prometer</a:t>
-            </a:r>
-            <a:endParaRPr lang="en-US" sz="1350" dirty="0"/>
-          </a:p>
-        </p:txBody>
-      </p:sp>
-      <p:sp>
-        <p:nvSpPr>
-          <p:cNvPr id="20" name="Shape 18"/>
-          <p:cNvSpPr/>
-          <p:nvPr/>
-        </p:nvSpPr>
-        <p:spPr>
-          <a:xfrm>
-            <a:off x="502920" y="6492240"/>
-            <a:ext cx="3200400" cy="2286000"/>
+            <a:off x="502920" y="4206240"/>
+            <a:ext cx="6556248" cy="2286000"/>
           </a:xfrm>
           <a:prstGeom prst="roundRect">
             <a:avLst>
@@ -1637,14 +1387,14 @@
       </p:sp>
       <p:sp>
         <p:nvSpPr>
-          <p:cNvPr id="21" name="Text 19"/>
-          <p:cNvSpPr/>
-          <p:nvPr/>
-        </p:nvSpPr>
-        <p:spPr>
-          <a:xfrm>
-            <a:off x="685800" y="6629400"/>
-            <a:ext cx="2834640" cy="274320"/>
+          <p:cNvPr id="11" name="Text 9"/>
+          <p:cNvSpPr/>
+          <p:nvPr/>
+        </p:nvSpPr>
+        <p:spPr>
+          <a:xfrm>
+            <a:off x="777240" y="4389120"/>
+            <a:ext cx="6035040" cy="274320"/>
           </a:xfrm>
           <a:prstGeom prst="rect">
             <a:avLst/>
@@ -1668,7 +1418,7 @@
                 <a:ea typeface="Calibri" pitchFamily="34" charset="-122"/>
                 <a:cs typeface="Calibri" pitchFamily="34" charset="-120"/>
               </a:rPr>
-              <a:t>Prometemos</a:t>
+              <a:t>A mentalidade que instalamos em cada colaborador — três perguntas:</a:t>
             </a:r>
             <a:endParaRPr lang="en-US" sz="1150" dirty="0"/>
           </a:p>
@@ -1676,14 +1426,14 @@
       </p:sp>
       <p:sp>
         <p:nvSpPr>
-          <p:cNvPr id="22" name="Text 20"/>
-          <p:cNvSpPr/>
-          <p:nvPr/>
-        </p:nvSpPr>
-        <p:spPr>
-          <a:xfrm>
-            <a:off x="777240" y="6949440"/>
-            <a:ext cx="2788920" cy="1737360"/>
+          <p:cNvPr id="12" name="Text 10"/>
+          <p:cNvSpPr/>
+          <p:nvPr/>
+        </p:nvSpPr>
+        <p:spPr>
+          <a:xfrm>
+            <a:off x="868680" y="4754880"/>
+            <a:ext cx="5852160" cy="1188720"/>
           </a:xfrm>
           <a:prstGeom prst="rect">
             <a:avLst/>
@@ -1697,55 +1447,94 @@
           <a:p>
             <a:pPr marL="342900" indent="-342900">
               <a:spcAft>
-                <a:spcPts val="600"/>
+                <a:spcPts val="800"/>
               </a:spcAft>
               <a:buSzPct val="100000"/>
               <a:buChar char="•"/>
             </a:pPr>
             <a:r>
-              <a:rPr lang="en-US" sz="950" dirty="0">
-                <a:solidFill>
-                  <a:srgbClr val="C9D2E4"/>
-                </a:solidFill>
-                <a:latin typeface="Calibri" pitchFamily="34" charset="0"/>
-                <a:ea typeface="Calibri" pitchFamily="34" charset="-122"/>
-                <a:cs typeface="Calibri" pitchFamily="34" charset="-120"/>
-              </a:rPr>
-              <a:t>Nada entra sem métrica combinada antes</a:t>
-            </a:r>
-            <a:endParaRPr lang="en-US" sz="950" dirty="0"/>
+              <a:rPr lang="en-US" sz="1250" b="1" dirty="0">
+                <a:solidFill>
+                  <a:srgbClr val="FFFFFF"/>
+                </a:solidFill>
+                <a:latin typeface="Calibri" pitchFamily="34" charset="0"/>
+                <a:ea typeface="Calibri" pitchFamily="34" charset="-122"/>
+                <a:cs typeface="Calibri" pitchFamily="34" charset="-120"/>
+              </a:rPr>
+              <a:t>O que eu posso PARAR de fazer — porque a IA agora faz?</a:t>
+            </a:r>
+            <a:endParaRPr lang="en-US" sz="1250" dirty="0"/>
           </a:p>
           <a:p>
             <a:pPr marL="342900" indent="-342900">
               <a:spcAft>
-                <a:spcPts val="600"/>
+                <a:spcPts val="800"/>
               </a:spcAft>
               <a:buSzPct val="100000"/>
               <a:buChar char="•"/>
             </a:pPr>
             <a:r>
-              <a:rPr lang="en-US" sz="950" dirty="0">
-                <a:solidFill>
-                  <a:srgbClr val="C9D2E4"/>
-                </a:solidFill>
-                <a:latin typeface="Calibri" pitchFamily="34" charset="0"/>
-                <a:ea typeface="Calibri" pitchFamily="34" charset="-122"/>
-                <a:cs typeface="Calibri" pitchFamily="34" charset="-120"/>
-              </a:rPr>
-              <a:t>Tudo sai medido — inclusive o que der errado</a:t>
-            </a:r>
-            <a:endParaRPr lang="en-US" sz="950" dirty="0"/>
+              <a:rPr lang="en-US" sz="1250" b="1" dirty="0">
+                <a:solidFill>
+                  <a:srgbClr val="FFFFFF"/>
+                </a:solidFill>
+                <a:latin typeface="Calibri" pitchFamily="34" charset="0"/>
+                <a:ea typeface="Calibri" pitchFamily="34" charset="-122"/>
+                <a:cs typeface="Calibri" pitchFamily="34" charset="-120"/>
+              </a:rPr>
+              <a:t>O que eu posso COMEÇAR a fazer — porque a IA agora permite?</a:t>
+            </a:r>
+            <a:endParaRPr lang="en-US" sz="1250" dirty="0"/>
           </a:p>
           <a:p>
             <a:pPr marL="342900" indent="-342900">
               <a:spcAft>
-                <a:spcPts val="600"/>
+                <a:spcPts val="800"/>
               </a:spcAft>
               <a:buSzPct val="100000"/>
               <a:buChar char="•"/>
             </a:pPr>
             <a:r>
-              <a:rPr lang="en-US" sz="950" dirty="0">
+              <a:rPr lang="en-US" sz="1250" b="1" dirty="0">
+                <a:solidFill>
+                  <a:srgbClr val="FFFFFF"/>
+                </a:solidFill>
+                <a:latin typeface="Calibri" pitchFamily="34" charset="0"/>
+                <a:ea typeface="Calibri" pitchFamily="34" charset="-122"/>
+                <a:cs typeface="Calibri" pitchFamily="34" charset="-120"/>
+              </a:rPr>
+              <a:t>O que SÓ EU faço — e devo fazer ainda melhor?</a:t>
+            </a:r>
+            <a:endParaRPr lang="en-US" sz="1250" dirty="0"/>
+          </a:p>
+        </p:txBody>
+      </p:sp>
+      <p:sp>
+        <p:nvSpPr>
+          <p:cNvPr id="13" name="Text 11"/>
+          <p:cNvSpPr/>
+          <p:nvPr/>
+        </p:nvSpPr>
+        <p:spPr>
+          <a:xfrm>
+            <a:off x="868680" y="5852160"/>
+            <a:ext cx="5852160" cy="502920"/>
+          </a:xfrm>
+          <a:prstGeom prst="rect">
+            <a:avLst/>
+          </a:prstGeom>
+          <a:noFill/>
+          <a:ln/>
+        </p:spPr>
+        <p:txBody>
+          <a:bodyPr wrap="square" lIns="0" tIns="0" rIns="0" bIns="0" rtlCol="0" anchor="ctr"/>
+          <a:lstStyle/>
+          <a:p>
+            <a:pPr indent="0" marL="0">
+              <a:buNone/>
+            </a:pPr>
+            <a:r>
+              <a:rPr lang="en-US" sz="950" i="1" dirty="0">
                 <a:solidFill>
                   <a:srgbClr val="C9D2E4"/>
                 </a:solidFill>
@@ -1753,26 +1542,121 @@
                 <a:ea typeface="Calibri" pitchFamily="34" charset="-122"/>
                 <a:cs typeface="Calibri" pitchFamily="34" charset="-120"/>
               </a:rPr>
-              <a:t>Vocês veem o registro inteiro, sempre</a:t>
+              <a:t>Quando a organização inteira pensa assim, a transformação deixa de depender de consultor.</a:t>
             </a:r>
             <a:endParaRPr lang="en-US" sz="950" dirty="0"/>
           </a:p>
-        </p:txBody>
-      </p:sp>
-      <p:sp>
-        <p:nvSpPr>
-          <p:cNvPr id="23" name="Shape 21"/>
-          <p:cNvSpPr/>
-          <p:nvPr/>
-        </p:nvSpPr>
-        <p:spPr>
-          <a:xfrm>
-            <a:off x="3858768" y="6492240"/>
-            <a:ext cx="3200400" cy="2286000"/>
+          <a:p>
+            <a:pPr indent="0" marL="0">
+              <a:buNone/>
+            </a:pPr>
+            <a:r>
+              <a:rPr lang="en-US" sz="950" i="1" dirty="0">
+                <a:solidFill>
+                  <a:srgbClr val="C9D2E4"/>
+                </a:solidFill>
+                <a:latin typeface="Calibri" pitchFamily="34" charset="0"/>
+                <a:ea typeface="Calibri" pitchFamily="34" charset="-122"/>
+                <a:cs typeface="Calibri" pitchFamily="34" charset="-120"/>
+              </a:rPr>
+              <a:t>Esse é o objetivo: a capacidade fica com vocês.</a:t>
+            </a:r>
+            <a:endParaRPr lang="en-US" sz="950" dirty="0"/>
+          </a:p>
+        </p:txBody>
+      </p:sp>
+      <p:sp>
+        <p:nvSpPr>
+          <p:cNvPr id="14" name="Text 12"/>
+          <p:cNvSpPr/>
+          <p:nvPr/>
+        </p:nvSpPr>
+        <p:spPr>
+          <a:xfrm>
+            <a:off x="502920" y="6720840"/>
+            <a:ext cx="6583680" cy="274320"/>
+          </a:xfrm>
+          <a:prstGeom prst="rect">
+            <a:avLst/>
+          </a:prstGeom>
+          <a:noFill/>
+          <a:ln/>
+        </p:spPr>
+        <p:txBody>
+          <a:bodyPr wrap="square" lIns="0" tIns="0" rIns="0" bIns="0" rtlCol="0" anchor="ctr"/>
+          <a:lstStyle/>
+          <a:p>
+            <a:pPr indent="0" marL="0">
+              <a:buNone/>
+            </a:pPr>
+            <a:r>
+              <a:rPr lang="en-US" sz="1400" b="1" dirty="0">
+                <a:solidFill>
+                  <a:srgbClr val="1B2A4A"/>
+                </a:solidFill>
+                <a:latin typeface="Calibri" pitchFamily="34" charset="0"/>
+                <a:ea typeface="Calibri" pitchFamily="34" charset="-122"/>
+                <a:cs typeface="Calibri" pitchFamily="34" charset="-120"/>
+              </a:rPr>
+              <a:t>Por que a maioria dos projetos de IA falha — e o que fazemos diferente</a:t>
+            </a:r>
+            <a:endParaRPr lang="en-US" sz="1400" dirty="0"/>
+          </a:p>
+        </p:txBody>
+      </p:sp>
+      <p:sp>
+        <p:nvSpPr>
+          <p:cNvPr id="15" name="Text 13"/>
+          <p:cNvSpPr/>
+          <p:nvPr/>
+        </p:nvSpPr>
+        <p:spPr>
+          <a:xfrm>
+            <a:off x="502920" y="7022592"/>
+            <a:ext cx="6583680" cy="960120"/>
+          </a:xfrm>
+          <a:prstGeom prst="rect">
+            <a:avLst/>
+          </a:prstGeom>
+          <a:noFill/>
+          <a:ln/>
+        </p:spPr>
+        <p:txBody>
+          <a:bodyPr wrap="square" lIns="0" tIns="0" rIns="0" bIns="0" rtlCol="0" anchor="ctr"/>
+          <a:lstStyle/>
+          <a:p>
+            <a:pPr indent="0" marL="0">
+              <a:buNone/>
+            </a:pPr>
+            <a:r>
+              <a:rPr lang="en-US" sz="1050" dirty="0">
+                <a:solidFill>
+                  <a:srgbClr val="5A6472"/>
+                </a:solidFill>
+                <a:latin typeface="Calibri" pitchFamily="34" charset="0"/>
+                <a:ea typeface="Calibri" pitchFamily="34" charset="-122"/>
+                <a:cs typeface="Calibri" pitchFamily="34" charset="-120"/>
+              </a:rPr>
+              <a:t>Não é a tecnologia: é a adoção. 70% do valor de uma transformação em IA vive em pessoas, processos e cultura — e a maioria dos projetos começa sem combinar o número que dirá se deu certo. O mercado vende os outros 30%: ferramenta, piloto sem métrica, curso avulso. Nós instalamos os 70% — e cada solução nossa nasce com uma métrica de sucesso acordada com vocês antes de começar, remedida depois, com o registro inteiro à vista.</a:t>
+            </a:r>
+            <a:endParaRPr lang="en-US" sz="1050" dirty="0"/>
+          </a:p>
+        </p:txBody>
+      </p:sp>
+      <p:sp>
+        <p:nvSpPr>
+          <p:cNvPr id="16" name="Shape 14"/>
+          <p:cNvSpPr/>
+          <p:nvPr/>
+        </p:nvSpPr>
+        <p:spPr>
+          <a:xfrm>
+            <a:off x="502920" y="8138160"/>
+            <a:ext cx="6556248" cy="960120"/>
           </a:xfrm>
           <a:prstGeom prst="roundRect">
             <a:avLst>
-              <a:gd name="adj" fmla="val 2400"/>
+              <a:gd name="adj" fmla="val 5714"/>
             </a:avLst>
           </a:prstGeom>
           <a:solidFill>
@@ -1783,30 +1667,30 @@
       </p:sp>
       <p:sp>
         <p:nvSpPr>
-          <p:cNvPr id="24" name="Text 22"/>
-          <p:cNvSpPr/>
-          <p:nvPr/>
-        </p:nvSpPr>
-        <p:spPr>
-          <a:xfrm>
-            <a:off x="4041648" y="6629400"/>
-            <a:ext cx="2834640" cy="274320"/>
-          </a:xfrm>
-          <a:prstGeom prst="rect">
-            <a:avLst/>
-          </a:prstGeom>
-          <a:noFill/>
-          <a:ln/>
-        </p:spPr>
-        <p:txBody>
-          <a:bodyPr wrap="square" lIns="0" tIns="0" rIns="0" bIns="0" rtlCol="0" anchor="ctr"/>
-          <a:lstStyle/>
-          <a:p>
-            <a:pPr indent="0" marL="0">
-              <a:buNone/>
-            </a:pPr>
-            <a:r>
-              <a:rPr lang="en-US" sz="1150" b="1" dirty="0">
+          <p:cNvPr id="17" name="Text 15"/>
+          <p:cNvSpPr/>
+          <p:nvPr/>
+        </p:nvSpPr>
+        <p:spPr>
+          <a:xfrm>
+            <a:off x="777240" y="8275320"/>
+            <a:ext cx="6035040" cy="713232"/>
+          </a:xfrm>
+          <a:prstGeom prst="rect">
+            <a:avLst/>
+          </a:prstGeom>
+          <a:noFill/>
+          <a:ln/>
+        </p:spPr>
+        <p:txBody>
+          <a:bodyPr wrap="square" lIns="0" tIns="0" rIns="0" bIns="0" rtlCol="0" anchor="ctr"/>
+          <a:lstStyle/>
+          <a:p>
+            <a:pPr indent="0" marL="0">
+              <a:buNone/>
+            </a:pPr>
+            <a:r>
+              <a:rPr lang="en-US" sz="1000" b="1" dirty="0">
                 <a:solidFill>
                   <a:srgbClr val="1B2A4A"/>
                 </a:solidFill>
@@ -1814,42 +1698,13 @@
                 <a:ea typeface="Calibri" pitchFamily="34" charset="-122"/>
                 <a:cs typeface="Calibri" pitchFamily="34" charset="-120"/>
               </a:rPr>
-              <a:t>Recusamos</a:t>
-            </a:r>
-            <a:endParaRPr lang="en-US" sz="1150" dirty="0"/>
-          </a:p>
-        </p:txBody>
-      </p:sp>
-      <p:sp>
-        <p:nvSpPr>
-          <p:cNvPr id="25" name="Text 23"/>
-          <p:cNvSpPr/>
-          <p:nvPr/>
-        </p:nvSpPr>
-        <p:spPr>
-          <a:xfrm>
-            <a:off x="4133088" y="6949440"/>
-            <a:ext cx="2788920" cy="1737360"/>
-          </a:xfrm>
-          <a:prstGeom prst="rect">
-            <a:avLst/>
-          </a:prstGeom>
-          <a:noFill/>
-          <a:ln/>
-        </p:spPr>
-        <p:txBody>
-          <a:bodyPr wrap="square" lIns="0" tIns="0" rIns="0" bIns="0" rtlCol="0" anchor="ctr"/>
-          <a:lstStyle/>
-          <a:p>
-            <a:pPr marL="342900" indent="-342900">
-              <a:spcAft>
-                <a:spcPts val="600"/>
-              </a:spcAft>
-              <a:buSzPct val="100000"/>
-              <a:buChar char="•"/>
-            </a:pPr>
-            <a:r>
-              <a:rPr lang="en-US" sz="950" dirty="0">
+              <a:t>Parceiros oficiais: Microsoft e CrewAI.  </a:t>
+            </a:r>
+            <a:pPr indent="0" marL="0">
+              <a:buNone/>
+            </a:pPr>
+            <a:r>
+              <a:rPr lang="en-US" sz="1000" dirty="0">
                 <a:solidFill>
                   <a:srgbClr val="5A6472"/>
                 </a:solidFill>
@@ -1857,107 +1712,65 @@
                 <a:ea typeface="Calibri" pitchFamily="34" charset="-122"/>
                 <a:cs typeface="Calibri" pitchFamily="34" charset="-120"/>
               </a:rPr>
-              <a:t>Piloto sem métrica de sucesso definida</a:t>
+              <a:t>Durante a capacitação, sua equipe usa ferramentas dos nossos parceiros para construir as próprias soluções — a mesma tecnologia com que construímos os agentes que entram em produção.</a:t>
+            </a:r>
+            <a:endParaRPr lang="en-US" sz="1000" dirty="0"/>
+          </a:p>
+        </p:txBody>
+      </p:sp>
+      <p:sp>
+        <p:nvSpPr>
+          <p:cNvPr id="18" name="Text 16"/>
+          <p:cNvSpPr/>
+          <p:nvPr/>
+        </p:nvSpPr>
+        <p:spPr>
+          <a:xfrm>
+            <a:off x="502920" y="9235440"/>
+            <a:ext cx="6583680" cy="411480"/>
+          </a:xfrm>
+          <a:prstGeom prst="rect">
+            <a:avLst/>
+          </a:prstGeom>
+          <a:noFill/>
+          <a:ln/>
+        </p:spPr>
+        <p:txBody>
+          <a:bodyPr wrap="square" lIns="0" tIns="0" rIns="0" bIns="0" rtlCol="0" anchor="ctr"/>
+          <a:lstStyle/>
+          <a:p>
+            <a:pPr indent="0" marL="0">
+              <a:buNone/>
+            </a:pPr>
+            <a:r>
+              <a:rPr lang="en-US" sz="950" i="1" dirty="0">
+                <a:solidFill>
+                  <a:srgbClr val="5A6472"/>
+                </a:solidFill>
+                <a:latin typeface="Calibri" pitchFamily="34" charset="0"/>
+                <a:ea typeface="Calibri" pitchFamily="34" charset="-122"/>
+                <a:cs typeface="Calibri" pitchFamily="34" charset="-120"/>
+              </a:rPr>
+              <a:t>Somos uma firma nova, e não inventamos histórico: vendemos o método e o registro — mais do que a maioria consegue mostrar depois de dez clientes.</a:t>
             </a:r>
             <a:endParaRPr lang="en-US" sz="950" dirty="0"/>
           </a:p>
-          <a:p>
-            <a:pPr marL="342900" indent="-342900">
-              <a:spcAft>
-                <a:spcPts val="600"/>
-              </a:spcAft>
-              <a:buSzPct val="100000"/>
-              <a:buChar char="•"/>
-            </a:pPr>
-            <a:r>
-              <a:rPr lang="en-US" sz="950" dirty="0">
-                <a:solidFill>
-                  <a:srgbClr val="5A6472"/>
-                </a:solidFill>
-                <a:latin typeface="Calibri" pitchFamily="34" charset="0"/>
-                <a:ea typeface="Calibri" pitchFamily="34" charset="-122"/>
-                <a:cs typeface="Calibri" pitchFamily="34" charset="-120"/>
-              </a:rPr>
-              <a:t>Prometer números que não medimos</a:t>
-            </a:r>
-            <a:endParaRPr lang="en-US" sz="950" dirty="0"/>
-          </a:p>
-          <a:p>
-            <a:pPr marL="342900" indent="-342900">
-              <a:spcAft>
-                <a:spcPts val="600"/>
-              </a:spcAft>
-              <a:buSzPct val="100000"/>
-              <a:buChar char="•"/>
-            </a:pPr>
-            <a:r>
-              <a:rPr lang="en-US" sz="950" dirty="0">
-                <a:solidFill>
-                  <a:srgbClr val="5A6472"/>
-                </a:solidFill>
-                <a:latin typeface="Calibri" pitchFamily="34" charset="0"/>
-                <a:ea typeface="Calibri" pitchFamily="34" charset="-122"/>
-                <a:cs typeface="Calibri" pitchFamily="34" charset="-120"/>
-              </a:rPr>
-              <a:t>Decidir por vocês — a IA rascunha, um humano assina, a diretoria decide</a:t>
-            </a:r>
-            <a:endParaRPr lang="en-US" sz="950" dirty="0"/>
-          </a:p>
-        </p:txBody>
-      </p:sp>
-      <p:sp>
-        <p:nvSpPr>
-          <p:cNvPr id="26" name="Text 24"/>
-          <p:cNvSpPr/>
-          <p:nvPr/>
-        </p:nvSpPr>
-        <p:spPr>
-          <a:xfrm>
-            <a:off x="502920" y="8915400"/>
-            <a:ext cx="6583680" cy="457200"/>
-          </a:xfrm>
-          <a:prstGeom prst="rect">
-            <a:avLst/>
-          </a:prstGeom>
-          <a:noFill/>
-          <a:ln/>
-        </p:spPr>
-        <p:txBody>
-          <a:bodyPr wrap="square" lIns="0" tIns="0" rIns="0" bIns="0" rtlCol="0" anchor="ctr"/>
-          <a:lstStyle/>
-          <a:p>
-            <a:pPr indent="0" marL="0">
-              <a:buNone/>
-            </a:pPr>
-            <a:r>
-              <a:rPr lang="en-US" sz="950" i="1" dirty="0">
-                <a:solidFill>
-                  <a:srgbClr val="5A6472"/>
-                </a:solidFill>
-                <a:latin typeface="Calibri" pitchFamily="34" charset="0"/>
-                <a:ea typeface="Calibri" pitchFamily="34" charset="-122"/>
-                <a:cs typeface="Calibri" pitchFamily="34" charset="-120"/>
-              </a:rPr>
-              <a:t>Somos uma firma nova, e não inventamos histórico: vendemos o método e o registro — é mais do que a maioria consegue mostrar depois de dez clientes.</a:t>
-            </a:r>
-            <a:endParaRPr lang="en-US" sz="950" dirty="0"/>
-          </a:p>
-        </p:txBody>
-      </p:sp>
-      <p:sp>
-        <p:nvSpPr>
-          <p:cNvPr id="27" name="Shape 25"/>
-          <p:cNvSpPr/>
-          <p:nvPr/>
-        </p:nvSpPr>
-        <p:spPr>
-          <a:xfrm>
-            <a:off x="502920" y="9464040"/>
-            <a:ext cx="6556248" cy="777240"/>
+        </p:txBody>
+      </p:sp>
+      <p:sp>
+        <p:nvSpPr>
+          <p:cNvPr id="19" name="Shape 17"/>
+          <p:cNvSpPr/>
+          <p:nvPr/>
+        </p:nvSpPr>
+        <p:spPr>
+          <a:xfrm>
+            <a:off x="502920" y="9646920"/>
+            <a:ext cx="6556248" cy="621792"/>
           </a:xfrm>
           <a:prstGeom prst="roundRect">
             <a:avLst>
-              <a:gd name="adj" fmla="val 7059"/>
+              <a:gd name="adj" fmla="val 8824"/>
             </a:avLst>
           </a:prstGeom>
           <a:solidFill>
@@ -1968,30 +1781,30 @@
       </p:sp>
       <p:sp>
         <p:nvSpPr>
-          <p:cNvPr id="28" name="Text 26"/>
-          <p:cNvSpPr/>
-          <p:nvPr/>
-        </p:nvSpPr>
-        <p:spPr>
-          <a:xfrm>
-            <a:off x="777240" y="9573768"/>
-            <a:ext cx="6035040" cy="566928"/>
-          </a:xfrm>
-          <a:prstGeom prst="rect">
-            <a:avLst/>
-          </a:prstGeom>
-          <a:noFill/>
-          <a:ln/>
-        </p:spPr>
-        <p:txBody>
-          <a:bodyPr wrap="square" lIns="0" tIns="0" rIns="0" bIns="0" rtlCol="0" anchor="ctr"/>
-          <a:lstStyle/>
-          <a:p>
-            <a:pPr indent="0" marL="0">
-              <a:buNone/>
-            </a:pPr>
-            <a:r>
-              <a:rPr lang="en-US" sz="1000" b="1" dirty="0">
+          <p:cNvPr id="20" name="Text 18"/>
+          <p:cNvSpPr/>
+          <p:nvPr/>
+        </p:nvSpPr>
+        <p:spPr>
+          <a:xfrm>
+            <a:off x="777240" y="9747504"/>
+            <a:ext cx="6035040" cy="438912"/>
+          </a:xfrm>
+          <a:prstGeom prst="rect">
+            <a:avLst/>
+          </a:prstGeom>
+          <a:noFill/>
+          <a:ln/>
+        </p:spPr>
+        <p:txBody>
+          <a:bodyPr wrap="square" lIns="0" tIns="0" rIns="0" bIns="0" rtlCol="0" anchor="ctr"/>
+          <a:lstStyle/>
+          <a:p>
+            <a:pPr indent="0" marL="0">
+              <a:buNone/>
+            </a:pPr>
+            <a:r>
+              <a:rPr lang="en-US" sz="950" b="1" dirty="0">
                 <a:solidFill>
                   <a:srgbClr val="FFFFFF"/>
                 </a:solidFill>
@@ -1999,13 +1812,13 @@
                 <a:ea typeface="Calibri" pitchFamily="34" charset="-122"/>
                 <a:cs typeface="Calibri" pitchFamily="34" charset="-120"/>
               </a:rPr>
-              <a:t>O próximo passo não custa nada: </a:t>
-            </a:r>
-            <a:pPr indent="0" marL="0">
-              <a:buNone/>
-            </a:pPr>
-            <a:r>
-              <a:rPr lang="en-US" sz="1000" dirty="0">
+              <a:t>O primeiro passo não custa nada: </a:t>
+            </a:r>
+            <a:pPr indent="0" marL="0">
+              <a:buNone/>
+            </a:pPr>
+            <a:r>
+              <a:rPr lang="en-US" sz="950" dirty="0">
                 <a:solidFill>
                   <a:srgbClr val="C9D2E4"/>
                 </a:solidFill>
@@ -2013,15 +1826,15 @@
                 <a:ea typeface="Calibri" pitchFamily="34" charset="-122"/>
                 <a:cs typeface="Calibri" pitchFamily="34" charset="-120"/>
               </a:rPr>
-              <a:t>o Mapa de Vazamento — uma análise da sua empresa feita com informação pública, com uma estimativa em reais do que pode estar vazando. Documento em 48h.</a:t>
-            </a:r>
-            <a:endParaRPr lang="en-US" sz="1000" dirty="0"/>
-          </a:p>
-        </p:txBody>
-      </p:sp>
-      <p:sp>
-        <p:nvSpPr>
-          <p:cNvPr id="29" name="Text 27"/>
+              <a:t>o Mapa de Vazamento — análise da sua empresa com informação pública e uma estimativa em reais do que pode estar vazando. Em 48h.</a:t>
+            </a:r>
+            <a:endParaRPr lang="en-US" sz="950" dirty="0"/>
+          </a:p>
+        </p:txBody>
+      </p:sp>
+      <p:sp>
+        <p:nvSpPr>
+          <p:cNvPr id="21" name="Text 19"/>
           <p:cNvSpPr/>
           <p:nvPr/>
         </p:nvSpPr>
@@ -2143,7 +1956,7 @@
                 <a:ea typeface="Calibri" pitchFamily="34" charset="-122"/>
                 <a:cs typeface="Calibri" pitchFamily="34" charset="-120"/>
               </a:rPr>
-              <a:t>O que exatamente se compra — a Escada ABBA</a:t>
+              <a:t>O que fazemos — os serviços da consultoria</a:t>
             </a:r>
             <a:endParaRPr lang="en-US" sz="1800" dirty="0"/>
           </a:p>
@@ -2182,7 +1995,7 @@
                 <a:ea typeface="Calibri" pitchFamily="34" charset="-122"/>
                 <a:cs typeface="Calibri" pitchFamily="34" charset="-120"/>
               </a:rPr>
-              <a:t>Cada degrau entrega valor inteiro sozinho — e produz o insumo do próximo.</a:t>
+              <a:t>Da análise profunda à cadeira na sua diretoria — cada etapa produz o insumo da próxima.</a:t>
             </a:r>
             <a:endParaRPr lang="en-US" sz="1050" dirty="0"/>
           </a:p>
@@ -2197,11 +2010,11 @@
         <p:spPr>
           <a:xfrm>
             <a:off x="502920" y="1325880"/>
-            <a:ext cx="6556248" cy="1481328"/>
+            <a:ext cx="6556248" cy="1371600"/>
           </a:xfrm>
           <a:prstGeom prst="roundRect">
             <a:avLst>
-              <a:gd name="adj" fmla="val 3704"/>
+              <a:gd name="adj" fmla="val 4000"/>
             </a:avLst>
           </a:prstGeom>
           <a:solidFill>
@@ -2218,8 +2031,8 @@
         </p:nvSpPr>
         <p:spPr>
           <a:xfrm>
-            <a:off x="685800" y="1490472"/>
-            <a:ext cx="457200" cy="457200"/>
+            <a:off x="685800" y="1472184"/>
+            <a:ext cx="438912" cy="438912"/>
           </a:xfrm>
           <a:prstGeom prst="ellipse">
             <a:avLst/>
@@ -2238,8 +2051,8 @@
         </p:nvSpPr>
         <p:spPr>
           <a:xfrm>
-            <a:off x="685800" y="1499616"/>
-            <a:ext cx="457200" cy="438912"/>
+            <a:off x="685800" y="1481328"/>
+            <a:ext cx="438912" cy="420624"/>
           </a:xfrm>
           <a:prstGeom prst="rect">
             <a:avLst/>
@@ -2255,7 +2068,7 @@
               <a:buNone/>
             </a:pPr>
             <a:r>
-              <a:rPr lang="en-US" sz="1500" b="1" dirty="0">
+              <a:rPr lang="en-US" sz="1400" b="1" dirty="0">
                 <a:solidFill>
                   <a:srgbClr val="C2A35B"/>
                 </a:solidFill>
@@ -2263,9 +2076,9 @@
                 <a:ea typeface="Calibri" pitchFamily="34" charset="-122"/>
                 <a:cs typeface="Calibri" pitchFamily="34" charset="-120"/>
               </a:rPr>
-              <a:t>0</a:t>
-            </a:r>
-            <a:endParaRPr lang="en-US" sz="1500" dirty="0"/>
+              <a:t>1</a:t>
+            </a:r>
+            <a:endParaRPr lang="en-US" sz="1400" dirty="0"/>
           </a:p>
         </p:txBody>
       </p:sp>
@@ -2277,7 +2090,7 @@
         </p:nvSpPr>
         <p:spPr>
           <a:xfrm>
-            <a:off x="1298448" y="1453896"/>
+            <a:off x="1280160" y="1444752"/>
             <a:ext cx="5577840" cy="274320"/>
           </a:xfrm>
           <a:prstGeom prst="rect">
@@ -2294,7 +2107,7 @@
               <a:buNone/>
             </a:pPr>
             <a:r>
-              <a:rPr lang="en-US" sz="1200" b="1" dirty="0">
+              <a:rPr lang="en-US" sz="1250" b="1" dirty="0">
                 <a:solidFill>
                   <a:srgbClr val="1B2A4A"/>
                 </a:solidFill>
@@ -2302,23 +2115,9 @@
                 <a:ea typeface="Calibri" pitchFamily="34" charset="-122"/>
                 <a:cs typeface="Calibri" pitchFamily="34" charset="-120"/>
               </a:rPr>
-              <a:t>Mapa de Vazamento  </a:t>
-            </a:r>
-            <a:pPr indent="0" marL="0">
-              <a:buNone/>
-            </a:pPr>
-            <a:r>
-              <a:rPr lang="en-US" sz="1100" b="1" dirty="0">
-                <a:solidFill>
-                  <a:srgbClr val="C2A35B"/>
-                </a:solidFill>
-                <a:latin typeface="Calibri" pitchFamily="34" charset="0"/>
-                <a:ea typeface="Calibri" pitchFamily="34" charset="-122"/>
-                <a:cs typeface="Calibri" pitchFamily="34" charset="-120"/>
-              </a:rPr>
-              <a:t>gratuito</a:t>
-            </a:r>
-            <a:endParaRPr lang="en-US" sz="1200" dirty="0"/>
+              <a:t>Assessment</a:t>
+            </a:r>
+            <a:endParaRPr lang="en-US" sz="1250" dirty="0"/>
           </a:p>
         </p:txBody>
       </p:sp>
@@ -2330,24 +2129,24 @@
         </p:nvSpPr>
         <p:spPr>
           <a:xfrm>
-            <a:off x="1298448" y="1764792"/>
-            <a:ext cx="5577840" cy="502920"/>
-          </a:xfrm>
-          <a:prstGeom prst="rect">
-            <a:avLst/>
-          </a:prstGeom>
-          <a:noFill/>
-          <a:ln/>
-        </p:spPr>
-        <p:txBody>
-          <a:bodyPr wrap="square" lIns="0" tIns="0" rIns="0" bIns="0" rtlCol="0" anchor="ctr"/>
-          <a:lstStyle/>
-          <a:p>
-            <a:pPr indent="0" marL="0">
-              <a:buNone/>
-            </a:pPr>
-            <a:r>
-              <a:rPr lang="en-US" sz="930" dirty="0">
+            <a:off x="1280160" y="1737360"/>
+            <a:ext cx="5577840" cy="548640"/>
+          </a:xfrm>
+          <a:prstGeom prst="rect">
+            <a:avLst/>
+          </a:prstGeom>
+          <a:noFill/>
+          <a:ln/>
+        </p:spPr>
+        <p:txBody>
+          <a:bodyPr wrap="square" lIns="0" tIns="0" rIns="0" bIns="0" rtlCol="0" anchor="ctr"/>
+          <a:lstStyle/>
+          <a:p>
+            <a:pPr indent="0" marL="0">
+              <a:buNone/>
+            </a:pPr>
+            <a:r>
+              <a:rPr lang="en-US" sz="900" dirty="0">
                 <a:solidFill>
                   <a:srgbClr val="5A6472"/>
                 </a:solidFill>
@@ -2355,9 +2154,9 @@
                 <a:ea typeface="Calibri" pitchFamily="34" charset="-122"/>
                 <a:cs typeface="Calibri" pitchFamily="34" charset="-120"/>
               </a:rPr>
-              <a:t>2 páginas com uma estimativa em R$ do que pode estar vazando, feitas com informação pública, em 48h.</a:t>
-            </a:r>
-            <a:endParaRPr lang="en-US" sz="930" dirty="0"/>
+              <a:t>Entramos na empresa e fazemos um mergulho profundo: avaliação em 25 dimensões proprietárias, do conselho à linha de frente, para identificar exatamente onde a IA gera valor no SEU negócio.</a:t>
+            </a:r>
+            <a:endParaRPr lang="en-US" sz="900" dirty="0"/>
           </a:p>
         </p:txBody>
       </p:sp>
@@ -2369,24 +2168,24 @@
         </p:nvSpPr>
         <p:spPr>
           <a:xfrm>
-            <a:off x="1298448" y="2295144"/>
-            <a:ext cx="5577840" cy="457200"/>
-          </a:xfrm>
-          <a:prstGeom prst="rect">
-            <a:avLst/>
-          </a:prstGeom>
-          <a:noFill/>
-          <a:ln/>
-        </p:spPr>
-        <p:txBody>
-          <a:bodyPr wrap="square" lIns="0" tIns="0" rIns="0" bIns="0" rtlCol="0" anchor="ctr"/>
-          <a:lstStyle/>
-          <a:p>
-            <a:pPr indent="0" marL="0">
-              <a:buNone/>
-            </a:pPr>
-            <a:r>
-              <a:rPr lang="en-US" sz="930" i="1" dirty="0">
+            <a:off x="1280160" y="2313432"/>
+            <a:ext cx="5577840" cy="329184"/>
+          </a:xfrm>
+          <a:prstGeom prst="rect">
+            <a:avLst/>
+          </a:prstGeom>
+          <a:noFill/>
+          <a:ln/>
+        </p:spPr>
+        <p:txBody>
+          <a:bodyPr wrap="square" lIns="0" tIns="0" rIns="0" bIns="0" rtlCol="0" anchor="ctr"/>
+          <a:lstStyle/>
+          <a:p>
+            <a:pPr indent="0" marL="0">
+              <a:buNone/>
+            </a:pPr>
+            <a:r>
+              <a:rPr lang="en-US" sz="900" b="1" i="1" dirty="0">
                 <a:solidFill>
                   <a:srgbClr val="1B2A4A"/>
                 </a:solidFill>
@@ -2394,9 +2193,9 @@
                 <a:ea typeface="Calibri" pitchFamily="34" charset="-122"/>
                 <a:cs typeface="Calibri" pitchFamily="34" charset="-120"/>
               </a:rPr>
-              <a:t>Aponta onde o dinheiro vaza — foi feito de fora, e é por isso que a primeira conversa existe.</a:t>
-            </a:r>
-            <a:endParaRPr lang="en-US" sz="930" dirty="0"/>
+              <a:t>Você sai com um portfólio de oportunidades ranqueado e quantificado — não uma lista de ideias.</a:t>
+            </a:r>
+            <a:endParaRPr lang="en-US" sz="900" dirty="0"/>
           </a:p>
         </p:txBody>
       </p:sp>
@@ -2408,16 +2207,16 @@
         </p:nvSpPr>
         <p:spPr>
           <a:xfrm>
-            <a:off x="502920" y="2953512"/>
-            <a:ext cx="6556248" cy="1481328"/>
+            <a:off x="502920" y="2807208"/>
+            <a:ext cx="6556248" cy="1371600"/>
           </a:xfrm>
           <a:prstGeom prst="roundRect">
             <a:avLst>
-              <a:gd name="adj" fmla="val 3704"/>
+              <a:gd name="adj" fmla="val 4000"/>
             </a:avLst>
           </a:prstGeom>
           <a:solidFill>
-            <a:srgbClr val="F4F1EA"/>
+            <a:srgbClr val="EFEBE2"/>
           </a:solidFill>
           <a:ln/>
         </p:spPr>
@@ -2430,8 +2229,8 @@
         </p:nvSpPr>
         <p:spPr>
           <a:xfrm>
-            <a:off x="685800" y="3118104"/>
-            <a:ext cx="457200" cy="457200"/>
+            <a:off x="685800" y="2953512"/>
+            <a:ext cx="438912" cy="438912"/>
           </a:xfrm>
           <a:prstGeom prst="ellipse">
             <a:avLst/>
@@ -2450,8 +2249,8 @@
         </p:nvSpPr>
         <p:spPr>
           <a:xfrm>
-            <a:off x="685800" y="3127248"/>
-            <a:ext cx="457200" cy="438912"/>
+            <a:off x="685800" y="2962656"/>
+            <a:ext cx="438912" cy="420624"/>
           </a:xfrm>
           <a:prstGeom prst="rect">
             <a:avLst/>
@@ -2467,7 +2266,7 @@
               <a:buNone/>
             </a:pPr>
             <a:r>
-              <a:rPr lang="en-US" sz="1500" b="1" dirty="0">
+              <a:rPr lang="en-US" sz="1400" b="1" dirty="0">
                 <a:solidFill>
                   <a:srgbClr val="C2A35B"/>
                 </a:solidFill>
@@ -2475,9 +2274,9 @@
                 <a:ea typeface="Calibri" pitchFamily="34" charset="-122"/>
                 <a:cs typeface="Calibri" pitchFamily="34" charset="-120"/>
               </a:rPr>
-              <a:t>1</a:t>
-            </a:r>
-            <a:endParaRPr lang="en-US" sz="1500" dirty="0"/>
+              <a:t>2</a:t>
+            </a:r>
+            <a:endParaRPr lang="en-US" sz="1400" dirty="0"/>
           </a:p>
         </p:txBody>
       </p:sp>
@@ -2489,7 +2288,7 @@
         </p:nvSpPr>
         <p:spPr>
           <a:xfrm>
-            <a:off x="1298448" y="3081528"/>
+            <a:off x="1280160" y="2926080"/>
             <a:ext cx="5577840" cy="274320"/>
           </a:xfrm>
           <a:prstGeom prst="rect">
@@ -2506,7 +2305,7 @@
               <a:buNone/>
             </a:pPr>
             <a:r>
-              <a:rPr lang="en-US" sz="1200" b="1" dirty="0">
+              <a:rPr lang="en-US" sz="1250" b="1" dirty="0">
                 <a:solidFill>
                   <a:srgbClr val="1B2A4A"/>
                 </a:solidFill>
@@ -2514,23 +2313,9 @@
                 <a:ea typeface="Calibri" pitchFamily="34" charset="-122"/>
                 <a:cs typeface="Calibri" pitchFamily="34" charset="-120"/>
               </a:rPr>
-              <a:t>Avaliação de Prontidão  </a:t>
-            </a:r>
-            <a:pPr indent="0" marL="0">
-              <a:buNone/>
-            </a:pPr>
-            <a:r>
-              <a:rPr lang="en-US" sz="1100" b="1" dirty="0">
-                <a:solidFill>
-                  <a:srgbClr val="C2A35B"/>
-                </a:solidFill>
-                <a:latin typeface="Calibri" pitchFamily="34" charset="0"/>
-                <a:ea typeface="Calibri" pitchFamily="34" charset="-122"/>
-                <a:cs typeface="Calibri" pitchFamily="34" charset="-120"/>
-              </a:rPr>
-              <a:t>R$ 28.000</a:t>
-            </a:r>
-            <a:endParaRPr lang="en-US" sz="1200" dirty="0"/>
+              <a:t>Protótipo de caso de uso</a:t>
+            </a:r>
+            <a:endParaRPr lang="en-US" sz="1250" dirty="0"/>
           </a:p>
         </p:txBody>
       </p:sp>
@@ -2542,24 +2327,24 @@
         </p:nvSpPr>
         <p:spPr>
           <a:xfrm>
-            <a:off x="1298448" y="3392424"/>
-            <a:ext cx="5577840" cy="502920"/>
-          </a:xfrm>
-          <a:prstGeom prst="rect">
-            <a:avLst/>
-          </a:prstGeom>
-          <a:noFill/>
-          <a:ln/>
-        </p:spPr>
-        <p:txBody>
-          <a:bodyPr wrap="square" lIns="0" tIns="0" rIns="0" bIns="0" rtlCol="0" anchor="ctr"/>
-          <a:lstStyle/>
-          <a:p>
-            <a:pPr indent="0" marL="0">
-              <a:buNone/>
-            </a:pPr>
-            <a:r>
-              <a:rPr lang="en-US" sz="930" dirty="0">
+            <a:off x="1280160" y="3218688"/>
+            <a:ext cx="5577840" cy="548640"/>
+          </a:xfrm>
+          <a:prstGeom prst="rect">
+            <a:avLst/>
+          </a:prstGeom>
+          <a:noFill/>
+          <a:ln/>
+        </p:spPr>
+        <p:txBody>
+          <a:bodyPr wrap="square" lIns="0" tIns="0" rIns="0" bIns="0" rtlCol="0" anchor="ctr"/>
+          <a:lstStyle/>
+          <a:p>
+            <a:pPr indent="0" marL="0">
+              <a:buNone/>
+            </a:pPr>
+            <a:r>
+              <a:rPr lang="en-US" sz="900" dirty="0">
                 <a:solidFill>
                   <a:srgbClr val="5A6472"/>
                 </a:solidFill>
@@ -2567,9 +2352,9 @@
                 <a:ea typeface="Calibri" pitchFamily="34" charset="-122"/>
                 <a:cs typeface="Calibri" pitchFamily="34" charset="-120"/>
               </a:rPr>
-              <a:t>A empresa lida em 25 dimensões, do conselho à linha de frente, com entrevistas.</a:t>
-            </a:r>
-            <a:endParaRPr lang="en-US" sz="930" dirty="0"/>
+              <a:t>Antes de construir de verdade, validamos: um protótipo com os seus dados reais, e a diretoria decide GO ou NO-GO com números na mesa.</a:t>
+            </a:r>
+            <a:endParaRPr lang="en-US" sz="900" dirty="0"/>
           </a:p>
         </p:txBody>
       </p:sp>
@@ -2581,24 +2366,24 @@
         </p:nvSpPr>
         <p:spPr>
           <a:xfrm>
-            <a:off x="1298448" y="3922776"/>
-            <a:ext cx="5577840" cy="457200"/>
-          </a:xfrm>
-          <a:prstGeom prst="rect">
-            <a:avLst/>
-          </a:prstGeom>
-          <a:noFill/>
-          <a:ln/>
-        </p:spPr>
-        <p:txBody>
-          <a:bodyPr wrap="square" lIns="0" tIns="0" rIns="0" bIns="0" rtlCol="0" anchor="ctr"/>
-          <a:lstStyle/>
-          <a:p>
-            <a:pPr indent="0" marL="0">
-              <a:buNone/>
-            </a:pPr>
-            <a:r>
-              <a:rPr lang="en-US" sz="930" i="1" dirty="0">
+            <a:off x="1280160" y="3794760"/>
+            <a:ext cx="5577840" cy="329184"/>
+          </a:xfrm>
+          <a:prstGeom prst="rect">
+            <a:avLst/>
+          </a:prstGeom>
+          <a:noFill/>
+          <a:ln/>
+        </p:spPr>
+        <p:txBody>
+          <a:bodyPr wrap="square" lIns="0" tIns="0" rIns="0" bIns="0" rtlCol="0" anchor="ctr"/>
+          <a:lstStyle/>
+          <a:p>
+            <a:pPr indent="0" marL="0">
+              <a:buNone/>
+            </a:pPr>
+            <a:r>
+              <a:rPr lang="en-US" sz="900" b="1" i="1" dirty="0">
                 <a:solidFill>
                   <a:srgbClr val="1B2A4A"/>
                 </a:solidFill>
@@ -2606,9 +2391,9 @@
                 <a:ea typeface="Calibri" pitchFamily="34" charset="-122"/>
                 <a:cs typeface="Calibri" pitchFamily="34" charset="-120"/>
               </a:rPr>
-              <a:t>Relatório + portfólio de oportunidades ranqueado e quantificado — o plano com dado por trás.</a:t>
-            </a:r>
-            <a:endParaRPr lang="en-US" sz="930" dirty="0"/>
+              <a:t>Ninguém investe no escuro — o protótipo é a prova antes do compromisso.</a:t>
+            </a:r>
+            <a:endParaRPr lang="en-US" sz="900" dirty="0"/>
           </a:p>
         </p:txBody>
       </p:sp>
@@ -2620,12 +2405,12 @@
         </p:nvSpPr>
         <p:spPr>
           <a:xfrm>
-            <a:off x="502920" y="4581144"/>
-            <a:ext cx="6556248" cy="1481328"/>
+            <a:off x="502920" y="4288536"/>
+            <a:ext cx="6556248" cy="1371600"/>
           </a:xfrm>
           <a:prstGeom prst="roundRect">
             <a:avLst>
-              <a:gd name="adj" fmla="val 3704"/>
+              <a:gd name="adj" fmla="val 4000"/>
             </a:avLst>
           </a:prstGeom>
           <a:solidFill>
@@ -2642,8 +2427,8 @@
         </p:nvSpPr>
         <p:spPr>
           <a:xfrm>
-            <a:off x="685800" y="4745736"/>
-            <a:ext cx="457200" cy="457200"/>
+            <a:off x="685800" y="4434840"/>
+            <a:ext cx="438912" cy="438912"/>
           </a:xfrm>
           <a:prstGeom prst="ellipse">
             <a:avLst/>
@@ -2662,8 +2447,8 @@
         </p:nvSpPr>
         <p:spPr>
           <a:xfrm>
-            <a:off x="685800" y="4754880"/>
-            <a:ext cx="457200" cy="438912"/>
+            <a:off x="685800" y="4443984"/>
+            <a:ext cx="438912" cy="420624"/>
           </a:xfrm>
           <a:prstGeom prst="rect">
             <a:avLst/>
@@ -2679,7 +2464,7 @@
               <a:buNone/>
             </a:pPr>
             <a:r>
-              <a:rPr lang="en-US" sz="1500" b="1" dirty="0">
+              <a:rPr lang="en-US" sz="1400" b="1" dirty="0">
                 <a:solidFill>
                   <a:srgbClr val="C2A35B"/>
                 </a:solidFill>
@@ -2687,9 +2472,9 @@
                 <a:ea typeface="Calibri" pitchFamily="34" charset="-122"/>
                 <a:cs typeface="Calibri" pitchFamily="34" charset="-120"/>
               </a:rPr>
-              <a:t>2</a:t>
-            </a:r>
-            <a:endParaRPr lang="en-US" sz="1500" dirty="0"/>
+              <a:t>3</a:t>
+            </a:r>
+            <a:endParaRPr lang="en-US" sz="1400" dirty="0"/>
           </a:p>
         </p:txBody>
       </p:sp>
@@ -2701,7 +2486,7 @@
         </p:nvSpPr>
         <p:spPr>
           <a:xfrm>
-            <a:off x="1298448" y="4709160"/>
+            <a:off x="1280160" y="4407408"/>
             <a:ext cx="5577840" cy="274320"/>
           </a:xfrm>
           <a:prstGeom prst="rect">
@@ -2718,7 +2503,7 @@
               <a:buNone/>
             </a:pPr>
             <a:r>
-              <a:rPr lang="en-US" sz="1200" b="1" dirty="0">
+              <a:rPr lang="en-US" sz="1250" b="1" dirty="0">
                 <a:solidFill>
                   <a:srgbClr val="1B2A4A"/>
                 </a:solidFill>
@@ -2726,23 +2511,9 @@
                 <a:ea typeface="Calibri" pitchFamily="34" charset="-122"/>
                 <a:cs typeface="Calibri" pitchFamily="34" charset="-120"/>
               </a:rPr>
-              <a:t>Programa Completo  </a:t>
-            </a:r>
-            <a:pPr indent="0" marL="0">
-              <a:buNone/>
-            </a:pPr>
-            <a:r>
-              <a:rPr lang="en-US" sz="1100" b="1" dirty="0">
-                <a:solidFill>
-                  <a:srgbClr val="C2A35B"/>
-                </a:solidFill>
-                <a:latin typeface="Calibri" pitchFamily="34" charset="0"/>
-                <a:ea typeface="Calibri" pitchFamily="34" charset="-122"/>
-                <a:cs typeface="Calibri" pitchFamily="34" charset="-120"/>
-              </a:rPr>
-              <a:t>R$ 185.000</a:t>
-            </a:r>
-            <a:endParaRPr lang="en-US" sz="1200" dirty="0"/>
+              <a:t>Construção e implantação</a:t>
+            </a:r>
+            <a:endParaRPr lang="en-US" sz="1250" dirty="0"/>
           </a:p>
         </p:txBody>
       </p:sp>
@@ -2754,24 +2525,24 @@
         </p:nvSpPr>
         <p:spPr>
           <a:xfrm>
-            <a:off x="1298448" y="5020056"/>
-            <a:ext cx="5577840" cy="502920"/>
-          </a:xfrm>
-          <a:prstGeom prst="rect">
-            <a:avLst/>
-          </a:prstGeom>
-          <a:noFill/>
-          <a:ln/>
-        </p:spPr>
-        <p:txBody>
-          <a:bodyPr wrap="square" lIns="0" tIns="0" rIns="0" bIns="0" rtlCol="0" anchor="ctr"/>
-          <a:lstStyle/>
-          <a:p>
-            <a:pPr indent="0" marL="0">
-              <a:buNone/>
-            </a:pPr>
-            <a:r>
-              <a:rPr lang="en-US" sz="930" dirty="0">
+            <a:off x="1280160" y="4700016"/>
+            <a:ext cx="5577840" cy="548640"/>
+          </a:xfrm>
+          <a:prstGeom prst="rect">
+            <a:avLst/>
+          </a:prstGeom>
+          <a:noFill/>
+          <a:ln/>
+        </p:spPr>
+        <p:txBody>
+          <a:bodyPr wrap="square" lIns="0" tIns="0" rIns="0" bIns="0" rtlCol="0" anchor="ctr"/>
+          <a:lstStyle/>
+          <a:p>
+            <a:pPr indent="0" marL="0">
+              <a:buNone/>
+            </a:pPr>
+            <a:r>
+              <a:rPr lang="en-US" sz="900" dirty="0">
                 <a:solidFill>
                   <a:srgbClr val="5A6472"/>
                 </a:solidFill>
@@ -2779,9 +2550,9 @@
                 <a:ea typeface="Calibri" pitchFamily="34" charset="-122"/>
                 <a:cs typeface="Calibri" pitchFamily="34" charset="-120"/>
               </a:rPr>
-              <a:t>Protótipo validado com dados reais (GO/NO-GO pela diretoria) → construção dos agentes + capacitação híbrida de todos os níveis.</a:t>
-            </a:r>
-            <a:endParaRPr lang="en-US" sz="930" dirty="0"/>
+              <a:t>Construímos os agentes de IA sob medida, com a tecnologia dos nossos parceiros, e colocamos em produção — com pontos de aprovação humana em tudo que é crítico.</a:t>
+            </a:r>
+            <a:endParaRPr lang="en-US" sz="900" dirty="0"/>
           </a:p>
         </p:txBody>
       </p:sp>
@@ -2793,24 +2564,24 @@
         </p:nvSpPr>
         <p:spPr>
           <a:xfrm>
-            <a:off x="1298448" y="5550408"/>
-            <a:ext cx="5577840" cy="457200"/>
-          </a:xfrm>
-          <a:prstGeom prst="rect">
-            <a:avLst/>
-          </a:prstGeom>
-          <a:noFill/>
-          <a:ln/>
-        </p:spPr>
-        <p:txBody>
-          <a:bodyPr wrap="square" lIns="0" tIns="0" rIns="0" bIns="0" rtlCol="0" anchor="ctr"/>
-          <a:lstStyle/>
-          <a:p>
-            <a:pPr indent="0" marL="0">
-              <a:buNone/>
-            </a:pPr>
-            <a:r>
-              <a:rPr lang="en-US" sz="930" i="1" dirty="0">
+            <a:off x="1280160" y="5276088"/>
+            <a:ext cx="5577840" cy="329184"/>
+          </a:xfrm>
+          <a:prstGeom prst="rect">
+            <a:avLst/>
+          </a:prstGeom>
+          <a:noFill/>
+          <a:ln/>
+        </p:spPr>
+        <p:txBody>
+          <a:bodyPr wrap="square" lIns="0" tIns="0" rIns="0" bIns="0" rtlCol="0" anchor="ctr"/>
+          <a:lstStyle/>
+          <a:p>
+            <a:pPr indent="0" marL="0">
+              <a:buNone/>
+            </a:pPr>
+            <a:r>
+              <a:rPr lang="en-US" sz="900" b="1" i="1" dirty="0">
                 <a:solidFill>
                   <a:srgbClr val="1B2A4A"/>
                 </a:solidFill>
@@ -2818,9 +2589,9 @@
                 <a:ea typeface="Calibri" pitchFamily="34" charset="-122"/>
                 <a:cs typeface="Calibri" pitchFamily="34" charset="-120"/>
               </a:rPr>
-              <a:t>Sistemas em produção + campeões formados. A capacidade fica com vocês.</a:t>
-            </a:r>
-            <a:endParaRPr lang="en-US" sz="930" dirty="0"/>
+              <a:t>Sistemas rodando no seu fluxo de trabalho, não relatório na gaveta.</a:t>
+            </a:r>
+            <a:endParaRPr lang="en-US" sz="900" dirty="0"/>
           </a:p>
         </p:txBody>
       </p:sp>
@@ -2832,16 +2603,16 @@
         </p:nvSpPr>
         <p:spPr>
           <a:xfrm>
-            <a:off x="502920" y="6208776"/>
-            <a:ext cx="6556248" cy="1481328"/>
+            <a:off x="502920" y="5769864"/>
+            <a:ext cx="6556248" cy="1371600"/>
           </a:xfrm>
           <a:prstGeom prst="roundRect">
             <a:avLst>
-              <a:gd name="adj" fmla="val 3704"/>
+              <a:gd name="adj" fmla="val 4000"/>
             </a:avLst>
           </a:prstGeom>
           <a:solidFill>
-            <a:srgbClr val="F4F1EA"/>
+            <a:srgbClr val="EFEBE2"/>
           </a:solidFill>
           <a:ln/>
         </p:spPr>
@@ -2854,8 +2625,8 @@
         </p:nvSpPr>
         <p:spPr>
           <a:xfrm>
-            <a:off x="685800" y="6373368"/>
-            <a:ext cx="457200" cy="457200"/>
+            <a:off x="685800" y="5916168"/>
+            <a:ext cx="438912" cy="438912"/>
           </a:xfrm>
           <a:prstGeom prst="ellipse">
             <a:avLst/>
@@ -2874,8 +2645,8 @@
         </p:nvSpPr>
         <p:spPr>
           <a:xfrm>
-            <a:off x="685800" y="6382512"/>
-            <a:ext cx="457200" cy="438912"/>
+            <a:off x="685800" y="5925312"/>
+            <a:ext cx="438912" cy="420624"/>
           </a:xfrm>
           <a:prstGeom prst="rect">
             <a:avLst/>
@@ -2891,7 +2662,7 @@
               <a:buNone/>
             </a:pPr>
             <a:r>
-              <a:rPr lang="en-US" sz="1500" b="1" dirty="0">
+              <a:rPr lang="en-US" sz="1400" b="1" dirty="0">
                 <a:solidFill>
                   <a:srgbClr val="C2A35B"/>
                 </a:solidFill>
@@ -2899,9 +2670,9 @@
                 <a:ea typeface="Calibri" pitchFamily="34" charset="-122"/>
                 <a:cs typeface="Calibri" pitchFamily="34" charset="-120"/>
               </a:rPr>
-              <a:t>3</a:t>
-            </a:r>
-            <a:endParaRPr lang="en-US" sz="1500" dirty="0"/>
+              <a:t>4</a:t>
+            </a:r>
+            <a:endParaRPr lang="en-US" sz="1400" dirty="0"/>
           </a:p>
         </p:txBody>
       </p:sp>
@@ -2913,7 +2684,7 @@
         </p:nvSpPr>
         <p:spPr>
           <a:xfrm>
-            <a:off x="1298448" y="6336792"/>
+            <a:off x="1280160" y="5888736"/>
             <a:ext cx="5577840" cy="274320"/>
           </a:xfrm>
           <a:prstGeom prst="rect">
@@ -2930,7 +2701,7 @@
               <a:buNone/>
             </a:pPr>
             <a:r>
-              <a:rPr lang="en-US" sz="1200" b="1" dirty="0">
+              <a:rPr lang="en-US" sz="1250" b="1" dirty="0">
                 <a:solidFill>
                   <a:srgbClr val="1B2A4A"/>
                 </a:solidFill>
@@ -2938,23 +2709,9 @@
                 <a:ea typeface="Calibri" pitchFamily="34" charset="-122"/>
                 <a:cs typeface="Calibri" pitchFamily="34" charset="-120"/>
               </a:rPr>
-              <a:t>Manutenção com presença  </a:t>
-            </a:r>
-            <a:pPr indent="0" marL="0">
-              <a:buNone/>
-            </a:pPr>
-            <a:r>
-              <a:rPr lang="en-US" sz="1100" b="1" dirty="0">
-                <a:solidFill>
-                  <a:srgbClr val="C2A35B"/>
-                </a:solidFill>
-                <a:latin typeface="Calibri" pitchFamily="34" charset="0"/>
-                <a:ea typeface="Calibri" pitchFamily="34" charset="-122"/>
-                <a:cs typeface="Calibri" pitchFamily="34" charset="-120"/>
-              </a:rPr>
-              <a:t>R$ 9.500/mês</a:t>
-            </a:r>
-            <a:endParaRPr lang="en-US" sz="1200" dirty="0"/>
+              <a:t>Treinamento + ABBA Portal</a:t>
+            </a:r>
+            <a:endParaRPr lang="en-US" sz="1250" dirty="0"/>
           </a:p>
         </p:txBody>
       </p:sp>
@@ -2966,24 +2723,24 @@
         </p:nvSpPr>
         <p:spPr>
           <a:xfrm>
-            <a:off x="1298448" y="6647688"/>
-            <a:ext cx="5577840" cy="502920"/>
-          </a:xfrm>
-          <a:prstGeom prst="rect">
-            <a:avLst/>
-          </a:prstGeom>
-          <a:noFill/>
-          <a:ln/>
-        </p:spPr>
-        <p:txBody>
-          <a:bodyPr wrap="square" lIns="0" tIns="0" rIns="0" bIns="0" rtlCol="0" anchor="ctr"/>
-          <a:lstStyle/>
-          <a:p>
-            <a:pPr indent="0" marL="0">
-              <a:buNone/>
-            </a:pPr>
-            <a:r>
-              <a:rPr lang="en-US" sz="930" dirty="0">
+            <a:off x="1280160" y="6181344"/>
+            <a:ext cx="5577840" cy="548640"/>
+          </a:xfrm>
+          <a:prstGeom prst="rect">
+            <a:avLst/>
+          </a:prstGeom>
+          <a:noFill/>
+          <a:ln/>
+        </p:spPr>
+        <p:txBody>
+          <a:bodyPr wrap="square" lIns="0" tIns="0" rIns="0" bIns="0" rtlCol="0" anchor="ctr"/>
+          <a:lstStyle/>
+          <a:p>
+            <a:pPr indent="0" marL="0">
+              <a:buNone/>
+            </a:pPr>
+            <a:r>
+              <a:rPr lang="en-US" sz="900" dirty="0">
                 <a:solidFill>
                   <a:srgbClr val="5A6472"/>
                 </a:solidFill>
@@ -2991,9 +2748,9 @@
                 <a:ea typeface="Calibri" pitchFamily="34" charset="-122"/>
                 <a:cs typeface="Calibri" pitchFamily="34" charset="-120"/>
               </a:rPr>
-              <a:t>Operação sob SLA + ritual semanal de 20 minutos + evolução contínua.</a:t>
-            </a:r>
-            <a:endParaRPr lang="en-US" sz="930" dirty="0"/>
+              <a:t>Formamos todos os níveis da equipe: plataforma própria (trilhas por nível, desafios práticos, coach de IA, credencial verificável) + sessões presenciais nos marcos.</a:t>
+            </a:r>
+            <a:endParaRPr lang="en-US" sz="900" dirty="0"/>
           </a:p>
         </p:txBody>
       </p:sp>
@@ -3005,24 +2762,24 @@
         </p:nvSpPr>
         <p:spPr>
           <a:xfrm>
-            <a:off x="1298448" y="7178040"/>
-            <a:ext cx="5577840" cy="457200"/>
-          </a:xfrm>
-          <a:prstGeom prst="rect">
-            <a:avLst/>
-          </a:prstGeom>
-          <a:noFill/>
-          <a:ln/>
-        </p:spPr>
-        <p:txBody>
-          <a:bodyPr wrap="square" lIns="0" tIns="0" rIns="0" bIns="0" rtlCol="0" anchor="ctr"/>
-          <a:lstStyle/>
-          <a:p>
-            <a:pPr indent="0" marL="0">
-              <a:buNone/>
-            </a:pPr>
-            <a:r>
-              <a:rPr lang="en-US" sz="930" i="1" dirty="0">
+            <a:off x="1280160" y="6757416"/>
+            <a:ext cx="5577840" cy="329184"/>
+          </a:xfrm>
+          <a:prstGeom prst="rect">
+            <a:avLst/>
+          </a:prstGeom>
+          <a:noFill/>
+          <a:ln/>
+        </p:spPr>
+        <p:txBody>
+          <a:bodyPr wrap="square" lIns="0" tIns="0" rIns="0" bIns="0" rtlCol="0" anchor="ctr"/>
+          <a:lstStyle/>
+          <a:p>
+            <a:pPr indent="0" marL="0">
+              <a:buNone/>
+            </a:pPr>
+            <a:r>
+              <a:rPr lang="en-US" sz="900" b="1" i="1" dirty="0">
                 <a:solidFill>
                   <a:srgbClr val="1B2A4A"/>
                 </a:solidFill>
@@ -3030,9 +2787,9 @@
                 <a:ea typeface="Calibri" pitchFamily="34" charset="-122"/>
                 <a:cs typeface="Calibri" pitchFamily="34" charset="-120"/>
               </a:rPr>
-              <a:t>O diário decisão → resultado medido: a prova, mês a mês, do que a IA está devolvendo.</a:t>
-            </a:r>
-            <a:endParaRPr lang="en-US" sz="930" dirty="0"/>
+              <a:t>Campeões internos formados — pessoas que carregam a transformação depois que saímos da sala.</a:t>
+            </a:r>
+            <a:endParaRPr lang="en-US" sz="900" dirty="0"/>
           </a:p>
         </p:txBody>
       </p:sp>
@@ -3044,12 +2801,12 @@
         </p:nvSpPr>
         <p:spPr>
           <a:xfrm>
-            <a:off x="502920" y="7836408"/>
-            <a:ext cx="6556248" cy="1481328"/>
+            <a:off x="502920" y="7251192"/>
+            <a:ext cx="6556248" cy="1371600"/>
           </a:xfrm>
           <a:prstGeom prst="roundRect">
             <a:avLst>
-              <a:gd name="adj" fmla="val 3704"/>
+              <a:gd name="adj" fmla="val 4000"/>
             </a:avLst>
           </a:prstGeom>
           <a:solidFill>
@@ -3066,8 +2823,8 @@
         </p:nvSpPr>
         <p:spPr>
           <a:xfrm>
-            <a:off x="685800" y="8001000"/>
-            <a:ext cx="457200" cy="457200"/>
+            <a:off x="685800" y="7397496"/>
+            <a:ext cx="438912" cy="438912"/>
           </a:xfrm>
           <a:prstGeom prst="ellipse">
             <a:avLst/>
@@ -3086,8 +2843,8 @@
         </p:nvSpPr>
         <p:spPr>
           <a:xfrm>
-            <a:off x="685800" y="8010144"/>
-            <a:ext cx="457200" cy="438912"/>
+            <a:off x="685800" y="7406640"/>
+            <a:ext cx="438912" cy="420624"/>
           </a:xfrm>
           <a:prstGeom prst="rect">
             <a:avLst/>
@@ -3103,7 +2860,7 @@
               <a:buNone/>
             </a:pPr>
             <a:r>
-              <a:rPr lang="en-US" sz="1500" b="1" dirty="0">
+              <a:rPr lang="en-US" sz="1400" b="1" dirty="0">
                 <a:solidFill>
                   <a:srgbClr val="C2A35B"/>
                 </a:solidFill>
@@ -3111,9 +2868,9 @@
                 <a:ea typeface="Calibri" pitchFamily="34" charset="-122"/>
                 <a:cs typeface="Calibri" pitchFamily="34" charset="-120"/>
               </a:rPr>
-              <a:t>4</a:t>
-            </a:r>
-            <a:endParaRPr lang="en-US" sz="1500" dirty="0"/>
+              <a:t>5</a:t>
+            </a:r>
+            <a:endParaRPr lang="en-US" sz="1400" dirty="0"/>
           </a:p>
         </p:txBody>
       </p:sp>
@@ -3125,7 +2882,7 @@
         </p:nvSpPr>
         <p:spPr>
           <a:xfrm>
-            <a:off x="1298448" y="7964424"/>
+            <a:off x="1280160" y="7370064"/>
             <a:ext cx="5577840" cy="274320"/>
           </a:xfrm>
           <a:prstGeom prst="rect">
@@ -3142,7 +2899,7 @@
               <a:buNone/>
             </a:pPr>
             <a:r>
-              <a:rPr lang="en-US" sz="1200" b="1" dirty="0">
+              <a:rPr lang="en-US" sz="1250" b="1" dirty="0">
                 <a:solidFill>
                   <a:srgbClr val="1B2A4A"/>
                 </a:solidFill>
@@ -3150,23 +2907,9 @@
                 <a:ea typeface="Calibri" pitchFamily="34" charset="-122"/>
                 <a:cs typeface="Calibri" pitchFamily="34" charset="-120"/>
               </a:rPr>
-              <a:t>Conselheiro de IA  </a:t>
-            </a:r>
-            <a:pPr indent="0" marL="0">
-              <a:buNone/>
-            </a:pPr>
-            <a:r>
-              <a:rPr lang="en-US" sz="1100" b="1" dirty="0">
-                <a:solidFill>
-                  <a:srgbClr val="C2A35B"/>
-                </a:solidFill>
-                <a:latin typeface="Calibri" pitchFamily="34" charset="0"/>
-                <a:ea typeface="Calibri" pitchFamily="34" charset="-122"/>
-                <a:cs typeface="Calibri" pitchFamily="34" charset="-120"/>
-              </a:rPr>
-              <a:t>sob proposta</a:t>
-            </a:r>
-            <a:endParaRPr lang="en-US" sz="1200" dirty="0"/>
+              <a:t>Sistemas gerenciados</a:t>
+            </a:r>
+            <a:endParaRPr lang="en-US" sz="1250" dirty="0"/>
           </a:p>
         </p:txBody>
       </p:sp>
@@ -3178,24 +2921,24 @@
         </p:nvSpPr>
         <p:spPr>
           <a:xfrm>
-            <a:off x="1298448" y="8275320"/>
-            <a:ext cx="5577840" cy="502920"/>
-          </a:xfrm>
-          <a:prstGeom prst="rect">
-            <a:avLst/>
-          </a:prstGeom>
-          <a:noFill/>
-          <a:ln/>
-        </p:spPr>
-        <p:txBody>
-          <a:bodyPr wrap="square" lIns="0" tIns="0" rIns="0" bIns="0" rtlCol="0" anchor="ctr"/>
-          <a:lstStyle/>
-          <a:p>
-            <a:pPr indent="0" marL="0">
-              <a:buNone/>
-            </a:pPr>
-            <a:r>
-              <a:rPr lang="en-US" sz="930" dirty="0">
+            <a:off x="1280160" y="7662672"/>
+            <a:ext cx="5577840" cy="548640"/>
+          </a:xfrm>
+          <a:prstGeom prst="rect">
+            <a:avLst/>
+          </a:prstGeom>
+          <a:noFill/>
+          <a:ln/>
+        </p:spPr>
+        <p:txBody>
+          <a:bodyPr wrap="square" lIns="0" tIns="0" rIns="0" bIns="0" rtlCol="0" anchor="ctr"/>
+          <a:lstStyle/>
+          <a:p>
+            <a:pPr indent="0" marL="0">
+              <a:buNone/>
+            </a:pPr>
+            <a:r>
+              <a:rPr lang="en-US" sz="900" dirty="0">
                 <a:solidFill>
                   <a:srgbClr val="5A6472"/>
                 </a:solidFill>
@@ -3203,9 +2946,9 @@
                 <a:ea typeface="Calibri" pitchFamily="34" charset="-122"/>
                 <a:cs typeface="Calibri" pitchFamily="34" charset="-120"/>
               </a:rPr>
-              <a:t>A cadeira de estrategista de IA, do seu lado da mesa: presença na diretoria, roadmap vivo, arbitragem independente de fornecedores.</a:t>
-            </a:r>
-            <a:endParaRPr lang="en-US" sz="930" dirty="0"/>
+              <a:t>Operamos o que construímos, com presença: SLA honesto, ritual semanal de 20 minutos com quem decide, e o diário decisão → resultado medido.</a:t>
+            </a:r>
+            <a:endParaRPr lang="en-US" sz="900" dirty="0"/>
           </a:p>
         </p:txBody>
       </p:sp>
@@ -3217,24 +2960,24 @@
         </p:nvSpPr>
         <p:spPr>
           <a:xfrm>
-            <a:off x="1298448" y="8805672"/>
-            <a:ext cx="5577840" cy="457200"/>
-          </a:xfrm>
-          <a:prstGeom prst="rect">
-            <a:avLst/>
-          </a:prstGeom>
-          <a:noFill/>
-          <a:ln/>
-        </p:spPr>
-        <p:txBody>
-          <a:bodyPr wrap="square" lIns="0" tIns="0" rIns="0" bIns="0" rtlCol="0" anchor="ctr"/>
-          <a:lstStyle/>
-          <a:p>
-            <a:pPr indent="0" marL="0">
-              <a:buNone/>
-            </a:pPr>
-            <a:r>
-              <a:rPr lang="en-US" sz="930" i="1" dirty="0">
+            <a:off x="1280160" y="8238744"/>
+            <a:ext cx="5577840" cy="329184"/>
+          </a:xfrm>
+          <a:prstGeom prst="rect">
+            <a:avLst/>
+          </a:prstGeom>
+          <a:noFill/>
+          <a:ln/>
+        </p:spPr>
+        <p:txBody>
+          <a:bodyPr wrap="square" lIns="0" tIns="0" rIns="0" bIns="0" rtlCol="0" anchor="ctr"/>
+          <a:lstStyle/>
+          <a:p>
+            <a:pPr indent="0" marL="0">
+              <a:buNone/>
+            </a:pPr>
+            <a:r>
+              <a:rPr lang="en-US" sz="900" b="1" i="1" dirty="0">
                 <a:solidFill>
                   <a:srgbClr val="1B2A4A"/>
                 </a:solidFill>
@@ -3242,9 +2985,9 @@
                 <a:ea typeface="Calibri" pitchFamily="34" charset="-122"/>
                 <a:cs typeface="Calibri" pitchFamily="34" charset="-120"/>
               </a:rPr>
-              <a:t>Também para quem já tem IA rodando — não precisa do programa para ter a cadeira.</a:t>
-            </a:r>
-            <a:endParaRPr lang="en-US" sz="930" dirty="0"/>
+              <a:t>A prova, mês a mês, do que a IA está devolvendo — visível para a diretoria.</a:t>
+            </a:r>
+            <a:endParaRPr lang="en-US" sz="900" dirty="0"/>
           </a:p>
         </p:txBody>
       </p:sp>
@@ -3256,15 +2999,35 @@
         </p:nvSpPr>
         <p:spPr>
           <a:xfrm>
-            <a:off x="502920" y="9555480"/>
-            <a:ext cx="6556248" cy="658368"/>
+            <a:off x="502920" y="8732520"/>
+            <a:ext cx="6556248" cy="1371600"/>
           </a:xfrm>
           <a:prstGeom prst="roundRect">
             <a:avLst>
-              <a:gd name="adj" fmla="val 8333"/>
+              <a:gd name="adj" fmla="val 4000"/>
             </a:avLst>
           </a:prstGeom>
           <a:solidFill>
+            <a:srgbClr val="EFEBE2"/>
+          </a:solidFill>
+          <a:ln/>
+        </p:spPr>
+      </p:sp>
+      <p:sp>
+        <p:nvSpPr>
+          <p:cNvPr id="36" name="Shape 34"/>
+          <p:cNvSpPr/>
+          <p:nvPr/>
+        </p:nvSpPr>
+        <p:spPr>
+          <a:xfrm>
+            <a:off x="685800" y="8878824"/>
+            <a:ext cx="438912" cy="438912"/>
+          </a:xfrm>
+          <a:prstGeom prst="ellipse">
+            <a:avLst/>
+          </a:prstGeom>
+          <a:solidFill>
             <a:srgbClr val="1B2A4A"/>
           </a:solidFill>
           <a:ln/>
@@ -3272,30 +3035,30 @@
       </p:sp>
       <p:sp>
         <p:nvSpPr>
-          <p:cNvPr id="36" name="Text 34"/>
-          <p:cNvSpPr/>
-          <p:nvPr/>
-        </p:nvSpPr>
-        <p:spPr>
-          <a:xfrm>
-            <a:off x="777240" y="9656064"/>
-            <a:ext cx="6035040" cy="457200"/>
-          </a:xfrm>
-          <a:prstGeom prst="rect">
-            <a:avLst/>
-          </a:prstGeom>
-          <a:noFill/>
-          <a:ln/>
-        </p:spPr>
-        <p:txBody>
-          <a:bodyPr wrap="square" lIns="0" tIns="0" rIns="0" bIns="0" rtlCol="0" anchor="ctr"/>
-          <a:lstStyle/>
-          <a:p>
-            <a:pPr indent="0" marL="0">
-              <a:buNone/>
-            </a:pPr>
-            <a:r>
-              <a:rPr lang="en-US" sz="950" b="1" dirty="0">
+          <p:cNvPr id="37" name="Text 35"/>
+          <p:cNvSpPr/>
+          <p:nvPr/>
+        </p:nvSpPr>
+        <p:spPr>
+          <a:xfrm>
+            <a:off x="685800" y="8887968"/>
+            <a:ext cx="438912" cy="420624"/>
+          </a:xfrm>
+          <a:prstGeom prst="rect">
+            <a:avLst/>
+          </a:prstGeom>
+          <a:noFill/>
+          <a:ln/>
+        </p:spPr>
+        <p:txBody>
+          <a:bodyPr wrap="square" lIns="0" tIns="0" rIns="0" bIns="0" rtlCol="0" anchor="ctr"/>
+          <a:lstStyle/>
+          <a:p>
+            <a:pPr algn="ctr" indent="0" marL="0">
+              <a:buNone/>
+            </a:pPr>
+            <a:r>
+              <a:rPr lang="en-US" sz="1400" b="1" dirty="0">
                 <a:solidFill>
                   <a:srgbClr val="C2A35B"/>
                 </a:solidFill>
@@ -3303,13 +3066,1112 @@
                 <a:ea typeface="Calibri" pitchFamily="34" charset="-122"/>
                 <a:cs typeface="Calibri" pitchFamily="34" charset="-120"/>
               </a:rPr>
-              <a:t>Regra da escada: </a:t>
-            </a:r>
-            <a:pPr indent="0" marL="0">
-              <a:buNone/>
-            </a:pPr>
-            <a:r>
-              <a:rPr lang="en-US" sz="950" dirty="0">
+              <a:t>6</a:t>
+            </a:r>
+            <a:endParaRPr lang="en-US" sz="1400" dirty="0"/>
+          </a:p>
+        </p:txBody>
+      </p:sp>
+      <p:sp>
+        <p:nvSpPr>
+          <p:cNvPr id="38" name="Text 36"/>
+          <p:cNvSpPr/>
+          <p:nvPr/>
+        </p:nvSpPr>
+        <p:spPr>
+          <a:xfrm>
+            <a:off x="1280160" y="8851392"/>
+            <a:ext cx="5577840" cy="274320"/>
+          </a:xfrm>
+          <a:prstGeom prst="rect">
+            <a:avLst/>
+          </a:prstGeom>
+          <a:noFill/>
+          <a:ln/>
+        </p:spPr>
+        <p:txBody>
+          <a:bodyPr wrap="square" lIns="0" tIns="0" rIns="0" bIns="0" rtlCol="0" anchor="ctr"/>
+          <a:lstStyle/>
+          <a:p>
+            <a:pPr indent="0" marL="0">
+              <a:buNone/>
+            </a:pPr>
+            <a:r>
+              <a:rPr lang="en-US" sz="1250" b="1" dirty="0">
+                <a:solidFill>
+                  <a:srgbClr val="1B2A4A"/>
+                </a:solidFill>
+                <a:latin typeface="Calibri" pitchFamily="34" charset="0"/>
+                <a:ea typeface="Calibri" pitchFamily="34" charset="-122"/>
+                <a:cs typeface="Calibri" pitchFamily="34" charset="-120"/>
+              </a:rPr>
+              <a:t>Conselheiro de IA</a:t>
+            </a:r>
+            <a:endParaRPr lang="en-US" sz="1250" dirty="0"/>
+          </a:p>
+        </p:txBody>
+      </p:sp>
+      <p:sp>
+        <p:nvSpPr>
+          <p:cNvPr id="39" name="Text 37"/>
+          <p:cNvSpPr/>
+          <p:nvPr/>
+        </p:nvSpPr>
+        <p:spPr>
+          <a:xfrm>
+            <a:off x="1280160" y="9144000"/>
+            <a:ext cx="5577840" cy="548640"/>
+          </a:xfrm>
+          <a:prstGeom prst="rect">
+            <a:avLst/>
+          </a:prstGeom>
+          <a:noFill/>
+          <a:ln/>
+        </p:spPr>
+        <p:txBody>
+          <a:bodyPr wrap="square" lIns="0" tIns="0" rIns="0" bIns="0" rtlCol="0" anchor="ctr"/>
+          <a:lstStyle/>
+          <a:p>
+            <a:pPr indent="0" marL="0">
+              <a:buNone/>
+            </a:pPr>
+            <a:r>
+              <a:rPr lang="en-US" sz="900" dirty="0">
+                <a:solidFill>
+                  <a:srgbClr val="5A6472"/>
+                </a:solidFill>
+                <a:latin typeface="Calibri" pitchFamily="34" charset="0"/>
+                <a:ea typeface="Calibri" pitchFamily="34" charset="-122"/>
+                <a:cs typeface="Calibri" pitchFamily="34" charset="-120"/>
+              </a:rPr>
+              <a:t>A cadeira de estrategista de IA do seu lado da mesa: presença na diretoria, roadmap vivo e arbitragem independente de qualquer proposta de fornecedor que chegar.</a:t>
+            </a:r>
+            <a:endParaRPr lang="en-US" sz="900" dirty="0"/>
+          </a:p>
+        </p:txBody>
+      </p:sp>
+      <p:sp>
+        <p:nvSpPr>
+          <p:cNvPr id="40" name="Text 38"/>
+          <p:cNvSpPr/>
+          <p:nvPr/>
+        </p:nvSpPr>
+        <p:spPr>
+          <a:xfrm>
+            <a:off x="1280160" y="9720072"/>
+            <a:ext cx="5577840" cy="329184"/>
+          </a:xfrm>
+          <a:prstGeom prst="rect">
+            <a:avLst/>
+          </a:prstGeom>
+          <a:noFill/>
+          <a:ln/>
+        </p:spPr>
+        <p:txBody>
+          <a:bodyPr wrap="square" lIns="0" tIns="0" rIns="0" bIns="0" rtlCol="0" anchor="ctr"/>
+          <a:lstStyle/>
+          <a:p>
+            <a:pPr indent="0" marL="0">
+              <a:buNone/>
+            </a:pPr>
+            <a:r>
+              <a:rPr lang="en-US" sz="900" b="1" i="1" dirty="0">
+                <a:solidFill>
+                  <a:srgbClr val="1B2A4A"/>
+                </a:solidFill>
+                <a:latin typeface="Calibri" pitchFamily="34" charset="0"/>
+                <a:ea typeface="Calibri" pitchFamily="34" charset="-122"/>
+                <a:cs typeface="Calibri" pitchFamily="34" charset="-120"/>
+              </a:rPr>
+              <a:t>Também para quem já tem IA rodando — não precisa do programa para ter a cadeira.</a:t>
+            </a:r>
+            <a:endParaRPr lang="en-US" sz="900" dirty="0"/>
+          </a:p>
+        </p:txBody>
+      </p:sp>
+      <p:sp>
+        <p:nvSpPr>
+          <p:cNvPr id="41" name="Text 39"/>
+          <p:cNvSpPr/>
+          <p:nvPr/>
+        </p:nvSpPr>
+        <p:spPr>
+          <a:xfrm>
+            <a:off x="502920" y="10351008"/>
+            <a:ext cx="6583680" cy="228600"/>
+          </a:xfrm>
+          <a:prstGeom prst="rect">
+            <a:avLst/>
+          </a:prstGeom>
+          <a:noFill/>
+          <a:ln/>
+        </p:spPr>
+        <p:txBody>
+          <a:bodyPr wrap="square" lIns="0" tIns="0" rIns="0" bIns="0" rtlCol="0" anchor="ctr"/>
+          <a:lstStyle/>
+          <a:p>
+            <a:pPr indent="0" marL="0">
+              <a:buNone/>
+            </a:pPr>
+            <a:r>
+              <a:rPr lang="en-US" sz="850" dirty="0">
+                <a:solidFill>
+                  <a:srgbClr val="9AA3B2"/>
+                </a:solidFill>
+                <a:latin typeface="Calibri" pitchFamily="34" charset="0"/>
+                <a:ea typeface="Calibri" pitchFamily="34" charset="-122"/>
+                <a:cs typeface="Calibri" pitchFamily="34" charset="-120"/>
+              </a:rPr>
+              <a:t>ABBA Consultoria de IA · comercial@abbaservices.com.br · abbaservices.com.br</a:t>
+            </a:r>
+            <a:endParaRPr lang="en-US" sz="850" dirty="0"/>
+          </a:p>
+        </p:txBody>
+      </p:sp>
+    </p:spTree>
+  </p:cSld>
+  <p:clrMapOvr>
+    <a:masterClrMapping/>
+  </p:clrMapOvr>
+</p:sld>
+</file>
+
+<file path=ppt/slides/slide3.xml><?xml version="1.0" encoding="utf-8"?>
+<p:sld xmlns:a="http://schemas.openxmlformats.org/drawingml/2006/main" xmlns:r="http://schemas.openxmlformats.org/officeDocument/2006/relationships" xmlns:p="http://schemas.openxmlformats.org/presentationml/2006/main">
+  <p:cSld name="Slide 3">
+    <p:bg>
+      <p:bgPr>
+        <a:solidFill>
+          <a:srgbClr val="FFFFFF"/>
+        </a:solidFill>
+      </p:bgPr>
+    </p:bg>
+    <p:spTree>
+      <p:nvGrpSpPr>
+        <p:cNvPr id="1" name=""/>
+        <p:cNvGrpSpPr/>
+        <p:nvPr/>
+      </p:nvGrpSpPr>
+      <p:grpSpPr>
+        <a:xfrm>
+          <a:off x="0" y="0"/>
+          <a:ext cx="0" cy="0"/>
+          <a:chOff x="0" y="0"/>
+          <a:chExt cx="0" cy="0"/>
+        </a:xfrm>
+      </p:grpSpPr>
+      <p:sp>
+        <p:nvSpPr>
+          <p:cNvPr id="2" name="Shape 0"/>
+          <p:cNvSpPr/>
+          <p:nvPr/>
+        </p:nvSpPr>
+        <p:spPr>
+          <a:xfrm>
+            <a:off x="0" y="0"/>
+            <a:ext cx="7562088" cy="1051560"/>
+          </a:xfrm>
+          <a:prstGeom prst="rect">
+            <a:avLst/>
+          </a:prstGeom>
+          <a:solidFill>
+            <a:srgbClr val="1B2A4A"/>
+          </a:solidFill>
+          <a:ln/>
+        </p:spPr>
+      </p:sp>
+      <p:sp>
+        <p:nvSpPr>
+          <p:cNvPr id="3" name="Text 1"/>
+          <p:cNvSpPr/>
+          <p:nvPr/>
+        </p:nvSpPr>
+        <p:spPr>
+          <a:xfrm>
+            <a:off x="502920" y="274320"/>
+            <a:ext cx="6583680" cy="365760"/>
+          </a:xfrm>
+          <a:prstGeom prst="rect">
+            <a:avLst/>
+          </a:prstGeom>
+          <a:noFill/>
+          <a:ln/>
+        </p:spPr>
+        <p:txBody>
+          <a:bodyPr wrap="square" lIns="0" tIns="0" rIns="0" bIns="0" rtlCol="0" anchor="ctr"/>
+          <a:lstStyle/>
+          <a:p>
+            <a:pPr indent="0" marL="0">
+              <a:buNone/>
+            </a:pPr>
+            <a:r>
+              <a:rPr lang="en-US" sz="1800" b="1" dirty="0">
+                <a:solidFill>
+                  <a:srgbClr val="FFFFFF"/>
+                </a:solidFill>
+                <a:latin typeface="Calibri" pitchFamily="34" charset="0"/>
+                <a:ea typeface="Calibri" pitchFamily="34" charset="-122"/>
+                <a:cs typeface="Calibri" pitchFamily="34" charset="-120"/>
+              </a:rPr>
+              <a:t>O investimento — o que exatamente se compra</a:t>
+            </a:r>
+            <a:endParaRPr lang="en-US" sz="1800" dirty="0"/>
+          </a:p>
+        </p:txBody>
+      </p:sp>
+      <p:sp>
+        <p:nvSpPr>
+          <p:cNvPr id="4" name="Text 2"/>
+          <p:cNvSpPr/>
+          <p:nvPr/>
+        </p:nvSpPr>
+        <p:spPr>
+          <a:xfrm>
+            <a:off x="502920" y="658368"/>
+            <a:ext cx="6583680" cy="274320"/>
+          </a:xfrm>
+          <a:prstGeom prst="rect">
+            <a:avLst/>
+          </a:prstGeom>
+          <a:noFill/>
+          <a:ln/>
+        </p:spPr>
+        <p:txBody>
+          <a:bodyPr wrap="square" lIns="0" tIns="0" rIns="0" bIns="0" rtlCol="0" anchor="ctr"/>
+          <a:lstStyle/>
+          <a:p>
+            <a:pPr indent="0" marL="0">
+              <a:buNone/>
+            </a:pPr>
+            <a:r>
+              <a:rPr lang="en-US" sz="1000" i="1" dirty="0">
+                <a:solidFill>
+                  <a:srgbClr val="C2A35B"/>
+                </a:solidFill>
+                <a:latin typeface="Calibri" pitchFamily="34" charset="0"/>
+                <a:ea typeface="Calibri" pitchFamily="34" charset="-122"/>
+                <a:cs typeface="Calibri" pitchFamily="34" charset="-120"/>
+              </a:rPr>
+              <a:t>Cada degrau entrega valor inteiro sozinho. O valor da entrada credita 100% no Programa em até 90 dias.</a:t>
+            </a:r>
+            <a:endParaRPr lang="en-US" sz="1000" dirty="0"/>
+          </a:p>
+        </p:txBody>
+      </p:sp>
+      <p:sp>
+        <p:nvSpPr>
+          <p:cNvPr id="5" name="Shape 3"/>
+          <p:cNvSpPr/>
+          <p:nvPr/>
+        </p:nvSpPr>
+        <p:spPr>
+          <a:xfrm>
+            <a:off x="502920" y="1325880"/>
+            <a:ext cx="6556248" cy="896112"/>
+          </a:xfrm>
+          <a:prstGeom prst="roundRect">
+            <a:avLst>
+              <a:gd name="adj" fmla="val 6122"/>
+            </a:avLst>
+          </a:prstGeom>
+          <a:solidFill>
+            <a:srgbClr val="F4F1EA"/>
+          </a:solidFill>
+          <a:ln/>
+        </p:spPr>
+      </p:sp>
+      <p:sp>
+        <p:nvSpPr>
+          <p:cNvPr id="6" name="Text 4"/>
+          <p:cNvSpPr/>
+          <p:nvPr/>
+        </p:nvSpPr>
+        <p:spPr>
+          <a:xfrm>
+            <a:off x="777240" y="1435608"/>
+            <a:ext cx="6035040" cy="274320"/>
+          </a:xfrm>
+          <a:prstGeom prst="rect">
+            <a:avLst/>
+          </a:prstGeom>
+          <a:noFill/>
+          <a:ln/>
+        </p:spPr>
+        <p:txBody>
+          <a:bodyPr wrap="square" lIns="0" tIns="0" rIns="0" bIns="0" rtlCol="0" anchor="ctr"/>
+          <a:lstStyle/>
+          <a:p>
+            <a:pPr indent="0" marL="0">
+              <a:buNone/>
+            </a:pPr>
+            <a:r>
+              <a:rPr lang="en-US" sz="1200" b="1" dirty="0">
+                <a:solidFill>
+                  <a:srgbClr val="1B2A4A"/>
+                </a:solidFill>
+                <a:latin typeface="Calibri" pitchFamily="34" charset="0"/>
+                <a:ea typeface="Calibri" pitchFamily="34" charset="-122"/>
+                <a:cs typeface="Calibri" pitchFamily="34" charset="-120"/>
+              </a:rPr>
+              <a:t>Mapa de Vazamento   </a:t>
+            </a:r>
+            <a:pPr indent="0" marL="0">
+              <a:buNone/>
+            </a:pPr>
+            <a:r>
+              <a:rPr lang="en-US" sz="1100" b="1" dirty="0">
+                <a:solidFill>
+                  <a:srgbClr val="C2A35B"/>
+                </a:solidFill>
+                <a:latin typeface="Calibri" pitchFamily="34" charset="0"/>
+                <a:ea typeface="Calibri" pitchFamily="34" charset="-122"/>
+                <a:cs typeface="Calibri" pitchFamily="34" charset="-120"/>
+              </a:rPr>
+              <a:t>gratuito</a:t>
+            </a:r>
+            <a:endParaRPr lang="en-US" sz="1200" dirty="0"/>
+          </a:p>
+        </p:txBody>
+      </p:sp>
+      <p:sp>
+        <p:nvSpPr>
+          <p:cNvPr id="7" name="Text 5"/>
+          <p:cNvSpPr/>
+          <p:nvPr/>
+        </p:nvSpPr>
+        <p:spPr>
+          <a:xfrm>
+            <a:off x="777240" y="1746504"/>
+            <a:ext cx="6035040" cy="411480"/>
+          </a:xfrm>
+          <a:prstGeom prst="rect">
+            <a:avLst/>
+          </a:prstGeom>
+          <a:noFill/>
+          <a:ln/>
+        </p:spPr>
+        <p:txBody>
+          <a:bodyPr wrap="square" lIns="0" tIns="0" rIns="0" bIns="0" rtlCol="0" anchor="ctr"/>
+          <a:lstStyle/>
+          <a:p>
+            <a:pPr indent="0" marL="0">
+              <a:buNone/>
+            </a:pPr>
+            <a:r>
+              <a:rPr lang="en-US" sz="930" dirty="0">
+                <a:solidFill>
+                  <a:srgbClr val="5A6472"/>
+                </a:solidFill>
+                <a:latin typeface="Calibri" pitchFamily="34" charset="0"/>
+                <a:ea typeface="Calibri" pitchFamily="34" charset="-122"/>
+                <a:cs typeface="Calibri" pitchFamily="34" charset="-120"/>
+              </a:rPr>
+              <a:t>2 páginas com uma estimativa em R$ do que pode estar vazando, com informação pública, em 48h.</a:t>
+            </a:r>
+            <a:endParaRPr lang="en-US" sz="930" dirty="0"/>
+          </a:p>
+        </p:txBody>
+      </p:sp>
+      <p:sp>
+        <p:nvSpPr>
+          <p:cNvPr id="8" name="Shape 6"/>
+          <p:cNvSpPr/>
+          <p:nvPr/>
+        </p:nvSpPr>
+        <p:spPr>
+          <a:xfrm>
+            <a:off x="502920" y="2350008"/>
+            <a:ext cx="6556248" cy="896112"/>
+          </a:xfrm>
+          <a:prstGeom prst="roundRect">
+            <a:avLst>
+              <a:gd name="adj" fmla="val 6122"/>
+            </a:avLst>
+          </a:prstGeom>
+          <a:solidFill>
+            <a:srgbClr val="F4F1EA"/>
+          </a:solidFill>
+          <a:ln/>
+        </p:spPr>
+      </p:sp>
+      <p:sp>
+        <p:nvSpPr>
+          <p:cNvPr id="9" name="Text 7"/>
+          <p:cNvSpPr/>
+          <p:nvPr/>
+        </p:nvSpPr>
+        <p:spPr>
+          <a:xfrm>
+            <a:off x="777240" y="2459736"/>
+            <a:ext cx="6035040" cy="274320"/>
+          </a:xfrm>
+          <a:prstGeom prst="rect">
+            <a:avLst/>
+          </a:prstGeom>
+          <a:noFill/>
+          <a:ln/>
+        </p:spPr>
+        <p:txBody>
+          <a:bodyPr wrap="square" lIns="0" tIns="0" rIns="0" bIns="0" rtlCol="0" anchor="ctr"/>
+          <a:lstStyle/>
+          <a:p>
+            <a:pPr indent="0" marL="0">
+              <a:buNone/>
+            </a:pPr>
+            <a:r>
+              <a:rPr lang="en-US" sz="1200" b="1" dirty="0">
+                <a:solidFill>
+                  <a:srgbClr val="1B2A4A"/>
+                </a:solidFill>
+                <a:latin typeface="Calibri" pitchFamily="34" charset="0"/>
+                <a:ea typeface="Calibri" pitchFamily="34" charset="-122"/>
+                <a:cs typeface="Calibri" pitchFamily="34" charset="-120"/>
+              </a:rPr>
+              <a:t>Avaliação de Prontidão (Assessment)   </a:t>
+            </a:r>
+            <a:pPr indent="0" marL="0">
+              <a:buNone/>
+            </a:pPr>
+            <a:r>
+              <a:rPr lang="en-US" sz="1100" b="1" dirty="0">
+                <a:solidFill>
+                  <a:srgbClr val="C2A35B"/>
+                </a:solidFill>
+                <a:latin typeface="Calibri" pitchFamily="34" charset="0"/>
+                <a:ea typeface="Calibri" pitchFamily="34" charset="-122"/>
+                <a:cs typeface="Calibri" pitchFamily="34" charset="-120"/>
+              </a:rPr>
+              <a:t>R$ 28.000</a:t>
+            </a:r>
+            <a:endParaRPr lang="en-US" sz="1200" dirty="0"/>
+          </a:p>
+        </p:txBody>
+      </p:sp>
+      <p:sp>
+        <p:nvSpPr>
+          <p:cNvPr id="10" name="Text 8"/>
+          <p:cNvSpPr/>
+          <p:nvPr/>
+        </p:nvSpPr>
+        <p:spPr>
+          <a:xfrm>
+            <a:off x="777240" y="2770632"/>
+            <a:ext cx="6035040" cy="411480"/>
+          </a:xfrm>
+          <a:prstGeom prst="rect">
+            <a:avLst/>
+          </a:prstGeom>
+          <a:noFill/>
+          <a:ln/>
+        </p:spPr>
+        <p:txBody>
+          <a:bodyPr wrap="square" lIns="0" tIns="0" rIns="0" bIns="0" rtlCol="0" anchor="ctr"/>
+          <a:lstStyle/>
+          <a:p>
+            <a:pPr indent="0" marL="0">
+              <a:buNone/>
+            </a:pPr>
+            <a:r>
+              <a:rPr lang="en-US" sz="930" dirty="0">
+                <a:solidFill>
+                  <a:srgbClr val="5A6472"/>
+                </a:solidFill>
+                <a:latin typeface="Calibri" pitchFamily="34" charset="0"/>
+                <a:ea typeface="Calibri" pitchFamily="34" charset="-122"/>
+                <a:cs typeface="Calibri" pitchFamily="34" charset="-120"/>
+              </a:rPr>
+              <a:t>As 25 dimensões, do conselho à linha de frente → portfólio ranqueado e quantificado.</a:t>
+            </a:r>
+            <a:endParaRPr lang="en-US" sz="930" dirty="0"/>
+          </a:p>
+        </p:txBody>
+      </p:sp>
+      <p:sp>
+        <p:nvSpPr>
+          <p:cNvPr id="11" name="Shape 9"/>
+          <p:cNvSpPr/>
+          <p:nvPr/>
+        </p:nvSpPr>
+        <p:spPr>
+          <a:xfrm>
+            <a:off x="502920" y="3374136"/>
+            <a:ext cx="6556248" cy="896112"/>
+          </a:xfrm>
+          <a:prstGeom prst="roundRect">
+            <a:avLst>
+              <a:gd name="adj" fmla="val 6122"/>
+            </a:avLst>
+          </a:prstGeom>
+          <a:solidFill>
+            <a:srgbClr val="F4F1EA"/>
+          </a:solidFill>
+          <a:ln/>
+        </p:spPr>
+      </p:sp>
+      <p:sp>
+        <p:nvSpPr>
+          <p:cNvPr id="12" name="Text 10"/>
+          <p:cNvSpPr/>
+          <p:nvPr/>
+        </p:nvSpPr>
+        <p:spPr>
+          <a:xfrm>
+            <a:off x="777240" y="3483864"/>
+            <a:ext cx="6035040" cy="274320"/>
+          </a:xfrm>
+          <a:prstGeom prst="rect">
+            <a:avLst/>
+          </a:prstGeom>
+          <a:noFill/>
+          <a:ln/>
+        </p:spPr>
+        <p:txBody>
+          <a:bodyPr wrap="square" lIns="0" tIns="0" rIns="0" bIns="0" rtlCol="0" anchor="ctr"/>
+          <a:lstStyle/>
+          <a:p>
+            <a:pPr indent="0" marL="0">
+              <a:buNone/>
+            </a:pPr>
+            <a:r>
+              <a:rPr lang="en-US" sz="1200" b="1" dirty="0">
+                <a:solidFill>
+                  <a:srgbClr val="1B2A4A"/>
+                </a:solidFill>
+                <a:latin typeface="Calibri" pitchFamily="34" charset="0"/>
+                <a:ea typeface="Calibri" pitchFamily="34" charset="-122"/>
+                <a:cs typeface="Calibri" pitchFamily="34" charset="-120"/>
+              </a:rPr>
+              <a:t>Programa Completo   </a:t>
+            </a:r>
+            <a:pPr indent="0" marL="0">
+              <a:buNone/>
+            </a:pPr>
+            <a:r>
+              <a:rPr lang="en-US" sz="1100" b="1" dirty="0">
+                <a:solidFill>
+                  <a:srgbClr val="C2A35B"/>
+                </a:solidFill>
+                <a:latin typeface="Calibri" pitchFamily="34" charset="0"/>
+                <a:ea typeface="Calibri" pitchFamily="34" charset="-122"/>
+                <a:cs typeface="Calibri" pitchFamily="34" charset="-120"/>
+              </a:rPr>
+              <a:t>R$ 185.000</a:t>
+            </a:r>
+            <a:endParaRPr lang="en-US" sz="1200" dirty="0"/>
+          </a:p>
+        </p:txBody>
+      </p:sp>
+      <p:sp>
+        <p:nvSpPr>
+          <p:cNvPr id="13" name="Text 11"/>
+          <p:cNvSpPr/>
+          <p:nvPr/>
+        </p:nvSpPr>
+        <p:spPr>
+          <a:xfrm>
+            <a:off x="777240" y="3794760"/>
+            <a:ext cx="6035040" cy="411480"/>
+          </a:xfrm>
+          <a:prstGeom prst="rect">
+            <a:avLst/>
+          </a:prstGeom>
+          <a:noFill/>
+          <a:ln/>
+        </p:spPr>
+        <p:txBody>
+          <a:bodyPr wrap="square" lIns="0" tIns="0" rIns="0" bIns="0" rtlCol="0" anchor="ctr"/>
+          <a:lstStyle/>
+          <a:p>
+            <a:pPr indent="0" marL="0">
+              <a:buNone/>
+            </a:pPr>
+            <a:r>
+              <a:rPr lang="en-US" sz="930" dirty="0">
+                <a:solidFill>
+                  <a:srgbClr val="5A6472"/>
+                </a:solidFill>
+                <a:latin typeface="Calibri" pitchFamily="34" charset="0"/>
+                <a:ea typeface="Calibri" pitchFamily="34" charset="-122"/>
+                <a:cs typeface="Calibri" pitchFamily="34" charset="-120"/>
+              </a:rPr>
+              <a:t>Protótipo validado (GO/NO-GO) → construção e implantação + treinamento de todos os níveis no ABBA Portal e presencial.</a:t>
+            </a:r>
+            <a:endParaRPr lang="en-US" sz="930" dirty="0"/>
+          </a:p>
+        </p:txBody>
+      </p:sp>
+      <p:sp>
+        <p:nvSpPr>
+          <p:cNvPr id="14" name="Shape 12"/>
+          <p:cNvSpPr/>
+          <p:nvPr/>
+        </p:nvSpPr>
+        <p:spPr>
+          <a:xfrm>
+            <a:off x="502920" y="4398264"/>
+            <a:ext cx="6556248" cy="896112"/>
+          </a:xfrm>
+          <a:prstGeom prst="roundRect">
+            <a:avLst>
+              <a:gd name="adj" fmla="val 6122"/>
+            </a:avLst>
+          </a:prstGeom>
+          <a:solidFill>
+            <a:srgbClr val="F4F1EA"/>
+          </a:solidFill>
+          <a:ln/>
+        </p:spPr>
+      </p:sp>
+      <p:sp>
+        <p:nvSpPr>
+          <p:cNvPr id="15" name="Text 13"/>
+          <p:cNvSpPr/>
+          <p:nvPr/>
+        </p:nvSpPr>
+        <p:spPr>
+          <a:xfrm>
+            <a:off x="777240" y="4507992"/>
+            <a:ext cx="6035040" cy="274320"/>
+          </a:xfrm>
+          <a:prstGeom prst="rect">
+            <a:avLst/>
+          </a:prstGeom>
+          <a:noFill/>
+          <a:ln/>
+        </p:spPr>
+        <p:txBody>
+          <a:bodyPr wrap="square" lIns="0" tIns="0" rIns="0" bIns="0" rtlCol="0" anchor="ctr"/>
+          <a:lstStyle/>
+          <a:p>
+            <a:pPr indent="0" marL="0">
+              <a:buNone/>
+            </a:pPr>
+            <a:r>
+              <a:rPr lang="en-US" sz="1200" b="1" dirty="0">
+                <a:solidFill>
+                  <a:srgbClr val="1B2A4A"/>
+                </a:solidFill>
+                <a:latin typeface="Calibri" pitchFamily="34" charset="0"/>
+                <a:ea typeface="Calibri" pitchFamily="34" charset="-122"/>
+                <a:cs typeface="Calibri" pitchFamily="34" charset="-120"/>
+              </a:rPr>
+              <a:t>Sistemas gerenciados   </a:t>
+            </a:r>
+            <a:pPr indent="0" marL="0">
+              <a:buNone/>
+            </a:pPr>
+            <a:r>
+              <a:rPr lang="en-US" sz="1100" b="1" dirty="0">
+                <a:solidFill>
+                  <a:srgbClr val="C2A35B"/>
+                </a:solidFill>
+                <a:latin typeface="Calibri" pitchFamily="34" charset="0"/>
+                <a:ea typeface="Calibri" pitchFamily="34" charset="-122"/>
+                <a:cs typeface="Calibri" pitchFamily="34" charset="-120"/>
+              </a:rPr>
+              <a:t>R$ 9.500/mês</a:t>
+            </a:r>
+            <a:endParaRPr lang="en-US" sz="1200" dirty="0"/>
+          </a:p>
+        </p:txBody>
+      </p:sp>
+      <p:sp>
+        <p:nvSpPr>
+          <p:cNvPr id="16" name="Text 14"/>
+          <p:cNvSpPr/>
+          <p:nvPr/>
+        </p:nvSpPr>
+        <p:spPr>
+          <a:xfrm>
+            <a:off x="777240" y="4818888"/>
+            <a:ext cx="6035040" cy="411480"/>
+          </a:xfrm>
+          <a:prstGeom prst="rect">
+            <a:avLst/>
+          </a:prstGeom>
+          <a:noFill/>
+          <a:ln/>
+        </p:spPr>
+        <p:txBody>
+          <a:bodyPr wrap="square" lIns="0" tIns="0" rIns="0" bIns="0" rtlCol="0" anchor="ctr"/>
+          <a:lstStyle/>
+          <a:p>
+            <a:pPr indent="0" marL="0">
+              <a:buNone/>
+            </a:pPr>
+            <a:r>
+              <a:rPr lang="en-US" sz="930" dirty="0">
+                <a:solidFill>
+                  <a:srgbClr val="5A6472"/>
+                </a:solidFill>
+                <a:latin typeface="Calibri" pitchFamily="34" charset="0"/>
+                <a:ea typeface="Calibri" pitchFamily="34" charset="-122"/>
+                <a:cs typeface="Calibri" pitchFamily="34" charset="-120"/>
+              </a:rPr>
+              <a:t>Operação com presença: SLA + ritual semanal de 20 min + diário decisão → resultado.</a:t>
+            </a:r>
+            <a:endParaRPr lang="en-US" sz="930" dirty="0"/>
+          </a:p>
+        </p:txBody>
+      </p:sp>
+      <p:sp>
+        <p:nvSpPr>
+          <p:cNvPr id="17" name="Shape 15"/>
+          <p:cNvSpPr/>
+          <p:nvPr/>
+        </p:nvSpPr>
+        <p:spPr>
+          <a:xfrm>
+            <a:off x="502920" y="5422392"/>
+            <a:ext cx="6556248" cy="896112"/>
+          </a:xfrm>
+          <a:prstGeom prst="roundRect">
+            <a:avLst>
+              <a:gd name="adj" fmla="val 6122"/>
+            </a:avLst>
+          </a:prstGeom>
+          <a:solidFill>
+            <a:srgbClr val="F4F1EA"/>
+          </a:solidFill>
+          <a:ln/>
+        </p:spPr>
+      </p:sp>
+      <p:sp>
+        <p:nvSpPr>
+          <p:cNvPr id="18" name="Text 16"/>
+          <p:cNvSpPr/>
+          <p:nvPr/>
+        </p:nvSpPr>
+        <p:spPr>
+          <a:xfrm>
+            <a:off x="777240" y="5532120"/>
+            <a:ext cx="6035040" cy="274320"/>
+          </a:xfrm>
+          <a:prstGeom prst="rect">
+            <a:avLst/>
+          </a:prstGeom>
+          <a:noFill/>
+          <a:ln/>
+        </p:spPr>
+        <p:txBody>
+          <a:bodyPr wrap="square" lIns="0" tIns="0" rIns="0" bIns="0" rtlCol="0" anchor="ctr"/>
+          <a:lstStyle/>
+          <a:p>
+            <a:pPr indent="0" marL="0">
+              <a:buNone/>
+            </a:pPr>
+            <a:r>
+              <a:rPr lang="en-US" sz="1200" b="1" dirty="0">
+                <a:solidFill>
+                  <a:srgbClr val="1B2A4A"/>
+                </a:solidFill>
+                <a:latin typeface="Calibri" pitchFamily="34" charset="0"/>
+                <a:ea typeface="Calibri" pitchFamily="34" charset="-122"/>
+                <a:cs typeface="Calibri" pitchFamily="34" charset="-120"/>
+              </a:rPr>
+              <a:t>Conselheiro de IA   </a:t>
+            </a:r>
+            <a:pPr indent="0" marL="0">
+              <a:buNone/>
+            </a:pPr>
+            <a:r>
+              <a:rPr lang="en-US" sz="1100" b="1" dirty="0">
+                <a:solidFill>
+                  <a:srgbClr val="C2A35B"/>
+                </a:solidFill>
+                <a:latin typeface="Calibri" pitchFamily="34" charset="0"/>
+                <a:ea typeface="Calibri" pitchFamily="34" charset="-122"/>
+                <a:cs typeface="Calibri" pitchFamily="34" charset="-120"/>
+              </a:rPr>
+              <a:t>sob proposta</a:t>
+            </a:r>
+            <a:endParaRPr lang="en-US" sz="1200" dirty="0"/>
+          </a:p>
+        </p:txBody>
+      </p:sp>
+      <p:sp>
+        <p:nvSpPr>
+          <p:cNvPr id="19" name="Text 17"/>
+          <p:cNvSpPr/>
+          <p:nvPr/>
+        </p:nvSpPr>
+        <p:spPr>
+          <a:xfrm>
+            <a:off x="777240" y="5843016"/>
+            <a:ext cx="6035040" cy="411480"/>
+          </a:xfrm>
+          <a:prstGeom prst="rect">
+            <a:avLst/>
+          </a:prstGeom>
+          <a:noFill/>
+          <a:ln/>
+        </p:spPr>
+        <p:txBody>
+          <a:bodyPr wrap="square" lIns="0" tIns="0" rIns="0" bIns="0" rtlCol="0" anchor="ctr"/>
+          <a:lstStyle/>
+          <a:p>
+            <a:pPr indent="0" marL="0">
+              <a:buNone/>
+            </a:pPr>
+            <a:r>
+              <a:rPr lang="en-US" sz="930" dirty="0">
+                <a:solidFill>
+                  <a:srgbClr val="5A6472"/>
+                </a:solidFill>
+                <a:latin typeface="Calibri" pitchFamily="34" charset="0"/>
+                <a:ea typeface="Calibri" pitchFamily="34" charset="-122"/>
+                <a:cs typeface="Calibri" pitchFamily="34" charset="-120"/>
+              </a:rPr>
+              <a:t>A cadeira de estrategista na sua diretoria — presença, roadmap vivo, arbitragem de fornecedores.</a:t>
+            </a:r>
+            <a:endParaRPr lang="en-US" sz="930" dirty="0"/>
+          </a:p>
+        </p:txBody>
+      </p:sp>
+      <p:sp>
+        <p:nvSpPr>
+          <p:cNvPr id="20" name="Shape 18"/>
+          <p:cNvSpPr/>
+          <p:nvPr/>
+        </p:nvSpPr>
+        <p:spPr>
+          <a:xfrm>
+            <a:off x="502920" y="6446520"/>
+            <a:ext cx="6556248" cy="896112"/>
+          </a:xfrm>
+          <a:prstGeom prst="roundRect">
+            <a:avLst>
+              <a:gd name="adj" fmla="val 6122"/>
+            </a:avLst>
+          </a:prstGeom>
+          <a:solidFill>
+            <a:srgbClr val="F4F1EA"/>
+          </a:solidFill>
+          <a:ln/>
+        </p:spPr>
+      </p:sp>
+      <p:sp>
+        <p:nvSpPr>
+          <p:cNvPr id="21" name="Text 19"/>
+          <p:cNvSpPr/>
+          <p:nvPr/>
+        </p:nvSpPr>
+        <p:spPr>
+          <a:xfrm>
+            <a:off x="777240" y="6556248"/>
+            <a:ext cx="6035040" cy="274320"/>
+          </a:xfrm>
+          <a:prstGeom prst="rect">
+            <a:avLst/>
+          </a:prstGeom>
+          <a:noFill/>
+          <a:ln/>
+        </p:spPr>
+        <p:txBody>
+          <a:bodyPr wrap="square" lIns="0" tIns="0" rIns="0" bIns="0" rtlCol="0" anchor="ctr"/>
+          <a:lstStyle/>
+          <a:p>
+            <a:pPr indent="0" marL="0">
+              <a:buNone/>
+            </a:pPr>
+            <a:r>
+              <a:rPr lang="en-US" sz="1200" b="1" dirty="0">
+                <a:solidFill>
+                  <a:srgbClr val="1B2A4A"/>
+                </a:solidFill>
+                <a:latin typeface="Calibri" pitchFamily="34" charset="0"/>
+                <a:ea typeface="Calibri" pitchFamily="34" charset="-122"/>
+                <a:cs typeface="Calibri" pitchFamily="34" charset="-120"/>
+              </a:rPr>
+              <a:t>Portas laterais   </a:t>
+            </a:r>
+            <a:pPr indent="0" marL="0">
+              <a:buNone/>
+            </a:pPr>
+            <a:r>
+              <a:rPr lang="en-US" sz="1100" b="1" dirty="0">
+                <a:solidFill>
+                  <a:srgbClr val="C2A35B"/>
+                </a:solidFill>
+                <a:latin typeface="Calibri" pitchFamily="34" charset="0"/>
+                <a:ea typeface="Calibri" pitchFamily="34" charset="-122"/>
+                <a:cs typeface="Calibri" pitchFamily="34" charset="-120"/>
+              </a:rPr>
+              <a:t>R$ 14.000 · R$ 24.000</a:t>
+            </a:r>
+            <a:endParaRPr lang="en-US" sz="1200" dirty="0"/>
+          </a:p>
+        </p:txBody>
+      </p:sp>
+      <p:sp>
+        <p:nvSpPr>
+          <p:cNvPr id="22" name="Text 20"/>
+          <p:cNvSpPr/>
+          <p:nvPr/>
+        </p:nvSpPr>
+        <p:spPr>
+          <a:xfrm>
+            <a:off x="777240" y="6867144"/>
+            <a:ext cx="6035040" cy="411480"/>
+          </a:xfrm>
+          <a:prstGeom prst="rect">
+            <a:avLst/>
+          </a:prstGeom>
+          <a:noFill/>
+          <a:ln/>
+        </p:spPr>
+        <p:txBody>
+          <a:bodyPr wrap="square" lIns="0" tIns="0" rIns="0" bIns="0" rtlCol="0" anchor="ctr"/>
+          <a:lstStyle/>
+          <a:p>
+            <a:pPr indent="0" marL="0">
+              <a:buNone/>
+            </a:pPr>
+            <a:r>
+              <a:rPr lang="en-US" sz="930" dirty="0">
+                <a:solidFill>
+                  <a:srgbClr val="5A6472"/>
+                </a:solidFill>
+                <a:latin typeface="Calibri" pitchFamily="34" charset="0"/>
+                <a:ea typeface="Calibri" pitchFamily="34" charset="-122"/>
+                <a:cs typeface="Calibri" pitchFamily="34" charset="-120"/>
+              </a:rPr>
+              <a:t>Workshop Shadow AI (a IA que seus funcionários já usam sem você saber) · Sprint LGPD + governança de IA.</a:t>
+            </a:r>
+            <a:endParaRPr lang="en-US" sz="930" dirty="0"/>
+          </a:p>
+        </p:txBody>
+      </p:sp>
+      <p:sp>
+        <p:nvSpPr>
+          <p:cNvPr id="23" name="Text 21"/>
+          <p:cNvSpPr/>
+          <p:nvPr/>
+        </p:nvSpPr>
+        <p:spPr>
+          <a:xfrm>
+            <a:off x="502920" y="7589520"/>
+            <a:ext cx="6583680" cy="292608"/>
+          </a:xfrm>
+          <a:prstGeom prst="rect">
+            <a:avLst/>
+          </a:prstGeom>
+          <a:noFill/>
+          <a:ln/>
+        </p:spPr>
+        <p:txBody>
+          <a:bodyPr wrap="square" lIns="0" tIns="0" rIns="0" bIns="0" rtlCol="0" anchor="ctr"/>
+          <a:lstStyle/>
+          <a:p>
+            <a:pPr indent="0" marL="0">
+              <a:buNone/>
+            </a:pPr>
+            <a:r>
+              <a:rPr lang="en-US" sz="1400" b="1" dirty="0">
+                <a:solidFill>
+                  <a:srgbClr val="1B2A4A"/>
+                </a:solidFill>
+                <a:latin typeface="Calibri" pitchFamily="34" charset="0"/>
+                <a:ea typeface="Calibri" pitchFamily="34" charset="-122"/>
+                <a:cs typeface="Calibri" pitchFamily="34" charset="-120"/>
+              </a:rPr>
+              <a:t>O que prometemos — e o que recusamos</a:t>
+            </a:r>
+            <a:endParaRPr lang="en-US" sz="1400" dirty="0"/>
+          </a:p>
+        </p:txBody>
+      </p:sp>
+      <p:sp>
+        <p:nvSpPr>
+          <p:cNvPr id="24" name="Shape 22"/>
+          <p:cNvSpPr/>
+          <p:nvPr/>
+        </p:nvSpPr>
+        <p:spPr>
+          <a:xfrm>
+            <a:off x="502920" y="7918704"/>
+            <a:ext cx="3200400" cy="1600200"/>
+          </a:xfrm>
+          <a:prstGeom prst="roundRect">
+            <a:avLst>
+              <a:gd name="adj" fmla="val 3429"/>
+            </a:avLst>
+          </a:prstGeom>
+          <a:solidFill>
+            <a:srgbClr val="1B2A4A"/>
+          </a:solidFill>
+          <a:ln/>
+        </p:spPr>
+      </p:sp>
+      <p:sp>
+        <p:nvSpPr>
+          <p:cNvPr id="25" name="Text 23"/>
+          <p:cNvSpPr/>
+          <p:nvPr/>
+        </p:nvSpPr>
+        <p:spPr>
+          <a:xfrm>
+            <a:off x="685800" y="8028432"/>
+            <a:ext cx="2834640" cy="256032"/>
+          </a:xfrm>
+          <a:prstGeom prst="rect">
+            <a:avLst/>
+          </a:prstGeom>
+          <a:noFill/>
+          <a:ln/>
+        </p:spPr>
+        <p:txBody>
+          <a:bodyPr wrap="square" lIns="0" tIns="0" rIns="0" bIns="0" rtlCol="0" anchor="ctr"/>
+          <a:lstStyle/>
+          <a:p>
+            <a:pPr indent="0" marL="0">
+              <a:buNone/>
+            </a:pPr>
+            <a:r>
+              <a:rPr lang="en-US" sz="1050" b="1" dirty="0">
+                <a:solidFill>
+                  <a:srgbClr val="C2A35B"/>
+                </a:solidFill>
+                <a:latin typeface="Calibri" pitchFamily="34" charset="0"/>
+                <a:ea typeface="Calibri" pitchFamily="34" charset="-122"/>
+                <a:cs typeface="Calibri" pitchFamily="34" charset="-120"/>
+              </a:rPr>
+              <a:t>Prometemos</a:t>
+            </a:r>
+            <a:endParaRPr lang="en-US" sz="1050" dirty="0"/>
+          </a:p>
+        </p:txBody>
+      </p:sp>
+      <p:sp>
+        <p:nvSpPr>
+          <p:cNvPr id="26" name="Text 24"/>
+          <p:cNvSpPr/>
+          <p:nvPr/>
+        </p:nvSpPr>
+        <p:spPr>
+          <a:xfrm>
+            <a:off x="777240" y="8302752"/>
+            <a:ext cx="2788920" cy="1143000"/>
+          </a:xfrm>
+          <a:prstGeom prst="rect">
+            <a:avLst/>
+          </a:prstGeom>
+          <a:noFill/>
+          <a:ln/>
+        </p:spPr>
+        <p:txBody>
+          <a:bodyPr wrap="square" lIns="0" tIns="0" rIns="0" bIns="0" rtlCol="0" anchor="ctr"/>
+          <a:lstStyle/>
+          <a:p>
+            <a:pPr marL="342900" indent="-342900">
+              <a:spcAft>
+                <a:spcPts val="400"/>
+              </a:spcAft>
+              <a:buSzPct val="100000"/>
+              <a:buChar char="•"/>
+            </a:pPr>
+            <a:r>
+              <a:rPr lang="en-US" sz="880" dirty="0">
                 <a:solidFill>
                   <a:srgbClr val="C9D2E4"/>
                 </a:solidFill>
@@ -3317,15 +4179,278 @@
                 <a:ea typeface="Calibri" pitchFamily="34" charset="-122"/>
                 <a:cs typeface="Calibri" pitchFamily="34" charset="-120"/>
               </a:rPr>
-              <a:t>o valor do produto de entrada credita 100% no Programa em até 90 dias. Portas laterais para urgências: Workshop Shadow AI (R$ 14.000) e Sprint LGPD (R$ 24.000).</a:t>
-            </a:r>
-            <a:endParaRPr lang="en-US" sz="950" dirty="0"/>
-          </a:p>
-        </p:txBody>
-      </p:sp>
-      <p:sp>
-        <p:nvSpPr>
-          <p:cNvPr id="37" name="Text 35"/>
+              <a:t>Nada entra sem métrica combinada antes</a:t>
+            </a:r>
+            <a:endParaRPr lang="en-US" sz="880" dirty="0"/>
+          </a:p>
+          <a:p>
+            <a:pPr marL="342900" indent="-342900">
+              <a:spcAft>
+                <a:spcPts val="400"/>
+              </a:spcAft>
+              <a:buSzPct val="100000"/>
+              <a:buChar char="•"/>
+            </a:pPr>
+            <a:r>
+              <a:rPr lang="en-US" sz="880" dirty="0">
+                <a:solidFill>
+                  <a:srgbClr val="C9D2E4"/>
+                </a:solidFill>
+                <a:latin typeface="Calibri" pitchFamily="34" charset="0"/>
+                <a:ea typeface="Calibri" pitchFamily="34" charset="-122"/>
+                <a:cs typeface="Calibri" pitchFamily="34" charset="-120"/>
+              </a:rPr>
+              <a:t>Tudo sai medido — inclusive o que der errado</a:t>
+            </a:r>
+            <a:endParaRPr lang="en-US" sz="880" dirty="0"/>
+          </a:p>
+          <a:p>
+            <a:pPr marL="342900" indent="-342900">
+              <a:spcAft>
+                <a:spcPts val="400"/>
+              </a:spcAft>
+              <a:buSzPct val="100000"/>
+              <a:buChar char="•"/>
+            </a:pPr>
+            <a:r>
+              <a:rPr lang="en-US" sz="880" dirty="0">
+                <a:solidFill>
+                  <a:srgbClr val="C9D2E4"/>
+                </a:solidFill>
+                <a:latin typeface="Calibri" pitchFamily="34" charset="0"/>
+                <a:ea typeface="Calibri" pitchFamily="34" charset="-122"/>
+                <a:cs typeface="Calibri" pitchFamily="34" charset="-120"/>
+              </a:rPr>
+              <a:t>Vocês veem o registro inteiro</a:t>
+            </a:r>
+            <a:endParaRPr lang="en-US" sz="880" dirty="0"/>
+          </a:p>
+        </p:txBody>
+      </p:sp>
+      <p:sp>
+        <p:nvSpPr>
+          <p:cNvPr id="27" name="Shape 25"/>
+          <p:cNvSpPr/>
+          <p:nvPr/>
+        </p:nvSpPr>
+        <p:spPr>
+          <a:xfrm>
+            <a:off x="3858768" y="7918704"/>
+            <a:ext cx="3200400" cy="1600200"/>
+          </a:xfrm>
+          <a:prstGeom prst="roundRect">
+            <a:avLst>
+              <a:gd name="adj" fmla="val 3429"/>
+            </a:avLst>
+          </a:prstGeom>
+          <a:solidFill>
+            <a:srgbClr val="F4F1EA"/>
+          </a:solidFill>
+          <a:ln/>
+        </p:spPr>
+      </p:sp>
+      <p:sp>
+        <p:nvSpPr>
+          <p:cNvPr id="28" name="Text 26"/>
+          <p:cNvSpPr/>
+          <p:nvPr/>
+        </p:nvSpPr>
+        <p:spPr>
+          <a:xfrm>
+            <a:off x="4041648" y="8028432"/>
+            <a:ext cx="2834640" cy="256032"/>
+          </a:xfrm>
+          <a:prstGeom prst="rect">
+            <a:avLst/>
+          </a:prstGeom>
+          <a:noFill/>
+          <a:ln/>
+        </p:spPr>
+        <p:txBody>
+          <a:bodyPr wrap="square" lIns="0" tIns="0" rIns="0" bIns="0" rtlCol="0" anchor="ctr"/>
+          <a:lstStyle/>
+          <a:p>
+            <a:pPr indent="0" marL="0">
+              <a:buNone/>
+            </a:pPr>
+            <a:r>
+              <a:rPr lang="en-US" sz="1050" b="1" dirty="0">
+                <a:solidFill>
+                  <a:srgbClr val="1B2A4A"/>
+                </a:solidFill>
+                <a:latin typeface="Calibri" pitchFamily="34" charset="0"/>
+                <a:ea typeface="Calibri" pitchFamily="34" charset="-122"/>
+                <a:cs typeface="Calibri" pitchFamily="34" charset="-120"/>
+              </a:rPr>
+              <a:t>Recusamos</a:t>
+            </a:r>
+            <a:endParaRPr lang="en-US" sz="1050" dirty="0"/>
+          </a:p>
+        </p:txBody>
+      </p:sp>
+      <p:sp>
+        <p:nvSpPr>
+          <p:cNvPr id="29" name="Text 27"/>
+          <p:cNvSpPr/>
+          <p:nvPr/>
+        </p:nvSpPr>
+        <p:spPr>
+          <a:xfrm>
+            <a:off x="4133088" y="8302752"/>
+            <a:ext cx="2788920" cy="1143000"/>
+          </a:xfrm>
+          <a:prstGeom prst="rect">
+            <a:avLst/>
+          </a:prstGeom>
+          <a:noFill/>
+          <a:ln/>
+        </p:spPr>
+        <p:txBody>
+          <a:bodyPr wrap="square" lIns="0" tIns="0" rIns="0" bIns="0" rtlCol="0" anchor="ctr"/>
+          <a:lstStyle/>
+          <a:p>
+            <a:pPr marL="342900" indent="-342900">
+              <a:spcAft>
+                <a:spcPts val="400"/>
+              </a:spcAft>
+              <a:buSzPct val="100000"/>
+              <a:buChar char="•"/>
+            </a:pPr>
+            <a:r>
+              <a:rPr lang="en-US" sz="880" dirty="0">
+                <a:solidFill>
+                  <a:srgbClr val="5A6472"/>
+                </a:solidFill>
+                <a:latin typeface="Calibri" pitchFamily="34" charset="0"/>
+                <a:ea typeface="Calibri" pitchFamily="34" charset="-122"/>
+                <a:cs typeface="Calibri" pitchFamily="34" charset="-120"/>
+              </a:rPr>
+              <a:t>Piloto sem métrica de sucesso definida</a:t>
+            </a:r>
+            <a:endParaRPr lang="en-US" sz="880" dirty="0"/>
+          </a:p>
+          <a:p>
+            <a:pPr marL="342900" indent="-342900">
+              <a:spcAft>
+                <a:spcPts val="400"/>
+              </a:spcAft>
+              <a:buSzPct val="100000"/>
+              <a:buChar char="•"/>
+            </a:pPr>
+            <a:r>
+              <a:rPr lang="en-US" sz="880" dirty="0">
+                <a:solidFill>
+                  <a:srgbClr val="5A6472"/>
+                </a:solidFill>
+                <a:latin typeface="Calibri" pitchFamily="34" charset="0"/>
+                <a:ea typeface="Calibri" pitchFamily="34" charset="-122"/>
+                <a:cs typeface="Calibri" pitchFamily="34" charset="-120"/>
+              </a:rPr>
+              <a:t>Prometer números que não medimos</a:t>
+            </a:r>
+            <a:endParaRPr lang="en-US" sz="880" dirty="0"/>
+          </a:p>
+          <a:p>
+            <a:pPr marL="342900" indent="-342900">
+              <a:spcAft>
+                <a:spcPts val="400"/>
+              </a:spcAft>
+              <a:buSzPct val="100000"/>
+              <a:buChar char="•"/>
+            </a:pPr>
+            <a:r>
+              <a:rPr lang="en-US" sz="880" dirty="0">
+                <a:solidFill>
+                  <a:srgbClr val="5A6472"/>
+                </a:solidFill>
+                <a:latin typeface="Calibri" pitchFamily="34" charset="0"/>
+                <a:ea typeface="Calibri" pitchFamily="34" charset="-122"/>
+                <a:cs typeface="Calibri" pitchFamily="34" charset="-120"/>
+              </a:rPr>
+              <a:t>Decidir por vocês — a IA rascunha, um humano assina, a diretoria decide</a:t>
+            </a:r>
+            <a:endParaRPr lang="en-US" sz="880" dirty="0"/>
+          </a:p>
+        </p:txBody>
+      </p:sp>
+      <p:sp>
+        <p:nvSpPr>
+          <p:cNvPr id="30" name="Shape 28"/>
+          <p:cNvSpPr/>
+          <p:nvPr/>
+        </p:nvSpPr>
+        <p:spPr>
+          <a:xfrm>
+            <a:off x="502920" y="9646920"/>
+            <a:ext cx="6556248" cy="621792"/>
+          </a:xfrm>
+          <a:prstGeom prst="roundRect">
+            <a:avLst>
+              <a:gd name="adj" fmla="val 8824"/>
+            </a:avLst>
+          </a:prstGeom>
+          <a:solidFill>
+            <a:srgbClr val="1B2A4A"/>
+          </a:solidFill>
+          <a:ln/>
+        </p:spPr>
+      </p:sp>
+      <p:sp>
+        <p:nvSpPr>
+          <p:cNvPr id="31" name="Text 29"/>
+          <p:cNvSpPr/>
+          <p:nvPr/>
+        </p:nvSpPr>
+        <p:spPr>
+          <a:xfrm>
+            <a:off x="777240" y="9765792"/>
+            <a:ext cx="6035040" cy="411480"/>
+          </a:xfrm>
+          <a:prstGeom prst="rect">
+            <a:avLst/>
+          </a:prstGeom>
+          <a:noFill/>
+          <a:ln/>
+        </p:spPr>
+        <p:txBody>
+          <a:bodyPr wrap="square" lIns="0" tIns="0" rIns="0" bIns="0" rtlCol="0" anchor="ctr"/>
+          <a:lstStyle/>
+          <a:p>
+            <a:pPr indent="0" marL="0">
+              <a:buNone/>
+            </a:pPr>
+            <a:r>
+              <a:rPr lang="en-US" sz="1050" b="1" dirty="0">
+                <a:solidFill>
+                  <a:srgbClr val="FFFFFF"/>
+                </a:solidFill>
+                <a:latin typeface="Calibri" pitchFamily="34" charset="0"/>
+                <a:ea typeface="Calibri" pitchFamily="34" charset="-122"/>
+                <a:cs typeface="Calibri" pitchFamily="34" charset="-120"/>
+              </a:rPr>
+              <a:t>Próximo passo: </a:t>
+            </a:r>
+            <a:pPr indent="0" marL="0">
+              <a:buNone/>
+            </a:pPr>
+            <a:r>
+              <a:rPr lang="en-US" sz="1050" dirty="0">
+                <a:solidFill>
+                  <a:srgbClr val="C9D2E4"/>
+                </a:solidFill>
+                <a:latin typeface="Calibri" pitchFamily="34" charset="0"/>
+                <a:ea typeface="Calibri" pitchFamily="34" charset="-122"/>
+                <a:cs typeface="Calibri" pitchFamily="34" charset="-120"/>
+              </a:rPr>
+              <a:t>uma conversa de 45 minutos — e o seu Mapa de Vazamento, gratuito, em 48h.</a:t>
+            </a:r>
+            <a:endParaRPr lang="en-US" sz="1050" dirty="0"/>
+          </a:p>
+        </p:txBody>
+      </p:sp>
+      <p:sp>
+        <p:nvSpPr>
+          <p:cNvPr id="32" name="Text 30"/>
           <p:cNvSpPr/>
           <p:nvPr/>
         </p:nvSpPr>

</xml_diff>

<commit_message>
Ajustes finos do sócio: e-mail oficial contato@, capa direta, raízes sem árvore (V3l)
- E-mail oficial em material externo: contato@abbaservices.com.br
  (2 PDFs + deck do Conselheiro corrigidos; doutrina na marca)
- Capa: sem árvore, sem pull-quote, sem parágrafos de contexto —
  abre direto na ABBA; seção dourada das raízes sem nomear árvore
- '25 dimensões' removido dos materiais de envio
- PASS no Revisor nos dois documentos

Co-Authored-By: Claude Fable 5 <noreply@anthropic.com>
Claude-Session: https://claude.ai/code/session_016RZJT8nVEB7u33HvjY5KvZ
</commit_message>
<xml_diff>
--- a/08-materiais/modelos/abba-apresentacao.pptx
+++ b/08-materiais/modelos/abba-apresentacao.pptx
@@ -1139,27 +1139,27 @@
         </p:nvSpPr>
         <p:spPr>
           <a:xfrm>
-            <a:off x="777240" y="1691640"/>
-            <a:ext cx="5120640" cy="1417320"/>
-          </a:xfrm>
-          <a:prstGeom prst="rect">
-            <a:avLst/>
-          </a:prstGeom>
-          <a:noFill/>
-          <a:ln/>
-        </p:spPr>
-        <p:txBody>
-          <a:bodyPr wrap="square" lIns="0" tIns="0" rIns="0" bIns="0" rtlCol="0" anchor="ctr"/>
-          <a:lstStyle/>
-          <a:p>
-            <a:pPr indent="0" marL="0">
-              <a:lnSpc>
-                <a:spcPts val="4000"/>
-              </a:lnSpc>
-              <a:buNone/>
-            </a:pPr>
-            <a:r>
-              <a:rPr lang="en-US" sz="3300" b="1" dirty="0">
+            <a:off x="777240" y="1828800"/>
+            <a:ext cx="5852160" cy="1417320"/>
+          </a:xfrm>
+          <a:prstGeom prst="rect">
+            <a:avLst/>
+          </a:prstGeom>
+          <a:noFill/>
+          <a:ln/>
+        </p:spPr>
+        <p:txBody>
+          <a:bodyPr wrap="square" lIns="0" tIns="0" rIns="0" bIns="0" rtlCol="0" anchor="ctr"/>
+          <a:lstStyle/>
+          <a:p>
+            <a:pPr indent="0" marL="0">
+              <a:lnSpc>
+                <a:spcPts val="4200"/>
+              </a:lnSpc>
+              <a:buNone/>
+            </a:pPr>
+            <a:r>
+              <a:rPr lang="en-US" sz="3400" b="1" dirty="0">
                 <a:solidFill>
                   <a:srgbClr val="1B2A4A"/>
                 </a:solidFill>
@@ -1169,78 +1169,132 @@
               </a:rPr>
               <a:t>Tornamos a sua empresa AI native.</a:t>
             </a:r>
-            <a:endParaRPr lang="en-US" sz="3300" dirty="0"/>
-          </a:p>
-        </p:txBody>
-      </p:sp>
-      <p:sp>
-        <p:nvSpPr>
-          <p:cNvPr id="5" name="Shape 3"/>
-          <p:cNvSpPr/>
-          <p:nvPr/>
-        </p:nvSpPr>
-        <p:spPr>
-          <a:xfrm>
-            <a:off x="6446520" y="1879092"/>
-            <a:ext cx="0" cy="1728216"/>
-          </a:xfrm>
-          <a:prstGeom prst="line">
-            <a:avLst/>
-          </a:prstGeom>
-          <a:noFill/>
-          <a:ln w="17780">
-            <a:solidFill>
-              <a:srgbClr val="B8985A"/>
-            </a:solidFill>
-            <a:prstDash val="solid"/>
-          </a:ln>
-        </p:spPr>
-      </p:sp>
-      <p:sp>
-        <p:nvSpPr>
-          <p:cNvPr id="6" name="Shape 4"/>
-          <p:cNvSpPr/>
-          <p:nvPr/>
-        </p:nvSpPr>
-        <p:spPr>
-          <a:xfrm flipV="1">
-            <a:off x="6446520" y="2215134"/>
-            <a:ext cx="-528066" cy="-576072"/>
-          </a:xfrm>
-          <a:prstGeom prst="line">
-            <a:avLst/>
-          </a:prstGeom>
-          <a:noFill/>
-          <a:ln w="13970">
-            <a:solidFill>
-              <a:srgbClr val="B8985A"/>
-            </a:solidFill>
-            <a:prstDash val="solid"/>
-          </a:ln>
-        </p:spPr>
-      </p:sp>
-      <p:sp>
-        <p:nvSpPr>
-          <p:cNvPr id="7" name="Shape 5"/>
-          <p:cNvSpPr/>
-          <p:nvPr/>
-        </p:nvSpPr>
-        <p:spPr>
-          <a:xfrm flipV="1">
-            <a:off x="6446520" y="2023110"/>
-            <a:ext cx="576072" cy="-528066"/>
-          </a:xfrm>
-          <a:prstGeom prst="line">
-            <a:avLst/>
-          </a:prstGeom>
-          <a:noFill/>
-          <a:ln w="13970">
-            <a:solidFill>
-              <a:srgbClr val="B8985A"/>
-            </a:solidFill>
-            <a:prstDash val="solid"/>
-          </a:ln>
-        </p:spPr>
+            <a:endParaRPr lang="en-US" sz="3400" dirty="0"/>
+          </a:p>
+        </p:txBody>
+      </p:sp>
+      <p:sp>
+        <p:nvSpPr>
+          <p:cNvPr id="5" name="Text 3"/>
+          <p:cNvSpPr/>
+          <p:nvPr/>
+        </p:nvSpPr>
+        <p:spPr>
+          <a:xfrm>
+            <a:off x="777240" y="3703320"/>
+            <a:ext cx="6007608" cy="219456"/>
+          </a:xfrm>
+          <a:prstGeom prst="rect">
+            <a:avLst/>
+          </a:prstGeom>
+          <a:noFill/>
+          <a:ln/>
+        </p:spPr>
+        <p:txBody>
+          <a:bodyPr wrap="square" lIns="0" tIns="0" rIns="0" bIns="0" rtlCol="0" anchor="ctr"/>
+          <a:lstStyle/>
+          <a:p>
+            <a:pPr indent="0" marL="0">
+              <a:buNone/>
+            </a:pPr>
+            <a:r>
+              <a:rPr lang="en-US" sz="900" b="1" spc="320" kern="0" dirty="0">
+                <a:solidFill>
+                  <a:srgbClr val="B8985A"/>
+                </a:solidFill>
+                <a:latin typeface="Calibri" pitchFamily="34" charset="0"/>
+                <a:ea typeface="Calibri" pitchFamily="34" charset="-122"/>
+                <a:cs typeface="Calibri" pitchFamily="34" charset="-120"/>
+              </a:rPr>
+              <a:t>QUEM SOMOS</a:t>
+            </a:r>
+            <a:endParaRPr lang="en-US" sz="900" dirty="0"/>
+          </a:p>
+        </p:txBody>
+      </p:sp>
+      <p:sp>
+        <p:nvSpPr>
+          <p:cNvPr id="6" name="Text 4"/>
+          <p:cNvSpPr/>
+          <p:nvPr/>
+        </p:nvSpPr>
+        <p:spPr>
+          <a:xfrm>
+            <a:off x="777240" y="4023360"/>
+            <a:ext cx="6007608" cy="914400"/>
+          </a:xfrm>
+          <a:prstGeom prst="rect">
+            <a:avLst/>
+          </a:prstGeom>
+          <a:noFill/>
+          <a:ln/>
+        </p:spPr>
+        <p:txBody>
+          <a:bodyPr wrap="square" lIns="0" tIns="0" rIns="0" bIns="0" rtlCol="0" anchor="ctr"/>
+          <a:lstStyle/>
+          <a:p>
+            <a:pPr indent="0" marL="0">
+              <a:lnSpc>
+                <a:spcPts val="1550"/>
+              </a:lnSpc>
+              <a:buNone/>
+            </a:pPr>
+            <a:r>
+              <a:rPr lang="en-US" sz="1100" dirty="0">
+                <a:solidFill>
+                  <a:srgbClr val="232B3A"/>
+                </a:solidFill>
+                <a:latin typeface="Calibri" pitchFamily="34" charset="0"/>
+                <a:ea typeface="Calibri" pitchFamily="34" charset="-122"/>
+                <a:cs typeface="Calibri" pitchFamily="34" charset="-120"/>
+              </a:rPr>
+              <a:t>A ABBA é uma consultoria de inteligência artificial. Entramos na sua empresa para entendê-la a fundo, construímos as soluções certas para o seu fluxo de trabalho, validamos cada uma com dados reais antes de qualquer investimento pesado, formamos as suas pessoas — e ficamos ao seu lado acompanhando, mês a mês, o que mudou.</a:t>
+            </a:r>
+            <a:endParaRPr lang="en-US" sz="1100" dirty="0"/>
+          </a:p>
+        </p:txBody>
+      </p:sp>
+      <p:sp>
+        <p:nvSpPr>
+          <p:cNvPr id="7" name="Text 5"/>
+          <p:cNvSpPr/>
+          <p:nvPr/>
+        </p:nvSpPr>
+        <p:spPr>
+          <a:xfrm>
+            <a:off x="777240" y="5029200"/>
+            <a:ext cx="6007608" cy="914400"/>
+          </a:xfrm>
+          <a:prstGeom prst="rect">
+            <a:avLst/>
+          </a:prstGeom>
+          <a:noFill/>
+          <a:ln/>
+        </p:spPr>
+        <p:txBody>
+          <a:bodyPr wrap="square" lIns="0" tIns="0" rIns="0" bIns="0" rtlCol="0" anchor="ctr"/>
+          <a:lstStyle/>
+          <a:p>
+            <a:pPr indent="0" marL="0">
+              <a:lnSpc>
+                <a:spcPts val="1550"/>
+              </a:lnSpc>
+              <a:buNone/>
+            </a:pPr>
+            <a:r>
+              <a:rPr lang="en-US" sz="1100" dirty="0">
+                <a:solidFill>
+                  <a:srgbClr val="232B3A"/>
+                </a:solidFill>
+                <a:latin typeface="Calibri" pitchFamily="34" charset="0"/>
+                <a:ea typeface="Calibri" pitchFamily="34" charset="-122"/>
+                <a:cs typeface="Calibri" pitchFamily="34" charset="-120"/>
+              </a:rPr>
+              <a:t>O trabalho acontece em duas frentes ao mesmo tempo. Nos processos: construímos e implantamos agentes de IA que tornam a operação mais eficiente, mais rápida e mais poderosa. E nas pessoas: formamos cada nível da equipe para trabalhar com IA e enxergar o próprio trabalho de um jeito novo.</a:t>
+            </a:r>
+            <a:endParaRPr lang="en-US" sz="1100" dirty="0"/>
+          </a:p>
+        </p:txBody>
       </p:sp>
       <p:sp>
         <p:nvSpPr>
@@ -1249,147 +1303,9 @@
           <p:nvPr/>
         </p:nvSpPr>
         <p:spPr>
-          <a:xfrm flipV="1">
-            <a:off x="6446520" y="2455164"/>
-            <a:ext cx="403250" cy="-432054"/>
-          </a:xfrm>
-          <a:prstGeom prst="line">
-            <a:avLst/>
-          </a:prstGeom>
-          <a:noFill/>
-          <a:ln w="11430">
-            <a:solidFill>
-              <a:srgbClr val="B8985A"/>
-            </a:solidFill>
-            <a:prstDash val="solid"/>
-          </a:ln>
-        </p:spPr>
-      </p:sp>
-      <p:sp>
-        <p:nvSpPr>
-          <p:cNvPr id="9" name="Shape 7"/>
-          <p:cNvSpPr/>
-          <p:nvPr/>
-        </p:nvSpPr>
-        <p:spPr>
-          <a:xfrm flipV="1">
-            <a:off x="6446520" y="2339950"/>
-            <a:ext cx="-326441" cy="-288036"/>
-          </a:xfrm>
-          <a:prstGeom prst="line">
-            <a:avLst/>
-          </a:prstGeom>
-          <a:noFill/>
-          <a:ln w="11430">
-            <a:solidFill>
-              <a:srgbClr val="B8985A"/>
-            </a:solidFill>
-            <a:prstDash val="solid"/>
-          </a:ln>
-        </p:spPr>
-      </p:sp>
-      <p:sp>
-        <p:nvSpPr>
-          <p:cNvPr id="10" name="Shape 8"/>
-          <p:cNvSpPr/>
-          <p:nvPr/>
-        </p:nvSpPr>
-        <p:spPr>
-          <a:xfrm>
-            <a:off x="6446520" y="3271266"/>
-            <a:ext cx="-595274" cy="480060"/>
-          </a:xfrm>
-          <a:prstGeom prst="line">
-            <a:avLst/>
-          </a:prstGeom>
-          <a:noFill/>
-          <a:ln w="13970">
-            <a:solidFill>
-              <a:srgbClr val="B8985A"/>
-            </a:solidFill>
-            <a:prstDash val="solid"/>
-          </a:ln>
-        </p:spPr>
-      </p:sp>
-      <p:sp>
-        <p:nvSpPr>
-          <p:cNvPr id="11" name="Shape 9"/>
-          <p:cNvSpPr/>
-          <p:nvPr/>
-        </p:nvSpPr>
-        <p:spPr>
-          <a:xfrm>
-            <a:off x="6446520" y="3415284"/>
-            <a:ext cx="556870" cy="432054"/>
-          </a:xfrm>
-          <a:prstGeom prst="line">
-            <a:avLst/>
-          </a:prstGeom>
-          <a:noFill/>
-          <a:ln w="13970">
-            <a:solidFill>
-              <a:srgbClr val="B8985A"/>
-            </a:solidFill>
-            <a:prstDash val="solid"/>
-          </a:ln>
-        </p:spPr>
-      </p:sp>
-      <p:sp>
-        <p:nvSpPr>
-          <p:cNvPr id="12" name="Shape 10"/>
-          <p:cNvSpPr/>
-          <p:nvPr/>
-        </p:nvSpPr>
-        <p:spPr>
-          <a:xfrm>
-            <a:off x="6446520" y="3079242"/>
-            <a:ext cx="288036" cy="336042"/>
-          </a:xfrm>
-          <a:prstGeom prst="line">
-            <a:avLst/>
-          </a:prstGeom>
-          <a:noFill/>
-          <a:ln w="11430">
-            <a:solidFill>
-              <a:srgbClr val="B8985A"/>
-            </a:solidFill>
-            <a:prstDash val="solid"/>
-          </a:ln>
-        </p:spPr>
-      </p:sp>
-      <p:sp>
-        <p:nvSpPr>
-          <p:cNvPr id="13" name="Shape 11"/>
-          <p:cNvSpPr/>
-          <p:nvPr/>
-        </p:nvSpPr>
-        <p:spPr>
-          <a:xfrm>
-            <a:off x="6446520" y="3175254"/>
-            <a:ext cx="-268834" cy="316840"/>
-          </a:xfrm>
-          <a:prstGeom prst="line">
-            <a:avLst/>
-          </a:prstGeom>
-          <a:noFill/>
-          <a:ln w="11430">
-            <a:solidFill>
-              <a:srgbClr val="B8985A"/>
-            </a:solidFill>
-            <a:prstDash val="solid"/>
-          </a:ln>
-        </p:spPr>
-      </p:sp>
-      <p:sp>
-        <p:nvSpPr>
-          <p:cNvPr id="14" name="Shape 12"/>
-          <p:cNvSpPr/>
-          <p:nvPr/>
-        </p:nvSpPr>
-        <p:spPr>
-          <a:xfrm>
-            <a:off x="5630418" y="3608222"/>
-            <a:ext cx="1632204" cy="0"/>
+          <a:xfrm>
+            <a:off x="777240" y="6263640"/>
+            <a:ext cx="6007608" cy="0"/>
           </a:xfrm>
           <a:prstGeom prst="line">
             <a:avLst/>
@@ -1405,13 +1321,13 @@
       </p:sp>
       <p:sp>
         <p:nvSpPr>
-          <p:cNvPr id="15" name="Text 13"/>
-          <p:cNvSpPr/>
-          <p:nvPr/>
-        </p:nvSpPr>
-        <p:spPr>
-          <a:xfrm>
-            <a:off x="777240" y="3520440"/>
+          <p:cNvPr id="9" name="Text 7"/>
+          <p:cNvSpPr/>
+          <p:nvPr/>
+        </p:nvSpPr>
+        <p:spPr>
+          <a:xfrm>
+            <a:off x="777240" y="6537960"/>
             <a:ext cx="6007608" cy="219456"/>
           </a:xfrm>
           <a:prstGeom prst="rect">
@@ -1436,7 +1352,7 @@
                 <a:ea typeface="Calibri" pitchFamily="34" charset="-122"/>
                 <a:cs typeface="Calibri" pitchFamily="34" charset="-120"/>
               </a:rPr>
-              <a:t>A HISTÓRIA, EM UM MINUTO</a:t>
+              <a:t>O NOSSO PROCESSO</a:t>
             </a:r>
             <a:endParaRPr lang="en-US" sz="900" dirty="0"/>
           </a:p>
@@ -1444,139 +1360,95 @@
       </p:sp>
       <p:sp>
         <p:nvSpPr>
-          <p:cNvPr id="16" name="Text 14"/>
-          <p:cNvSpPr/>
-          <p:nvPr/>
-        </p:nvSpPr>
-        <p:spPr>
-          <a:xfrm>
-            <a:off x="777240" y="3822192"/>
-            <a:ext cx="5257800" cy="777240"/>
-          </a:xfrm>
-          <a:prstGeom prst="rect">
-            <a:avLst/>
-          </a:prstGeom>
-          <a:noFill/>
-          <a:ln/>
-        </p:spPr>
-        <p:txBody>
-          <a:bodyPr wrap="square" lIns="0" tIns="0" rIns="0" bIns="0" rtlCol="0" anchor="ctr"/>
-          <a:lstStyle/>
-          <a:p>
-            <a:pPr indent="0" marL="0">
-              <a:lnSpc>
-                <a:spcPts val="1500"/>
-              </a:lnSpc>
-              <a:buNone/>
-            </a:pPr>
-            <a:r>
-              <a:rPr lang="en-US" sz="1050" dirty="0">
-                <a:solidFill>
-                  <a:srgbClr val="232B3A"/>
-                </a:solidFill>
-                <a:latin typeface="Calibri" pitchFamily="34" charset="0"/>
-                <a:ea typeface="Calibri" pitchFamily="34" charset="-122"/>
-                <a:cs typeface="Calibri" pitchFamily="34" charset="-120"/>
-              </a:rPr>
-              <a:t>Toda semana, um dono de empresa ouve que precisa “fazer algo com IA”. Muitos já tentaram: compraram uma ferramenta, rodaram um piloto, mandaram o time para um curso. E quase tudo morreu na praia.</a:t>
-            </a:r>
-            <a:endParaRPr lang="en-US" sz="1050" dirty="0"/>
-          </a:p>
-        </p:txBody>
-      </p:sp>
-      <p:sp>
-        <p:nvSpPr>
-          <p:cNvPr id="17" name="Text 15"/>
-          <p:cNvSpPr/>
-          <p:nvPr/>
-        </p:nvSpPr>
-        <p:spPr>
-          <a:xfrm>
-            <a:off x="777240" y="4681728"/>
-            <a:ext cx="5257800" cy="960120"/>
-          </a:xfrm>
-          <a:prstGeom prst="rect">
-            <a:avLst/>
-          </a:prstGeom>
-          <a:noFill/>
-          <a:ln/>
-        </p:spPr>
-        <p:txBody>
-          <a:bodyPr wrap="square" lIns="0" tIns="0" rIns="0" bIns="0" rtlCol="0" anchor="ctr"/>
-          <a:lstStyle/>
-          <a:p>
-            <a:pPr indent="0" marL="0">
-              <a:lnSpc>
-                <a:spcPts val="1500"/>
-              </a:lnSpc>
-              <a:buNone/>
-            </a:pPr>
-            <a:r>
-              <a:rPr lang="en-US" sz="1050" dirty="0">
-                <a:solidFill>
-                  <a:srgbClr val="232B3A"/>
-                </a:solidFill>
-                <a:latin typeface="Calibri" pitchFamily="34" charset="0"/>
-                <a:ea typeface="Calibri" pitchFamily="34" charset="-122"/>
-                <a:cs typeface="Calibri" pitchFamily="34" charset="-120"/>
-              </a:rPr>
-              <a:t>Não foi por causa da tecnologia. Foi porque ninguém combinou, antes de começar, o que seria “dar certo” — e porque ninguém preparou as pessoas para trabalhar de um jeito novo. Setenta por cento do valor de uma transformação em IA está em pessoas, processos e cultura. O mercado vende os outros trinta.</a:t>
-            </a:r>
-            <a:endParaRPr lang="en-US" sz="1050" dirty="0"/>
-          </a:p>
-        </p:txBody>
-      </p:sp>
-      <p:sp>
-        <p:nvSpPr>
-          <p:cNvPr id="18" name="Text 16"/>
-          <p:cNvSpPr/>
-          <p:nvPr/>
-        </p:nvSpPr>
-        <p:spPr>
-          <a:xfrm>
-            <a:off x="777240" y="5742432"/>
-            <a:ext cx="5257800" cy="960120"/>
-          </a:xfrm>
-          <a:prstGeom prst="rect">
-            <a:avLst/>
-          </a:prstGeom>
-          <a:noFill/>
-          <a:ln/>
-        </p:spPr>
-        <p:txBody>
-          <a:bodyPr wrap="square" lIns="0" tIns="0" rIns="0" bIns="0" rtlCol="0" anchor="ctr"/>
-          <a:lstStyle/>
-          <a:p>
-            <a:pPr indent="0" marL="0">
-              <a:lnSpc>
-                <a:spcPts val="1500"/>
-              </a:lnSpc>
-              <a:buNone/>
-            </a:pPr>
-            <a:r>
-              <a:rPr lang="en-US" sz="1050" dirty="0">
-                <a:solidFill>
-                  <a:srgbClr val="232B3A"/>
-                </a:solidFill>
-                <a:latin typeface="Calibri" pitchFamily="34" charset="0"/>
-                <a:ea typeface="Calibri" pitchFamily="34" charset="-122"/>
-                <a:cs typeface="Calibri" pitchFamily="34" charset="-120"/>
-              </a:rPr>
-              <a:t>A ABBA nasceu para fazer o caminho inteiro: entender a sua empresa a fundo, construir as soluções certas para o seu fluxo de trabalho, validar cada uma com dados reais antes de qualquer investimento pesado, formar as suas pessoas — e ficar ao seu lado provando, mês a mês, o que mudou.</a:t>
-            </a:r>
-            <a:endParaRPr lang="en-US" sz="1050" dirty="0"/>
-          </a:p>
-        </p:txBody>
-      </p:sp>
-      <p:sp>
-        <p:nvSpPr>
-          <p:cNvPr id="19" name="Shape 17"/>
-          <p:cNvSpPr/>
-          <p:nvPr/>
-        </p:nvSpPr>
-        <p:spPr>
-          <a:xfrm>
-            <a:off x="777240" y="6949440"/>
+          <p:cNvPr id="10" name="Text 8"/>
+          <p:cNvSpPr/>
+          <p:nvPr/>
+        </p:nvSpPr>
+        <p:spPr>
+          <a:xfrm>
+            <a:off x="777240" y="6903720"/>
+            <a:ext cx="6007608" cy="1371600"/>
+          </a:xfrm>
+          <a:prstGeom prst="rect">
+            <a:avLst/>
+          </a:prstGeom>
+          <a:noFill/>
+          <a:ln/>
+        </p:spPr>
+        <p:txBody>
+          <a:bodyPr wrap="square" lIns="0" tIns="0" rIns="0" bIns="0" rtlCol="0" anchor="ctr"/>
+          <a:lstStyle/>
+          <a:p>
+            <a:pPr indent="0" marL="0">
+              <a:lnSpc>
+                <a:spcPts val="2800"/>
+              </a:lnSpc>
+              <a:buNone/>
+            </a:pPr>
+            <a:r>
+              <a:rPr lang="en-US" sz="1900" i="1" dirty="0">
+                <a:solidFill>
+                  <a:srgbClr val="B8985A"/>
+                </a:solidFill>
+                <a:latin typeface="Cambria" pitchFamily="34" charset="0"/>
+                <a:ea typeface="Cambria" pitchFamily="34" charset="-122"/>
+                <a:cs typeface="Cambria" pitchFamily="34" charset="-120"/>
+              </a:rPr>
+              <a:t>Começa na diretoria e se estende, como raízes,</a:t>
+            </a:r>
+            <a:endParaRPr lang="en-US" sz="1900" dirty="0"/>
+          </a:p>
+          <a:p>
+            <a:pPr indent="0" marL="0">
+              <a:lnSpc>
+                <a:spcPts val="2800"/>
+              </a:lnSpc>
+              <a:buNone/>
+            </a:pPr>
+            <a:r>
+              <a:rPr lang="en-US" sz="1900" i="1" dirty="0">
+                <a:solidFill>
+                  <a:srgbClr val="B8985A"/>
+                </a:solidFill>
+                <a:latin typeface="Cambria" pitchFamily="34" charset="0"/>
+                <a:ea typeface="Cambria" pitchFamily="34" charset="-122"/>
+                <a:cs typeface="Cambria" pitchFamily="34" charset="-120"/>
+              </a:rPr>
+              <a:t>por toda a empresa — até alcançar cada pessoa,</a:t>
+            </a:r>
+            <a:endParaRPr lang="en-US" sz="1900" dirty="0"/>
+          </a:p>
+          <a:p>
+            <a:pPr indent="0" marL="0">
+              <a:lnSpc>
+                <a:spcPts val="2800"/>
+              </a:lnSpc>
+              <a:buNone/>
+            </a:pPr>
+            <a:r>
+              <a:rPr lang="en-US" sz="1900" i="1" dirty="0">
+                <a:solidFill>
+                  <a:srgbClr val="B8985A"/>
+                </a:solidFill>
+                <a:latin typeface="Cambria" pitchFamily="34" charset="0"/>
+                <a:ea typeface="Cambria" pitchFamily="34" charset="-122"/>
+                <a:cs typeface="Cambria" pitchFamily="34" charset="-120"/>
+              </a:rPr>
+              <a:t>em cada processo, todos os dias.</a:t>
+            </a:r>
+            <a:endParaRPr lang="en-US" sz="1900" dirty="0"/>
+          </a:p>
+        </p:txBody>
+      </p:sp>
+      <p:sp>
+        <p:nvSpPr>
+          <p:cNvPr id="11" name="Shape 9"/>
+          <p:cNvSpPr/>
+          <p:nvPr/>
+        </p:nvSpPr>
+        <p:spPr>
+          <a:xfrm>
+            <a:off x="777240" y="8503920"/>
             <a:ext cx="6007608" cy="0"/>
           </a:xfrm>
           <a:prstGeom prst="line">
@@ -1593,53 +1465,14 @@
       </p:sp>
       <p:sp>
         <p:nvSpPr>
-          <p:cNvPr id="20" name="Text 18"/>
-          <p:cNvSpPr/>
-          <p:nvPr/>
-        </p:nvSpPr>
-        <p:spPr>
-          <a:xfrm>
-            <a:off x="777240" y="7114032"/>
-            <a:ext cx="6007608" cy="219456"/>
-          </a:xfrm>
-          <a:prstGeom prst="rect">
-            <a:avLst/>
-          </a:prstGeom>
-          <a:noFill/>
-          <a:ln/>
-        </p:spPr>
-        <p:txBody>
-          <a:bodyPr wrap="square" lIns="0" tIns="0" rIns="0" bIns="0" rtlCol="0" anchor="ctr"/>
-          <a:lstStyle/>
-          <a:p>
-            <a:pPr indent="0" marL="0">
-              <a:buNone/>
-            </a:pPr>
-            <a:r>
-              <a:rPr lang="en-US" sz="900" b="1" spc="320" kern="0" dirty="0">
-                <a:solidFill>
-                  <a:srgbClr val="B8985A"/>
-                </a:solidFill>
-                <a:latin typeface="Calibri" pitchFamily="34" charset="0"/>
-                <a:ea typeface="Calibri" pitchFamily="34" charset="-122"/>
-                <a:cs typeface="Calibri" pitchFamily="34" charset="-120"/>
-              </a:rPr>
-              <a:t>A TRANSFORMAÇÃO COMO UMA ÁRVORE</a:t>
-            </a:r>
-            <a:endParaRPr lang="en-US" sz="900" dirty="0"/>
-          </a:p>
-        </p:txBody>
-      </p:sp>
-      <p:sp>
-        <p:nvSpPr>
-          <p:cNvPr id="21" name="Text 19"/>
-          <p:cNvSpPr/>
-          <p:nvPr/>
-        </p:nvSpPr>
-        <p:spPr>
-          <a:xfrm>
-            <a:off x="777240" y="7406640"/>
-            <a:ext cx="6007608" cy="685800"/>
+          <p:cNvPr id="12" name="Text 10"/>
+          <p:cNvSpPr/>
+          <p:nvPr/>
+        </p:nvSpPr>
+        <p:spPr>
+          <a:xfrm>
+            <a:off x="777240" y="8778240"/>
+            <a:ext cx="6007608" cy="548640"/>
           </a:xfrm>
           <a:prstGeom prst="rect">
             <a:avLst/>
@@ -1660,13 +1493,13 @@
             <a:r>
               <a:rPr lang="en-US" sz="1050" dirty="0">
                 <a:solidFill>
-                  <a:srgbClr val="232B3A"/>
-                </a:solidFill>
-                <a:latin typeface="Calibri" pitchFamily="34" charset="0"/>
-                <a:ea typeface="Calibri" pitchFamily="34" charset="-122"/>
-                <a:cs typeface="Calibri" pitchFamily="34" charset="-120"/>
-              </a:rPr>
-              <a:t>Uma transformação de verdade não é um sistema instalado num canto. É uma árvore: plantada com a diretoria, ela estende as raízes até tocar cada funcionário — do conselho à linha de frente. Sistemas novos no fluxo de trabalho, e uma mentalidade nova em cada pessoa.</a:t>
+                  <a:srgbClr val="5A6472"/>
+                </a:solidFill>
+                <a:latin typeface="Calibri" pitchFamily="34" charset="0"/>
+                <a:ea typeface="Calibri" pitchFamily="34" charset="-122"/>
+                <a:cs typeface="Calibri" pitchFamily="34" charset="-120"/>
+              </a:rPr>
+              <a:t>Nas próximas páginas, o caminho completo — da primeira conversa à cadeira de estrategista na sua diretoria: o que fazemos em cada etapa, por quê, e como.</a:t>
             </a:r>
             <a:endParaRPr lang="en-US" sz="1050" dirty="0"/>
           </a:p>
@@ -1674,13 +1507,13 @@
       </p:sp>
       <p:sp>
         <p:nvSpPr>
-          <p:cNvPr id="22" name="Shape 20"/>
-          <p:cNvSpPr/>
-          <p:nvPr/>
-        </p:nvSpPr>
-        <p:spPr>
-          <a:xfrm>
-            <a:off x="777240" y="8366760"/>
+          <p:cNvPr id="13" name="Shape 11"/>
+          <p:cNvSpPr/>
+          <p:nvPr/>
+        </p:nvSpPr>
+        <p:spPr>
+          <a:xfrm>
+            <a:off x="777240" y="10195560"/>
             <a:ext cx="6007608" cy="0"/>
           </a:xfrm>
           <a:prstGeom prst="line">
@@ -1697,134 +1530,7 @@
       </p:sp>
       <p:sp>
         <p:nvSpPr>
-          <p:cNvPr id="23" name="Text 21"/>
-          <p:cNvSpPr/>
-          <p:nvPr/>
-        </p:nvSpPr>
-        <p:spPr>
-          <a:xfrm>
-            <a:off x="777240" y="8613648"/>
-            <a:ext cx="6007608" cy="914400"/>
-          </a:xfrm>
-          <a:prstGeom prst="rect">
-            <a:avLst/>
-          </a:prstGeom>
-          <a:noFill/>
-          <a:ln/>
-        </p:spPr>
-        <p:txBody>
-          <a:bodyPr wrap="square" lIns="0" tIns="0" rIns="0" bIns="0" rtlCol="0" anchor="ctr"/>
-          <a:lstStyle/>
-          <a:p>
-            <a:pPr indent="0" marL="0">
-              <a:lnSpc>
-                <a:spcPts val="2700"/>
-              </a:lnSpc>
-              <a:buNone/>
-            </a:pPr>
-            <a:r>
-              <a:rPr lang="en-US" sz="2200" i="1" dirty="0">
-                <a:solidFill>
-                  <a:srgbClr val="B8985A"/>
-                </a:solidFill>
-                <a:latin typeface="Cambria" pitchFamily="34" charset="0"/>
-                <a:ea typeface="Cambria" pitchFamily="34" charset="-122"/>
-                <a:cs typeface="Cambria" pitchFamily="34" charset="-120"/>
-              </a:rPr>
-              <a:t>Número combinado antes.</a:t>
-            </a:r>
-            <a:endParaRPr lang="en-US" sz="2200" dirty="0"/>
-          </a:p>
-          <a:p>
-            <a:pPr indent="0" marL="0">
-              <a:lnSpc>
-                <a:spcPts val="2700"/>
-              </a:lnSpc>
-              <a:buNone/>
-            </a:pPr>
-            <a:r>
-              <a:rPr lang="en-US" sz="2200" i="1" dirty="0">
-                <a:solidFill>
-                  <a:srgbClr val="B8985A"/>
-                </a:solidFill>
-                <a:latin typeface="Cambria" pitchFamily="34" charset="0"/>
-                <a:ea typeface="Cambria" pitchFamily="34" charset="-122"/>
-                <a:cs typeface="Cambria" pitchFamily="34" charset="-120"/>
-              </a:rPr>
-              <a:t>Medido depois. Assinado por gente.</a:t>
-            </a:r>
-            <a:endParaRPr lang="en-US" sz="2200" dirty="0"/>
-          </a:p>
-        </p:txBody>
-      </p:sp>
-      <p:sp>
-        <p:nvSpPr>
-          <p:cNvPr id="24" name="Text 22"/>
-          <p:cNvSpPr/>
-          <p:nvPr/>
-        </p:nvSpPr>
-        <p:spPr>
-          <a:xfrm>
-            <a:off x="777240" y="9582912"/>
-            <a:ext cx="6007608" cy="548640"/>
-          </a:xfrm>
-          <a:prstGeom prst="rect">
-            <a:avLst/>
-          </a:prstGeom>
-          <a:noFill/>
-          <a:ln/>
-        </p:spPr>
-        <p:txBody>
-          <a:bodyPr wrap="square" lIns="0" tIns="0" rIns="0" bIns="0" rtlCol="0" anchor="ctr"/>
-          <a:lstStyle/>
-          <a:p>
-            <a:pPr indent="0" marL="0">
-              <a:lnSpc>
-                <a:spcPts val="1300"/>
-              </a:lnSpc>
-              <a:buNone/>
-            </a:pPr>
-            <a:r>
-              <a:rPr lang="en-US" sz="950" dirty="0">
-                <a:solidFill>
-                  <a:srgbClr val="5A6472"/>
-                </a:solidFill>
-                <a:latin typeface="Calibri" pitchFamily="34" charset="0"/>
-                <a:ea typeface="Calibri" pitchFamily="34" charset="-122"/>
-                <a:cs typeface="Calibri" pitchFamily="34" charset="-120"/>
-              </a:rPr>
-              <a:t>Nenhuma solução nossa começa sem uma métrica de sucesso acordada com você — e nenhuma termina sem esse número remedido, esteja bom ou ruim. Você vê o registro inteiro. Nas próximas páginas: como isso acontece, passo a passo.</a:t>
-            </a:r>
-            <a:endParaRPr lang="en-US" sz="950" dirty="0"/>
-          </a:p>
-        </p:txBody>
-      </p:sp>
-      <p:sp>
-        <p:nvSpPr>
-          <p:cNvPr id="25" name="Shape 23"/>
-          <p:cNvSpPr/>
-          <p:nvPr/>
-        </p:nvSpPr>
-        <p:spPr>
-          <a:xfrm>
-            <a:off x="777240" y="10195560"/>
-            <a:ext cx="6007608" cy="0"/>
-          </a:xfrm>
-          <a:prstGeom prst="line">
-            <a:avLst/>
-          </a:prstGeom>
-          <a:noFill/>
-          <a:ln w="9525">
-            <a:solidFill>
-              <a:srgbClr val="D9D2C4"/>
-            </a:solidFill>
-            <a:prstDash val="solid"/>
-          </a:ln>
-        </p:spPr>
-      </p:sp>
-      <p:sp>
-        <p:nvSpPr>
-          <p:cNvPr id="26" name="Text 24"/>
+          <p:cNvPr id="14" name="Text 12"/>
           <p:cNvSpPr/>
           <p:nvPr/>
         </p:nvSpPr>
@@ -1863,7 +1569,7 @@
       </p:sp>
       <p:sp>
         <p:nvSpPr>
-          <p:cNvPr id="27" name="Text 25"/>
+          <p:cNvPr id="15" name="Text 13"/>
           <p:cNvSpPr/>
           <p:nvPr/>
         </p:nvSpPr>
@@ -2458,7 +2164,7 @@
                 <a:ea typeface="Calibri" pitchFamily="34" charset="-122"/>
                 <a:cs typeface="Calibri" pitchFamily="34" charset="-120"/>
               </a:rPr>
-              <a:t>Entramos na empresa e avaliamos 25 dimensões proprietárias, do conselho à linha de frente: como o trabalho realmente flui, onde quebra, onde vaza valor, quem decide o quê.</a:t>
+              <a:t>Entramos na empresa e fazemos um mergulho profundo, do conselho à linha de frente: como o trabalho realmente flui, onde quebra, onde vaza valor, quem decide o quê.</a:t>
             </a:r>
             <a:endParaRPr lang="en-US" sz="750" dirty="0"/>
           </a:p>
@@ -4559,7 +4265,7 @@
                 <a:ea typeface="Calibri" pitchFamily="34" charset="-122"/>
                 <a:cs typeface="Calibri" pitchFamily="34" charset="-120"/>
               </a:rPr>
-              <a:t>COMERCIAL@ABBASERVICES.COM.BR</a:t>
+              <a:t>CONTATO@ABBASERVICES.COM.BR</a:t>
             </a:r>
             <a:endParaRPr lang="en-US" sz="750" dirty="0"/>
           </a:p>

</xml_diff>

<commit_message>
Discurso de engenharia na construção: arquitetura + integrações + agentes inseridos (V3m)
Correção do sócio: a solução não é 'agentes de IA' — é engenharia
(arquitetura, integrações, lógica de decisão) com os agentes inseridos
onde fazem diferença. Aplicado na capa, na etapa 4 e na versão de 1
página. PASS no Revisor nos dois documentos.

Co-Authored-By: Claude Fable 5 <noreply@anthropic.com>
Claude-Session: https://claude.ai/code/session_016RZJT8nVEB7u33HvjY5KvZ
</commit_message>
<xml_diff>
--- a/08-materiais/modelos/abba-apresentacao.pptx
+++ b/08-materiais/modelos/abba-apresentacao.pptx
@@ -1290,7 +1290,7 @@
                 <a:ea typeface="Calibri" pitchFamily="34" charset="-122"/>
                 <a:cs typeface="Calibri" pitchFamily="34" charset="-120"/>
               </a:rPr>
-              <a:t>O trabalho acontece em duas frentes ao mesmo tempo. Nos processos: construímos e implantamos agentes de IA que tornam a operação mais eficiente, mais rápida e mais poderosa. E nas pessoas: formamos cada nível da equipe para trabalhar com IA e enxergar o próprio trabalho de um jeito novo.</a:t>
+              <a:t>O trabalho acontece em duas frentes ao mesmo tempo. Nos processos: projetamos e implantamos sistemas inteligentes — arquitetura, integrações e agentes de IA trabalhando em conjunto — que tornam a operação mais eficiente, mais rápida e mais poderosa. E nas pessoas: formamos cada nível da equipe para trabalhar com IA e enxergar o próprio trabalho de um jeito novo.</a:t>
             </a:r>
             <a:endParaRPr lang="en-US" sz="1100" dirty="0"/>
           </a:p>
@@ -2661,7 +2661,7 @@
                 <a:ea typeface="Cambria" pitchFamily="34" charset="-122"/>
                 <a:cs typeface="Cambria" pitchFamily="34" charset="-120"/>
               </a:rPr>
-              <a:t>Construção e implantação — os sistemas no seu fluxo</a:t>
+              <a:t>Construção e implantação — a engenharia da solução</a:t>
             </a:r>
             <a:endParaRPr lang="en-US" sz="1450" dirty="0"/>
           </a:p>
@@ -2676,6 +2676,65 @@
         <p:spPr>
           <a:xfrm>
             <a:off x="1554480" y="8741664"/>
+            <a:ext cx="5230368" cy="566928"/>
+          </a:xfrm>
+          <a:prstGeom prst="rect">
+            <a:avLst/>
+          </a:prstGeom>
+          <a:noFill/>
+          <a:ln/>
+        </p:spPr>
+        <p:txBody>
+          <a:bodyPr wrap="square" lIns="0" tIns="0" rIns="0" bIns="0" rtlCol="0" anchor="ctr"/>
+          <a:lstStyle/>
+          <a:p>
+            <a:pPr indent="0" marL="0">
+              <a:lnSpc>
+                <a:spcPts val="1350"/>
+              </a:lnSpc>
+              <a:buNone/>
+            </a:pPr>
+            <a:r>
+              <a:rPr lang="en-US" sz="750" b="1" spc="200" kern="0" dirty="0">
+                <a:solidFill>
+                  <a:srgbClr val="B8985A"/>
+                </a:solidFill>
+                <a:latin typeface="Calibri" pitchFamily="34" charset="0"/>
+                <a:ea typeface="Calibri" pitchFamily="34" charset="-122"/>
+                <a:cs typeface="Calibri" pitchFamily="34" charset="-120"/>
+              </a:rPr>
+              <a:t>O QUÊ   </a:t>
+            </a:r>
+            <a:pPr indent="0" marL="0">
+              <a:lnSpc>
+                <a:spcPts val="1350"/>
+              </a:lnSpc>
+              <a:buNone/>
+            </a:pPr>
+            <a:r>
+              <a:rPr lang="en-US" sz="980" dirty="0">
+                <a:solidFill>
+                  <a:srgbClr val="232B3A"/>
+                </a:solidFill>
+                <a:latin typeface="Calibri" pitchFamily="34" charset="0"/>
+                <a:ea typeface="Calibri" pitchFamily="34" charset="-122"/>
+                <a:cs typeface="Calibri" pitchFamily="34" charset="-120"/>
+              </a:rPr>
+              <a:t>Projetamos a arquitetura da solução — dados, integrações, lógica de decisão — e construímos sistemas inteligentes sob medida, com agentes de IA inseridos onde fazem diferença, em produção no fluxo real da sua equipe.</a:t>
+            </a:r>
+            <a:endParaRPr lang="en-US" sz="750" dirty="0"/>
+          </a:p>
+        </p:txBody>
+      </p:sp>
+      <p:sp>
+        <p:nvSpPr>
+          <p:cNvPr id="26" name="Text 24"/>
+          <p:cNvSpPr/>
+          <p:nvPr/>
+        </p:nvSpPr>
+        <p:spPr>
+          <a:xfrm>
+            <a:off x="1554480" y="9390888"/>
             <a:ext cx="5230368" cy="320040"/>
           </a:xfrm>
           <a:prstGeom prst="rect">
@@ -2703,7 +2762,7 @@
                 <a:ea typeface="Calibri" pitchFamily="34" charset="-122"/>
                 <a:cs typeface="Calibri" pitchFamily="34" charset="-120"/>
               </a:rPr>
-              <a:t>O QUÊ   </a:t>
+              <a:t>POR QUÊ   </a:t>
             </a:r>
             <a:pPr indent="0" marL="0">
               <a:lnSpc>
@@ -2720,7 +2779,7 @@
                 <a:ea typeface="Calibri" pitchFamily="34" charset="-122"/>
                 <a:cs typeface="Calibri" pitchFamily="34" charset="-120"/>
               </a:rPr>
-              <a:t>Construímos os agentes de IA sob medida e colocamos em produção, dentro do fluxo de trabalho real da sua equipe.</a:t>
+              <a:t>Relatório na gaveta não muda empresa. Sistema rodando muda — deixa a operação mais eficiente, mais rápida e mais poderosa.</a:t>
             </a:r>
             <a:endParaRPr lang="en-US" sz="750" dirty="0"/>
           </a:p>
@@ -2728,72 +2787,13 @@
       </p:sp>
       <p:sp>
         <p:nvSpPr>
-          <p:cNvPr id="26" name="Text 24"/>
-          <p:cNvSpPr/>
-          <p:nvPr/>
-        </p:nvSpPr>
-        <p:spPr>
-          <a:xfrm>
-            <a:off x="1554480" y="9144000"/>
-            <a:ext cx="5230368" cy="320040"/>
-          </a:xfrm>
-          <a:prstGeom prst="rect">
-            <a:avLst/>
-          </a:prstGeom>
-          <a:noFill/>
-          <a:ln/>
-        </p:spPr>
-        <p:txBody>
-          <a:bodyPr wrap="square" lIns="0" tIns="0" rIns="0" bIns="0" rtlCol="0" anchor="ctr"/>
-          <a:lstStyle/>
-          <a:p>
-            <a:pPr indent="0" marL="0">
-              <a:lnSpc>
-                <a:spcPts val="1350"/>
-              </a:lnSpc>
-              <a:buNone/>
-            </a:pPr>
-            <a:r>
-              <a:rPr lang="en-US" sz="750" b="1" spc="200" kern="0" dirty="0">
-                <a:solidFill>
-                  <a:srgbClr val="B8985A"/>
-                </a:solidFill>
-                <a:latin typeface="Calibri" pitchFamily="34" charset="0"/>
-                <a:ea typeface="Calibri" pitchFamily="34" charset="-122"/>
-                <a:cs typeface="Calibri" pitchFamily="34" charset="-120"/>
-              </a:rPr>
-              <a:t>POR QUÊ   </a:t>
-            </a:r>
-            <a:pPr indent="0" marL="0">
-              <a:lnSpc>
-                <a:spcPts val="1350"/>
-              </a:lnSpc>
-              <a:buNone/>
-            </a:pPr>
-            <a:r>
-              <a:rPr lang="en-US" sz="980" dirty="0">
-                <a:solidFill>
-                  <a:srgbClr val="232B3A"/>
-                </a:solidFill>
-                <a:latin typeface="Calibri" pitchFamily="34" charset="0"/>
-                <a:ea typeface="Calibri" pitchFamily="34" charset="-122"/>
-                <a:cs typeface="Calibri" pitchFamily="34" charset="-120"/>
-              </a:rPr>
-              <a:t>Relatório na gaveta não muda empresa. Sistema rodando muda — deixa a operação mais eficiente, mais rápida e mais poderosa.</a:t>
-            </a:r>
-            <a:endParaRPr lang="en-US" sz="750" dirty="0"/>
-          </a:p>
-        </p:txBody>
-      </p:sp>
-      <p:sp>
-        <p:nvSpPr>
           <p:cNvPr id="27" name="Text 25"/>
           <p:cNvSpPr/>
           <p:nvPr/>
         </p:nvSpPr>
         <p:spPr>
           <a:xfrm>
-            <a:off x="1554480" y="9546336"/>
+            <a:off x="1554480" y="9793224"/>
             <a:ext cx="5230368" cy="320040"/>
           </a:xfrm>
           <a:prstGeom prst="rect">

</xml_diff>

<commit_message>
Ajuste de corpo do título da jornada (1 linha)
Co-Authored-By: Claude Fable 5 <noreply@anthropic.com>
Claude-Session: https://claude.ai/code/session_016RZJT8nVEB7u33HvjY5KvZ
</commit_message>
<xml_diff>
--- a/08-materiais/modelos/abba-apresentacao.pptx
+++ b/08-materiais/modelos/abba-apresentacao.pptx
@@ -1685,24 +1685,24 @@
         </p:nvSpPr>
         <p:spPr>
           <a:xfrm>
-            <a:off x="777240" y="932688"/>
-            <a:ext cx="6007608" cy="457200"/>
-          </a:xfrm>
-          <a:prstGeom prst="rect">
-            <a:avLst/>
-          </a:prstGeom>
-          <a:noFill/>
-          <a:ln/>
-        </p:spPr>
-        <p:txBody>
-          <a:bodyPr wrap="square" lIns="0" tIns="0" rIns="0" bIns="0" rtlCol="0" anchor="ctr"/>
-          <a:lstStyle/>
-          <a:p>
-            <a:pPr indent="0" marL="0">
-              <a:buNone/>
-            </a:pPr>
-            <a:r>
-              <a:rPr lang="en-US" sz="2100" b="1" dirty="0">
+            <a:off x="777240" y="950976"/>
+            <a:ext cx="6007608" cy="420624"/>
+          </a:xfrm>
+          <a:prstGeom prst="rect">
+            <a:avLst/>
+          </a:prstGeom>
+          <a:noFill/>
+          <a:ln/>
+        </p:spPr>
+        <p:txBody>
+          <a:bodyPr wrap="square" lIns="0" tIns="0" rIns="0" bIns="0" rtlCol="0" anchor="ctr"/>
+          <a:lstStyle/>
+          <a:p>
+            <a:pPr indent="0" marL="0">
+              <a:buNone/>
+            </a:pPr>
+            <a:r>
+              <a:rPr lang="en-US" sz="1800" b="1" dirty="0">
                 <a:solidFill>
                   <a:srgbClr val="1B2A4A"/>
                 </a:solidFill>
@@ -1712,7 +1712,7 @@
               </a:rPr>
               <a:t>Da primeira conversa aos sistemas rodando.</a:t>
             </a:r>
-            <a:endParaRPr lang="en-US" sz="2100" dirty="0"/>
+            <a:endParaRPr lang="en-US" sz="1800" dirty="0"/>
           </a:p>
         </p:txBody>
       </p:sp>

</xml_diff>

<commit_message>
Apresentação: remove parágrafo 'firma nova' e adiciona logos Microsoft/CrewAI (pedido do sócio)
- Página 3 da apresentação fecha direto na CTA, sem o parágrafo de firma nova
- Logos oficiais Microsoft e CrewAI nos dois documentos de envio, discretas mas visíveis
- Revisor: PASS nos dois documentos
- V-log: V3n (café→conversa, retroativo) e V3o registrados

Co-Authored-By: Claude Fable 5 <noreply@anthropic.com>
Claude-Session: https://claude.ai/code/session_016RZJT8nVEB7u33HvjY5KvZ
</commit_message>
<xml_diff>
--- a/08-materiais/modelos/abba-apresentacao.pptx
+++ b/08-materiais/modelos/abba-apresentacao.pptx
@@ -4016,7 +4016,7 @@
         <p:spPr>
           <a:xfrm>
             <a:off x="777240" y="8933688"/>
-            <a:ext cx="6007608" cy="320040"/>
+            <a:ext cx="6007608" cy="274320"/>
           </a:xfrm>
           <a:prstGeom prst="rect">
             <a:avLst/>
@@ -4060,57 +4060,63 @@
                 <a:ea typeface="Calibri" pitchFamily="34" charset="-122"/>
                 <a:cs typeface="Calibri" pitchFamily="34" charset="-120"/>
               </a:rPr>
-              <a:t>Microsoft e CrewAI — durante a capacitação, sua equipe usa ferramentas dos nossos parceiros para construir as próprias soluções.</a:t>
+              <a:t>Durante a capacitação, sua equipe usa ferramentas dos nossos parceiros para construir as próprias soluções.</a:t>
             </a:r>
             <a:endParaRPr lang="en-US" sz="750" dirty="0"/>
           </a:p>
         </p:txBody>
       </p:sp>
-      <p:sp>
-        <p:nvSpPr>
-          <p:cNvPr id="25" name="Text 23"/>
-          <p:cNvSpPr/>
-          <p:nvPr/>
-        </p:nvSpPr>
-        <p:spPr>
-          <a:xfrm>
-            <a:off x="777240" y="9299448"/>
-            <a:ext cx="6007608" cy="320040"/>
-          </a:xfrm>
-          <a:prstGeom prst="rect">
-            <a:avLst/>
-          </a:prstGeom>
-          <a:noFill/>
-          <a:ln/>
-        </p:spPr>
-        <p:txBody>
-          <a:bodyPr wrap="square" lIns="0" tIns="0" rIns="0" bIns="0" rtlCol="0" anchor="ctr"/>
-          <a:lstStyle/>
-          <a:p>
-            <a:pPr indent="0" marL="0">
-              <a:lnSpc>
-                <a:spcPts val="1250"/>
-              </a:lnSpc>
-              <a:buNone/>
-            </a:pPr>
-            <a:r>
-              <a:rPr lang="en-US" sz="900" i="1" dirty="0">
-                <a:solidFill>
-                  <a:srgbClr val="5A6472"/>
-                </a:solidFill>
-                <a:latin typeface="Calibri" pitchFamily="34" charset="0"/>
-                <a:ea typeface="Calibri" pitchFamily="34" charset="-122"/>
-                <a:cs typeface="Calibri" pitchFamily="34" charset="-120"/>
-              </a:rPr>
-              <a:t>Somos uma firma nova, e não inventamos histórico: o que mostramos é o método e o registro — mais do que a maioria consegue mostrar depois de dez clientes.</a:t>
-            </a:r>
-            <a:endParaRPr lang="en-US" sz="900" dirty="0"/>
-          </a:p>
-        </p:txBody>
-      </p:sp>
-      <p:sp>
-        <p:nvSpPr>
-          <p:cNvPr id="26" name="Text 24"/>
+      <p:pic>
+        <p:nvPicPr>
+          <p:cNvPr id="25" name="Image 0" descr="/tmp/claude-0/-home-user/3b340934-06d1-5f26-b467-4c811e620256/scratchpad/onepager/ms.png">    </p:cNvPr>
+          <p:cNvPicPr>
+            <a:picLocks noChangeAspect="1"/>
+          </p:cNvPicPr>
+          <p:nvPr/>
+        </p:nvPicPr>
+        <p:blipFill>
+          <a:blip r:embed="rId1"/>
+          <a:stretch>
+            <a:fillRect/>
+          </a:stretch>
+        </p:blipFill>
+        <p:spPr>
+          <a:xfrm>
+            <a:off x="777240" y="9317736"/>
+            <a:ext cx="1097280" cy="237744"/>
+          </a:xfrm>
+          <a:prstGeom prst="rect">
+            <a:avLst/>
+          </a:prstGeom>
+        </p:spPr>
+      </p:pic>
+      <p:pic>
+        <p:nvPicPr>
+          <p:cNvPr id="26" name="Image 1" descr="/tmp/claude-0/-home-user/3b340934-06d1-5f26-b467-4c811e620256/scratchpad/onepager/crewai-logo.png">    </p:cNvPr>
+          <p:cNvPicPr>
+            <a:picLocks noChangeAspect="1"/>
+          </p:cNvPicPr>
+          <p:nvPr/>
+        </p:nvPicPr>
+        <p:blipFill>
+          <a:blip r:embed="rId2"/>
+          <a:stretch>
+            <a:fillRect/>
+          </a:stretch>
+        </p:blipFill>
+        <p:spPr>
+          <a:xfrm>
+            <a:off x="2194560" y="9317736"/>
+            <a:ext cx="786384" cy="237744"/>
+          </a:xfrm>
+          <a:prstGeom prst="rect">
+            <a:avLst/>
+          </a:prstGeom>
+        </p:spPr>
+      </p:pic>
+      <p:sp>
+        <p:nvSpPr>
+          <p:cNvPr id="27" name="Text 23"/>
           <p:cNvSpPr/>
           <p:nvPr/>
         </p:nvSpPr>
@@ -4172,7 +4178,7 @@
       </p:sp>
       <p:sp>
         <p:nvSpPr>
-          <p:cNvPr id="27" name="Shape 25"/>
+          <p:cNvPr id="28" name="Shape 24"/>
           <p:cNvSpPr/>
           <p:nvPr/>
         </p:nvSpPr>
@@ -4195,7 +4201,7 @@
       </p:sp>
       <p:sp>
         <p:nvSpPr>
-          <p:cNvPr id="28" name="Text 26"/>
+          <p:cNvPr id="29" name="Text 25"/>
           <p:cNvSpPr/>
           <p:nvPr/>
         </p:nvSpPr>
@@ -4234,7 +4240,7 @@
       </p:sp>
       <p:sp>
         <p:nvSpPr>
-          <p:cNvPr id="29" name="Text 27"/>
+          <p:cNvPr id="30" name="Text 26"/>
           <p:cNvSpPr/>
           <p:nvPr/>
         </p:nvSpPr>

</xml_diff>

<commit_message>
Apresentacao: sai a metafora das raizes, saem todos os travessoes, e a analise gratuita passa a ser feita em cinco minutos na conversa
Pedido do socio (V3v): a frase do 'nosso processo' estava clichê e a
imagem das raizes/arvore saiu do documento inteiro; todos os travessoes
foram substituidos por virgula, dois-pontos ou ponto; o topico 1 e o
fecho da pagina 3 passam a dizer analise gratuita feita em menos de
cinco minutos durante a propria conversa, no lugar de documento em 48h.
A de uma pagina acompanha, para os dois enviaveis falarem igual.

Co-Authored-By: Claude Opus 5 <noreply@anthropic.com>
Claude-Session: https://claude.ai/code/session_016RZJT8nVEB7u33HvjY5KvZ
</commit_message>
<xml_diff>
--- a/08-materiais/modelos/abba-apresentacao.pptx
+++ b/08-materiais/modelos/abba-apresentacao.pptx
@@ -1248,7 +1248,7 @@
                 <a:ea typeface="Calibri" pitchFamily="34" charset="-122"/>
                 <a:cs typeface="Calibri" pitchFamily="34" charset="-120"/>
               </a:rPr>
-              <a:t>A ABBA é uma consultoria de inteligência artificial. Entramos na sua empresa para entendê-la a fundo, construímos as soluções certas para o seu fluxo de trabalho, validamos cada uma com dados reais antes de qualquer investimento pesado, formamos as suas pessoas — e ficamos ao seu lado acompanhando, mês a mês, o que mudou.</a:t>
+              <a:t>A ABBA é uma consultoria de inteligência artificial. Entramos na sua empresa para entendê-la a fundo, construímos as soluções certas para o seu fluxo de trabalho, validamos cada uma com dados reais antes de qualquer investimento pesado, formamos as suas pessoas e ficamos ao seu lado acompanhando, mês a mês, o que mudou.</a:t>
             </a:r>
             <a:endParaRPr lang="en-US" sz="1100" dirty="0"/>
           </a:p>
@@ -1262,7 +1262,7 @@
         </p:nvSpPr>
         <p:spPr>
           <a:xfrm>
-            <a:off x="777240" y="5029200"/>
+            <a:off x="777240" y="5138928"/>
             <a:ext cx="6007608" cy="914400"/>
           </a:xfrm>
           <a:prstGeom prst="rect">
@@ -1290,7 +1290,7 @@
                 <a:ea typeface="Calibri" pitchFamily="34" charset="-122"/>
                 <a:cs typeface="Calibri" pitchFamily="34" charset="-120"/>
               </a:rPr>
-              <a:t>O trabalho acontece em duas frentes ao mesmo tempo. Nos processos: projetamos e implantamos sistemas inteligentes — arquitetura, integrações e agentes de IA trabalhando em conjunto — que tornam a operação mais eficiente, mais rápida e mais poderosa. E nas pessoas: formamos cada nível da equipe para trabalhar com IA e enxergar o próprio trabalho de um jeito novo.</a:t>
+              <a:t>O trabalho acontece em duas frentes ao mesmo tempo. Nos processos: projetamos e implantamos sistemas inteligentes, com arquitetura, integrações e agentes de IA trabalhando em conjunto, que tornam a operação mais eficiente, mais rápida e mais poderosa. E nas pessoas: formamos cada nível da equipe para trabalhar com IA e enxergar o próprio trabalho de um jeito novo.</a:t>
             </a:r>
             <a:endParaRPr lang="en-US" sz="1100" dirty="0"/>
           </a:p>
@@ -1394,7 +1394,7 @@
                 <a:ea typeface="Cambria" pitchFamily="34" charset="-122"/>
                 <a:cs typeface="Cambria" pitchFamily="34" charset="-120"/>
               </a:rPr>
-              <a:t>Começa na diretoria e se estende, como raízes,</a:t>
+              <a:t>Começa com quem decide e só termina</a:t>
             </a:r>
             <a:endParaRPr lang="en-US" sz="1900" dirty="0"/>
           </a:p>
@@ -1414,7 +1414,7 @@
                 <a:ea typeface="Cambria" pitchFamily="34" charset="-122"/>
                 <a:cs typeface="Cambria" pitchFamily="34" charset="-120"/>
               </a:rPr>
-              <a:t>por toda a empresa — até alcançar cada pessoa,</a:t>
+              <a:t>quando chega a quem executa. Uma empresa</a:t>
             </a:r>
             <a:endParaRPr lang="en-US" sz="1900" dirty="0"/>
           </a:p>
@@ -1434,7 +1434,7 @@
                 <a:ea typeface="Cambria" pitchFamily="34" charset="-122"/>
                 <a:cs typeface="Cambria" pitchFamily="34" charset="-120"/>
               </a:rPr>
-              <a:t>em cada processo, todos os dias.</a:t>
+              <a:t>não muda por uma ponta só.</a:t>
             </a:r>
             <a:endParaRPr lang="en-US" sz="1900" dirty="0"/>
           </a:p>
@@ -1499,7 +1499,7 @@
                 <a:ea typeface="Calibri" pitchFamily="34" charset="-122"/>
                 <a:cs typeface="Calibri" pitchFamily="34" charset="-120"/>
               </a:rPr>
-              <a:t>Nas próximas páginas, o caminho completo — da primeira conversa à cadeira de estrategista na sua diretoria: o que fazemos em cada etapa, por quê, e como.</a:t>
+              <a:t>Nas próximas páginas, o caminho completo, da primeira conversa à cadeira de estrategista na sua diretoria: o que fazemos em cada etapa, por quê, e como.</a:t>
             </a:r>
             <a:endParaRPr lang="en-US" sz="1050" dirty="0"/>
           </a:p>
@@ -1561,7 +1561,7 @@
                 <a:ea typeface="Calibri" pitchFamily="34" charset="-122"/>
                 <a:cs typeface="Calibri" pitchFamily="34" charset="-120"/>
               </a:rPr>
-              <a:t>ABBA — CONSULTORIA DE INTELIGÊNCIA ARTIFICIAL</a:t>
+              <a:t>ABBA · CONSULTORIA DE INTELIGÊNCIA ARTIFICIAL</a:t>
             </a:r>
             <a:endParaRPr lang="en-US" sz="750" dirty="0"/>
           </a:p>
@@ -1749,7 +1749,7 @@
                 <a:ea typeface="Cambria" pitchFamily="34" charset="-122"/>
                 <a:cs typeface="Cambria" pitchFamily="34" charset="-120"/>
               </a:rPr>
-              <a:t>Cada etapa entrega algo inteiro sozinha — e produz o insumo da próxima.</a:t>
+              <a:t>Cada etapa entrega algo inteiro sozinha e produz o insumo da próxima.</a:t>
             </a:r>
             <a:endParaRPr lang="en-US" sz="1100" dirty="0"/>
           </a:p>
@@ -1763,7 +1763,7 @@
         </p:nvSpPr>
         <p:spPr>
           <a:xfrm>
-            <a:off x="722376" y="1874520"/>
+            <a:off x="722376" y="1810512"/>
             <a:ext cx="685800" cy="685800"/>
           </a:xfrm>
           <a:prstGeom prst="rect">
@@ -1802,7 +1802,7 @@
         </p:nvSpPr>
         <p:spPr>
           <a:xfrm>
-            <a:off x="1554480" y="1965960"/>
+            <a:off x="1554480" y="1901952"/>
             <a:ext cx="5230368" cy="292608"/>
           </a:xfrm>
           <a:prstGeom prst="rect">
@@ -1827,7 +1827,7 @@
                 <a:ea typeface="Cambria" pitchFamily="34" charset="-122"/>
                 <a:cs typeface="Cambria" pitchFamily="34" charset="-120"/>
               </a:rPr>
-              <a:t>A primeira conversa — e o Mapa de Vazamento</a:t>
+              <a:t>A primeira conversa, com a análise gratuita</a:t>
             </a:r>
             <a:endParaRPr lang="en-US" sz="1450" dirty="0"/>
           </a:p>
@@ -1841,7 +1841,7 @@
         </p:nvSpPr>
         <p:spPr>
           <a:xfrm>
-            <a:off x="1554480" y="2331720"/>
+            <a:off x="1554480" y="2267712"/>
             <a:ext cx="5230368" cy="457200"/>
           </a:xfrm>
           <a:prstGeom prst="rect">
@@ -1886,7 +1886,7 @@
                 <a:ea typeface="Calibri" pitchFamily="34" charset="-122"/>
                 <a:cs typeface="Calibri" pitchFamily="34" charset="-120"/>
               </a:rPr>
-              <a:t>45 minutos de conversa — e nós já chegamos com uma análise da sua empresa feita, com informação pública, incluindo uma estimativa em reais do que pode estar vazando na operação.</a:t>
+              <a:t>45 minutos de conversa e uma análise da sua empresa feita na hora, com informação pública, incluindo uma estimativa em reais do que pode estar vazando na operação.</a:t>
             </a:r>
             <a:endParaRPr lang="en-US" sz="750" dirty="0"/>
           </a:p>
@@ -1900,7 +1900,7 @@
         </p:nvSpPr>
         <p:spPr>
           <a:xfrm>
-            <a:off x="1554480" y="2871216"/>
+            <a:off x="1554480" y="2807208"/>
             <a:ext cx="5230368" cy="320040"/>
           </a:xfrm>
           <a:prstGeom prst="rect">
@@ -1959,8 +1959,8 @@
         </p:nvSpPr>
         <p:spPr>
           <a:xfrm>
-            <a:off x="1554480" y="3273552"/>
-            <a:ext cx="5230368" cy="320040"/>
+            <a:off x="1554480" y="3209544"/>
+            <a:ext cx="5230368" cy="384048"/>
           </a:xfrm>
           <a:prstGeom prst="rect">
             <a:avLst/>
@@ -2004,7 +2004,7 @@
                 <a:ea typeface="Calibri" pitchFamily="34" charset="-122"/>
                 <a:cs typeface="Calibri" pitchFamily="34" charset="-120"/>
               </a:rPr>
-              <a:t>Você recebe o documento em 48 horas, sem custo e sem compromisso. Se fizer sentido, seguimos.</a:t>
+              <a:t>Fica pronta em menos de cinco minutos, durante a própria conversa, sem custo e sem compromisso. Se fizer sentido, seguimos.</a:t>
             </a:r>
             <a:endParaRPr lang="en-US" sz="750" dirty="0"/>
           </a:p>
@@ -2105,7 +2105,7 @@
                 <a:ea typeface="Cambria" pitchFamily="34" charset="-122"/>
                 <a:cs typeface="Cambria" pitchFamily="34" charset="-120"/>
               </a:rPr>
-              <a:t>Assessment — o mergulho profundo</a:t>
+              <a:t>Assessment: o mergulho profundo</a:t>
             </a:r>
             <a:endParaRPr lang="en-US" sz="1450" dirty="0"/>
           </a:p>
@@ -2223,7 +2223,7 @@
                 <a:ea typeface="Calibri" pitchFamily="34" charset="-122"/>
                 <a:cs typeface="Calibri" pitchFamily="34" charset="-120"/>
               </a:rPr>
-              <a:t>Solução genérica falha. O que funciona nasce de entender o seu negócio — e não é o que a empresa acha que precisa: é o que o mergulho revela.</a:t>
+              <a:t>Solução genérica falha. O que funciona nasce de entender o seu negócio. E não é o que a empresa acha que precisa: é o que o mergulho revela.</a:t>
             </a:r>
             <a:endParaRPr lang="en-US" sz="750" dirty="0"/>
           </a:p>
@@ -2282,7 +2282,7 @@
                 <a:ea typeface="Calibri" pitchFamily="34" charset="-122"/>
                 <a:cs typeface="Calibri" pitchFamily="34" charset="-120"/>
               </a:rPr>
-              <a:t>Entrevistas em todos os níveis, com nossa ferramenta própria de análise. Você sai com um portfólio de oportunidades ranqueado e quantificado — não uma lista de ideias.</a:t>
+              <a:t>Entrevistas em todos os níveis, com nossa ferramenta própria de análise. Você sai com um portfólio de oportunidades ranqueado e quantificado, não uma lista de ideias.</a:t>
             </a:r>
             <a:endParaRPr lang="en-US" sz="750" dirty="0"/>
           </a:p>
@@ -2383,7 +2383,7 @@
                 <a:ea typeface="Cambria" pitchFamily="34" charset="-122"/>
                 <a:cs typeface="Cambria" pitchFamily="34" charset="-120"/>
               </a:rPr>
-              <a:t>Protótipo de caso de uso — a prova antes do investimento</a:t>
+              <a:t>Protótipo de caso de uso: a prova antes do investimento</a:t>
             </a:r>
             <a:endParaRPr lang="en-US" sz="1450" dirty="0"/>
           </a:p>
@@ -2501,7 +2501,7 @@
                 <a:ea typeface="Calibri" pitchFamily="34" charset="-122"/>
                 <a:cs typeface="Calibri" pitchFamily="34" charset="-120"/>
               </a:rPr>
-              <a:t>Ninguém investe no escuro. O protótipo é a prova antes do compromisso — e mata no papel a ideia que não fica de pé.</a:t>
+              <a:t>Ninguém investe no escuro. O protótipo é a prova antes do compromisso e mata no papel a ideia que não fica de pé.</a:t>
             </a:r>
             <a:endParaRPr lang="en-US" sz="750" dirty="0"/>
           </a:p>
@@ -2661,7 +2661,7 @@
                 <a:ea typeface="Cambria" pitchFamily="34" charset="-122"/>
                 <a:cs typeface="Cambria" pitchFamily="34" charset="-120"/>
               </a:rPr>
-              <a:t>Construção e implantação — a engenharia da solução</a:t>
+              <a:t>Construção e implantação: a engenharia da solução</a:t>
             </a:r>
             <a:endParaRPr lang="en-US" sz="1450" dirty="0"/>
           </a:p>
@@ -2720,7 +2720,7 @@
                 <a:ea typeface="Calibri" pitchFamily="34" charset="-122"/>
                 <a:cs typeface="Calibri" pitchFamily="34" charset="-120"/>
               </a:rPr>
-              <a:t>Projetamos a arquitetura da solução — dados, integrações, lógica de decisão — e construímos sistemas inteligentes sob medida, com agentes de IA inseridos onde fazem diferença, em produção no fluxo real da sua equipe.</a:t>
+              <a:t>Projetamos a arquitetura da solução, com dados, integrações e lógica de decisão, e construímos sistemas inteligentes sob medida, com agentes de IA inseridos onde fazem diferença, em produção no fluxo real da sua equipe.</a:t>
             </a:r>
             <a:endParaRPr lang="en-US" sz="750" dirty="0"/>
           </a:p>
@@ -2779,7 +2779,7 @@
                 <a:ea typeface="Calibri" pitchFamily="34" charset="-122"/>
                 <a:cs typeface="Calibri" pitchFamily="34" charset="-120"/>
               </a:rPr>
-              <a:t>Relatório na gaveta não muda empresa. Sistema rodando muda — deixa a operação mais eficiente, mais rápida e mais poderosa.</a:t>
+              <a:t>Relatório na gaveta não muda empresa. Sistema rodando muda: deixa a operação mais eficiente, mais rápida e mais poderosa.</a:t>
             </a:r>
             <a:endParaRPr lang="en-US" sz="750" dirty="0"/>
           </a:p>
@@ -2900,7 +2900,7 @@
                 <a:ea typeface="Calibri" pitchFamily="34" charset="-122"/>
                 <a:cs typeface="Calibri" pitchFamily="34" charset="-120"/>
               </a:rPr>
-              <a:t>ABBA — CONSULTORIA DE INTELIGÊNCIA ARTIFICIAL</a:t>
+              <a:t>ABBA · CONSULTORIA DE INTELIGÊNCIA ARTIFICIAL</a:t>
             </a:r>
             <a:endParaRPr lang="en-US" sz="750" dirty="0"/>
           </a:p>
@@ -3166,7 +3166,7 @@
                 <a:ea typeface="Cambria" pitchFamily="34" charset="-122"/>
                 <a:cs typeface="Cambria" pitchFamily="34" charset="-120"/>
               </a:rPr>
-              <a:t>Treinamento + ABBA Portal — a mentalidade nova</a:t>
+              <a:t>Treinamento + ABBA Portal: a mentalidade nova</a:t>
             </a:r>
             <a:endParaRPr lang="en-US" sz="1450" dirty="0"/>
           </a:p>
@@ -3225,7 +3225,7 @@
                 <a:ea typeface="Calibri" pitchFamily="34" charset="-122"/>
                 <a:cs typeface="Calibri" pitchFamily="34" charset="-120"/>
               </a:rPr>
-              <a:t>Formamos todos os níveis da equipe — na nossa plataforma própria (trilhas por nível, desafios práticos, um coach de IA disponível o tempo todo, credencial verificável ao graduar) e em sessões presenciais nos marcos do programa.</a:t>
+              <a:t>Formamos todos os níveis da equipe na nossa plataforma própria (trilhas por nível, desafios práticos, um coach de IA disponível o tempo todo, credencial verificável ao graduar) e em sessões presenciais nos marcos do programa.</a:t>
             </a:r>
             <a:endParaRPr lang="en-US" sz="750" dirty="0"/>
           </a:p>
@@ -3284,7 +3284,7 @@
                 <a:ea typeface="Calibri" pitchFamily="34" charset="-122"/>
                 <a:cs typeface="Calibri" pitchFamily="34" charset="-120"/>
               </a:rPr>
-              <a:t>É aqui que a árvore toca cada funcionário. O objetivo não é ensinar ferramenta — é instalar, em cada pessoa, três perguntas que mudam o jeito de olhar o próprio trabalho:</a:t>
+              <a:t>É aqui que o programa chega a cada funcionário. O objetivo não é ensinar ferramenta. É instalar, em cada pessoa, três perguntas que mudam o jeito de olhar o próprio trabalho:</a:t>
             </a:r>
             <a:endParaRPr lang="en-US" sz="750" dirty="0"/>
           </a:p>
@@ -3346,7 +3346,7 @@
                 <a:ea typeface="Cambria" pitchFamily="34" charset="-122"/>
                 <a:cs typeface="Cambria" pitchFamily="34" charset="-120"/>
               </a:rPr>
-              <a:t>O que eu posso parar de fazer — porque a IA agora faz?</a:t>
+              <a:t>O que eu posso parar de fazer, porque a IA agora faz?</a:t>
             </a:r>
             <a:endParaRPr lang="en-US" sz="1150" dirty="0"/>
           </a:p>
@@ -3366,7 +3366,7 @@
                 <a:ea typeface="Cambria" pitchFamily="34" charset="-122"/>
                 <a:cs typeface="Cambria" pitchFamily="34" charset="-120"/>
               </a:rPr>
-              <a:t>O que eu posso começar a fazer — porque a IA agora permite?</a:t>
+              <a:t>O que eu posso começar a fazer, porque a IA agora permite?</a:t>
             </a:r>
             <a:endParaRPr lang="en-US" sz="1150" dirty="0"/>
           </a:p>
@@ -3386,7 +3386,7 @@
                 <a:ea typeface="Cambria" pitchFamily="34" charset="-122"/>
                 <a:cs typeface="Cambria" pitchFamily="34" charset="-120"/>
               </a:rPr>
-              <a:t>O que só eu faço — e devo fazer ainda melhor?</a:t>
+              <a:t>O que só eu faço, e devo fazer ainda melhor?</a:t>
             </a:r>
             <a:endParaRPr lang="en-US" sz="1150" dirty="0"/>
           </a:p>
@@ -3445,7 +3445,7 @@
                 <a:ea typeface="Calibri" pitchFamily="34" charset="-122"/>
                 <a:cs typeface="Calibri" pitchFamily="34" charset="-120"/>
               </a:rPr>
-              <a:t>Campeões internos formados carregam a transformação depois que saímos da sala. Quando a organização inteira pensa assim, a mudança deixa de depender de consultor — e a capacidade fica com vocês.</a:t>
+              <a:t>Campeões internos formados carregam a transformação depois que saímos da sala. Quando a organização inteira pensa assim, a mudança deixa de depender de consultor, e a capacidade fica com vocês.</a:t>
             </a:r>
             <a:endParaRPr lang="en-US" sz="750" dirty="0"/>
           </a:p>
@@ -3546,7 +3546,7 @@
                 <a:ea typeface="Cambria" pitchFamily="34" charset="-122"/>
                 <a:cs typeface="Cambria" pitchFamily="34" charset="-120"/>
               </a:rPr>
-              <a:t>Sistemas gerenciados — a operação com presença</a:t>
+              <a:t>Sistemas gerenciados: a operação com presença</a:t>
             </a:r>
             <a:endParaRPr lang="en-US" sz="1450" dirty="0"/>
           </a:p>
@@ -3664,7 +3664,7 @@
                 <a:ea typeface="Calibri" pitchFamily="34" charset="-122"/>
                 <a:cs typeface="Calibri" pitchFamily="34" charset="-120"/>
               </a:rPr>
-              <a:t>Sistema sem dono definha. E a diretoria precisa ver o retorno — não sentir que ele existe.</a:t>
+              <a:t>Sistema sem dono definha. E a diretoria precisa ver o retorno, não sentir que ele existe.</a:t>
             </a:r>
             <a:endParaRPr lang="en-US" sz="750" dirty="0"/>
           </a:p>
@@ -3824,7 +3824,7 @@
                 <a:ea typeface="Cambria" pitchFamily="34" charset="-122"/>
                 <a:cs typeface="Cambria" pitchFamily="34" charset="-120"/>
               </a:rPr>
-              <a:t>Conselheiro de IA — do seu lado da mesa</a:t>
+              <a:t>Conselheiro de IA: do seu lado da mesa</a:t>
             </a:r>
             <a:endParaRPr lang="en-US" sz="1450" dirty="0"/>
           </a:p>
@@ -4001,7 +4001,7 @@
                 <a:ea typeface="Calibri" pitchFamily="34" charset="-122"/>
                 <a:cs typeface="Calibri" pitchFamily="34" charset="-120"/>
               </a:rPr>
-              <a:t>Presença recorrente na diretoria, com cada recomendação registrada. Também para quem já tem IA rodando — não precisa do programa para ter a cadeira.</a:t>
+              <a:t>Presença recorrente na diretoria, com cada recomendação registrada. Também para quem já tem IA rodando: não precisa do programa para ter a cadeira.</a:t>
             </a:r>
             <a:endParaRPr lang="en-US" sz="750" dirty="0"/>
           </a:p>
@@ -4150,7 +4150,7 @@
                 <a:ea typeface="Cambria" pitchFamily="34" charset="-122"/>
                 <a:cs typeface="Cambria" pitchFamily="34" charset="-120"/>
               </a:rPr>
-              <a:t>A história começa com uma conversa de 45 minutos —</a:t>
+              <a:t>A história começa com uma conversa de 45 minutos</a:t>
             </a:r>
             <a:endParaRPr lang="en-US" sz="1350" dirty="0"/>
           </a:p>
@@ -4170,7 +4170,7 @@
                 <a:ea typeface="Cambria" pitchFamily="34" charset="-122"/>
                 <a:cs typeface="Cambria" pitchFamily="34" charset="-120"/>
               </a:rPr>
-              <a:t>e com o seu Mapa de Vazamento, gratuito, em 48 horas.</a:t>
+              <a:t>e com a sua análise gratuita, feita em cinco minutos.</a:t>
             </a:r>
             <a:endParaRPr lang="en-US" sz="1350" dirty="0"/>
           </a:p>
@@ -4232,7 +4232,7 @@
                 <a:ea typeface="Calibri" pitchFamily="34" charset="-122"/>
                 <a:cs typeface="Calibri" pitchFamily="34" charset="-120"/>
               </a:rPr>
-              <a:t>ABBA — CONSULTORIA DE IA</a:t>
+              <a:t>ABBA · CONSULTORIA DE IA</a:t>
             </a:r>
             <a:endParaRPr lang="en-US" sz="750" dirty="0"/>
           </a:p>

</xml_diff>

<commit_message>
Materiais na voz do pitch: sem travessão, fases por dentro, Conselheiro mecânico
Feedback do sócio (2026-09-01): travessões removidos de todo material
oficial (regra registrada no §0); os textos dos 5 materiais reescritos
na voz do pitch do palco (IA na ponta vs. na veia, mesa de três pés, a
primeira parede paga a fundação, número combinado antes e medido depois);
slide novo no deck do Programa mostrando o que cada capacidade faz em
cada fase, por informação; Conselheiro demonstrado pelo mecanismo em
quatro movimentos, não só pela imagem; slide de exemplo real de metas
combinadas (proposta de agosto/2026, empresa preservada); fotos novas do
portal capturadas do portal vigente (sessão demo) substituem o print
antigo.

Co-Authored-By: Claude <noreply@anthropic.com>
Claude-Session: https://claude.ai/code/session_016RZJT8nVEB7u33HvjY5KvZ
</commit_message>
<xml_diff>
--- a/08-materiais/modelos/abba-apresentacao.pptx
+++ b/08-materiais/modelos/abba-apresentacao.pptx
@@ -1061,7 +1061,7 @@
         </p:nvSpPr>
         <p:spPr>
           <a:xfrm>
-            <a:off x="822960" y="685800"/>
+            <a:off x="822960" y="640080"/>
             <a:ext cx="5486400" cy="292608"/>
           </a:xfrm>
           <a:prstGeom prst="rect">
@@ -1100,8 +1100,8 @@
         </p:nvSpPr>
         <p:spPr>
           <a:xfrm>
-            <a:off x="822960" y="1051560"/>
-            <a:ext cx="10543032" cy="1051560"/>
+            <a:off x="822960" y="1005840"/>
+            <a:ext cx="10543032" cy="1005840"/>
           </a:xfrm>
           <a:prstGeom prst="rect">
             <a:avLst/>
@@ -1139,7 +1139,7 @@
         </p:nvSpPr>
         <p:spPr>
           <a:xfrm>
-            <a:off x="822960" y="2212848"/>
+            <a:off x="822960" y="2121408"/>
             <a:ext cx="2011680" cy="0"/>
           </a:xfrm>
           <a:prstGeom prst="line">
@@ -1162,8 +1162,8 @@
         </p:nvSpPr>
         <p:spPr>
           <a:xfrm>
-            <a:off x="822960" y="2468880"/>
-            <a:ext cx="10543032" cy="1371600"/>
+            <a:off x="822960" y="2377440"/>
+            <a:ext cx="10543032" cy="1325880"/>
           </a:xfrm>
           <a:prstGeom prst="rect">
             <a:avLst/>
@@ -1177,12 +1177,12 @@
           <a:p>
             <a:pPr algn="l" indent="0" marL="0">
               <a:lnSpc>
-                <a:spcPts val="2400"/>
+                <a:spcPts val="2300"/>
               </a:lnSpc>
               <a:buNone/>
             </a:pPr>
             <a:r>
-              <a:rPr lang="en-US" sz="1550" dirty="0">
+              <a:rPr lang="en-US" sz="1500" dirty="0">
                 <a:solidFill>
                   <a:srgbClr val="33394A"/>
                 </a:solidFill>
@@ -1190,9 +1190,9 @@
                 <a:ea typeface="Calibri" pitchFamily="34" charset="-122"/>
                 <a:cs typeface="Calibri" pitchFamily="34" charset="-120"/>
               </a:rPr>
-              <a:t>A ABBA faz duas coisas que não dá para fazer de dentro de uma empresa: constrói capacidade de IA em escala, com arquitetura, integrações e agentes trabalhando em conjunto e um time inteiro formado, e prova, como terceiro, o que mudou: cada decisão com o número que ela precisa mover, combinado antes, medido depois, assinado por gente. No fim, a diretoria tem prova, não impressão.</a:t>
-            </a:r>
-            <a:endParaRPr lang="en-US" sz="1550" dirty="0"/>
+              <a:t>De cada dez empresas que decidiram usar IA este ano, mais de oito não vão conseguir mostrar um número no fim. E não é por falta de tecnologia: é porque a IA entrou pelo lugar errado. Quando entra pela ponta, uma pessoa pede e recebe, e o ganho fica com ela. Se ela sai amanhã, o ganho sai junto pela porta. Quando entra pela veia, dentro do processo, o organismo passa a funcionar diferente. E o ganho fica na empresa.</a:t>
+            </a:r>
+            <a:endParaRPr lang="en-US" sz="1500" dirty="0"/>
           </a:p>
         </p:txBody>
       </p:sp>
@@ -1205,7 +1205,7 @@
         <p:spPr>
           <a:xfrm>
             <a:off x="822960" y="3794760"/>
-            <a:ext cx="10543032" cy="1005840"/>
+            <a:ext cx="10543032" cy="1234440"/>
           </a:xfrm>
           <a:prstGeom prst="rect">
             <a:avLst/>
@@ -1219,7 +1219,7 @@
           <a:p>
             <a:pPr algn="l" indent="0" marL="0">
               <a:lnSpc>
-                <a:spcPts val="2100"/>
+                <a:spcPts val="2000"/>
               </a:lnSpc>
               <a:buNone/>
             </a:pPr>
@@ -1232,7 +1232,7 @@
                 <a:ea typeface="Calibri" pitchFamily="34" charset="-122"/>
                 <a:cs typeface="Calibri" pitchFamily="34" charset="-120"/>
               </a:rPr>
-              <a:t>A maioria dos projetos de IA não falha na tecnologia. A pesquisa mais séria que existe, da RAND, mediu: mais de 80% falham, o dobro dos projetos comuns de tecnologia, e a causa número um é começar sem combinar o que seria dar certo. É exatamente aí que trabalhamos.</a:t>
+              <a:t>A pesquisa mais séria que existe sobre isso, da RAND, mediu: mais de 80% dos projetos de IA falham, o dobro dos projetos comuns de tecnologia. A causa número um não foi a qualidade do modelo. Foi começar sem ninguém combinar o que seria dar certo. É exatamente aí que trabalhamos: escolhemos um processo que dói, fazemos a IA rodar dentro dele até virar parte da operação, formamos as pessoas que vivem nesse processo e provamos, de fora, o que mudou. Número combinado antes, medido depois. No fim, a diretoria tem prova, não impressão.</a:t>
             </a:r>
             <a:endParaRPr lang="en-US" sz="1350" dirty="0"/>
           </a:p>
@@ -1246,7 +1246,7 @@
         </p:nvSpPr>
         <p:spPr>
           <a:xfrm>
-            <a:off x="822960" y="4892040"/>
+            <a:off x="822960" y="5120640"/>
             <a:ext cx="10543032" cy="0"/>
           </a:xfrm>
           <a:prstGeom prst="line">
@@ -1269,7 +1269,7 @@
         </p:nvSpPr>
         <p:spPr>
           <a:xfrm>
-            <a:off x="822960" y="5074920"/>
+            <a:off x="822960" y="5285232"/>
             <a:ext cx="5486400" cy="292608"/>
           </a:xfrm>
           <a:prstGeom prst="rect">
@@ -1308,8 +1308,8 @@
         </p:nvSpPr>
         <p:spPr>
           <a:xfrm>
-            <a:off x="822960" y="5440680"/>
-            <a:ext cx="10543032" cy="914400"/>
+            <a:off x="822960" y="5614416"/>
+            <a:ext cx="10543032" cy="777240"/>
           </a:xfrm>
           <a:prstGeom prst="rect">
             <a:avLst/>
@@ -1323,12 +1323,12 @@
           <a:p>
             <a:pPr algn="l" indent="0" marL="0">
               <a:lnSpc>
-                <a:spcPts val="2100"/>
+                <a:spcPts val="1950"/>
               </a:lnSpc>
               <a:buNone/>
             </a:pPr>
             <a:r>
-              <a:rPr lang="en-US" sz="1350" i="1" dirty="0">
+              <a:rPr lang="en-US" sz="1300" i="1" dirty="0">
                 <a:solidFill>
                   <a:srgbClr val="33394A"/>
                 </a:solidFill>
@@ -1336,9 +1336,9 @@
                 <a:ea typeface="Cambria" pitchFamily="34" charset="-122"/>
                 <a:cs typeface="Cambria" pitchFamily="34" charset="-120"/>
               </a:rPr>
-              <a:t>Trabalhamos com raízes: verdade dita mesmo quando custa, número antes de opinião, e o compromisso de nos tornarmos desnecessários no operacional. O que instalamos fica com você — os sistemas, as pessoas formadas e o registro de tudo o que foi decidido e medido.</a:t>
-            </a:r>
-            <a:endParaRPr lang="en-US" sz="1350" dirty="0"/>
+              <a:t>Trabalhamos com raízes: verdade dita mesmo quando custa, número antes de opinião, e o compromisso de terminar com a sua empresa mais capaz, não mais dependente. O que instalamos fica com você: os sistemas, as pessoas formadas e o registro de tudo o que foi decidido e medido.</a:t>
+            </a:r>
+            <a:endParaRPr lang="en-US" sz="1300" dirty="0"/>
           </a:p>
         </p:txBody>
       </p:sp>
@@ -1421,7 +1421,7 @@
         </p:nvSpPr>
         <p:spPr>
           <a:xfrm>
-            <a:off x="822960" y="594360"/>
+            <a:off x="822960" y="548640"/>
             <a:ext cx="5486400" cy="292608"/>
           </a:xfrm>
           <a:prstGeom prst="rect">
@@ -1460,8 +1460,8 @@
         </p:nvSpPr>
         <p:spPr>
           <a:xfrm>
-            <a:off x="822960" y="914400"/>
-            <a:ext cx="10543032" cy="777240"/>
+            <a:off x="822960" y="868680"/>
+            <a:ext cx="10543032" cy="731520"/>
           </a:xfrm>
           <a:prstGeom prst="rect">
             <a:avLst/>
@@ -1477,7 +1477,7 @@
               <a:buNone/>
             </a:pPr>
             <a:r>
-              <a:rPr lang="en-US" sz="2600" b="1" dirty="0">
+              <a:rPr lang="en-US" sz="2500" b="1" dirty="0">
                 <a:solidFill>
                   <a:srgbClr val="1B2A4A"/>
                 </a:solidFill>
@@ -1487,7 +1487,7 @@
               </a:rPr>
               <a:t>Da primeira conversa à capacidade instalada: um programa, um ano.</a:t>
             </a:r>
-            <a:endParaRPr lang="en-US" sz="2600" dirty="0"/>
+            <a:endParaRPr lang="en-US" sz="2500" dirty="0"/>
           </a:p>
         </p:txBody>
       </p:sp>
@@ -1499,8 +1499,8 @@
         </p:nvSpPr>
         <p:spPr>
           <a:xfrm>
-            <a:off x="822960" y="1737360"/>
-            <a:ext cx="10543032" cy="640080"/>
+            <a:off x="822960" y="1627632"/>
+            <a:ext cx="10543032" cy="658368"/>
           </a:xfrm>
           <a:prstGeom prst="rect">
             <a:avLst/>
@@ -1514,12 +1514,12 @@
           <a:p>
             <a:pPr algn="l" indent="0" marL="0">
               <a:lnSpc>
-                <a:spcPts val="2000"/>
+                <a:spcPts val="1850"/>
               </a:lnSpc>
               <a:buNone/>
             </a:pPr>
             <a:r>
-              <a:rPr lang="en-US" sz="1300" dirty="0">
+              <a:rPr lang="en-US" sz="1250" dirty="0">
                 <a:solidFill>
                   <a:srgbClr val="6E6858"/>
                 </a:solidFill>
@@ -1527,9 +1527,9 @@
                 <a:ea typeface="Calibri" pitchFamily="34" charset="-122"/>
                 <a:cs typeface="Calibri" pitchFamily="34" charset="-120"/>
               </a:rPr>
-              <a:t>Tudo começa com um mapa do que estimamos estar vazando, feito de fora e sem custo. Se fizer sentido, o programa percorre três fases — e você tem uma porta de saída limpa em cada uma delas.</a:t>
-            </a:r>
-            <a:endParaRPr lang="en-US" sz="1300" dirty="0"/>
+              <a:t>Tudo começa com um mapa do que estimamos estar vazando, feito de fora e sem custo. Ninguém espera o terreno ficar perfeito para começar a obra: escolhemos juntos a primeira parede, e é ela que paga a fundação do resto. Cada fase termina numa porta de saída limpa.</a:t>
+            </a:r>
+            <a:endParaRPr lang="en-US" sz="1250" dirty="0"/>
           </a:p>
         </p:txBody>
       </p:sp>
@@ -1541,7 +1541,7 @@
         </p:nvSpPr>
         <p:spPr>
           <a:xfrm>
-            <a:off x="822960" y="2514600"/>
+            <a:off x="822960" y="2395728"/>
             <a:ext cx="3270504" cy="0"/>
           </a:xfrm>
           <a:prstGeom prst="line">
@@ -1564,7 +1564,7 @@
         </p:nvSpPr>
         <p:spPr>
           <a:xfrm>
-            <a:off x="822960" y="2651760"/>
+            <a:off x="822960" y="2523744"/>
             <a:ext cx="3270504" cy="292608"/>
           </a:xfrm>
           <a:prstGeom prst="rect">
@@ -1603,8 +1603,8 @@
         </p:nvSpPr>
         <p:spPr>
           <a:xfrm>
-            <a:off x="822960" y="2926080"/>
-            <a:ext cx="3270504" cy="274320"/>
+            <a:off x="822960" y="2798064"/>
+            <a:ext cx="3270504" cy="256032"/>
           </a:xfrm>
           <a:prstGeom prst="rect">
             <a:avLst/>
@@ -1620,7 +1620,7 @@
               <a:buNone/>
             </a:pPr>
             <a:r>
-              <a:rPr lang="en-US" sz="1200" i="1" dirty="0">
+              <a:rPr lang="en-US" sz="1150" i="1" dirty="0">
                 <a:solidFill>
                   <a:srgbClr val="6E6858"/>
                 </a:solidFill>
@@ -1630,7 +1630,7 @@
               </a:rPr>
               <a:t>seis semanas</a:t>
             </a:r>
-            <a:endParaRPr lang="en-US" sz="1200" dirty="0"/>
+            <a:endParaRPr lang="en-US" sz="1150" dirty="0"/>
           </a:p>
         </p:txBody>
       </p:sp>
@@ -1642,8 +1642,8 @@
         </p:nvSpPr>
         <p:spPr>
           <a:xfrm>
-            <a:off x="822960" y="3246120"/>
-            <a:ext cx="3270504" cy="1737360"/>
+            <a:off x="822960" y="3090672"/>
+            <a:ext cx="3270504" cy="1005840"/>
           </a:xfrm>
           <a:prstGeom prst="rect">
             <a:avLst/>
@@ -1657,7 +1657,7 @@
           <a:p>
             <a:pPr algn="l" indent="0" marL="0">
               <a:lnSpc>
-                <a:spcPts val="1650"/>
+                <a:spcPts val="1600"/>
               </a:lnSpc>
               <a:buNone/>
             </a:pPr>
@@ -1670,7 +1670,7 @@
                 <a:ea typeface="Calibri" pitchFamily="34" charset="-122"/>
                 <a:cs typeface="Calibri" pitchFamily="34" charset="-120"/>
               </a:rPr>
-              <a:t>Mergulho nos processos onde o dinheiro vaza e um caso construído com os seus dados, rodando e medido contra a métrica combinada por escrito na primeira semana — mais o portfólio completo de oportunidades, ranqueado.</a:t>
+              <a:t>Um caso construído com os seus dados, rodando e medido contra a métrica combinada por escrito na primeira semana.</a:t>
             </a:r>
             <a:endParaRPr lang="en-US" sz="1150" dirty="0"/>
           </a:p>
@@ -1684,8 +1684,8 @@
         </p:nvSpPr>
         <p:spPr>
           <a:xfrm>
-            <a:off x="822960" y="5029200"/>
-            <a:ext cx="3270504" cy="1097280"/>
+            <a:off x="822960" y="4133088"/>
+            <a:ext cx="3270504" cy="1417320"/>
           </a:xfrm>
           <a:prstGeom prst="rect">
             <a:avLst/>
@@ -1699,12 +1699,12 @@
           <a:p>
             <a:pPr algn="l" indent="0" marL="0">
               <a:lnSpc>
-                <a:spcPts val="1550"/>
+                <a:spcPts val="1500"/>
               </a:lnSpc>
               <a:buNone/>
             </a:pPr>
             <a:r>
-              <a:rPr lang="en-US" sz="1050" i="1" dirty="0">
+              <a:rPr lang="en-US" sz="1050" dirty="0">
                 <a:solidFill>
                   <a:srgbClr val="6E6858"/>
                 </a:solidFill>
@@ -1712,7 +1712,7 @@
                 <a:ea typeface="Calibri" pitchFamily="34" charset="-122"/>
                 <a:cs typeface="Calibri" pitchFamily="34" charset="-120"/>
               </a:rPr>
-              <a:t>Porque promessa não decide investimento; número decide. Você delibera sobre o ano inteiro com um caso provado na mesa.</a:t>
+              <a:t>Dentro dela: a avaliação profunda, do conselho à linha de frente · o protótipo em uso real · o retrato completo de oportunidades, ranqueado por retorno e esforço.</a:t>
             </a:r>
             <a:endParaRPr lang="en-US" sz="1050" dirty="0"/>
           </a:p>
@@ -1720,13 +1720,55 @@
       </p:sp>
       <p:sp>
         <p:nvSpPr>
-          <p:cNvPr id="10" name="Shape 8"/>
-          <p:cNvSpPr/>
-          <p:nvPr/>
-        </p:nvSpPr>
-        <p:spPr>
-          <a:xfrm>
-            <a:off x="4459224" y="2514600"/>
+          <p:cNvPr id="10" name="Text 8"/>
+          <p:cNvSpPr/>
+          <p:nvPr/>
+        </p:nvSpPr>
+        <p:spPr>
+          <a:xfrm>
+            <a:off x="822960" y="5577840"/>
+            <a:ext cx="3270504" cy="566928"/>
+          </a:xfrm>
+          <a:prstGeom prst="rect">
+            <a:avLst/>
+          </a:prstGeom>
+          <a:noFill/>
+          <a:ln/>
+        </p:spPr>
+        <p:txBody>
+          <a:bodyPr wrap="square" rtlCol="0" anchor="ctr"/>
+          <a:lstStyle/>
+          <a:p>
+            <a:pPr algn="l" indent="0" marL="0">
+              <a:lnSpc>
+                <a:spcPts val="1500"/>
+              </a:lnSpc>
+              <a:buNone/>
+            </a:pPr>
+            <a:r>
+              <a:rPr lang="en-US" sz="1050" i="1" dirty="0">
+                <a:solidFill>
+                  <a:srgbClr val="1B2A4A"/>
+                </a:solidFill>
+                <a:latin typeface="Calibri" pitchFamily="34" charset="0"/>
+                <a:ea typeface="Calibri" pitchFamily="34" charset="-122"/>
+                <a:cs typeface="Calibri" pitchFamily="34" charset="-120"/>
+              </a:rPr>
+              <a:t>Porque promessa não decide investimento. Número decide.</a:t>
+            </a:r>
+            <a:endParaRPr lang="en-US" sz="1050" dirty="0"/>
+          </a:p>
+        </p:txBody>
+      </p:sp>
+      <p:sp>
+        <p:nvSpPr>
+          <p:cNvPr id="11" name="Shape 9"/>
+          <p:cNvSpPr/>
+          <p:nvPr/>
+        </p:nvSpPr>
+        <p:spPr>
+          <a:xfrm>
+            <a:off x="4459224" y="2395728"/>
             <a:ext cx="3270504" cy="0"/>
           </a:xfrm>
           <a:prstGeom prst="line">
@@ -1743,13 +1785,13 @@
       </p:sp>
       <p:sp>
         <p:nvSpPr>
-          <p:cNvPr id="11" name="Text 9"/>
-          <p:cNvSpPr/>
-          <p:nvPr/>
-        </p:nvSpPr>
-        <p:spPr>
-          <a:xfrm>
-            <a:off x="4459224" y="2651760"/>
+          <p:cNvPr id="12" name="Text 10"/>
+          <p:cNvSpPr/>
+          <p:nvPr/>
+        </p:nvSpPr>
+        <p:spPr>
+          <a:xfrm>
+            <a:off x="4459224" y="2523744"/>
             <a:ext cx="3270504" cy="292608"/>
           </a:xfrm>
           <a:prstGeom prst="rect">
@@ -1782,14 +1824,14 @@
       </p:sp>
       <p:sp>
         <p:nvSpPr>
-          <p:cNvPr id="12" name="Text 10"/>
-          <p:cNvSpPr/>
-          <p:nvPr/>
-        </p:nvSpPr>
-        <p:spPr>
-          <a:xfrm>
-            <a:off x="4459224" y="2926080"/>
-            <a:ext cx="3270504" cy="274320"/>
+          <p:cNvPr id="13" name="Text 11"/>
+          <p:cNvSpPr/>
+          <p:nvPr/>
+        </p:nvSpPr>
+        <p:spPr>
+          <a:xfrm>
+            <a:off x="4459224" y="2798064"/>
+            <a:ext cx="3270504" cy="256032"/>
           </a:xfrm>
           <a:prstGeom prst="rect">
             <a:avLst/>
@@ -1805,7 +1847,7 @@
               <a:buNone/>
             </a:pPr>
             <a:r>
-              <a:rPr lang="en-US" sz="1200" i="1" dirty="0">
+              <a:rPr lang="en-US" sz="1150" i="1" dirty="0">
                 <a:solidFill>
                   <a:srgbClr val="6E6858"/>
                 </a:solidFill>
@@ -1815,20 +1857,20 @@
               </a:rPr>
               <a:t>meses dois a seis</a:t>
             </a:r>
-            <a:endParaRPr lang="en-US" sz="1200" dirty="0"/>
-          </a:p>
-        </p:txBody>
-      </p:sp>
-      <p:sp>
-        <p:nvSpPr>
-          <p:cNvPr id="13" name="Text 11"/>
-          <p:cNvSpPr/>
-          <p:nvPr/>
-        </p:nvSpPr>
-        <p:spPr>
-          <a:xfrm>
-            <a:off x="4459224" y="3246120"/>
-            <a:ext cx="3270504" cy="1737360"/>
+            <a:endParaRPr lang="en-US" sz="1150" dirty="0"/>
+          </a:p>
+        </p:txBody>
+      </p:sp>
+      <p:sp>
+        <p:nvSpPr>
+          <p:cNvPr id="14" name="Text 12"/>
+          <p:cNvSpPr/>
+          <p:nvPr/>
+        </p:nvSpPr>
+        <p:spPr>
+          <a:xfrm>
+            <a:off x="4459224" y="3090672"/>
+            <a:ext cx="3270504" cy="1005840"/>
           </a:xfrm>
           <a:prstGeom prst="rect">
             <a:avLst/>
@@ -1842,7 +1884,7 @@
           <a:p>
             <a:pPr algn="l" indent="0" marL="0">
               <a:lnSpc>
-                <a:spcPts val="1650"/>
+                <a:spcPts val="1600"/>
               </a:lnSpc>
               <a:buNone/>
             </a:pPr>
@@ -1855,7 +1897,7 @@
                 <a:ea typeface="Calibri" pitchFamily="34" charset="-122"/>
                 <a:cs typeface="Calibri" pitchFamily="34" charset="-120"/>
               </a:rPr>
-              <a:t>Os casos aprovados entram em produção, com arquitetura, integrações e agentes de IA com pontos de aprovação humana — e a sua equipe é formada em turma própria, com fluência medida em 30, 60 e 90 dias.</a:t>
+              <a:t>Os casos aprovados entram em produção e a sua equipe aprende a operar e a criar junto.</a:t>
             </a:r>
             <a:endParaRPr lang="en-US" sz="1150" dirty="0"/>
           </a:p>
@@ -1863,14 +1905,14 @@
       </p:sp>
       <p:sp>
         <p:nvSpPr>
-          <p:cNvPr id="14" name="Text 12"/>
-          <p:cNvSpPr/>
-          <p:nvPr/>
-        </p:nvSpPr>
-        <p:spPr>
-          <a:xfrm>
-            <a:off x="4459224" y="5029200"/>
-            <a:ext cx="3270504" cy="1097280"/>
+          <p:cNvPr id="15" name="Text 13"/>
+          <p:cNvSpPr/>
+          <p:nvPr/>
+        </p:nvSpPr>
+        <p:spPr>
+          <a:xfrm>
+            <a:off x="4459224" y="4133088"/>
+            <a:ext cx="3270504" cy="1417320"/>
           </a:xfrm>
           <a:prstGeom prst="rect">
             <a:avLst/>
@@ -1884,12 +1926,12 @@
           <a:p>
             <a:pPr algn="l" indent="0" marL="0">
               <a:lnSpc>
-                <a:spcPts val="1550"/>
+                <a:spcPts val="1500"/>
               </a:lnSpc>
               <a:buNone/>
             </a:pPr>
             <a:r>
-              <a:rPr lang="en-US" sz="1050" i="1" dirty="0">
+              <a:rPr lang="en-US" sz="1050" dirty="0">
                 <a:solidFill>
                   <a:srgbClr val="6E6858"/>
                 </a:solidFill>
@@ -1897,7 +1939,7 @@
                 <a:ea typeface="Calibri" pitchFamily="34" charset="-122"/>
                 <a:cs typeface="Calibri" pitchFamily="34" charset="-120"/>
               </a:rPr>
-              <a:t>Porque sistemas novos com a empresa pensando do jeito antigo não transformam nada. Pessoas e sistemas andam juntos.</a:t>
+              <a:t>Dentro dela: arquitetura, integrações e agentes com aprovação humana nos pontos certos · a turma da sua equipe no nosso portal, com fluência medida em 30, 60 e 90 dias.</a:t>
             </a:r>
             <a:endParaRPr lang="en-US" sz="1050" dirty="0"/>
           </a:p>
@@ -1905,13 +1947,55 @@
       </p:sp>
       <p:sp>
         <p:nvSpPr>
-          <p:cNvPr id="15" name="Shape 13"/>
-          <p:cNvSpPr/>
-          <p:nvPr/>
-        </p:nvSpPr>
-        <p:spPr>
-          <a:xfrm>
-            <a:off x="8095488" y="2514600"/>
+          <p:cNvPr id="16" name="Text 14"/>
+          <p:cNvSpPr/>
+          <p:nvPr/>
+        </p:nvSpPr>
+        <p:spPr>
+          <a:xfrm>
+            <a:off x="4459224" y="5577840"/>
+            <a:ext cx="3270504" cy="566928"/>
+          </a:xfrm>
+          <a:prstGeom prst="rect">
+            <a:avLst/>
+          </a:prstGeom>
+          <a:noFill/>
+          <a:ln/>
+        </p:spPr>
+        <p:txBody>
+          <a:bodyPr wrap="square" rtlCol="0" anchor="ctr"/>
+          <a:lstStyle/>
+          <a:p>
+            <a:pPr algn="l" indent="0" marL="0">
+              <a:lnSpc>
+                <a:spcPts val="1500"/>
+              </a:lnSpc>
+              <a:buNone/>
+            </a:pPr>
+            <a:r>
+              <a:rPr lang="en-US" sz="1050" i="1" dirty="0">
+                <a:solidFill>
+                  <a:srgbClr val="1B2A4A"/>
+                </a:solidFill>
+                <a:latin typeface="Calibri" pitchFamily="34" charset="0"/>
+                <a:ea typeface="Calibri" pitchFamily="34" charset="-122"/>
+                <a:cs typeface="Calibri" pitchFamily="34" charset="-120"/>
+              </a:rPr>
+              <a:t>Porque sistema novo com a empresa pensando do jeito antigo não transforma nada.</a:t>
+            </a:r>
+            <a:endParaRPr lang="en-US" sz="1050" dirty="0"/>
+          </a:p>
+        </p:txBody>
+      </p:sp>
+      <p:sp>
+        <p:nvSpPr>
+          <p:cNvPr id="17" name="Shape 15"/>
+          <p:cNvSpPr/>
+          <p:nvPr/>
+        </p:nvSpPr>
+        <p:spPr>
+          <a:xfrm>
+            <a:off x="8095488" y="2395728"/>
             <a:ext cx="3270504" cy="0"/>
           </a:xfrm>
           <a:prstGeom prst="line">
@@ -1928,13 +2012,13 @@
       </p:sp>
       <p:sp>
         <p:nvSpPr>
-          <p:cNvPr id="16" name="Text 14"/>
-          <p:cNvSpPr/>
-          <p:nvPr/>
-        </p:nvSpPr>
-        <p:spPr>
-          <a:xfrm>
-            <a:off x="8095488" y="2651760"/>
+          <p:cNvPr id="18" name="Text 16"/>
+          <p:cNvSpPr/>
+          <p:nvPr/>
+        </p:nvSpPr>
+        <p:spPr>
+          <a:xfrm>
+            <a:off x="8095488" y="2523744"/>
             <a:ext cx="3270504" cy="292608"/>
           </a:xfrm>
           <a:prstGeom prst="rect">
@@ -1967,14 +2051,14 @@
       </p:sp>
       <p:sp>
         <p:nvSpPr>
-          <p:cNvPr id="17" name="Text 15"/>
-          <p:cNvSpPr/>
-          <p:nvPr/>
-        </p:nvSpPr>
-        <p:spPr>
-          <a:xfrm>
-            <a:off x="8095488" y="2926080"/>
-            <a:ext cx="3270504" cy="274320"/>
+          <p:cNvPr id="19" name="Text 17"/>
+          <p:cNvSpPr/>
+          <p:nvPr/>
+        </p:nvSpPr>
+        <p:spPr>
+          <a:xfrm>
+            <a:off x="8095488" y="2798064"/>
+            <a:ext cx="3270504" cy="256032"/>
           </a:xfrm>
           <a:prstGeom prst="rect">
             <a:avLst/>
@@ -1990,7 +2074,7 @@
               <a:buNone/>
             </a:pPr>
             <a:r>
-              <a:rPr lang="en-US" sz="1200" i="1" dirty="0">
+              <a:rPr lang="en-US" sz="1150" i="1" dirty="0">
                 <a:solidFill>
                   <a:srgbClr val="6E6858"/>
                 </a:solidFill>
@@ -2000,20 +2084,20 @@
               </a:rPr>
               <a:t>meses sete a doze</a:t>
             </a:r>
-            <a:endParaRPr lang="en-US" sz="1200" dirty="0"/>
-          </a:p>
-        </p:txBody>
-      </p:sp>
-      <p:sp>
-        <p:nvSpPr>
-          <p:cNvPr id="18" name="Text 16"/>
-          <p:cNvSpPr/>
-          <p:nvPr/>
-        </p:nvSpPr>
-        <p:spPr>
-          <a:xfrm>
-            <a:off x="8095488" y="3246120"/>
-            <a:ext cx="3270504" cy="1737360"/>
+            <a:endParaRPr lang="en-US" sz="1150" dirty="0"/>
+          </a:p>
+        </p:txBody>
+      </p:sp>
+      <p:sp>
+        <p:nvSpPr>
+          <p:cNvPr id="20" name="Text 18"/>
+          <p:cNvSpPr/>
+          <p:nvPr/>
+        </p:nvSpPr>
+        <p:spPr>
+          <a:xfrm>
+            <a:off x="8095488" y="3090672"/>
+            <a:ext cx="3270504" cy="1005840"/>
           </a:xfrm>
           <a:prstGeom prst="rect">
             <a:avLst/>
@@ -2027,7 +2111,7 @@
           <a:p>
             <a:pPr algn="l" indent="0" marL="0">
               <a:lnSpc>
-                <a:spcPts val="1650"/>
+                <a:spcPts val="1600"/>
               </a:lnSpc>
               <a:buNone/>
             </a:pPr>
@@ -2040,7 +2124,7 @@
                 <a:ea typeface="Calibri" pitchFamily="34" charset="-122"/>
                 <a:cs typeface="Calibri" pitchFamily="34" charset="-120"/>
               </a:rPr>
-              <a:t>Operação acompanhada, presença semanal, relatório mensal de projetado versus realizado e o registro de cada decisão contra o resultado medido.</a:t>
+              <a:t>A capacidade rodando no dia a dia, com a nossa mão cada vez mais leve, de propósito.</a:t>
             </a:r>
             <a:endParaRPr lang="en-US" sz="1150" dirty="0"/>
           </a:p>
@@ -2048,14 +2132,14 @@
       </p:sp>
       <p:sp>
         <p:nvSpPr>
-          <p:cNvPr id="19" name="Text 17"/>
-          <p:cNvSpPr/>
-          <p:nvPr/>
-        </p:nvSpPr>
-        <p:spPr>
-          <a:xfrm>
-            <a:off x="8095488" y="5029200"/>
-            <a:ext cx="3270504" cy="1097280"/>
+          <p:cNvPr id="21" name="Text 19"/>
+          <p:cNvSpPr/>
+          <p:nvPr/>
+        </p:nvSpPr>
+        <p:spPr>
+          <a:xfrm>
+            <a:off x="8095488" y="4133088"/>
+            <a:ext cx="3270504" cy="1417320"/>
           </a:xfrm>
           <a:prstGeom prst="rect">
             <a:avLst/>
@@ -2069,12 +2153,12 @@
           <a:p>
             <a:pPr algn="l" indent="0" marL="0">
               <a:lnSpc>
-                <a:spcPts val="1550"/>
+                <a:spcPts val="1500"/>
               </a:lnSpc>
               <a:buNone/>
             </a:pPr>
             <a:r>
-              <a:rPr lang="en-US" sz="1050" i="1" dirty="0">
+              <a:rPr lang="en-US" sz="1050" dirty="0">
                 <a:solidFill>
                   <a:srgbClr val="6E6858"/>
                 </a:solidFill>
@@ -2082,7 +2166,7 @@
                 <a:ea typeface="Calibri" pitchFamily="34" charset="-122"/>
                 <a:cs typeface="Calibri" pitchFamily="34" charset="-120"/>
               </a:rPr>
-              <a:t>Porque a única prova que importa para a sua diretoria é a capacidade funcionando sem consultor no meio — e isso só o tempo mostra.</a:t>
+              <a:t>Dentro dela: operação sob SLA com presença semanal · relatório mensal de projetado versus realizado · o ritual com a diretoria e o registro de cada decisão.</a:t>
             </a:r>
             <a:endParaRPr lang="en-US" sz="1050" dirty="0"/>
           </a:p>
@@ -2090,14 +2174,56 @@
       </p:sp>
       <p:sp>
         <p:nvSpPr>
-          <p:cNvPr id="20" name="Text 18"/>
-          <p:cNvSpPr/>
-          <p:nvPr/>
-        </p:nvSpPr>
-        <p:spPr>
-          <a:xfrm>
-            <a:off x="822960" y="6053328"/>
-            <a:ext cx="10543032" cy="566928"/>
+          <p:cNvPr id="22" name="Text 20"/>
+          <p:cNvSpPr/>
+          <p:nvPr/>
+        </p:nvSpPr>
+        <p:spPr>
+          <a:xfrm>
+            <a:off x="8095488" y="5577840"/>
+            <a:ext cx="3270504" cy="566928"/>
+          </a:xfrm>
+          <a:prstGeom prst="rect">
+            <a:avLst/>
+          </a:prstGeom>
+          <a:noFill/>
+          <a:ln/>
+        </p:spPr>
+        <p:txBody>
+          <a:bodyPr wrap="square" rtlCol="0" anchor="ctr"/>
+          <a:lstStyle/>
+          <a:p>
+            <a:pPr algn="l" indent="0" marL="0">
+              <a:lnSpc>
+                <a:spcPts val="1500"/>
+              </a:lnSpc>
+              <a:buNone/>
+            </a:pPr>
+            <a:r>
+              <a:rPr lang="en-US" sz="1050" i="1" dirty="0">
+                <a:solidFill>
+                  <a:srgbClr val="1B2A4A"/>
+                </a:solidFill>
+                <a:latin typeface="Calibri" pitchFamily="34" charset="0"/>
+                <a:ea typeface="Calibri" pitchFamily="34" charset="-122"/>
+                <a:cs typeface="Calibri" pitchFamily="34" charset="-120"/>
+              </a:rPr>
+              <a:t>Porque a única prova que importa é funcionar sem consultor no meio.</a:t>
+            </a:r>
+            <a:endParaRPr lang="en-US" sz="1050" dirty="0"/>
+          </a:p>
+        </p:txBody>
+      </p:sp>
+      <p:sp>
+        <p:nvSpPr>
+          <p:cNvPr id="23" name="Text 21"/>
+          <p:cNvSpPr/>
+          <p:nvPr/>
+        </p:nvSpPr>
+        <p:spPr>
+          <a:xfrm>
+            <a:off x="822960" y="6108192"/>
+            <a:ext cx="10543032" cy="384048"/>
           </a:xfrm>
           <a:prstGeom prst="rect">
             <a:avLst/>
@@ -2111,12 +2237,12 @@
           <a:p>
             <a:pPr algn="ctr" indent="0" marL="0">
               <a:lnSpc>
-                <a:spcPts val="1700"/>
+                <a:spcPts val="1400"/>
               </a:lnSpc>
               <a:buNone/>
             </a:pPr>
             <a:r>
-              <a:rPr lang="en-US" sz="1250" i="1" dirty="0">
+              <a:rPr lang="en-US" sz="1100" i="1" dirty="0">
                 <a:solidFill>
                   <a:srgbClr val="1B2A4A"/>
                 </a:solidFill>
@@ -2124,48 +2250,9 @@
                 <a:ea typeface="Cambria" pitchFamily="34" charset="-122"/>
                 <a:cs typeface="Cambria" pitchFamily="34" charset="-120"/>
               </a:rPr>
-              <a:t>O Portão da Prova: ao fim da fase 1, a decisão volta para a sua mão. Se o número não apareceu, ou se você simplesmente mudar de ideia, sai levando tudo o que foi produzido — sem multa e sem constrangimento.</a:t>
-            </a:r>
-            <a:endParaRPr lang="en-US" sz="1250" dirty="0"/>
-          </a:p>
-        </p:txBody>
-      </p:sp>
-      <p:sp>
-        <p:nvSpPr>
-          <p:cNvPr id="21" name="Text 19"/>
-          <p:cNvSpPr/>
-          <p:nvPr/>
-        </p:nvSpPr>
-        <p:spPr>
-          <a:xfrm>
-            <a:off x="822960" y="6400800"/>
-            <a:ext cx="10543032" cy="274320"/>
-          </a:xfrm>
-          <a:prstGeom prst="rect">
-            <a:avLst/>
-          </a:prstGeom>
-          <a:noFill/>
-          <a:ln/>
-        </p:spPr>
-        <p:txBody>
-          <a:bodyPr wrap="square" rtlCol="0" anchor="ctr"/>
-          <a:lstStyle/>
-          <a:p>
-            <a:pPr algn="ctr" indent="0" marL="0">
-              <a:buNone/>
-            </a:pPr>
-            <a:r>
-              <a:rPr lang="en-US" sz="900" spc="100" kern="0" dirty="0">
-                <a:solidFill>
-                  <a:srgbClr val="6E6858"/>
-                </a:solidFill>
-                <a:latin typeface="Calibri" pitchFamily="34" charset="0"/>
-                <a:ea typeface="Calibri" pitchFamily="34" charset="-122"/>
-                <a:cs typeface="Calibri" pitchFamily="34" charset="-120"/>
-              </a:rPr>
-              <a:t>ABBA Consultoria de IA · contato@abbaservices.com.br</a:t>
-            </a:r>
-            <a:endParaRPr lang="en-US" sz="900" dirty="0"/>
+              <a:t>O Portão da Prova: ao fim da fase 1 a decisão volta para a sua mão. Se o número não apareceu, ou se você simplesmente mudar de ideia, você sai levando tudo o que foi produzido. Sem multa e sem constrangimento.</a:t>
+            </a:r>
+            <a:endParaRPr lang="en-US" sz="1100" dirty="0"/>
           </a:p>
         </p:txBody>
       </p:sp>
@@ -2209,7 +2296,7 @@
         </p:nvSpPr>
         <p:spPr>
           <a:xfrm>
-            <a:off x="822960" y="594360"/>
+            <a:off x="822960" y="548640"/>
             <a:ext cx="5486400" cy="292608"/>
           </a:xfrm>
           <a:prstGeom prst="rect">
@@ -2248,8 +2335,8 @@
         </p:nvSpPr>
         <p:spPr>
           <a:xfrm>
-            <a:off x="822960" y="914400"/>
-            <a:ext cx="10543032" cy="731520"/>
+            <a:off x="822960" y="868680"/>
+            <a:ext cx="10543032" cy="685800"/>
           </a:xfrm>
           <a:prstGeom prst="rect">
             <a:avLst/>
@@ -2265,7 +2352,7 @@
               <a:buNone/>
             </a:pPr>
             <a:r>
-              <a:rPr lang="en-US" sz="2600" b="1" dirty="0">
+              <a:rPr lang="en-US" sz="2500" b="1" dirty="0">
                 <a:solidFill>
                   <a:srgbClr val="1B2A4A"/>
                 </a:solidFill>
@@ -2275,7 +2362,7 @@
               </a:rPr>
               <a:t>A relação não termina: ela passa a ser medida todo ano.</a:t>
             </a:r>
-            <a:endParaRPr lang="en-US" sz="2600" dirty="0"/>
+            <a:endParaRPr lang="en-US" sz="2500" dirty="0"/>
           </a:p>
         </p:txBody>
       </p:sp>
@@ -2287,8 +2374,8 @@
         </p:nvSpPr>
         <p:spPr>
           <a:xfrm>
-            <a:off x="822960" y="1691640"/>
-            <a:ext cx="10543032" cy="1188720"/>
+            <a:off x="822960" y="1600200"/>
+            <a:ext cx="10543032" cy="1051560"/>
           </a:xfrm>
           <a:prstGeom prst="rect">
             <a:avLst/>
@@ -2302,12 +2389,12 @@
           <a:p>
             <a:pPr algn="l" indent="0" marL="0">
               <a:lnSpc>
-                <a:spcPts val="2100"/>
+                <a:spcPts val="1950"/>
               </a:lnSpc>
               <a:buNone/>
             </a:pPr>
             <a:r>
-              <a:rPr lang="en-US" sz="1350" dirty="0">
+              <a:rPr lang="en-US" sz="1300" dirty="0">
                 <a:solidFill>
                   <a:srgbClr val="33394A"/>
                 </a:solidFill>
@@ -2315,9 +2402,9 @@
                 <a:ea typeface="Calibri" pitchFamily="34" charset="-122"/>
                 <a:cs typeface="Calibri" pitchFamily="34" charset="-120"/>
               </a:rPr>
-              <a:t>Do segundo ano em diante, a empresa opera sozinha e nós ficamos com o que não dá para fazer de dentro: a operação acompanhada, o conselho trimestral e o Exame Anual de IA — a re-medição completa da maturidade da empresa, comparada ano contra ano. A série histórica que nasce daí só existe aqui, vale mais a cada ano, e é dela que sai a fila de oportunidades do ano seguinte.</a:t>
-            </a:r>
-            <a:endParaRPr lang="en-US" sz="1350" dirty="0"/>
+              <a:t>Do segundo ano em diante a empresa opera sozinha, e nós ficamos com o que não dá para fazer de dentro: a operação acompanhada, o conselho trimestral e o Exame Anual de IA, a re-medição completa da maturidade, comparada ano contra ano. A série histórica que nasce daí só existe aqui, vale mais a cada ano, e é dela que sai a fila de oportunidades do ano seguinte.</a:t>
+            </a:r>
+            <a:endParaRPr lang="en-US" sz="1300" dirty="0"/>
           </a:p>
         </p:txBody>
       </p:sp>
@@ -2329,7 +2416,7 @@
         </p:nvSpPr>
         <p:spPr>
           <a:xfrm>
-            <a:off x="822960" y="3063240"/>
+            <a:off x="822960" y="2788920"/>
             <a:ext cx="10543032" cy="0"/>
           </a:xfrm>
           <a:prstGeom prst="line">
@@ -2352,7 +2439,7 @@
         </p:nvSpPr>
         <p:spPr>
           <a:xfrm>
-            <a:off x="822960" y="3246120"/>
+            <a:off x="822960" y="2944368"/>
             <a:ext cx="5486400" cy="292608"/>
           </a:xfrm>
           <a:prstGeom prst="rect">
@@ -2377,7 +2464,7 @@
                 <a:ea typeface="Calibri" pitchFamily="34" charset="-122"/>
                 <a:cs typeface="Calibri" pitchFamily="34" charset="-120"/>
               </a:rPr>
-              <a:t>JÁ TEM IA RODANDO?</a:t>
+              <a:t>JÁ TEM IA RODANDO? O CONSELHEIRO DE IA</a:t>
             </a:r>
             <a:endParaRPr lang="en-US" sz="1100" dirty="0"/>
           </a:p>
@@ -2391,8 +2478,8 @@
         </p:nvSpPr>
         <p:spPr>
           <a:xfrm>
-            <a:off x="822960" y="3566160"/>
-            <a:ext cx="10543032" cy="777240"/>
+            <a:off x="822960" y="3273552"/>
+            <a:ext cx="10543032" cy="1234440"/>
           </a:xfrm>
           <a:prstGeom prst="rect">
             <a:avLst/>
@@ -2406,12 +2493,12 @@
           <a:p>
             <a:pPr algn="l" indent="0" marL="0">
               <a:lnSpc>
-                <a:spcPts val="2000"/>
+                <a:spcPts val="1850"/>
               </a:lnSpc>
               <a:buNone/>
             </a:pPr>
             <a:r>
-              <a:rPr lang="en-US" sz="1300" dirty="0">
+              <a:rPr lang="en-US" sz="1250" dirty="0">
                 <a:solidFill>
                   <a:srgbClr val="33394A"/>
                 </a:solidFill>
@@ -2419,9 +2506,9 @@
                 <a:ea typeface="Calibri" pitchFamily="34" charset="-122"/>
                 <a:cs typeface="Calibri" pitchFamily="34" charset="-120"/>
               </a:rPr>
-              <a:t>Para quem já construiu, a oferta é outra: o Conselheiro de IA — a cadeira de direção estratégica, fracionária, do seu lado da mesa, com parecer por escrito sobre cada fornecedor e a memória do que foi decidido e medido.</a:t>
-            </a:r>
-            <a:endParaRPr lang="en-US" sz="1300" dirty="0"/>
+              <a:t>Para quem já construiu, a oferta é outra: a cadeira de direção de IA do seu lado da mesa, em fração. Funciona em quatro movimentos: presença recorrente na diretoria · o roadmap vivo, re-ranqueado conforme os números chegam · parecer por escrito sobre cada fornecedor que aparece · e a memória de decisão, com a expectativa declarada antes e o resultado medido depois, que nunca se apaga. Nenhum time interno pode ser a própria prova. É por isso que empresa com um ótimo CFO ainda contrata quem verifique as contas de fora.</a:t>
+            </a:r>
+            <a:endParaRPr lang="en-US" sz="1250" dirty="0"/>
           </a:p>
         </p:txBody>
       </p:sp>
@@ -2433,7 +2520,7 @@
         </p:nvSpPr>
         <p:spPr>
           <a:xfrm>
-            <a:off x="822960" y="4526280"/>
+            <a:off x="822960" y="4617720"/>
             <a:ext cx="10543032" cy="0"/>
           </a:xfrm>
           <a:prstGeom prst="line">
@@ -2456,7 +2543,7 @@
         </p:nvSpPr>
         <p:spPr>
           <a:xfrm>
-            <a:off x="822960" y="4681728"/>
+            <a:off x="822960" y="4773168"/>
             <a:ext cx="5486400" cy="292608"/>
           </a:xfrm>
           <a:prstGeom prst="rect">
@@ -2503,7 +2590,7 @@
         </p:blipFill>
         <p:spPr>
           <a:xfrm>
-            <a:off x="822960" y="5029200"/>
+            <a:off x="822960" y="5120640"/>
             <a:ext cx="1435608" cy="310896"/>
           </a:xfrm>
           <a:prstGeom prst="rect">
@@ -2527,7 +2614,7 @@
         </p:blipFill>
         <p:spPr>
           <a:xfrm>
-            <a:off x="2651760" y="4974336"/>
+            <a:off x="2651760" y="5065776"/>
             <a:ext cx="1325880" cy="402336"/>
           </a:xfrm>
           <a:prstGeom prst="rect">
@@ -2543,7 +2630,7 @@
         </p:nvSpPr>
         <p:spPr>
           <a:xfrm>
-            <a:off x="4480560" y="4956048"/>
+            <a:off x="4480560" y="5047488"/>
             <a:ext cx="6885432" cy="457200"/>
           </a:xfrm>
           <a:prstGeom prst="rect">
@@ -2585,7 +2672,7 @@
         </p:nvSpPr>
         <p:spPr>
           <a:xfrm>
-            <a:off x="822960" y="5715000"/>
+            <a:off x="822960" y="5806440"/>
             <a:ext cx="10543032" cy="502920"/>
           </a:xfrm>
           <a:prstGeom prst="rect">

</xml_diff>

<commit_message>
Materiais no registro institucional: serviços por dentro de cada fase
Segundo feedback do sócio (2026-09-01): a base volta a ser a apresentação
antiga comprovada. Institucional refeito em 15 slides com um slide 'por
dentro' por fase (Assessment, Protótipo, Construção, Treinamento+Portal,
Sistemas gerenciados em 'o quê · por quê · como', com as fotos), as duas
frentes (processos e pessoas) reunidas com a leitura ponta/veia, Portão
da Prova em linguagem de diretoria, Conselheiro especificado (+ slide 'o
que NÃO é'), fecho sóbrio com prometemos/recusamos. Mesa de três pés e
demais expressões de palco removidas do material escrito; a regra do §0
agora fixa o registro. Apresentação de 3 páginas reestruturada no mesmo
formato. Fase 1 do institucional usa a página do relatório de maturidade.

Co-Authored-By: Claude <noreply@anthropic.com>
Claude-Session: https://claude.ai/code/session_016RZJT8nVEB7u33HvjY5KvZ
</commit_message>
<xml_diff>
--- a/08-materiais/modelos/abba-apresentacao.pptx
+++ b/08-materiais/modelos/abba-apresentacao.pptx
@@ -1061,7 +1061,7 @@
         </p:nvSpPr>
         <p:spPr>
           <a:xfrm>
-            <a:off x="822960" y="640080"/>
+            <a:off x="822960" y="594360"/>
             <a:ext cx="5486400" cy="292608"/>
           </a:xfrm>
           <a:prstGeom prst="rect">
@@ -1100,8 +1100,8 @@
         </p:nvSpPr>
         <p:spPr>
           <a:xfrm>
-            <a:off x="822960" y="1005840"/>
-            <a:ext cx="10543032" cy="1005840"/>
+            <a:off x="822960" y="932688"/>
+            <a:ext cx="10543032" cy="960120"/>
           </a:xfrm>
           <a:prstGeom prst="rect">
             <a:avLst/>
@@ -1117,7 +1117,7 @@
               <a:buNone/>
             </a:pPr>
             <a:r>
-              <a:rPr lang="en-US" sz="4000" b="1" dirty="0">
+              <a:rPr lang="en-US" sz="3800" b="1" dirty="0">
                 <a:solidFill>
                   <a:srgbClr val="1B2A4A"/>
                 </a:solidFill>
@@ -1127,7 +1127,7 @@
               </a:rPr>
               <a:t>Tornamos a sua empresa AI native.</a:t>
             </a:r>
-            <a:endParaRPr lang="en-US" sz="4000" dirty="0"/>
+            <a:endParaRPr lang="en-US" sz="3800" dirty="0"/>
           </a:p>
         </p:txBody>
       </p:sp>
@@ -1139,7 +1139,7 @@
         </p:nvSpPr>
         <p:spPr>
           <a:xfrm>
-            <a:off x="822960" y="2121408"/>
+            <a:off x="822960" y="1993392"/>
             <a:ext cx="2011680" cy="0"/>
           </a:xfrm>
           <a:prstGeom prst="line">
@@ -1162,8 +1162,8 @@
         </p:nvSpPr>
         <p:spPr>
           <a:xfrm>
-            <a:off x="822960" y="2377440"/>
-            <a:ext cx="10543032" cy="1325880"/>
+            <a:off x="822960" y="2240280"/>
+            <a:ext cx="10543032" cy="1463040"/>
           </a:xfrm>
           <a:prstGeom prst="rect">
             <a:avLst/>
@@ -1177,12 +1177,12 @@
           <a:p>
             <a:pPr algn="l" indent="0" marL="0">
               <a:lnSpc>
-                <a:spcPts val="2300"/>
+                <a:spcPts val="2150"/>
               </a:lnSpc>
               <a:buNone/>
             </a:pPr>
             <a:r>
-              <a:rPr lang="en-US" sz="1500" dirty="0">
+              <a:rPr lang="en-US" sz="1400" dirty="0">
                 <a:solidFill>
                   <a:srgbClr val="33394A"/>
                 </a:solidFill>
@@ -1190,9 +1190,9 @@
                 <a:ea typeface="Calibri" pitchFamily="34" charset="-122"/>
                 <a:cs typeface="Calibri" pitchFamily="34" charset="-120"/>
               </a:rPr>
-              <a:t>De cada dez empresas que decidiram usar IA este ano, mais de oito não vão conseguir mostrar um número no fim. E não é por falta de tecnologia: é porque a IA entrou pelo lugar errado. Quando entra pela ponta, uma pessoa pede e recebe, e o ganho fica com ela. Se ela sai amanhã, o ganho sai junto pela porta. Quando entra pela veia, dentro do processo, o organismo passa a funcionar diferente. E o ganho fica na empresa.</a:t>
-            </a:r>
-            <a:endParaRPr lang="en-US" sz="1500" dirty="0"/>
+              <a:t>A ABBA é uma consultoria de inteligência artificial. Entramos na sua empresa para entendê-la a fundo, construímos as soluções certas para o seu fluxo de trabalho, validamos cada uma com dados reais antes de qualquer investimento pesado, formamos as suas pessoas e ficamos ao seu lado acompanhando, mês a mês, o que mudou. O trabalho acontece em duas frentes ao mesmo tempo: nos processos, com sistemas inteligentes implantados dentro do fluxo real, e nas pessoas, formadas para enxergar o próprio trabalho de um jeito novo.</a:t>
+            </a:r>
+            <a:endParaRPr lang="en-US" sz="1400" dirty="0"/>
           </a:p>
         </p:txBody>
       </p:sp>
@@ -1205,7 +1205,7 @@
         <p:spPr>
           <a:xfrm>
             <a:off x="822960" y="3794760"/>
-            <a:ext cx="10543032" cy="1234440"/>
+            <a:ext cx="10543032" cy="1371600"/>
           </a:xfrm>
           <a:prstGeom prst="rect">
             <a:avLst/>
@@ -1219,12 +1219,12 @@
           <a:p>
             <a:pPr algn="l" indent="0" marL="0">
               <a:lnSpc>
-                <a:spcPts val="2000"/>
+                <a:spcPts val="1950"/>
               </a:lnSpc>
               <a:buNone/>
             </a:pPr>
             <a:r>
-              <a:rPr lang="en-US" sz="1350" dirty="0">
+              <a:rPr lang="en-US" sz="1300" dirty="0">
                 <a:solidFill>
                   <a:srgbClr val="6E6858"/>
                 </a:solidFill>
@@ -1232,9 +1232,9 @@
                 <a:ea typeface="Calibri" pitchFamily="34" charset="-122"/>
                 <a:cs typeface="Calibri" pitchFamily="34" charset="-120"/>
               </a:rPr>
-              <a:t>A pesquisa mais séria que existe sobre isso, da RAND, mediu: mais de 80% dos projetos de IA falham, o dobro dos projetos comuns de tecnologia. A causa número um não foi a qualidade do modelo. Foi começar sem ninguém combinar o que seria dar certo. É exatamente aí que trabalhamos: escolhemos um processo que dói, fazemos a IA rodar dentro dele até virar parte da operação, formamos as pessoas que vivem nesse processo e provamos, de fora, o que mudou. Número combinado antes, medido depois. No fim, a diretoria tem prova, não impressão.</a:t>
-            </a:r>
-            <a:endParaRPr lang="en-US" sz="1350" dirty="0"/>
+              <a:t>Por que assim? De cada dez empresas que decidiram usar IA este ano, mais de oito não vão conseguir mostrar um número no fim (RAND: mais de 80% dos projetos falham, o dobro dos projetos comuns de tecnologia, e a causa número um é começar sem combinar o que seria dar certo). Não é falta de tecnologia: é a IA entrando pela ponta, na mão de uma pessoa, em vez de entrar pela veia, dentro do processo. Por isso cada caso nosso nasce com a métrica combinada por escrito, e termina medido por terceiro. No fim, a diretoria tem prova, não impressão.</a:t>
+            </a:r>
+            <a:endParaRPr lang="en-US" sz="1300" dirty="0"/>
           </a:p>
         </p:txBody>
       </p:sp>
@@ -1246,7 +1246,7 @@
         </p:nvSpPr>
         <p:spPr>
           <a:xfrm>
-            <a:off x="822960" y="5120640"/>
+            <a:off x="822960" y="5257800"/>
             <a:ext cx="10543032" cy="0"/>
           </a:xfrm>
           <a:prstGeom prst="line">
@@ -1269,7 +1269,7 @@
         </p:nvSpPr>
         <p:spPr>
           <a:xfrm>
-            <a:off x="822960" y="5285232"/>
+            <a:off x="822960" y="5413248"/>
             <a:ext cx="5486400" cy="292608"/>
           </a:xfrm>
           <a:prstGeom prst="rect">
@@ -1308,8 +1308,8 @@
         </p:nvSpPr>
         <p:spPr>
           <a:xfrm>
-            <a:off x="822960" y="5614416"/>
-            <a:ext cx="10543032" cy="777240"/>
+            <a:off x="822960" y="5724144"/>
+            <a:ext cx="10543032" cy="685800"/>
           </a:xfrm>
           <a:prstGeom prst="rect">
             <a:avLst/>
@@ -1323,12 +1323,12 @@
           <a:p>
             <a:pPr algn="l" indent="0" marL="0">
               <a:lnSpc>
-                <a:spcPts val="1950"/>
+                <a:spcPts val="1750"/>
               </a:lnSpc>
               <a:buNone/>
             </a:pPr>
             <a:r>
-              <a:rPr lang="en-US" sz="1300" i="1" dirty="0">
+              <a:rPr lang="en-US" sz="1200" i="1" dirty="0">
                 <a:solidFill>
                   <a:srgbClr val="33394A"/>
                 </a:solidFill>
@@ -1336,9 +1336,9 @@
                 <a:ea typeface="Cambria" pitchFamily="34" charset="-122"/>
                 <a:cs typeface="Cambria" pitchFamily="34" charset="-120"/>
               </a:rPr>
-              <a:t>Trabalhamos com raízes: verdade dita mesmo quando custa, número antes de opinião, e o compromisso de terminar com a sua empresa mais capaz, não mais dependente. O que instalamos fica com você: os sistemas, as pessoas formadas e o registro de tudo o que foi decidido e medido.</a:t>
-            </a:r>
-            <a:endParaRPr lang="en-US" sz="1300" dirty="0"/>
+              <a:t>Verdade dita mesmo quando custa, número antes de opinião, e o compromisso de terminar com a sua empresa mais capaz, não mais dependente. O que instalamos fica com você: os sistemas, as pessoas formadas e o registro de tudo o que foi decidido e medido.</a:t>
+            </a:r>
+            <a:endParaRPr lang="en-US" sz="1200" dirty="0"/>
           </a:p>
         </p:txBody>
       </p:sp>
@@ -1421,8 +1421,8 @@
         </p:nvSpPr>
         <p:spPr>
           <a:xfrm>
-            <a:off x="822960" y="548640"/>
-            <a:ext cx="5486400" cy="292608"/>
+            <a:off x="822960" y="502920"/>
+            <a:ext cx="8229600" cy="292608"/>
           </a:xfrm>
           <a:prstGeom prst="rect">
             <a:avLst/>
@@ -1446,7 +1446,7 @@
                 <a:ea typeface="Calibri" pitchFamily="34" charset="-122"/>
                 <a:cs typeface="Calibri" pitchFamily="34" charset="-120"/>
               </a:rPr>
-              <a:t>O CAMINHO</a:t>
+              <a:t>O PROGRAMA · ANO 1 · PRIMEIRA PARTE</a:t>
             </a:r>
             <a:endParaRPr lang="en-US" sz="1100" dirty="0"/>
           </a:p>
@@ -1460,8 +1460,8 @@
         </p:nvSpPr>
         <p:spPr>
           <a:xfrm>
-            <a:off x="822960" y="868680"/>
-            <a:ext cx="10543032" cy="731520"/>
+            <a:off x="822960" y="822960"/>
+            <a:ext cx="10543032" cy="594360"/>
           </a:xfrm>
           <a:prstGeom prst="rect">
             <a:avLst/>
@@ -1477,7 +1477,7 @@
               <a:buNone/>
             </a:pPr>
             <a:r>
-              <a:rPr lang="en-US" sz="2500" b="1" dirty="0">
+              <a:rPr lang="en-US" sz="2300" b="1" dirty="0">
                 <a:solidFill>
                   <a:srgbClr val="1B2A4A"/>
                 </a:solidFill>
@@ -1485,9 +1485,9 @@
                 <a:ea typeface="Cambria" pitchFamily="34" charset="-122"/>
                 <a:cs typeface="Cambria" pitchFamily="34" charset="-120"/>
               </a:rPr>
-              <a:t>Da primeira conversa à capacidade instalada: um programa, um ano.</a:t>
-            </a:r>
-            <a:endParaRPr lang="en-US" sz="2500" dirty="0"/>
+              <a:t>Da primeira conversa aos sistemas rodando.</a:t>
+            </a:r>
+            <a:endParaRPr lang="en-US" sz="2300" dirty="0"/>
           </a:p>
         </p:txBody>
       </p:sp>
@@ -1499,8 +1499,8 @@
         </p:nvSpPr>
         <p:spPr>
           <a:xfrm>
-            <a:off x="822960" y="1627632"/>
-            <a:ext cx="10543032" cy="658368"/>
+            <a:off x="822960" y="1463040"/>
+            <a:ext cx="10543032" cy="566928"/>
           </a:xfrm>
           <a:prstGeom prst="rect">
             <a:avLst/>
@@ -1514,12 +1514,12 @@
           <a:p>
             <a:pPr algn="l" indent="0" marL="0">
               <a:lnSpc>
-                <a:spcPts val="1850"/>
+                <a:spcPts val="1650"/>
               </a:lnSpc>
               <a:buNone/>
             </a:pPr>
             <a:r>
-              <a:rPr lang="en-US" sz="1250" dirty="0">
+              <a:rPr lang="en-US" sz="1150" dirty="0">
                 <a:solidFill>
                   <a:srgbClr val="6E6858"/>
                 </a:solidFill>
@@ -1527,28 +1527,67 @@
                 <a:ea typeface="Calibri" pitchFamily="34" charset="-122"/>
                 <a:cs typeface="Calibri" pitchFamily="34" charset="-120"/>
               </a:rPr>
-              <a:t>Tudo começa com um mapa do que estimamos estar vazando, feito de fora e sem custo. Ninguém espera o terreno ficar perfeito para começar a obra: escolhemos juntos a primeira parede, e é ela que paga a fundação do resto. Cada fase termina numa porta de saída limpa.</a:t>
-            </a:r>
-            <a:endParaRPr lang="en-US" sz="1250" dirty="0"/>
-          </a:p>
-        </p:txBody>
-      </p:sp>
-      <p:sp>
-        <p:nvSpPr>
-          <p:cNvPr id="5" name="Shape 3"/>
-          <p:cNvSpPr/>
-          <p:nvPr/>
-        </p:nvSpPr>
-        <p:spPr>
-          <a:xfrm>
-            <a:off x="822960" y="2395728"/>
-            <a:ext cx="3270504" cy="0"/>
+              <a:t>Tudo começa com o Mapa de Vazamento, gratuito: feito de fora, com uma estimativa em reais do que pode estar vazando na operação. Depois dele, o Programa percorre três fases em um ano. Cada etapa entrega algo inteiro sozinha e produz o insumo da próxima.</a:t>
+            </a:r>
+            <a:endParaRPr lang="en-US" sz="1150" dirty="0"/>
+          </a:p>
+        </p:txBody>
+      </p:sp>
+      <p:sp>
+        <p:nvSpPr>
+          <p:cNvPr id="5" name="Text 3"/>
+          <p:cNvSpPr/>
+          <p:nvPr/>
+        </p:nvSpPr>
+        <p:spPr>
+          <a:xfrm>
+            <a:off x="822960" y="2148840"/>
+            <a:ext cx="4997196" cy="292608"/>
+          </a:xfrm>
+          <a:prstGeom prst="rect">
+            <a:avLst/>
+          </a:prstGeom>
+          <a:noFill/>
+          <a:ln/>
+        </p:spPr>
+        <p:txBody>
+          <a:bodyPr wrap="square" rtlCol="0" anchor="ctr"/>
+          <a:lstStyle/>
+          <a:p>
+            <a:pPr algn="l" indent="0" marL="0">
+              <a:buNone/>
+            </a:pPr>
+            <a:r>
+              <a:rPr lang="en-US" sz="1100" b="1" spc="300" kern="0" dirty="0">
+                <a:solidFill>
+                  <a:srgbClr val="C2A35B"/>
+                </a:solidFill>
+                <a:latin typeface="Calibri" pitchFamily="34" charset="0"/>
+                <a:ea typeface="Calibri" pitchFamily="34" charset="-122"/>
+                <a:cs typeface="Calibri" pitchFamily="34" charset="-120"/>
+              </a:rPr>
+              <a:t>FASE 1 · A PROVA · SEIS SEMANAS</a:t>
+            </a:r>
+            <a:endParaRPr lang="en-US" sz="1100" dirty="0"/>
+          </a:p>
+        </p:txBody>
+      </p:sp>
+      <p:sp>
+        <p:nvSpPr>
+          <p:cNvPr id="6" name="Shape 4"/>
+          <p:cNvSpPr/>
+          <p:nvPr/>
+        </p:nvSpPr>
+        <p:spPr>
+          <a:xfrm>
+            <a:off x="822960" y="2487168"/>
+            <a:ext cx="4997196" cy="0"/>
           </a:xfrm>
           <a:prstGeom prst="line">
             <a:avLst/>
           </a:prstGeom>
           <a:noFill/>
-          <a:ln w="15240">
+          <a:ln w="13970">
             <a:solidFill>
               <a:srgbClr val="C2A35B"/>
             </a:solidFill>
@@ -1558,14 +1597,14 @@
       </p:sp>
       <p:sp>
         <p:nvSpPr>
-          <p:cNvPr id="6" name="Text 4"/>
-          <p:cNvSpPr/>
-          <p:nvPr/>
-        </p:nvSpPr>
-        <p:spPr>
-          <a:xfrm>
-            <a:off x="822960" y="2523744"/>
-            <a:ext cx="3270504" cy="292608"/>
+          <p:cNvPr id="7" name="Text 5"/>
+          <p:cNvSpPr/>
+          <p:nvPr/>
+        </p:nvSpPr>
+        <p:spPr>
+          <a:xfrm>
+            <a:off x="822960" y="2587752"/>
+            <a:ext cx="4997196" cy="292608"/>
           </a:xfrm>
           <a:prstGeom prst="rect">
             <a:avLst/>
@@ -1581,7 +1620,7 @@
               <a:buNone/>
             </a:pPr>
             <a:r>
-              <a:rPr lang="en-US" sz="1050" b="1" spc="300" kern="0" dirty="0">
+              <a:rPr lang="en-US" sz="1000" b="1" spc="300" kern="0" dirty="0">
                 <a:solidFill>
                   <a:srgbClr val="C2A35B"/>
                 </a:solidFill>
@@ -1589,22 +1628,22 @@
                 <a:ea typeface="Calibri" pitchFamily="34" charset="-122"/>
                 <a:cs typeface="Calibri" pitchFamily="34" charset="-120"/>
               </a:rPr>
-              <a:t>FASE 1 · A PROVA</a:t>
-            </a:r>
-            <a:endParaRPr lang="en-US" sz="1050" dirty="0"/>
-          </a:p>
-        </p:txBody>
-      </p:sp>
-      <p:sp>
-        <p:nvSpPr>
-          <p:cNvPr id="7" name="Text 5"/>
-          <p:cNvSpPr/>
-          <p:nvPr/>
-        </p:nvSpPr>
-        <p:spPr>
-          <a:xfrm>
-            <a:off x="822960" y="2798064"/>
-            <a:ext cx="3270504" cy="256032"/>
+              <a:t>O ASSESSMENT · O MERGULHO PROFUNDO</a:t>
+            </a:r>
+            <a:endParaRPr lang="en-US" sz="1000" dirty="0"/>
+          </a:p>
+        </p:txBody>
+      </p:sp>
+      <p:sp>
+        <p:nvSpPr>
+          <p:cNvPr id="8" name="Text 6"/>
+          <p:cNvSpPr/>
+          <p:nvPr/>
+        </p:nvSpPr>
+        <p:spPr>
+          <a:xfrm>
+            <a:off x="822960" y="2889504"/>
+            <a:ext cx="868680" cy="228600"/>
           </a:xfrm>
           <a:prstGeom prst="rect">
             <a:avLst/>
@@ -1620,30 +1659,30 @@
               <a:buNone/>
             </a:pPr>
             <a:r>
-              <a:rPr lang="en-US" sz="1150" i="1" dirty="0">
-                <a:solidFill>
-                  <a:srgbClr val="6E6858"/>
-                </a:solidFill>
-                <a:latin typeface="Cambria" pitchFamily="34" charset="0"/>
-                <a:ea typeface="Cambria" pitchFamily="34" charset="-122"/>
-                <a:cs typeface="Cambria" pitchFamily="34" charset="-120"/>
-              </a:rPr>
-              <a:t>seis semanas</a:t>
-            </a:r>
-            <a:endParaRPr lang="en-US" sz="1150" dirty="0"/>
-          </a:p>
-        </p:txBody>
-      </p:sp>
-      <p:sp>
-        <p:nvSpPr>
-          <p:cNvPr id="8" name="Text 6"/>
-          <p:cNvSpPr/>
-          <p:nvPr/>
-        </p:nvSpPr>
-        <p:spPr>
-          <a:xfrm>
-            <a:off x="822960" y="3090672"/>
-            <a:ext cx="3270504" cy="1005840"/>
+              <a:rPr lang="en-US" sz="800" b="1" spc="200" kern="0" dirty="0">
+                <a:solidFill>
+                  <a:srgbClr val="C2A35B"/>
+                </a:solidFill>
+                <a:latin typeface="Calibri" pitchFamily="34" charset="0"/>
+                <a:ea typeface="Calibri" pitchFamily="34" charset="-122"/>
+                <a:cs typeface="Calibri" pitchFamily="34" charset="-120"/>
+              </a:rPr>
+              <a:t>O QUÊ</a:t>
+            </a:r>
+            <a:endParaRPr lang="en-US" sz="800" dirty="0"/>
+          </a:p>
+        </p:txBody>
+      </p:sp>
+      <p:sp>
+        <p:nvSpPr>
+          <p:cNvPr id="9" name="Text 7"/>
+          <p:cNvSpPr/>
+          <p:nvPr/>
+        </p:nvSpPr>
+        <p:spPr>
+          <a:xfrm>
+            <a:off x="1737360" y="2862072"/>
+            <a:ext cx="4082796" cy="475488"/>
           </a:xfrm>
           <a:prstGeom prst="rect">
             <a:avLst/>
@@ -1657,12 +1696,12 @@
           <a:p>
             <a:pPr algn="l" indent="0" marL="0">
               <a:lnSpc>
-                <a:spcPts val="1600"/>
+                <a:spcPts val="1350"/>
               </a:lnSpc>
               <a:buNone/>
             </a:pPr>
             <a:r>
-              <a:rPr lang="en-US" sz="1150" dirty="0">
+              <a:rPr lang="en-US" sz="1000" dirty="0">
                 <a:solidFill>
                   <a:srgbClr val="33394A"/>
                 </a:solidFill>
@@ -1670,22 +1709,61 @@
                 <a:ea typeface="Calibri" pitchFamily="34" charset="-122"/>
                 <a:cs typeface="Calibri" pitchFamily="34" charset="-120"/>
               </a:rPr>
-              <a:t>Um caso construído com os seus dados, rodando e medido contra a métrica combinada por escrito na primeira semana.</a:t>
-            </a:r>
-            <a:endParaRPr lang="en-US" sz="1150" dirty="0"/>
-          </a:p>
-        </p:txBody>
-      </p:sp>
-      <p:sp>
-        <p:nvSpPr>
-          <p:cNvPr id="9" name="Text 7"/>
-          <p:cNvSpPr/>
-          <p:nvPr/>
-        </p:nvSpPr>
-        <p:spPr>
-          <a:xfrm>
-            <a:off x="822960" y="4133088"/>
-            <a:ext cx="3270504" cy="1417320"/>
+              <a:t>Do conselho à linha de frente: como o trabalho realmente flui, onde quebra, onde vaza valor, quem decide o quê.</a:t>
+            </a:r>
+            <a:endParaRPr lang="en-US" sz="1000" dirty="0"/>
+          </a:p>
+        </p:txBody>
+      </p:sp>
+      <p:sp>
+        <p:nvSpPr>
+          <p:cNvPr id="10" name="Text 8"/>
+          <p:cNvSpPr/>
+          <p:nvPr/>
+        </p:nvSpPr>
+        <p:spPr>
+          <a:xfrm>
+            <a:off x="822960" y="3438144"/>
+            <a:ext cx="868680" cy="228600"/>
+          </a:xfrm>
+          <a:prstGeom prst="rect">
+            <a:avLst/>
+          </a:prstGeom>
+          <a:noFill/>
+          <a:ln/>
+        </p:spPr>
+        <p:txBody>
+          <a:bodyPr wrap="square" rtlCol="0" anchor="ctr"/>
+          <a:lstStyle/>
+          <a:p>
+            <a:pPr indent="0" marL="0">
+              <a:buNone/>
+            </a:pPr>
+            <a:r>
+              <a:rPr lang="en-US" sz="800" b="1" spc="200" kern="0" dirty="0">
+                <a:solidFill>
+                  <a:srgbClr val="C2A35B"/>
+                </a:solidFill>
+                <a:latin typeface="Calibri" pitchFamily="34" charset="0"/>
+                <a:ea typeface="Calibri" pitchFamily="34" charset="-122"/>
+                <a:cs typeface="Calibri" pitchFamily="34" charset="-120"/>
+              </a:rPr>
+              <a:t>POR QUÊ</a:t>
+            </a:r>
+            <a:endParaRPr lang="en-US" sz="800" dirty="0"/>
+          </a:p>
+        </p:txBody>
+      </p:sp>
+      <p:sp>
+        <p:nvSpPr>
+          <p:cNvPr id="11" name="Text 9"/>
+          <p:cNvSpPr/>
+          <p:nvPr/>
+        </p:nvSpPr>
+        <p:spPr>
+          <a:xfrm>
+            <a:off x="1737360" y="3410712"/>
+            <a:ext cx="4082796" cy="347472"/>
           </a:xfrm>
           <a:prstGeom prst="rect">
             <a:avLst/>
@@ -1699,35 +1777,74 @@
           <a:p>
             <a:pPr algn="l" indent="0" marL="0">
               <a:lnSpc>
-                <a:spcPts val="1500"/>
+                <a:spcPts val="1350"/>
               </a:lnSpc>
               <a:buNone/>
             </a:pPr>
             <a:r>
-              <a:rPr lang="en-US" sz="1050" dirty="0">
-                <a:solidFill>
-                  <a:srgbClr val="6E6858"/>
-                </a:solidFill>
-                <a:latin typeface="Calibri" pitchFamily="34" charset="0"/>
-                <a:ea typeface="Calibri" pitchFamily="34" charset="-122"/>
-                <a:cs typeface="Calibri" pitchFamily="34" charset="-120"/>
-              </a:rPr>
-              <a:t>Dentro dela: a avaliação profunda, do conselho à linha de frente · o protótipo em uso real · o retrato completo de oportunidades, ranqueado por retorno e esforço.</a:t>
-            </a:r>
-            <a:endParaRPr lang="en-US" sz="1050" dirty="0"/>
-          </a:p>
-        </p:txBody>
-      </p:sp>
-      <p:sp>
-        <p:nvSpPr>
-          <p:cNvPr id="10" name="Text 8"/>
-          <p:cNvSpPr/>
-          <p:nvPr/>
-        </p:nvSpPr>
-        <p:spPr>
-          <a:xfrm>
-            <a:off x="822960" y="5577840"/>
-            <a:ext cx="3270504" cy="566928"/>
+              <a:rPr lang="en-US" sz="1000" dirty="0">
+                <a:solidFill>
+                  <a:srgbClr val="33394A"/>
+                </a:solidFill>
+                <a:latin typeface="Calibri" pitchFamily="34" charset="0"/>
+                <a:ea typeface="Calibri" pitchFamily="34" charset="-122"/>
+                <a:cs typeface="Calibri" pitchFamily="34" charset="-120"/>
+              </a:rPr>
+              <a:t>Solução genérica falha. O que funciona nasce de entender o seu negócio.</a:t>
+            </a:r>
+            <a:endParaRPr lang="en-US" sz="1000" dirty="0"/>
+          </a:p>
+        </p:txBody>
+      </p:sp>
+      <p:sp>
+        <p:nvSpPr>
+          <p:cNvPr id="12" name="Text 10"/>
+          <p:cNvSpPr/>
+          <p:nvPr/>
+        </p:nvSpPr>
+        <p:spPr>
+          <a:xfrm>
+            <a:off x="822960" y="3858768"/>
+            <a:ext cx="868680" cy="228600"/>
+          </a:xfrm>
+          <a:prstGeom prst="rect">
+            <a:avLst/>
+          </a:prstGeom>
+          <a:noFill/>
+          <a:ln/>
+        </p:spPr>
+        <p:txBody>
+          <a:bodyPr wrap="square" rtlCol="0" anchor="ctr"/>
+          <a:lstStyle/>
+          <a:p>
+            <a:pPr indent="0" marL="0">
+              <a:buNone/>
+            </a:pPr>
+            <a:r>
+              <a:rPr lang="en-US" sz="800" b="1" spc="200" kern="0" dirty="0">
+                <a:solidFill>
+                  <a:srgbClr val="C2A35B"/>
+                </a:solidFill>
+                <a:latin typeface="Calibri" pitchFamily="34" charset="0"/>
+                <a:ea typeface="Calibri" pitchFamily="34" charset="-122"/>
+                <a:cs typeface="Calibri" pitchFamily="34" charset="-120"/>
+              </a:rPr>
+              <a:t>O QUE FICA</a:t>
+            </a:r>
+            <a:endParaRPr lang="en-US" sz="800" dirty="0"/>
+          </a:p>
+        </p:txBody>
+      </p:sp>
+      <p:sp>
+        <p:nvSpPr>
+          <p:cNvPr id="13" name="Text 11"/>
+          <p:cNvSpPr/>
+          <p:nvPr/>
+        </p:nvSpPr>
+        <p:spPr>
+          <a:xfrm>
+            <a:off x="1737360" y="3831336"/>
+            <a:ext cx="4082796" cy="475488"/>
           </a:xfrm>
           <a:prstGeom prst="rect">
             <a:avLst/>
@@ -1741,41 +1858,41 @@
           <a:p>
             <a:pPr algn="l" indent="0" marL="0">
               <a:lnSpc>
-                <a:spcPts val="1500"/>
+                <a:spcPts val="1350"/>
               </a:lnSpc>
               <a:buNone/>
             </a:pPr>
             <a:r>
-              <a:rPr lang="en-US" sz="1050" i="1" dirty="0">
-                <a:solidFill>
-                  <a:srgbClr val="1B2A4A"/>
-                </a:solidFill>
-                <a:latin typeface="Calibri" pitchFamily="34" charset="0"/>
-                <a:ea typeface="Calibri" pitchFamily="34" charset="-122"/>
-                <a:cs typeface="Calibri" pitchFamily="34" charset="-120"/>
-              </a:rPr>
-              <a:t>Porque promessa não decide investimento. Número decide.</a:t>
-            </a:r>
-            <a:endParaRPr lang="en-US" sz="1050" dirty="0"/>
-          </a:p>
-        </p:txBody>
-      </p:sp>
-      <p:sp>
-        <p:nvSpPr>
-          <p:cNvPr id="11" name="Shape 9"/>
-          <p:cNvSpPr/>
-          <p:nvPr/>
-        </p:nvSpPr>
-        <p:spPr>
-          <a:xfrm>
-            <a:off x="4459224" y="2395728"/>
-            <a:ext cx="3270504" cy="0"/>
+              <a:rPr lang="en-US" sz="1000" dirty="0">
+                <a:solidFill>
+                  <a:srgbClr val="33394A"/>
+                </a:solidFill>
+                <a:latin typeface="Calibri" pitchFamily="34" charset="0"/>
+                <a:ea typeface="Calibri" pitchFamily="34" charset="-122"/>
+                <a:cs typeface="Calibri" pitchFamily="34" charset="-120"/>
+              </a:rPr>
+              <a:t>Portfólio de oportunidades ranqueado e quantificado, relatório de maturidade e plano diretor. Não uma lista de ideias.</a:t>
+            </a:r>
+            <a:endParaRPr lang="en-US" sz="1000" dirty="0"/>
+          </a:p>
+        </p:txBody>
+      </p:sp>
+      <p:sp>
+        <p:nvSpPr>
+          <p:cNvPr id="14" name="Shape 12"/>
+          <p:cNvSpPr/>
+          <p:nvPr/>
+        </p:nvSpPr>
+        <p:spPr>
+          <a:xfrm>
+            <a:off x="822960" y="4517136"/>
+            <a:ext cx="4997196" cy="0"/>
           </a:xfrm>
           <a:prstGeom prst="line">
             <a:avLst/>
           </a:prstGeom>
           <a:noFill/>
-          <a:ln w="15240">
+          <a:ln w="13970">
             <a:solidFill>
               <a:srgbClr val="C2A35B"/>
             </a:solidFill>
@@ -1785,14 +1902,14 @@
       </p:sp>
       <p:sp>
         <p:nvSpPr>
-          <p:cNvPr id="12" name="Text 10"/>
-          <p:cNvSpPr/>
-          <p:nvPr/>
-        </p:nvSpPr>
-        <p:spPr>
-          <a:xfrm>
-            <a:off x="4459224" y="2523744"/>
-            <a:ext cx="3270504" cy="292608"/>
+          <p:cNvPr id="15" name="Text 13"/>
+          <p:cNvSpPr/>
+          <p:nvPr/>
+        </p:nvSpPr>
+        <p:spPr>
+          <a:xfrm>
+            <a:off x="822960" y="4617720"/>
+            <a:ext cx="4997196" cy="292608"/>
           </a:xfrm>
           <a:prstGeom prst="rect">
             <a:avLst/>
@@ -1808,7 +1925,7 @@
               <a:buNone/>
             </a:pPr>
             <a:r>
-              <a:rPr lang="en-US" sz="1050" b="1" spc="300" kern="0" dirty="0">
+              <a:rPr lang="en-US" sz="1000" b="1" spc="300" kern="0" dirty="0">
                 <a:solidFill>
                   <a:srgbClr val="C2A35B"/>
                 </a:solidFill>
@@ -1816,22 +1933,22 @@
                 <a:ea typeface="Calibri" pitchFamily="34" charset="-122"/>
                 <a:cs typeface="Calibri" pitchFamily="34" charset="-120"/>
               </a:rPr>
-              <a:t>FASE 2 · A CONSTRUÇÃO</a:t>
-            </a:r>
-            <a:endParaRPr lang="en-US" sz="1050" dirty="0"/>
-          </a:p>
-        </p:txBody>
-      </p:sp>
-      <p:sp>
-        <p:nvSpPr>
-          <p:cNvPr id="13" name="Text 11"/>
-          <p:cNvSpPr/>
-          <p:nvPr/>
-        </p:nvSpPr>
-        <p:spPr>
-          <a:xfrm>
-            <a:off x="4459224" y="2798064"/>
-            <a:ext cx="3270504" cy="256032"/>
+              <a:t>O PROTÓTIPO · A PROVA ANTES DO INVESTIMENTO</a:t>
+            </a:r>
+            <a:endParaRPr lang="en-US" sz="1000" dirty="0"/>
+          </a:p>
+        </p:txBody>
+      </p:sp>
+      <p:sp>
+        <p:nvSpPr>
+          <p:cNvPr id="16" name="Text 14"/>
+          <p:cNvSpPr/>
+          <p:nvPr/>
+        </p:nvSpPr>
+        <p:spPr>
+          <a:xfrm>
+            <a:off x="822960" y="4919472"/>
+            <a:ext cx="868680" cy="228600"/>
           </a:xfrm>
           <a:prstGeom prst="rect">
             <a:avLst/>
@@ -1847,30 +1964,30 @@
               <a:buNone/>
             </a:pPr>
             <a:r>
-              <a:rPr lang="en-US" sz="1150" i="1" dirty="0">
-                <a:solidFill>
-                  <a:srgbClr val="6E6858"/>
-                </a:solidFill>
-                <a:latin typeface="Cambria" pitchFamily="34" charset="0"/>
-                <a:ea typeface="Cambria" pitchFamily="34" charset="-122"/>
-                <a:cs typeface="Cambria" pitchFamily="34" charset="-120"/>
-              </a:rPr>
-              <a:t>meses dois a seis</a:t>
-            </a:r>
-            <a:endParaRPr lang="en-US" sz="1150" dirty="0"/>
-          </a:p>
-        </p:txBody>
-      </p:sp>
-      <p:sp>
-        <p:nvSpPr>
-          <p:cNvPr id="14" name="Text 12"/>
-          <p:cNvSpPr/>
-          <p:nvPr/>
-        </p:nvSpPr>
-        <p:spPr>
-          <a:xfrm>
-            <a:off x="4459224" y="3090672"/>
-            <a:ext cx="3270504" cy="1005840"/>
+              <a:rPr lang="en-US" sz="800" b="1" spc="200" kern="0" dirty="0">
+                <a:solidFill>
+                  <a:srgbClr val="C2A35B"/>
+                </a:solidFill>
+                <a:latin typeface="Calibri" pitchFamily="34" charset="0"/>
+                <a:ea typeface="Calibri" pitchFamily="34" charset="-122"/>
+                <a:cs typeface="Calibri" pitchFamily="34" charset="-120"/>
+              </a:rPr>
+              <a:t>O QUÊ</a:t>
+            </a:r>
+            <a:endParaRPr lang="en-US" sz="800" dirty="0"/>
+          </a:p>
+        </p:txBody>
+      </p:sp>
+      <p:sp>
+        <p:nvSpPr>
+          <p:cNvPr id="17" name="Text 15"/>
+          <p:cNvSpPr/>
+          <p:nvPr/>
+        </p:nvSpPr>
+        <p:spPr>
+          <a:xfrm>
+            <a:off x="1737360" y="4892040"/>
+            <a:ext cx="4082796" cy="457200"/>
           </a:xfrm>
           <a:prstGeom prst="rect">
             <a:avLst/>
@@ -1884,12 +2001,12 @@
           <a:p>
             <a:pPr algn="l" indent="0" marL="0">
               <a:lnSpc>
-                <a:spcPts val="1600"/>
+                <a:spcPts val="1350"/>
               </a:lnSpc>
               <a:buNone/>
             </a:pPr>
             <a:r>
-              <a:rPr lang="en-US" sz="1150" dirty="0">
+              <a:rPr lang="en-US" sz="1000" dirty="0">
                 <a:solidFill>
                   <a:srgbClr val="33394A"/>
                 </a:solidFill>
@@ -1897,22 +2014,61 @@
                 <a:ea typeface="Calibri" pitchFamily="34" charset="-122"/>
                 <a:cs typeface="Calibri" pitchFamily="34" charset="-120"/>
               </a:rPr>
-              <a:t>Os casos aprovados entram em produção e a sua equipe aprende a operar e a criar junto.</a:t>
-            </a:r>
-            <a:endParaRPr lang="en-US" sz="1150" dirty="0"/>
-          </a:p>
-        </p:txBody>
-      </p:sp>
-      <p:sp>
-        <p:nvSpPr>
-          <p:cNvPr id="15" name="Text 13"/>
-          <p:cNvSpPr/>
-          <p:nvPr/>
-        </p:nvSpPr>
-        <p:spPr>
-          <a:xfrm>
-            <a:off x="4459224" y="4133088"/>
-            <a:ext cx="3270504" cy="1417320"/>
+              <a:t>O caso mais promissor, construído com os seus dados reais, contra critérios combinados por escrito antes.</a:t>
+            </a:r>
+            <a:endParaRPr lang="en-US" sz="1000" dirty="0"/>
+          </a:p>
+        </p:txBody>
+      </p:sp>
+      <p:sp>
+        <p:nvSpPr>
+          <p:cNvPr id="18" name="Text 16"/>
+          <p:cNvSpPr/>
+          <p:nvPr/>
+        </p:nvSpPr>
+        <p:spPr>
+          <a:xfrm>
+            <a:off x="822960" y="5449824"/>
+            <a:ext cx="868680" cy="228600"/>
+          </a:xfrm>
+          <a:prstGeom prst="rect">
+            <a:avLst/>
+          </a:prstGeom>
+          <a:noFill/>
+          <a:ln/>
+        </p:spPr>
+        <p:txBody>
+          <a:bodyPr wrap="square" rtlCol="0" anchor="ctr"/>
+          <a:lstStyle/>
+          <a:p>
+            <a:pPr indent="0" marL="0">
+              <a:buNone/>
+            </a:pPr>
+            <a:r>
+              <a:rPr lang="en-US" sz="800" b="1" spc="200" kern="0" dirty="0">
+                <a:solidFill>
+                  <a:srgbClr val="C2A35B"/>
+                </a:solidFill>
+                <a:latin typeface="Calibri" pitchFamily="34" charset="0"/>
+                <a:ea typeface="Calibri" pitchFamily="34" charset="-122"/>
+                <a:cs typeface="Calibri" pitchFamily="34" charset="-120"/>
+              </a:rPr>
+              <a:t>POR QUÊ</a:t>
+            </a:r>
+            <a:endParaRPr lang="en-US" sz="800" dirty="0"/>
+          </a:p>
+        </p:txBody>
+      </p:sp>
+      <p:sp>
+        <p:nvSpPr>
+          <p:cNvPr id="19" name="Text 17"/>
+          <p:cNvSpPr/>
+          <p:nvPr/>
+        </p:nvSpPr>
+        <p:spPr>
+          <a:xfrm>
+            <a:off x="1737360" y="5422392"/>
+            <a:ext cx="4082796" cy="475488"/>
           </a:xfrm>
           <a:prstGeom prst="rect">
             <a:avLst/>
@@ -1926,35 +2082,35 @@
           <a:p>
             <a:pPr algn="l" indent="0" marL="0">
               <a:lnSpc>
-                <a:spcPts val="1500"/>
+                <a:spcPts val="1350"/>
               </a:lnSpc>
               <a:buNone/>
             </a:pPr>
             <a:r>
-              <a:rPr lang="en-US" sz="1050" dirty="0">
-                <a:solidFill>
-                  <a:srgbClr val="6E6858"/>
-                </a:solidFill>
-                <a:latin typeface="Calibri" pitchFamily="34" charset="0"/>
-                <a:ea typeface="Calibri" pitchFamily="34" charset="-122"/>
-                <a:cs typeface="Calibri" pitchFamily="34" charset="-120"/>
-              </a:rPr>
-              <a:t>Dentro dela: arquitetura, integrações e agentes com aprovação humana nos pontos certos · a turma da sua equipe no nosso portal, com fluência medida em 30, 60 e 90 dias.</a:t>
-            </a:r>
-            <a:endParaRPr lang="en-US" sz="1050" dirty="0"/>
-          </a:p>
-        </p:txBody>
-      </p:sp>
-      <p:sp>
-        <p:nvSpPr>
-          <p:cNvPr id="16" name="Text 14"/>
-          <p:cNvSpPr/>
-          <p:nvPr/>
-        </p:nvSpPr>
-        <p:spPr>
-          <a:xfrm>
-            <a:off x="4459224" y="5577840"/>
-            <a:ext cx="3270504" cy="566928"/>
+              <a:rPr lang="en-US" sz="1000" dirty="0">
+                <a:solidFill>
+                  <a:srgbClr val="33394A"/>
+                </a:solidFill>
+                <a:latin typeface="Calibri" pitchFamily="34" charset="0"/>
+                <a:ea typeface="Calibri" pitchFamily="34" charset="-122"/>
+                <a:cs typeface="Calibri" pitchFamily="34" charset="-120"/>
+              </a:rPr>
+              <a:t>Ninguém investe no escuro. A diretoria decide GO ou NO-GO com números na mesa; NO-GO também é resultado.</a:t>
+            </a:r>
+            <a:endParaRPr lang="en-US" sz="1000" dirty="0"/>
+          </a:p>
+        </p:txBody>
+      </p:sp>
+      <p:sp>
+        <p:nvSpPr>
+          <p:cNvPr id="20" name="Text 18"/>
+          <p:cNvSpPr/>
+          <p:nvPr/>
+        </p:nvSpPr>
+        <p:spPr>
+          <a:xfrm>
+            <a:off x="6368796" y="2148840"/>
+            <a:ext cx="4997196" cy="292608"/>
           </a:xfrm>
           <a:prstGeom prst="rect">
             <a:avLst/>
@@ -1967,42 +2123,39 @@
           <a:lstStyle/>
           <a:p>
             <a:pPr algn="l" indent="0" marL="0">
-              <a:lnSpc>
-                <a:spcPts val="1500"/>
-              </a:lnSpc>
-              <a:buNone/>
-            </a:pPr>
-            <a:r>
-              <a:rPr lang="en-US" sz="1050" i="1" dirty="0">
-                <a:solidFill>
-                  <a:srgbClr val="1B2A4A"/>
-                </a:solidFill>
-                <a:latin typeface="Calibri" pitchFamily="34" charset="0"/>
-                <a:ea typeface="Calibri" pitchFamily="34" charset="-122"/>
-                <a:cs typeface="Calibri" pitchFamily="34" charset="-120"/>
-              </a:rPr>
-              <a:t>Porque sistema novo com a empresa pensando do jeito antigo não transforma nada.</a:t>
-            </a:r>
-            <a:endParaRPr lang="en-US" sz="1050" dirty="0"/>
-          </a:p>
-        </p:txBody>
-      </p:sp>
-      <p:sp>
-        <p:nvSpPr>
-          <p:cNvPr id="17" name="Shape 15"/>
-          <p:cNvSpPr/>
-          <p:nvPr/>
-        </p:nvSpPr>
-        <p:spPr>
-          <a:xfrm>
-            <a:off x="8095488" y="2395728"/>
-            <a:ext cx="3270504" cy="0"/>
+              <a:buNone/>
+            </a:pPr>
+            <a:r>
+              <a:rPr lang="en-US" sz="1100" b="1" spc="300" kern="0" dirty="0">
+                <a:solidFill>
+                  <a:srgbClr val="C2A35B"/>
+                </a:solidFill>
+                <a:latin typeface="Calibri" pitchFamily="34" charset="0"/>
+                <a:ea typeface="Calibri" pitchFamily="34" charset="-122"/>
+                <a:cs typeface="Calibri" pitchFamily="34" charset="-120"/>
+              </a:rPr>
+              <a:t>FASE 2 · A CONSTRUÇÃO · MESES 2 A 6</a:t>
+            </a:r>
+            <a:endParaRPr lang="en-US" sz="1100" dirty="0"/>
+          </a:p>
+        </p:txBody>
+      </p:sp>
+      <p:sp>
+        <p:nvSpPr>
+          <p:cNvPr id="21" name="Shape 19"/>
+          <p:cNvSpPr/>
+          <p:nvPr/>
+        </p:nvSpPr>
+        <p:spPr>
+          <a:xfrm>
+            <a:off x="6368796" y="2487168"/>
+            <a:ext cx="4997196" cy="0"/>
           </a:xfrm>
           <a:prstGeom prst="line">
             <a:avLst/>
           </a:prstGeom>
           <a:noFill/>
-          <a:ln w="15240">
+          <a:ln w="13970">
             <a:solidFill>
               <a:srgbClr val="C2A35B"/>
             </a:solidFill>
@@ -2012,14 +2165,14 @@
       </p:sp>
       <p:sp>
         <p:nvSpPr>
-          <p:cNvPr id="18" name="Text 16"/>
-          <p:cNvSpPr/>
-          <p:nvPr/>
-        </p:nvSpPr>
-        <p:spPr>
-          <a:xfrm>
-            <a:off x="8095488" y="2523744"/>
-            <a:ext cx="3270504" cy="292608"/>
+          <p:cNvPr id="22" name="Text 20"/>
+          <p:cNvSpPr/>
+          <p:nvPr/>
+        </p:nvSpPr>
+        <p:spPr>
+          <a:xfrm>
+            <a:off x="6368796" y="2587752"/>
+            <a:ext cx="4997196" cy="292608"/>
           </a:xfrm>
           <a:prstGeom prst="rect">
             <a:avLst/>
@@ -2035,7 +2188,7 @@
               <a:buNone/>
             </a:pPr>
             <a:r>
-              <a:rPr lang="en-US" sz="1050" b="1" spc="300" kern="0" dirty="0">
+              <a:rPr lang="en-US" sz="1000" b="1" spc="300" kern="0" dirty="0">
                 <a:solidFill>
                   <a:srgbClr val="C2A35B"/>
                 </a:solidFill>
@@ -2043,22 +2196,22 @@
                 <a:ea typeface="Calibri" pitchFamily="34" charset="-122"/>
                 <a:cs typeface="Calibri" pitchFamily="34" charset="-120"/>
               </a:rPr>
-              <a:t>FASE 3 · A DURABILIDADE</a:t>
-            </a:r>
-            <a:endParaRPr lang="en-US" sz="1050" dirty="0"/>
-          </a:p>
-        </p:txBody>
-      </p:sp>
-      <p:sp>
-        <p:nvSpPr>
-          <p:cNvPr id="19" name="Text 17"/>
-          <p:cNvSpPr/>
-          <p:nvPr/>
-        </p:nvSpPr>
-        <p:spPr>
-          <a:xfrm>
-            <a:off x="8095488" y="2798064"/>
-            <a:ext cx="3270504" cy="256032"/>
+              <a:t>CONSTRUÇÃO E IMPLANTAÇÃO · A ENGENHARIA</a:t>
+            </a:r>
+            <a:endParaRPr lang="en-US" sz="1000" dirty="0"/>
+          </a:p>
+        </p:txBody>
+      </p:sp>
+      <p:sp>
+        <p:nvSpPr>
+          <p:cNvPr id="23" name="Text 21"/>
+          <p:cNvSpPr/>
+          <p:nvPr/>
+        </p:nvSpPr>
+        <p:spPr>
+          <a:xfrm>
+            <a:off x="6368796" y="2889504"/>
+            <a:ext cx="868680" cy="228600"/>
           </a:xfrm>
           <a:prstGeom prst="rect">
             <a:avLst/>
@@ -2074,91 +2227,516 @@
               <a:buNone/>
             </a:pPr>
             <a:r>
-              <a:rPr lang="en-US" sz="1150" i="1" dirty="0">
-                <a:solidFill>
-                  <a:srgbClr val="6E6858"/>
+              <a:rPr lang="en-US" sz="800" b="1" spc="200" kern="0" dirty="0">
+                <a:solidFill>
+                  <a:srgbClr val="C2A35B"/>
+                </a:solidFill>
+                <a:latin typeface="Calibri" pitchFamily="34" charset="0"/>
+                <a:ea typeface="Calibri" pitchFamily="34" charset="-122"/>
+                <a:cs typeface="Calibri" pitchFamily="34" charset="-120"/>
+              </a:rPr>
+              <a:t>O QUÊ</a:t>
+            </a:r>
+            <a:endParaRPr lang="en-US" sz="800" dirty="0"/>
+          </a:p>
+        </p:txBody>
+      </p:sp>
+      <p:sp>
+        <p:nvSpPr>
+          <p:cNvPr id="24" name="Text 22"/>
+          <p:cNvSpPr/>
+          <p:nvPr/>
+        </p:nvSpPr>
+        <p:spPr>
+          <a:xfrm>
+            <a:off x="7283196" y="2862072"/>
+            <a:ext cx="4082796" cy="457200"/>
+          </a:xfrm>
+          <a:prstGeom prst="rect">
+            <a:avLst/>
+          </a:prstGeom>
+          <a:noFill/>
+          <a:ln/>
+        </p:spPr>
+        <p:txBody>
+          <a:bodyPr wrap="square" rtlCol="0" anchor="ctr"/>
+          <a:lstStyle/>
+          <a:p>
+            <a:pPr algn="l" indent="0" marL="0">
+              <a:lnSpc>
+                <a:spcPts val="1350"/>
+              </a:lnSpc>
+              <a:buNone/>
+            </a:pPr>
+            <a:r>
+              <a:rPr lang="en-US" sz="1000" dirty="0">
+                <a:solidFill>
+                  <a:srgbClr val="33394A"/>
+                </a:solidFill>
+                <a:latin typeface="Calibri" pitchFamily="34" charset="0"/>
+                <a:ea typeface="Calibri" pitchFamily="34" charset="-122"/>
+                <a:cs typeface="Calibri" pitchFamily="34" charset="-120"/>
+              </a:rPr>
+              <a:t>Arquitetura, integrações e agentes de IA sob medida, em produção no fluxo real da sua equipe.</a:t>
+            </a:r>
+            <a:endParaRPr lang="en-US" sz="1000" dirty="0"/>
+          </a:p>
+        </p:txBody>
+      </p:sp>
+      <p:sp>
+        <p:nvSpPr>
+          <p:cNvPr id="25" name="Text 23"/>
+          <p:cNvSpPr/>
+          <p:nvPr/>
+        </p:nvSpPr>
+        <p:spPr>
+          <a:xfrm>
+            <a:off x="6368796" y="3419856"/>
+            <a:ext cx="868680" cy="228600"/>
+          </a:xfrm>
+          <a:prstGeom prst="rect">
+            <a:avLst/>
+          </a:prstGeom>
+          <a:noFill/>
+          <a:ln/>
+        </p:spPr>
+        <p:txBody>
+          <a:bodyPr wrap="square" rtlCol="0" anchor="ctr"/>
+          <a:lstStyle/>
+          <a:p>
+            <a:pPr indent="0" marL="0">
+              <a:buNone/>
+            </a:pPr>
+            <a:r>
+              <a:rPr lang="en-US" sz="800" b="1" spc="200" kern="0" dirty="0">
+                <a:solidFill>
+                  <a:srgbClr val="C2A35B"/>
+                </a:solidFill>
+                <a:latin typeface="Calibri" pitchFamily="34" charset="0"/>
+                <a:ea typeface="Calibri" pitchFamily="34" charset="-122"/>
+                <a:cs typeface="Calibri" pitchFamily="34" charset="-120"/>
+              </a:rPr>
+              <a:t>POR QUÊ</a:t>
+            </a:r>
+            <a:endParaRPr lang="en-US" sz="800" dirty="0"/>
+          </a:p>
+        </p:txBody>
+      </p:sp>
+      <p:sp>
+        <p:nvSpPr>
+          <p:cNvPr id="26" name="Text 24"/>
+          <p:cNvSpPr/>
+          <p:nvPr/>
+        </p:nvSpPr>
+        <p:spPr>
+          <a:xfrm>
+            <a:off x="7283196" y="3392424"/>
+            <a:ext cx="4082796" cy="347472"/>
+          </a:xfrm>
+          <a:prstGeom prst="rect">
+            <a:avLst/>
+          </a:prstGeom>
+          <a:noFill/>
+          <a:ln/>
+        </p:spPr>
+        <p:txBody>
+          <a:bodyPr wrap="square" rtlCol="0" anchor="ctr"/>
+          <a:lstStyle/>
+          <a:p>
+            <a:pPr algn="l" indent="0" marL="0">
+              <a:lnSpc>
+                <a:spcPts val="1350"/>
+              </a:lnSpc>
+              <a:buNone/>
+            </a:pPr>
+            <a:r>
+              <a:rPr lang="en-US" sz="1000" dirty="0">
+                <a:solidFill>
+                  <a:srgbClr val="33394A"/>
+                </a:solidFill>
+                <a:latin typeface="Calibri" pitchFamily="34" charset="0"/>
+                <a:ea typeface="Calibri" pitchFamily="34" charset="-122"/>
+                <a:cs typeface="Calibri" pitchFamily="34" charset="-120"/>
+              </a:rPr>
+              <a:t>Relatório na gaveta não muda empresa. Sistema rodando muda.</a:t>
+            </a:r>
+            <a:endParaRPr lang="en-US" sz="1000" dirty="0"/>
+          </a:p>
+        </p:txBody>
+      </p:sp>
+      <p:sp>
+        <p:nvSpPr>
+          <p:cNvPr id="27" name="Text 25"/>
+          <p:cNvSpPr/>
+          <p:nvPr/>
+        </p:nvSpPr>
+        <p:spPr>
+          <a:xfrm>
+            <a:off x="6368796" y="3840480"/>
+            <a:ext cx="868680" cy="228600"/>
+          </a:xfrm>
+          <a:prstGeom prst="rect">
+            <a:avLst/>
+          </a:prstGeom>
+          <a:noFill/>
+          <a:ln/>
+        </p:spPr>
+        <p:txBody>
+          <a:bodyPr wrap="square" rtlCol="0" anchor="ctr"/>
+          <a:lstStyle/>
+          <a:p>
+            <a:pPr indent="0" marL="0">
+              <a:buNone/>
+            </a:pPr>
+            <a:r>
+              <a:rPr lang="en-US" sz="800" b="1" spc="200" kern="0" dirty="0">
+                <a:solidFill>
+                  <a:srgbClr val="C2A35B"/>
+                </a:solidFill>
+                <a:latin typeface="Calibri" pitchFamily="34" charset="0"/>
+                <a:ea typeface="Calibri" pitchFamily="34" charset="-122"/>
+                <a:cs typeface="Calibri" pitchFamily="34" charset="-120"/>
+              </a:rPr>
+              <a:t>COMO</a:t>
+            </a:r>
+            <a:endParaRPr lang="en-US" sz="800" dirty="0"/>
+          </a:p>
+        </p:txBody>
+      </p:sp>
+      <p:sp>
+        <p:nvSpPr>
+          <p:cNvPr id="28" name="Text 26"/>
+          <p:cNvSpPr/>
+          <p:nvPr/>
+        </p:nvSpPr>
+        <p:spPr>
+          <a:xfrm>
+            <a:off x="7283196" y="3813048"/>
+            <a:ext cx="4082796" cy="475488"/>
+          </a:xfrm>
+          <a:prstGeom prst="rect">
+            <a:avLst/>
+          </a:prstGeom>
+          <a:noFill/>
+          <a:ln/>
+        </p:spPr>
+        <p:txBody>
+          <a:bodyPr wrap="square" rtlCol="0" anchor="ctr"/>
+          <a:lstStyle/>
+          <a:p>
+            <a:pPr algn="l" indent="0" marL="0">
+              <a:lnSpc>
+                <a:spcPts val="1350"/>
+              </a:lnSpc>
+              <a:buNone/>
+            </a:pPr>
+            <a:r>
+              <a:rPr lang="en-US" sz="1000" dirty="0">
+                <a:solidFill>
+                  <a:srgbClr val="33394A"/>
+                </a:solidFill>
+                <a:latin typeface="Calibri" pitchFamily="34" charset="0"/>
+                <a:ea typeface="Calibri" pitchFamily="34" charset="-122"/>
+                <a:cs typeface="Calibri" pitchFamily="34" charset="-120"/>
+              </a:rPr>
+              <a:t>Aprovação humana em tudo que é crítico: a IA executa, gente da sua confiança valida. Testes de aceite antes do trabalho real.</a:t>
+            </a:r>
+            <a:endParaRPr lang="en-US" sz="1000" dirty="0"/>
+          </a:p>
+        </p:txBody>
+      </p:sp>
+      <p:sp>
+        <p:nvSpPr>
+          <p:cNvPr id="29" name="Shape 27"/>
+          <p:cNvSpPr/>
+          <p:nvPr/>
+        </p:nvSpPr>
+        <p:spPr>
+          <a:xfrm>
+            <a:off x="6368796" y="4498848"/>
+            <a:ext cx="4997196" cy="0"/>
+          </a:xfrm>
+          <a:prstGeom prst="line">
+            <a:avLst/>
+          </a:prstGeom>
+          <a:noFill/>
+          <a:ln w="13970">
+            <a:solidFill>
+              <a:srgbClr val="C2A35B"/>
+            </a:solidFill>
+            <a:prstDash val="solid"/>
+          </a:ln>
+        </p:spPr>
+      </p:sp>
+      <p:sp>
+        <p:nvSpPr>
+          <p:cNvPr id="30" name="Text 28"/>
+          <p:cNvSpPr/>
+          <p:nvPr/>
+        </p:nvSpPr>
+        <p:spPr>
+          <a:xfrm>
+            <a:off x="6368796" y="4599432"/>
+            <a:ext cx="4997196" cy="292608"/>
+          </a:xfrm>
+          <a:prstGeom prst="rect">
+            <a:avLst/>
+          </a:prstGeom>
+          <a:noFill/>
+          <a:ln/>
+        </p:spPr>
+        <p:txBody>
+          <a:bodyPr wrap="square" rtlCol="0" anchor="ctr"/>
+          <a:lstStyle/>
+          <a:p>
+            <a:pPr algn="l" indent="0" marL="0">
+              <a:buNone/>
+            </a:pPr>
+            <a:r>
+              <a:rPr lang="en-US" sz="1000" b="1" spc="300" kern="0" dirty="0">
+                <a:solidFill>
+                  <a:srgbClr val="C2A35B"/>
+                </a:solidFill>
+                <a:latin typeface="Calibri" pitchFamily="34" charset="0"/>
+                <a:ea typeface="Calibri" pitchFamily="34" charset="-122"/>
+                <a:cs typeface="Calibri" pitchFamily="34" charset="-120"/>
+              </a:rPr>
+              <a:t>TREINAMENTO + ABBA PORTAL · A MENTALIDADE NOVA</a:t>
+            </a:r>
+            <a:endParaRPr lang="en-US" sz="1000" dirty="0"/>
+          </a:p>
+        </p:txBody>
+      </p:sp>
+      <p:sp>
+        <p:nvSpPr>
+          <p:cNvPr id="31" name="Text 29"/>
+          <p:cNvSpPr/>
+          <p:nvPr/>
+        </p:nvSpPr>
+        <p:spPr>
+          <a:xfrm>
+            <a:off x="6368796" y="4901184"/>
+            <a:ext cx="868680" cy="228600"/>
+          </a:xfrm>
+          <a:prstGeom prst="rect">
+            <a:avLst/>
+          </a:prstGeom>
+          <a:noFill/>
+          <a:ln/>
+        </p:spPr>
+        <p:txBody>
+          <a:bodyPr wrap="square" rtlCol="0" anchor="ctr"/>
+          <a:lstStyle/>
+          <a:p>
+            <a:pPr indent="0" marL="0">
+              <a:buNone/>
+            </a:pPr>
+            <a:r>
+              <a:rPr lang="en-US" sz="800" b="1" spc="200" kern="0" dirty="0">
+                <a:solidFill>
+                  <a:srgbClr val="C2A35B"/>
+                </a:solidFill>
+                <a:latin typeface="Calibri" pitchFamily="34" charset="0"/>
+                <a:ea typeface="Calibri" pitchFamily="34" charset="-122"/>
+                <a:cs typeface="Calibri" pitchFamily="34" charset="-120"/>
+              </a:rPr>
+              <a:t>O QUÊ</a:t>
+            </a:r>
+            <a:endParaRPr lang="en-US" sz="800" dirty="0"/>
+          </a:p>
+        </p:txBody>
+      </p:sp>
+      <p:sp>
+        <p:nvSpPr>
+          <p:cNvPr id="32" name="Text 30"/>
+          <p:cNvSpPr/>
+          <p:nvPr/>
+        </p:nvSpPr>
+        <p:spPr>
+          <a:xfrm>
+            <a:off x="7283196" y="4873752"/>
+            <a:ext cx="4082796" cy="457200"/>
+          </a:xfrm>
+          <a:prstGeom prst="rect">
+            <a:avLst/>
+          </a:prstGeom>
+          <a:noFill/>
+          <a:ln/>
+        </p:spPr>
+        <p:txBody>
+          <a:bodyPr wrap="square" rtlCol="0" anchor="ctr"/>
+          <a:lstStyle/>
+          <a:p>
+            <a:pPr algn="l" indent="0" marL="0">
+              <a:lnSpc>
+                <a:spcPts val="1350"/>
+              </a:lnSpc>
+              <a:buNone/>
+            </a:pPr>
+            <a:r>
+              <a:rPr lang="en-US" sz="1000" dirty="0">
+                <a:solidFill>
+                  <a:srgbClr val="33394A"/>
+                </a:solidFill>
+                <a:latin typeface="Calibri" pitchFamily="34" charset="0"/>
+                <a:ea typeface="Calibri" pitchFamily="34" charset="-122"/>
+                <a:cs typeface="Calibri" pitchFamily="34" charset="-120"/>
+              </a:rPr>
+              <a:t>Todos os níveis, em plataforma própria e sessões presenciais, com fluência medida em 30, 60 e 90 dias.</a:t>
+            </a:r>
+            <a:endParaRPr lang="en-US" sz="1000" dirty="0"/>
+          </a:p>
+        </p:txBody>
+      </p:sp>
+      <p:sp>
+        <p:nvSpPr>
+          <p:cNvPr id="33" name="Text 31"/>
+          <p:cNvSpPr/>
+          <p:nvPr/>
+        </p:nvSpPr>
+        <p:spPr>
+          <a:xfrm>
+            <a:off x="6368796" y="5431536"/>
+            <a:ext cx="868680" cy="228600"/>
+          </a:xfrm>
+          <a:prstGeom prst="rect">
+            <a:avLst/>
+          </a:prstGeom>
+          <a:noFill/>
+          <a:ln/>
+        </p:spPr>
+        <p:txBody>
+          <a:bodyPr wrap="square" rtlCol="0" anchor="ctr"/>
+          <a:lstStyle/>
+          <a:p>
+            <a:pPr indent="0" marL="0">
+              <a:buNone/>
+            </a:pPr>
+            <a:r>
+              <a:rPr lang="en-US" sz="800" b="1" spc="200" kern="0" dirty="0">
+                <a:solidFill>
+                  <a:srgbClr val="C2A35B"/>
+                </a:solidFill>
+                <a:latin typeface="Calibri" pitchFamily="34" charset="0"/>
+                <a:ea typeface="Calibri" pitchFamily="34" charset="-122"/>
+                <a:cs typeface="Calibri" pitchFamily="34" charset="-120"/>
+              </a:rPr>
+              <a:t>POR QUÊ</a:t>
+            </a:r>
+            <a:endParaRPr lang="en-US" sz="800" dirty="0"/>
+          </a:p>
+        </p:txBody>
+      </p:sp>
+      <p:sp>
+        <p:nvSpPr>
+          <p:cNvPr id="34" name="Text 32"/>
+          <p:cNvSpPr/>
+          <p:nvPr/>
+        </p:nvSpPr>
+        <p:spPr>
+          <a:xfrm>
+            <a:off x="7283196" y="5404104"/>
+            <a:ext cx="4082796" cy="475488"/>
+          </a:xfrm>
+          <a:prstGeom prst="rect">
+            <a:avLst/>
+          </a:prstGeom>
+          <a:noFill/>
+          <a:ln/>
+        </p:spPr>
+        <p:txBody>
+          <a:bodyPr wrap="square" rtlCol="0" anchor="ctr"/>
+          <a:lstStyle/>
+          <a:p>
+            <a:pPr algn="l" indent="0" marL="0">
+              <a:lnSpc>
+                <a:spcPts val="1350"/>
+              </a:lnSpc>
+              <a:buNone/>
+            </a:pPr>
+            <a:r>
+              <a:rPr lang="en-US" sz="1000" dirty="0">
+                <a:solidFill>
+                  <a:srgbClr val="33394A"/>
+                </a:solidFill>
+                <a:latin typeface="Calibri" pitchFamily="34" charset="0"/>
+                <a:ea typeface="Calibri" pitchFamily="34" charset="-122"/>
+                <a:cs typeface="Calibri" pitchFamily="34" charset="-120"/>
+              </a:rPr>
+              <a:t>O objetivo não é ensinar ferramenta: é instalar as três perguntas (parar · começar · só eu) em cada pessoa.</a:t>
+            </a:r>
+            <a:endParaRPr lang="en-US" sz="1000" dirty="0"/>
+          </a:p>
+        </p:txBody>
+      </p:sp>
+      <p:sp>
+        <p:nvSpPr>
+          <p:cNvPr id="35" name="Text 33"/>
+          <p:cNvSpPr/>
+          <p:nvPr/>
+        </p:nvSpPr>
+        <p:spPr>
+          <a:xfrm>
+            <a:off x="822960" y="6053328"/>
+            <a:ext cx="10543032" cy="411480"/>
+          </a:xfrm>
+          <a:prstGeom prst="rect">
+            <a:avLst/>
+          </a:prstGeom>
+          <a:noFill/>
+          <a:ln/>
+        </p:spPr>
+        <p:txBody>
+          <a:bodyPr wrap="square" rtlCol="0" anchor="ctr"/>
+          <a:lstStyle/>
+          <a:p>
+            <a:pPr algn="ctr" indent="0" marL="0">
+              <a:lnSpc>
+                <a:spcPts val="1350"/>
+              </a:lnSpc>
+              <a:buNone/>
+            </a:pPr>
+            <a:r>
+              <a:rPr lang="en-US" sz="1050" i="1" dirty="0">
+                <a:solidFill>
+                  <a:srgbClr val="1B2A4A"/>
                 </a:solidFill>
                 <a:latin typeface="Cambria" pitchFamily="34" charset="0"/>
                 <a:ea typeface="Cambria" pitchFamily="34" charset="-122"/>
                 <a:cs typeface="Cambria" pitchFamily="34" charset="-120"/>
               </a:rPr>
-              <a:t>meses sete a doze</a:t>
-            </a:r>
-            <a:endParaRPr lang="en-US" sz="1150" dirty="0"/>
-          </a:p>
-        </p:txBody>
-      </p:sp>
-      <p:sp>
-        <p:nvSpPr>
-          <p:cNvPr id="20" name="Text 18"/>
-          <p:cNvSpPr/>
-          <p:nvPr/>
-        </p:nvSpPr>
-        <p:spPr>
-          <a:xfrm>
-            <a:off x="8095488" y="3090672"/>
-            <a:ext cx="3270504" cy="1005840"/>
-          </a:xfrm>
-          <a:prstGeom prst="rect">
-            <a:avLst/>
-          </a:prstGeom>
-          <a:noFill/>
-          <a:ln/>
-        </p:spPr>
-        <p:txBody>
-          <a:bodyPr wrap="square" rtlCol="0" anchor="ctr"/>
-          <a:lstStyle/>
-          <a:p>
-            <a:pPr algn="l" indent="0" marL="0">
-              <a:lnSpc>
-                <a:spcPts val="1600"/>
-              </a:lnSpc>
-              <a:buNone/>
-            </a:pPr>
-            <a:r>
-              <a:rPr lang="en-US" sz="1150" dirty="0">
-                <a:solidFill>
-                  <a:srgbClr val="33394A"/>
-                </a:solidFill>
-                <a:latin typeface="Calibri" pitchFamily="34" charset="0"/>
-                <a:ea typeface="Calibri" pitchFamily="34" charset="-122"/>
-                <a:cs typeface="Calibri" pitchFamily="34" charset="-120"/>
-              </a:rPr>
-              <a:t>A capacidade rodando no dia a dia, com a nossa mão cada vez mais leve, de propósito.</a:t>
-            </a:r>
-            <a:endParaRPr lang="en-US" sz="1150" dirty="0"/>
-          </a:p>
-        </p:txBody>
-      </p:sp>
-      <p:sp>
-        <p:nvSpPr>
-          <p:cNvPr id="21" name="Text 19"/>
-          <p:cNvSpPr/>
-          <p:nvPr/>
-        </p:nvSpPr>
-        <p:spPr>
-          <a:xfrm>
-            <a:off x="8095488" y="4133088"/>
-            <a:ext cx="3270504" cy="1417320"/>
-          </a:xfrm>
-          <a:prstGeom prst="rect">
-            <a:avLst/>
-          </a:prstGeom>
-          <a:noFill/>
-          <a:ln/>
-        </p:spPr>
-        <p:txBody>
-          <a:bodyPr wrap="square" rtlCol="0" anchor="ctr"/>
-          <a:lstStyle/>
-          <a:p>
-            <a:pPr algn="l" indent="0" marL="0">
-              <a:lnSpc>
-                <a:spcPts val="1500"/>
-              </a:lnSpc>
-              <a:buNone/>
-            </a:pPr>
-            <a:r>
-              <a:rPr lang="en-US" sz="1050" dirty="0">
+              <a:t>O Portão da Prova: ao término da fase 1, a decisão de continuar é integralmente sua. Se o resultado medido não confirmar o critério combinado, o Programa se encerra ali, sem multa e com os entregáveis em suas mãos.</a:t>
+            </a:r>
+            <a:endParaRPr lang="en-US" sz="1050" dirty="0"/>
+          </a:p>
+        </p:txBody>
+      </p:sp>
+      <p:sp>
+        <p:nvSpPr>
+          <p:cNvPr id="36" name="Text 34"/>
+          <p:cNvSpPr/>
+          <p:nvPr/>
+        </p:nvSpPr>
+        <p:spPr>
+          <a:xfrm>
+            <a:off x="822960" y="6400800"/>
+            <a:ext cx="10543032" cy="274320"/>
+          </a:xfrm>
+          <a:prstGeom prst="rect">
+            <a:avLst/>
+          </a:prstGeom>
+          <a:noFill/>
+          <a:ln/>
+        </p:spPr>
+        <p:txBody>
+          <a:bodyPr wrap="square" rtlCol="0" anchor="ctr"/>
+          <a:lstStyle/>
+          <a:p>
+            <a:pPr algn="ctr" indent="0" marL="0">
+              <a:buNone/>
+            </a:pPr>
+            <a:r>
+              <a:rPr lang="en-US" sz="900" spc="100" kern="0" dirty="0">
                 <a:solidFill>
                   <a:srgbClr val="6E6858"/>
                 </a:solidFill>
@@ -2166,93 +2744,9 @@
                 <a:ea typeface="Calibri" pitchFamily="34" charset="-122"/>
                 <a:cs typeface="Calibri" pitchFamily="34" charset="-120"/>
               </a:rPr>
-              <a:t>Dentro dela: operação sob SLA com presença semanal · relatório mensal de projetado versus realizado · o ritual com a diretoria e o registro de cada decisão.</a:t>
-            </a:r>
-            <a:endParaRPr lang="en-US" sz="1050" dirty="0"/>
-          </a:p>
-        </p:txBody>
-      </p:sp>
-      <p:sp>
-        <p:nvSpPr>
-          <p:cNvPr id="22" name="Text 20"/>
-          <p:cNvSpPr/>
-          <p:nvPr/>
-        </p:nvSpPr>
-        <p:spPr>
-          <a:xfrm>
-            <a:off x="8095488" y="5577840"/>
-            <a:ext cx="3270504" cy="566928"/>
-          </a:xfrm>
-          <a:prstGeom prst="rect">
-            <a:avLst/>
-          </a:prstGeom>
-          <a:noFill/>
-          <a:ln/>
-        </p:spPr>
-        <p:txBody>
-          <a:bodyPr wrap="square" rtlCol="0" anchor="ctr"/>
-          <a:lstStyle/>
-          <a:p>
-            <a:pPr algn="l" indent="0" marL="0">
-              <a:lnSpc>
-                <a:spcPts val="1500"/>
-              </a:lnSpc>
-              <a:buNone/>
-            </a:pPr>
-            <a:r>
-              <a:rPr lang="en-US" sz="1050" i="1" dirty="0">
-                <a:solidFill>
-                  <a:srgbClr val="1B2A4A"/>
-                </a:solidFill>
-                <a:latin typeface="Calibri" pitchFamily="34" charset="0"/>
-                <a:ea typeface="Calibri" pitchFamily="34" charset="-122"/>
-                <a:cs typeface="Calibri" pitchFamily="34" charset="-120"/>
-              </a:rPr>
-              <a:t>Porque a única prova que importa é funcionar sem consultor no meio.</a:t>
-            </a:r>
-            <a:endParaRPr lang="en-US" sz="1050" dirty="0"/>
-          </a:p>
-        </p:txBody>
-      </p:sp>
-      <p:sp>
-        <p:nvSpPr>
-          <p:cNvPr id="23" name="Text 21"/>
-          <p:cNvSpPr/>
-          <p:nvPr/>
-        </p:nvSpPr>
-        <p:spPr>
-          <a:xfrm>
-            <a:off x="822960" y="6108192"/>
-            <a:ext cx="10543032" cy="384048"/>
-          </a:xfrm>
-          <a:prstGeom prst="rect">
-            <a:avLst/>
-          </a:prstGeom>
-          <a:noFill/>
-          <a:ln/>
-        </p:spPr>
-        <p:txBody>
-          <a:bodyPr wrap="square" rtlCol="0" anchor="ctr"/>
-          <a:lstStyle/>
-          <a:p>
-            <a:pPr algn="ctr" indent="0" marL="0">
-              <a:lnSpc>
-                <a:spcPts val="1400"/>
-              </a:lnSpc>
-              <a:buNone/>
-            </a:pPr>
-            <a:r>
-              <a:rPr lang="en-US" sz="1100" i="1" dirty="0">
-                <a:solidFill>
-                  <a:srgbClr val="1B2A4A"/>
-                </a:solidFill>
-                <a:latin typeface="Cambria" pitchFamily="34" charset="0"/>
-                <a:ea typeface="Cambria" pitchFamily="34" charset="-122"/>
-                <a:cs typeface="Cambria" pitchFamily="34" charset="-120"/>
-              </a:rPr>
-              <a:t>O Portão da Prova: ao fim da fase 1 a decisão volta para a sua mão. Se o número não apareceu, ou se você simplesmente mudar de ideia, você sai levando tudo o que foi produzido. Sem multa e sem constrangimento.</a:t>
-            </a:r>
-            <a:endParaRPr lang="en-US" sz="1100" dirty="0"/>
+              <a:t>ABBA Consultoria de IA · contato@abbaservices.com.br</a:t>
+            </a:r>
+            <a:endParaRPr lang="en-US" sz="900" dirty="0"/>
           </a:p>
         </p:txBody>
       </p:sp>
@@ -2296,8 +2790,8 @@
         </p:nvSpPr>
         <p:spPr>
           <a:xfrm>
-            <a:off x="822960" y="548640"/>
-            <a:ext cx="5486400" cy="292608"/>
+            <a:off x="822960" y="502920"/>
+            <a:ext cx="8229600" cy="292608"/>
           </a:xfrm>
           <a:prstGeom prst="rect">
             <a:avLst/>
@@ -2321,7 +2815,7 @@
                 <a:ea typeface="Calibri" pitchFamily="34" charset="-122"/>
                 <a:cs typeface="Calibri" pitchFamily="34" charset="-120"/>
               </a:rPr>
-              <a:t>DEPOIS DO PRIMEIRO ANO</a:t>
+              <a:t>O PROGRAMA · SEGUNDA PARTE</a:t>
             </a:r>
             <a:endParaRPr lang="en-US" sz="1100" dirty="0"/>
           </a:p>
@@ -2335,8 +2829,8 @@
         </p:nvSpPr>
         <p:spPr>
           <a:xfrm>
-            <a:off x="822960" y="868680"/>
-            <a:ext cx="10543032" cy="685800"/>
+            <a:off x="822960" y="822960"/>
+            <a:ext cx="10543032" cy="594360"/>
           </a:xfrm>
           <a:prstGeom prst="rect">
             <a:avLst/>
@@ -2352,7 +2846,7 @@
               <a:buNone/>
             </a:pPr>
             <a:r>
-              <a:rPr lang="en-US" sz="2500" b="1" dirty="0">
+              <a:rPr lang="en-US" sz="2300" b="1" dirty="0">
                 <a:solidFill>
                   <a:srgbClr val="1B2A4A"/>
                 </a:solidFill>
@@ -2360,22 +2854,123 @@
                 <a:ea typeface="Cambria" pitchFamily="34" charset="-122"/>
                 <a:cs typeface="Cambria" pitchFamily="34" charset="-120"/>
               </a:rPr>
-              <a:t>A relação não termina: ela passa a ser medida todo ano.</a:t>
-            </a:r>
-            <a:endParaRPr lang="en-US" sz="2500" dirty="0"/>
-          </a:p>
-        </p:txBody>
-      </p:sp>
-      <p:sp>
-        <p:nvSpPr>
-          <p:cNvPr id="4" name="Text 2"/>
-          <p:cNvSpPr/>
-          <p:nvPr/>
-        </p:nvSpPr>
-        <p:spPr>
-          <a:xfrm>
-            <a:off x="822960" y="1600200"/>
-            <a:ext cx="10543032" cy="1051560"/>
+              <a:t>A operação com presença, e a medição que não para.</a:t>
+            </a:r>
+            <a:endParaRPr lang="en-US" sz="2300" dirty="0"/>
+          </a:p>
+        </p:txBody>
+      </p:sp>
+      <p:sp>
+        <p:nvSpPr>
+          <p:cNvPr id="4" name="Shape 2"/>
+          <p:cNvSpPr/>
+          <p:nvPr/>
+        </p:nvSpPr>
+        <p:spPr>
+          <a:xfrm>
+            <a:off x="822960" y="1554480"/>
+            <a:ext cx="4997196" cy="0"/>
+          </a:xfrm>
+          <a:prstGeom prst="line">
+            <a:avLst/>
+          </a:prstGeom>
+          <a:noFill/>
+          <a:ln w="13970">
+            <a:solidFill>
+              <a:srgbClr val="C2A35B"/>
+            </a:solidFill>
+            <a:prstDash val="solid"/>
+          </a:ln>
+        </p:spPr>
+      </p:sp>
+      <p:sp>
+        <p:nvSpPr>
+          <p:cNvPr id="5" name="Text 3"/>
+          <p:cNvSpPr/>
+          <p:nvPr/>
+        </p:nvSpPr>
+        <p:spPr>
+          <a:xfrm>
+            <a:off x="822960" y="1655064"/>
+            <a:ext cx="4997196" cy="292608"/>
+          </a:xfrm>
+          <a:prstGeom prst="rect">
+            <a:avLst/>
+          </a:prstGeom>
+          <a:noFill/>
+          <a:ln/>
+        </p:spPr>
+        <p:txBody>
+          <a:bodyPr wrap="square" rtlCol="0" anchor="ctr"/>
+          <a:lstStyle/>
+          <a:p>
+            <a:pPr algn="l" indent="0" marL="0">
+              <a:buNone/>
+            </a:pPr>
+            <a:r>
+              <a:rPr lang="en-US" sz="1000" b="1" spc="300" kern="0" dirty="0">
+                <a:solidFill>
+                  <a:srgbClr val="C2A35B"/>
+                </a:solidFill>
+                <a:latin typeface="Calibri" pitchFamily="34" charset="0"/>
+                <a:ea typeface="Calibri" pitchFamily="34" charset="-122"/>
+                <a:cs typeface="Calibri" pitchFamily="34" charset="-120"/>
+              </a:rPr>
+              <a:t>FASE 3 · SISTEMAS GERENCIADOS · MESES 7 A 12</a:t>
+            </a:r>
+            <a:endParaRPr lang="en-US" sz="1000" dirty="0"/>
+          </a:p>
+        </p:txBody>
+      </p:sp>
+      <p:sp>
+        <p:nvSpPr>
+          <p:cNvPr id="6" name="Text 4"/>
+          <p:cNvSpPr/>
+          <p:nvPr/>
+        </p:nvSpPr>
+        <p:spPr>
+          <a:xfrm>
+            <a:off x="822960" y="1956816"/>
+            <a:ext cx="868680" cy="228600"/>
+          </a:xfrm>
+          <a:prstGeom prst="rect">
+            <a:avLst/>
+          </a:prstGeom>
+          <a:noFill/>
+          <a:ln/>
+        </p:spPr>
+        <p:txBody>
+          <a:bodyPr wrap="square" rtlCol="0" anchor="ctr"/>
+          <a:lstStyle/>
+          <a:p>
+            <a:pPr indent="0" marL="0">
+              <a:buNone/>
+            </a:pPr>
+            <a:r>
+              <a:rPr lang="en-US" sz="800" b="1" spc="200" kern="0" dirty="0">
+                <a:solidFill>
+                  <a:srgbClr val="C2A35B"/>
+                </a:solidFill>
+                <a:latin typeface="Calibri" pitchFamily="34" charset="0"/>
+                <a:ea typeface="Calibri" pitchFamily="34" charset="-122"/>
+                <a:cs typeface="Calibri" pitchFamily="34" charset="-120"/>
+              </a:rPr>
+              <a:t>O QUÊ</a:t>
+            </a:r>
+            <a:endParaRPr lang="en-US" sz="800" dirty="0"/>
+          </a:p>
+        </p:txBody>
+      </p:sp>
+      <p:sp>
+        <p:nvSpPr>
+          <p:cNvPr id="7" name="Text 5"/>
+          <p:cNvSpPr/>
+          <p:nvPr/>
+        </p:nvSpPr>
+        <p:spPr>
+          <a:xfrm>
+            <a:off x="1737360" y="1929384"/>
+            <a:ext cx="4082796" cy="475488"/>
           </a:xfrm>
           <a:prstGeom prst="rect">
             <a:avLst/>
@@ -2389,12 +2984,12 @@
           <a:p>
             <a:pPr algn="l" indent="0" marL="0">
               <a:lnSpc>
-                <a:spcPts val="1950"/>
+                <a:spcPts val="1350"/>
               </a:lnSpc>
               <a:buNone/>
             </a:pPr>
             <a:r>
-              <a:rPr lang="en-US" sz="1300" dirty="0">
+              <a:rPr lang="en-US" sz="1000" dirty="0">
                 <a:solidFill>
                   <a:srgbClr val="33394A"/>
                 </a:solidFill>
@@ -2402,21 +2997,488 @@
                 <a:ea typeface="Calibri" pitchFamily="34" charset="-122"/>
                 <a:cs typeface="Calibri" pitchFamily="34" charset="-120"/>
               </a:rPr>
-              <a:t>Do segundo ano em diante a empresa opera sozinha, e nós ficamos com o que não dá para fazer de dentro: a operação acompanhada, o conselho trimestral e o Exame Anual de IA, a re-medição completa da maturidade, comparada ano contra ano. A série histórica que nasce daí só existe aqui, vale mais a cada ano, e é dela que sai a fila de oportunidades do ano seguinte.</a:t>
-            </a:r>
-            <a:endParaRPr lang="en-US" sz="1300" dirty="0"/>
-          </a:p>
-        </p:txBody>
-      </p:sp>
-      <p:sp>
-        <p:nvSpPr>
-          <p:cNvPr id="5" name="Shape 3"/>
-          <p:cNvSpPr/>
-          <p:nvPr/>
-        </p:nvSpPr>
-        <p:spPr>
-          <a:xfrm>
-            <a:off x="822960" y="2788920"/>
+              <a:t>Operamos o que construímos: monitoramento, evolução contínua e um ritual semanal de 20 minutos com quem decide.</a:t>
+            </a:r>
+            <a:endParaRPr lang="en-US" sz="1000" dirty="0"/>
+          </a:p>
+        </p:txBody>
+      </p:sp>
+      <p:sp>
+        <p:nvSpPr>
+          <p:cNvPr id="8" name="Text 6"/>
+          <p:cNvSpPr/>
+          <p:nvPr/>
+        </p:nvSpPr>
+        <p:spPr>
+          <a:xfrm>
+            <a:off x="822960" y="2505456"/>
+            <a:ext cx="868680" cy="228600"/>
+          </a:xfrm>
+          <a:prstGeom prst="rect">
+            <a:avLst/>
+          </a:prstGeom>
+          <a:noFill/>
+          <a:ln/>
+        </p:spPr>
+        <p:txBody>
+          <a:bodyPr wrap="square" rtlCol="0" anchor="ctr"/>
+          <a:lstStyle/>
+          <a:p>
+            <a:pPr indent="0" marL="0">
+              <a:buNone/>
+            </a:pPr>
+            <a:r>
+              <a:rPr lang="en-US" sz="800" b="1" spc="200" kern="0" dirty="0">
+                <a:solidFill>
+                  <a:srgbClr val="C2A35B"/>
+                </a:solidFill>
+                <a:latin typeface="Calibri" pitchFamily="34" charset="0"/>
+                <a:ea typeface="Calibri" pitchFamily="34" charset="-122"/>
+                <a:cs typeface="Calibri" pitchFamily="34" charset="-120"/>
+              </a:rPr>
+              <a:t>POR QUÊ</a:t>
+            </a:r>
+            <a:endParaRPr lang="en-US" sz="800" dirty="0"/>
+          </a:p>
+        </p:txBody>
+      </p:sp>
+      <p:sp>
+        <p:nvSpPr>
+          <p:cNvPr id="9" name="Text 7"/>
+          <p:cNvSpPr/>
+          <p:nvPr/>
+        </p:nvSpPr>
+        <p:spPr>
+          <a:xfrm>
+            <a:off x="1737360" y="2478024"/>
+            <a:ext cx="4082796" cy="365760"/>
+          </a:xfrm>
+          <a:prstGeom prst="rect">
+            <a:avLst/>
+          </a:prstGeom>
+          <a:noFill/>
+          <a:ln/>
+        </p:spPr>
+        <p:txBody>
+          <a:bodyPr wrap="square" rtlCol="0" anchor="ctr"/>
+          <a:lstStyle/>
+          <a:p>
+            <a:pPr algn="l" indent="0" marL="0">
+              <a:lnSpc>
+                <a:spcPts val="1350"/>
+              </a:lnSpc>
+              <a:buNone/>
+            </a:pPr>
+            <a:r>
+              <a:rPr lang="en-US" sz="1000" dirty="0">
+                <a:solidFill>
+                  <a:srgbClr val="33394A"/>
+                </a:solidFill>
+                <a:latin typeface="Calibri" pitchFamily="34" charset="0"/>
+                <a:ea typeface="Calibri" pitchFamily="34" charset="-122"/>
+                <a:cs typeface="Calibri" pitchFamily="34" charset="-120"/>
+              </a:rPr>
+              <a:t>Sistema sem dono definha. E a diretoria precisa ver o retorno, não sentir que ele existe.</a:t>
+            </a:r>
+            <a:endParaRPr lang="en-US" sz="1000" dirty="0"/>
+          </a:p>
+        </p:txBody>
+      </p:sp>
+      <p:sp>
+        <p:nvSpPr>
+          <p:cNvPr id="10" name="Text 8"/>
+          <p:cNvSpPr/>
+          <p:nvPr/>
+        </p:nvSpPr>
+        <p:spPr>
+          <a:xfrm>
+            <a:off x="822960" y="2944368"/>
+            <a:ext cx="868680" cy="228600"/>
+          </a:xfrm>
+          <a:prstGeom prst="rect">
+            <a:avLst/>
+          </a:prstGeom>
+          <a:noFill/>
+          <a:ln/>
+        </p:spPr>
+        <p:txBody>
+          <a:bodyPr wrap="square" rtlCol="0" anchor="ctr"/>
+          <a:lstStyle/>
+          <a:p>
+            <a:pPr indent="0" marL="0">
+              <a:buNone/>
+            </a:pPr>
+            <a:r>
+              <a:rPr lang="en-US" sz="800" b="1" spc="200" kern="0" dirty="0">
+                <a:solidFill>
+                  <a:srgbClr val="C2A35B"/>
+                </a:solidFill>
+                <a:latin typeface="Calibri" pitchFamily="34" charset="0"/>
+                <a:ea typeface="Calibri" pitchFamily="34" charset="-122"/>
+                <a:cs typeface="Calibri" pitchFamily="34" charset="-120"/>
+              </a:rPr>
+              <a:t>COMO</a:t>
+            </a:r>
+            <a:endParaRPr lang="en-US" sz="800" dirty="0"/>
+          </a:p>
+        </p:txBody>
+      </p:sp>
+      <p:sp>
+        <p:nvSpPr>
+          <p:cNvPr id="11" name="Text 9"/>
+          <p:cNvSpPr/>
+          <p:nvPr/>
+        </p:nvSpPr>
+        <p:spPr>
+          <a:xfrm>
+            <a:off x="1737360" y="2916936"/>
+            <a:ext cx="4082796" cy="475488"/>
+          </a:xfrm>
+          <a:prstGeom prst="rect">
+            <a:avLst/>
+          </a:prstGeom>
+          <a:noFill/>
+          <a:ln/>
+        </p:spPr>
+        <p:txBody>
+          <a:bodyPr wrap="square" rtlCol="0" anchor="ctr"/>
+          <a:lstStyle/>
+          <a:p>
+            <a:pPr algn="l" indent="0" marL="0">
+              <a:lnSpc>
+                <a:spcPts val="1350"/>
+              </a:lnSpc>
+              <a:buNone/>
+            </a:pPr>
+            <a:r>
+              <a:rPr lang="en-US" sz="1000" dirty="0">
+                <a:solidFill>
+                  <a:srgbClr val="33394A"/>
+                </a:solidFill>
+                <a:latin typeface="Calibri" pitchFamily="34" charset="0"/>
+                <a:ea typeface="Calibri" pitchFamily="34" charset="-122"/>
+                <a:cs typeface="Calibri" pitchFamily="34" charset="-120"/>
+              </a:rPr>
+              <a:t>Toda decisão entra num diário: métrica combinada antes, resultado medido depois. Relatório mensal de projetado versus realizado, sempre.</a:t>
+            </a:r>
+            <a:endParaRPr lang="en-US" sz="1000" dirty="0"/>
+          </a:p>
+        </p:txBody>
+      </p:sp>
+      <p:sp>
+        <p:nvSpPr>
+          <p:cNvPr id="12" name="Shape 10"/>
+          <p:cNvSpPr/>
+          <p:nvPr/>
+        </p:nvSpPr>
+        <p:spPr>
+          <a:xfrm>
+            <a:off x="6368796" y="1554480"/>
+            <a:ext cx="4997196" cy="0"/>
+          </a:xfrm>
+          <a:prstGeom prst="line">
+            <a:avLst/>
+          </a:prstGeom>
+          <a:noFill/>
+          <a:ln w="13970">
+            <a:solidFill>
+              <a:srgbClr val="C2A35B"/>
+            </a:solidFill>
+            <a:prstDash val="solid"/>
+          </a:ln>
+        </p:spPr>
+      </p:sp>
+      <p:sp>
+        <p:nvSpPr>
+          <p:cNvPr id="13" name="Text 11"/>
+          <p:cNvSpPr/>
+          <p:nvPr/>
+        </p:nvSpPr>
+        <p:spPr>
+          <a:xfrm>
+            <a:off x="6368796" y="1655064"/>
+            <a:ext cx="4997196" cy="292608"/>
+          </a:xfrm>
+          <a:prstGeom prst="rect">
+            <a:avLst/>
+          </a:prstGeom>
+          <a:noFill/>
+          <a:ln/>
+        </p:spPr>
+        <p:txBody>
+          <a:bodyPr wrap="square" rtlCol="0" anchor="ctr"/>
+          <a:lstStyle/>
+          <a:p>
+            <a:pPr algn="l" indent="0" marL="0">
+              <a:buNone/>
+            </a:pPr>
+            <a:r>
+              <a:rPr lang="en-US" sz="1000" b="1" spc="300" kern="0" dirty="0">
+                <a:solidFill>
+                  <a:srgbClr val="C2A35B"/>
+                </a:solidFill>
+                <a:latin typeface="Calibri" pitchFamily="34" charset="0"/>
+                <a:ea typeface="Calibri" pitchFamily="34" charset="-122"/>
+                <a:cs typeface="Calibri" pitchFamily="34" charset="-120"/>
+              </a:rPr>
+              <a:t>ANO 2 EM DIANTE · A ASSINATURA DA CAPACIDADE</a:t>
+            </a:r>
+            <a:endParaRPr lang="en-US" sz="1000" dirty="0"/>
+          </a:p>
+        </p:txBody>
+      </p:sp>
+      <p:sp>
+        <p:nvSpPr>
+          <p:cNvPr id="14" name="Text 12"/>
+          <p:cNvSpPr/>
+          <p:nvPr/>
+        </p:nvSpPr>
+        <p:spPr>
+          <a:xfrm>
+            <a:off x="6368796" y="1956816"/>
+            <a:ext cx="868680" cy="228600"/>
+          </a:xfrm>
+          <a:prstGeom prst="rect">
+            <a:avLst/>
+          </a:prstGeom>
+          <a:noFill/>
+          <a:ln/>
+        </p:spPr>
+        <p:txBody>
+          <a:bodyPr wrap="square" rtlCol="0" anchor="ctr"/>
+          <a:lstStyle/>
+          <a:p>
+            <a:pPr indent="0" marL="0">
+              <a:buNone/>
+            </a:pPr>
+            <a:r>
+              <a:rPr lang="en-US" sz="800" b="1" spc="200" kern="0" dirty="0">
+                <a:solidFill>
+                  <a:srgbClr val="C2A35B"/>
+                </a:solidFill>
+                <a:latin typeface="Calibri" pitchFamily="34" charset="0"/>
+                <a:ea typeface="Calibri" pitchFamily="34" charset="-122"/>
+                <a:cs typeface="Calibri" pitchFamily="34" charset="-120"/>
+              </a:rPr>
+              <a:t>O QUÊ</a:t>
+            </a:r>
+            <a:endParaRPr lang="en-US" sz="800" dirty="0"/>
+          </a:p>
+        </p:txBody>
+      </p:sp>
+      <p:sp>
+        <p:nvSpPr>
+          <p:cNvPr id="15" name="Text 13"/>
+          <p:cNvSpPr/>
+          <p:nvPr/>
+        </p:nvSpPr>
+        <p:spPr>
+          <a:xfrm>
+            <a:off x="7283196" y="1929384"/>
+            <a:ext cx="4082796" cy="475488"/>
+          </a:xfrm>
+          <a:prstGeom prst="rect">
+            <a:avLst/>
+          </a:prstGeom>
+          <a:noFill/>
+          <a:ln/>
+        </p:spPr>
+        <p:txBody>
+          <a:bodyPr wrap="square" rtlCol="0" anchor="ctr"/>
+          <a:lstStyle/>
+          <a:p>
+            <a:pPr algn="l" indent="0" marL="0">
+              <a:lnSpc>
+                <a:spcPts val="1350"/>
+              </a:lnSpc>
+              <a:buNone/>
+            </a:pPr>
+            <a:r>
+              <a:rPr lang="en-US" sz="1000" dirty="0">
+                <a:solidFill>
+                  <a:srgbClr val="33394A"/>
+                </a:solidFill>
+                <a:latin typeface="Calibri" pitchFamily="34" charset="0"/>
+                <a:ea typeface="Calibri" pitchFamily="34" charset="-122"/>
+                <a:cs typeface="Calibri" pitchFamily="34" charset="-120"/>
+              </a:rPr>
+              <a:t>Operação sob SLA, conselho trimestral e o Exame Anual de IA: a maturidade re-medida e comparada ano contra ano.</a:t>
+            </a:r>
+            <a:endParaRPr lang="en-US" sz="1000" dirty="0"/>
+          </a:p>
+        </p:txBody>
+      </p:sp>
+      <p:sp>
+        <p:nvSpPr>
+          <p:cNvPr id="16" name="Text 14"/>
+          <p:cNvSpPr/>
+          <p:nvPr/>
+        </p:nvSpPr>
+        <p:spPr>
+          <a:xfrm>
+            <a:off x="6368796" y="2505456"/>
+            <a:ext cx="868680" cy="228600"/>
+          </a:xfrm>
+          <a:prstGeom prst="rect">
+            <a:avLst/>
+          </a:prstGeom>
+          <a:noFill/>
+          <a:ln/>
+        </p:spPr>
+        <p:txBody>
+          <a:bodyPr wrap="square" rtlCol="0" anchor="ctr"/>
+          <a:lstStyle/>
+          <a:p>
+            <a:pPr indent="0" marL="0">
+              <a:buNone/>
+            </a:pPr>
+            <a:r>
+              <a:rPr lang="en-US" sz="800" b="1" spc="200" kern="0" dirty="0">
+                <a:solidFill>
+                  <a:srgbClr val="C2A35B"/>
+                </a:solidFill>
+                <a:latin typeface="Calibri" pitchFamily="34" charset="0"/>
+                <a:ea typeface="Calibri" pitchFamily="34" charset="-122"/>
+                <a:cs typeface="Calibri" pitchFamily="34" charset="-120"/>
+              </a:rPr>
+              <a:t>POR QUÊ</a:t>
+            </a:r>
+            <a:endParaRPr lang="en-US" sz="800" dirty="0"/>
+          </a:p>
+        </p:txBody>
+      </p:sp>
+      <p:sp>
+        <p:nvSpPr>
+          <p:cNvPr id="17" name="Text 15"/>
+          <p:cNvSpPr/>
+          <p:nvPr/>
+        </p:nvSpPr>
+        <p:spPr>
+          <a:xfrm>
+            <a:off x="7283196" y="2478024"/>
+            <a:ext cx="4082796" cy="475488"/>
+          </a:xfrm>
+          <a:prstGeom prst="rect">
+            <a:avLst/>
+          </a:prstGeom>
+          <a:noFill/>
+          <a:ln/>
+        </p:spPr>
+        <p:txBody>
+          <a:bodyPr wrap="square" rtlCol="0" anchor="ctr"/>
+          <a:lstStyle/>
+          <a:p>
+            <a:pPr algn="l" indent="0" marL="0">
+              <a:lnSpc>
+                <a:spcPts val="1350"/>
+              </a:lnSpc>
+              <a:buNone/>
+            </a:pPr>
+            <a:r>
+              <a:rPr lang="en-US" sz="1000" dirty="0">
+                <a:solidFill>
+                  <a:srgbClr val="33394A"/>
+                </a:solidFill>
+                <a:latin typeface="Calibri" pitchFamily="34" charset="0"/>
+                <a:ea typeface="Calibri" pitchFamily="34" charset="-122"/>
+                <a:cs typeface="Calibri" pitchFamily="34" charset="-120"/>
+              </a:rPr>
+              <a:t>A série histórica que nasce daí só existe aqui e vale mais a cada ano. É dela que sai a fila de oportunidades do ano seguinte.</a:t>
+            </a:r>
+            <a:endParaRPr lang="en-US" sz="1000" dirty="0"/>
+          </a:p>
+        </p:txBody>
+      </p:sp>
+      <p:sp>
+        <p:nvSpPr>
+          <p:cNvPr id="18" name="Text 16"/>
+          <p:cNvSpPr/>
+          <p:nvPr/>
+        </p:nvSpPr>
+        <p:spPr>
+          <a:xfrm>
+            <a:off x="6368796" y="3054096"/>
+            <a:ext cx="868680" cy="228600"/>
+          </a:xfrm>
+          <a:prstGeom prst="rect">
+            <a:avLst/>
+          </a:prstGeom>
+          <a:noFill/>
+          <a:ln/>
+        </p:spPr>
+        <p:txBody>
+          <a:bodyPr wrap="square" rtlCol="0" anchor="ctr"/>
+          <a:lstStyle/>
+          <a:p>
+            <a:pPr indent="0" marL="0">
+              <a:buNone/>
+            </a:pPr>
+            <a:r>
+              <a:rPr lang="en-US" sz="800" b="1" spc="200" kern="0" dirty="0">
+                <a:solidFill>
+                  <a:srgbClr val="C2A35B"/>
+                </a:solidFill>
+                <a:latin typeface="Calibri" pitchFamily="34" charset="0"/>
+                <a:ea typeface="Calibri" pitchFamily="34" charset="-122"/>
+                <a:cs typeface="Calibri" pitchFamily="34" charset="-120"/>
+              </a:rPr>
+              <a:t>COMO</a:t>
+            </a:r>
+            <a:endParaRPr lang="en-US" sz="800" dirty="0"/>
+          </a:p>
+        </p:txBody>
+      </p:sp>
+      <p:sp>
+        <p:nvSpPr>
+          <p:cNvPr id="19" name="Text 17"/>
+          <p:cNvSpPr/>
+          <p:nvPr/>
+        </p:nvSpPr>
+        <p:spPr>
+          <a:xfrm>
+            <a:off x="7283196" y="3026664"/>
+            <a:ext cx="4082796" cy="365760"/>
+          </a:xfrm>
+          <a:prstGeom prst="rect">
+            <a:avLst/>
+          </a:prstGeom>
+          <a:noFill/>
+          <a:ln/>
+        </p:spPr>
+        <p:txBody>
+          <a:bodyPr wrap="square" rtlCol="0" anchor="ctr"/>
+          <a:lstStyle/>
+          <a:p>
+            <a:pPr algn="l" indent="0" marL="0">
+              <a:lnSpc>
+                <a:spcPts val="1350"/>
+              </a:lnSpc>
+              <a:buNone/>
+            </a:pPr>
+            <a:r>
+              <a:rPr lang="en-US" sz="1000" dirty="0">
+                <a:solidFill>
+                  <a:srgbClr val="33394A"/>
+                </a:solidFill>
+                <a:latin typeface="Calibri" pitchFamily="34" charset="0"/>
+                <a:ea typeface="Calibri" pitchFamily="34" charset="-122"/>
+                <a:cs typeface="Calibri" pitchFamily="34" charset="-120"/>
+              </a:rPr>
+              <a:t>Renovação anual com saída limpa: tudo o que construímos é seu, e o dado é exportável.</a:t>
+            </a:r>
+            <a:endParaRPr lang="en-US" sz="1000" dirty="0"/>
+          </a:p>
+        </p:txBody>
+      </p:sp>
+      <p:sp>
+        <p:nvSpPr>
+          <p:cNvPr id="20" name="Shape 18"/>
+          <p:cNvSpPr/>
+          <p:nvPr/>
+        </p:nvSpPr>
+        <p:spPr>
+          <a:xfrm>
+            <a:off x="822960" y="3977640"/>
             <a:ext cx="10543032" cy="0"/>
           </a:xfrm>
           <a:prstGeom prst="line">
@@ -2433,14 +3495,37 @@
       </p:sp>
       <p:sp>
         <p:nvSpPr>
-          <p:cNvPr id="6" name="Text 4"/>
-          <p:cNvSpPr/>
-          <p:nvPr/>
-        </p:nvSpPr>
-        <p:spPr>
-          <a:xfrm>
-            <a:off x="822960" y="2944368"/>
-            <a:ext cx="5486400" cy="292608"/>
+          <p:cNvPr id="21" name="Shape 19"/>
+          <p:cNvSpPr/>
+          <p:nvPr/>
+        </p:nvSpPr>
+        <p:spPr>
+          <a:xfrm>
+            <a:off x="822960" y="4160520"/>
+            <a:ext cx="10543032" cy="0"/>
+          </a:xfrm>
+          <a:prstGeom prst="line">
+            <a:avLst/>
+          </a:prstGeom>
+          <a:noFill/>
+          <a:ln w="13970">
+            <a:solidFill>
+              <a:srgbClr val="C2A35B"/>
+            </a:solidFill>
+            <a:prstDash val="solid"/>
+          </a:ln>
+        </p:spPr>
+      </p:sp>
+      <p:sp>
+        <p:nvSpPr>
+          <p:cNvPr id="22" name="Text 20"/>
+          <p:cNvSpPr/>
+          <p:nvPr/>
+        </p:nvSpPr>
+        <p:spPr>
+          <a:xfrm>
+            <a:off x="822960" y="4261104"/>
+            <a:ext cx="10543032" cy="292608"/>
           </a:xfrm>
           <a:prstGeom prst="rect">
             <a:avLst/>
@@ -2456,7 +3541,7 @@
               <a:buNone/>
             </a:pPr>
             <a:r>
-              <a:rPr lang="en-US" sz="1100" b="1" spc="300" kern="0" dirty="0">
+              <a:rPr lang="en-US" sz="1000" b="1" spc="300" kern="0" dirty="0">
                 <a:solidFill>
                   <a:srgbClr val="C2A35B"/>
                 </a:solidFill>
@@ -2464,22 +3549,61 @@
                 <a:ea typeface="Calibri" pitchFamily="34" charset="-122"/>
                 <a:cs typeface="Calibri" pitchFamily="34" charset="-120"/>
               </a:rPr>
-              <a:t>JÁ TEM IA RODANDO? O CONSELHEIRO DE IA</a:t>
-            </a:r>
-            <a:endParaRPr lang="en-US" sz="1100" dirty="0"/>
-          </a:p>
-        </p:txBody>
-      </p:sp>
-      <p:sp>
-        <p:nvSpPr>
-          <p:cNvPr id="7" name="Text 5"/>
-          <p:cNvSpPr/>
-          <p:nvPr/>
-        </p:nvSpPr>
-        <p:spPr>
-          <a:xfrm>
-            <a:off x="822960" y="3273552"/>
-            <a:ext cx="10543032" cy="1234440"/>
+              <a:t>JÁ TEM IA RODANDO? O CONSELHEIRO DE IA · DO SEU LADO DA MESA</a:t>
+            </a:r>
+            <a:endParaRPr lang="en-US" sz="1000" dirty="0"/>
+          </a:p>
+        </p:txBody>
+      </p:sp>
+      <p:sp>
+        <p:nvSpPr>
+          <p:cNvPr id="23" name="Text 21"/>
+          <p:cNvSpPr/>
+          <p:nvPr/>
+        </p:nvSpPr>
+        <p:spPr>
+          <a:xfrm>
+            <a:off x="822960" y="4562856"/>
+            <a:ext cx="868680" cy="228600"/>
+          </a:xfrm>
+          <a:prstGeom prst="rect">
+            <a:avLst/>
+          </a:prstGeom>
+          <a:noFill/>
+          <a:ln/>
+        </p:spPr>
+        <p:txBody>
+          <a:bodyPr wrap="square" rtlCol="0" anchor="ctr"/>
+          <a:lstStyle/>
+          <a:p>
+            <a:pPr indent="0" marL="0">
+              <a:buNone/>
+            </a:pPr>
+            <a:r>
+              <a:rPr lang="en-US" sz="800" b="1" spc="200" kern="0" dirty="0">
+                <a:solidFill>
+                  <a:srgbClr val="C2A35B"/>
+                </a:solidFill>
+                <a:latin typeface="Calibri" pitchFamily="34" charset="0"/>
+                <a:ea typeface="Calibri" pitchFamily="34" charset="-122"/>
+                <a:cs typeface="Calibri" pitchFamily="34" charset="-120"/>
+              </a:rPr>
+              <a:t>O QUÊ</a:t>
+            </a:r>
+            <a:endParaRPr lang="en-US" sz="800" dirty="0"/>
+          </a:p>
+        </p:txBody>
+      </p:sp>
+      <p:sp>
+        <p:nvSpPr>
+          <p:cNvPr id="24" name="Text 22"/>
+          <p:cNvSpPr/>
+          <p:nvPr/>
+        </p:nvSpPr>
+        <p:spPr>
+          <a:xfrm>
+            <a:off x="1737360" y="4535424"/>
+            <a:ext cx="9628632" cy="347472"/>
           </a:xfrm>
           <a:prstGeom prst="rect">
             <a:avLst/>
@@ -2493,12 +3617,12 @@
           <a:p>
             <a:pPr algn="l" indent="0" marL="0">
               <a:lnSpc>
-                <a:spcPts val="1850"/>
+                <a:spcPts val="1350"/>
               </a:lnSpc>
               <a:buNone/>
             </a:pPr>
             <a:r>
-              <a:rPr lang="en-US" sz="1250" dirty="0">
+              <a:rPr lang="en-US" sz="1000" dirty="0">
                 <a:solidFill>
                   <a:srgbClr val="33394A"/>
                 </a:solidFill>
@@ -2506,21 +3630,183 @@
                 <a:ea typeface="Calibri" pitchFamily="34" charset="-122"/>
                 <a:cs typeface="Calibri" pitchFamily="34" charset="-120"/>
               </a:rPr>
-              <a:t>Para quem já construiu, a oferta é outra: a cadeira de direção de IA do seu lado da mesa, em fração. Funciona em quatro movimentos: presença recorrente na diretoria · o roadmap vivo, re-ranqueado conforme os números chegam · parecer por escrito sobre cada fornecedor que aparece · e a memória de decisão, com a expectativa declarada antes e o resultado medido depois, que nunca se apaga. Nenhum time interno pode ser a própria prova. É por isso que empresa com um ótimo CFO ainda contrata quem verifique as contas de fora.</a:t>
-            </a:r>
-            <a:endParaRPr lang="en-US" sz="1250" dirty="0"/>
-          </a:p>
-        </p:txBody>
-      </p:sp>
-      <p:sp>
-        <p:nvSpPr>
-          <p:cNvPr id="8" name="Shape 6"/>
-          <p:cNvSpPr/>
-          <p:nvPr/>
-        </p:nvSpPr>
-        <p:spPr>
-          <a:xfrm>
-            <a:off x="822960" y="4617720"/>
+              <a:t>Um estrategista de IA presente na sua diretoria: roadmap vivo, governança, e análise independente de qualquer proposta de fornecedor que chegar, com parecer por escrito.</a:t>
+            </a:r>
+            <a:endParaRPr lang="en-US" sz="1000" dirty="0"/>
+          </a:p>
+        </p:txBody>
+      </p:sp>
+      <p:sp>
+        <p:nvSpPr>
+          <p:cNvPr id="25" name="Text 23"/>
+          <p:cNvSpPr/>
+          <p:nvPr/>
+        </p:nvSpPr>
+        <p:spPr>
+          <a:xfrm>
+            <a:off x="822960" y="4983480"/>
+            <a:ext cx="868680" cy="228600"/>
+          </a:xfrm>
+          <a:prstGeom prst="rect">
+            <a:avLst/>
+          </a:prstGeom>
+          <a:noFill/>
+          <a:ln/>
+        </p:spPr>
+        <p:txBody>
+          <a:bodyPr wrap="square" rtlCol="0" anchor="ctr"/>
+          <a:lstStyle/>
+          <a:p>
+            <a:pPr indent="0" marL="0">
+              <a:buNone/>
+            </a:pPr>
+            <a:r>
+              <a:rPr lang="en-US" sz="800" b="1" spc="200" kern="0" dirty="0">
+                <a:solidFill>
+                  <a:srgbClr val="C2A35B"/>
+                </a:solidFill>
+                <a:latin typeface="Calibri" pitchFamily="34" charset="0"/>
+                <a:ea typeface="Calibri" pitchFamily="34" charset="-122"/>
+                <a:cs typeface="Calibri" pitchFamily="34" charset="-120"/>
+              </a:rPr>
+              <a:t>POR QUÊ</a:t>
+            </a:r>
+            <a:endParaRPr lang="en-US" sz="800" dirty="0"/>
+          </a:p>
+        </p:txBody>
+      </p:sp>
+      <p:sp>
+        <p:nvSpPr>
+          <p:cNvPr id="26" name="Text 24"/>
+          <p:cNvSpPr/>
+          <p:nvPr/>
+        </p:nvSpPr>
+        <p:spPr>
+          <a:xfrm>
+            <a:off x="1737360" y="4956048"/>
+            <a:ext cx="9628632" cy="347472"/>
+          </a:xfrm>
+          <a:prstGeom prst="rect">
+            <a:avLst/>
+          </a:prstGeom>
+          <a:noFill/>
+          <a:ln/>
+        </p:spPr>
+        <p:txBody>
+          <a:bodyPr wrap="square" rtlCol="0" anchor="ctr"/>
+          <a:lstStyle/>
+          <a:p>
+            <a:pPr algn="l" indent="0" marL="0">
+              <a:lnSpc>
+                <a:spcPts val="1350"/>
+              </a:lnSpc>
+              <a:buNone/>
+            </a:pPr>
+            <a:r>
+              <a:rPr lang="en-US" sz="1000" dirty="0">
+                <a:solidFill>
+                  <a:srgbClr val="33394A"/>
+                </a:solidFill>
+                <a:latin typeface="Calibri" pitchFamily="34" charset="0"/>
+                <a:ea typeface="Calibri" pitchFamily="34" charset="-122"/>
+                <a:cs typeface="Calibri" pitchFamily="34" charset="-120"/>
+              </a:rPr>
+              <a:t>Todo fornecedor de IA tem um vendedor. A sua mesa merece alguém do seu lado quando a fatura chega. E cada recomendação entra no registro com o número que dirá, depois, se deu certo.</a:t>
+            </a:r>
+            <a:endParaRPr lang="en-US" sz="1000" dirty="0"/>
+          </a:p>
+        </p:txBody>
+      </p:sp>
+      <p:sp>
+        <p:nvSpPr>
+          <p:cNvPr id="27" name="Text 25"/>
+          <p:cNvSpPr/>
+          <p:nvPr/>
+        </p:nvSpPr>
+        <p:spPr>
+          <a:xfrm>
+            <a:off x="822960" y="5404104"/>
+            <a:ext cx="868680" cy="228600"/>
+          </a:xfrm>
+          <a:prstGeom prst="rect">
+            <a:avLst/>
+          </a:prstGeom>
+          <a:noFill/>
+          <a:ln/>
+        </p:spPr>
+        <p:txBody>
+          <a:bodyPr wrap="square" rtlCol="0" anchor="ctr"/>
+          <a:lstStyle/>
+          <a:p>
+            <a:pPr indent="0" marL="0">
+              <a:buNone/>
+            </a:pPr>
+            <a:r>
+              <a:rPr lang="en-US" sz="800" b="1" spc="200" kern="0" dirty="0">
+                <a:solidFill>
+                  <a:srgbClr val="C2A35B"/>
+                </a:solidFill>
+                <a:latin typeface="Calibri" pitchFamily="34" charset="0"/>
+                <a:ea typeface="Calibri" pitchFamily="34" charset="-122"/>
+                <a:cs typeface="Calibri" pitchFamily="34" charset="-120"/>
+              </a:rPr>
+              <a:t>AS PORTAS</a:t>
+            </a:r>
+            <a:endParaRPr lang="en-US" sz="800" dirty="0"/>
+          </a:p>
+        </p:txBody>
+      </p:sp>
+      <p:sp>
+        <p:nvSpPr>
+          <p:cNvPr id="28" name="Text 26"/>
+          <p:cNvSpPr/>
+          <p:nvPr/>
+        </p:nvSpPr>
+        <p:spPr>
+          <a:xfrm>
+            <a:off x="1737360" y="5376672"/>
+            <a:ext cx="9628632" cy="347472"/>
+          </a:xfrm>
+          <a:prstGeom prst="rect">
+            <a:avLst/>
+          </a:prstGeom>
+          <a:noFill/>
+          <a:ln/>
+        </p:spPr>
+        <p:txBody>
+          <a:bodyPr wrap="square" rtlCol="0" anchor="ctr"/>
+          <a:lstStyle/>
+          <a:p>
+            <a:pPr algn="l" indent="0" marL="0">
+              <a:lnSpc>
+                <a:spcPts val="1350"/>
+              </a:lnSpc>
+              <a:buNone/>
+            </a:pPr>
+            <a:r>
+              <a:rPr lang="en-US" sz="1000" dirty="0">
+                <a:solidFill>
+                  <a:srgbClr val="33394A"/>
+                </a:solidFill>
+                <a:latin typeface="Calibri" pitchFamily="34" charset="0"/>
+                <a:ea typeface="Calibri" pitchFamily="34" charset="-122"/>
+                <a:cs typeface="Calibri" pitchFamily="34" charset="-120"/>
+              </a:rPr>
+              <a:t>Ao fim do Programa, a cadeira dá continuidade ao que foi construído. E para quem já tem IA rodando, a porta é direta: não precisa do Programa para ter a cadeira.</a:t>
+            </a:r>
+            <a:endParaRPr lang="en-US" sz="1000" dirty="0"/>
+          </a:p>
+        </p:txBody>
+      </p:sp>
+      <p:sp>
+        <p:nvSpPr>
+          <p:cNvPr id="29" name="Shape 27"/>
+          <p:cNvSpPr/>
+          <p:nvPr/>
+        </p:nvSpPr>
+        <p:spPr>
+          <a:xfrm>
+            <a:off x="822960" y="5623560"/>
             <a:ext cx="10543032" cy="0"/>
           </a:xfrm>
           <a:prstGeom prst="line">
@@ -2537,13 +3823,13 @@
       </p:sp>
       <p:sp>
         <p:nvSpPr>
-          <p:cNvPr id="9" name="Text 7"/>
-          <p:cNvSpPr/>
-          <p:nvPr/>
-        </p:nvSpPr>
-        <p:spPr>
-          <a:xfrm>
-            <a:off x="822960" y="4773168"/>
+          <p:cNvPr id="30" name="Text 28"/>
+          <p:cNvSpPr/>
+          <p:nvPr/>
+        </p:nvSpPr>
+        <p:spPr>
+          <a:xfrm>
+            <a:off x="822960" y="5760720"/>
             <a:ext cx="5486400" cy="292608"/>
           </a:xfrm>
           <a:prstGeom prst="rect">
@@ -2560,7 +3846,7 @@
               <a:buNone/>
             </a:pPr>
             <a:r>
-              <a:rPr lang="en-US" sz="1100" b="1" spc="300" kern="0" dirty="0">
+              <a:rPr lang="en-US" sz="950" b="1" spc="300" kern="0" dirty="0">
                 <a:solidFill>
                   <a:srgbClr val="C2A35B"/>
                 </a:solidFill>
@@ -2570,13 +3856,13 @@
               </a:rPr>
               <a:t>PARCEIROS OFICIAIS</a:t>
             </a:r>
-            <a:endParaRPr lang="en-US" sz="1100" dirty="0"/>
+            <a:endParaRPr lang="en-US" sz="950" dirty="0"/>
           </a:p>
         </p:txBody>
       </p:sp>
       <p:pic>
         <p:nvPicPr>
-          <p:cNvPr id="10" name="Image 0" descr="/home/user/abba-ops/08-materiais/assets/marca/logo-microsoft.png">    </p:cNvPr>
+          <p:cNvPr id="31" name="Image 0" descr="/home/user/abba-ops/08-materiais/assets/marca/logo-microsoft.png">    </p:cNvPr>
           <p:cNvPicPr>
             <a:picLocks noChangeAspect="1"/>
           </p:cNvPicPr>
@@ -2590,8 +3876,8 @@
         </p:blipFill>
         <p:spPr>
           <a:xfrm>
-            <a:off x="822960" y="5120640"/>
-            <a:ext cx="1435608" cy="310896"/>
+            <a:off x="822960" y="6053328"/>
+            <a:ext cx="1106424" cy="237744"/>
           </a:xfrm>
           <a:prstGeom prst="rect">
             <a:avLst/>
@@ -2600,7 +3886,7 @@
       </p:pic>
       <p:pic>
         <p:nvPicPr>
-          <p:cNvPr id="11" name="Image 1" descr="/home/user/abba-ops/08-materiais/assets/marca/logo-crewai.png">    </p:cNvPr>
+          <p:cNvPr id="32" name="Image 1" descr="/home/user/abba-ops/08-materiais/assets/marca/logo-crewai.png">    </p:cNvPr>
           <p:cNvPicPr>
             <a:picLocks noChangeAspect="1"/>
           </p:cNvPicPr>
@@ -2614,8 +3900,8 @@
         </p:blipFill>
         <p:spPr>
           <a:xfrm>
-            <a:off x="2651760" y="5065776"/>
-            <a:ext cx="1325880" cy="402336"/>
+            <a:off x="2286000" y="6016752"/>
+            <a:ext cx="1024128" cy="310896"/>
           </a:xfrm>
           <a:prstGeom prst="rect">
             <a:avLst/>
@@ -2624,14 +3910,14 @@
       </p:pic>
       <p:sp>
         <p:nvSpPr>
-          <p:cNvPr id="12" name="Text 8"/>
-          <p:cNvSpPr/>
-          <p:nvPr/>
-        </p:nvSpPr>
-        <p:spPr>
-          <a:xfrm>
-            <a:off x="4480560" y="5047488"/>
-            <a:ext cx="6885432" cy="457200"/>
+          <p:cNvPr id="33" name="Text 29"/>
+          <p:cNvSpPr/>
+          <p:nvPr/>
+        </p:nvSpPr>
+        <p:spPr>
+          <a:xfrm>
+            <a:off x="3749040" y="6016752"/>
+            <a:ext cx="7616952" cy="365760"/>
           </a:xfrm>
           <a:prstGeom prst="rect">
             <a:avLst/>
@@ -2650,46 +3936,7 @@
               <a:buNone/>
             </a:pPr>
             <a:r>
-              <a:rPr lang="en-US" sz="1150" dirty="0">
-                <a:solidFill>
-                  <a:srgbClr val="6E6858"/>
-                </a:solidFill>
-                <a:latin typeface="Calibri" pitchFamily="34" charset="0"/>
-                <a:ea typeface="Calibri" pitchFamily="34" charset="-122"/>
-                <a:cs typeface="Calibri" pitchFamily="34" charset="-120"/>
-              </a:rPr>
-              <a:t>Durante a capacitação, a sua equipe usa ferramentas dos nossos parceiros para construir as próprias soluções.</a:t>
-            </a:r>
-            <a:endParaRPr lang="en-US" sz="1150" dirty="0"/>
-          </a:p>
-        </p:txBody>
-      </p:sp>
-      <p:sp>
-        <p:nvSpPr>
-          <p:cNvPr id="13" name="Text 9"/>
-          <p:cNvSpPr/>
-          <p:nvPr/>
-        </p:nvSpPr>
-        <p:spPr>
-          <a:xfrm>
-            <a:off x="822960" y="5806440"/>
-            <a:ext cx="10543032" cy="502920"/>
-          </a:xfrm>
-          <a:prstGeom prst="rect">
-            <a:avLst/>
-          </a:prstGeom>
-          <a:noFill/>
-          <a:ln/>
-        </p:spPr>
-        <p:txBody>
-          <a:bodyPr wrap="square" rtlCol="0" anchor="ctr"/>
-          <a:lstStyle/>
-          <a:p>
-            <a:pPr algn="ctr" indent="0" marL="0">
-              <a:buNone/>
-            </a:pPr>
-            <a:r>
-              <a:rPr lang="en-US" sz="1500" b="1" dirty="0">
+              <a:rPr lang="en-US" sz="1200" dirty="0">
                 <a:solidFill>
                   <a:srgbClr val="1B2A4A"/>
                 </a:solidFill>
@@ -2697,15 +3944,15 @@
                 <a:ea typeface="Cambria" pitchFamily="34" charset="-122"/>
                 <a:cs typeface="Cambria" pitchFamily="34" charset="-120"/>
               </a:rPr>
-              <a:t>O próximo passo não custa nada e cabe em 45 minutos: o Mapa de Vazamento da sua operação.</a:t>
-            </a:r>
-            <a:endParaRPr lang="en-US" sz="1500" dirty="0"/>
-          </a:p>
-        </p:txBody>
-      </p:sp>
-      <p:sp>
-        <p:nvSpPr>
-          <p:cNvPr id="14" name="Text 10"/>
+              <a:t>A história começa com uma conversa de 45 minutos, e com o seu Mapa de Vazamento, gratuito.</a:t>
+            </a:r>
+            <a:endParaRPr lang="en-US" sz="1200" dirty="0"/>
+          </a:p>
+        </p:txBody>
+      </p:sp>
+      <p:sp>
+        <p:nvSpPr>
+          <p:cNvPr id="34" name="Text 30"/>
           <p:cNvSpPr/>
           <p:nvPr/>
         </p:nvSpPr>

</xml_diff>